<commit_message>
Frame final review around completed Gen5 thesis findings
</commit_message>
<xml_diff>
--- a/university/final_review_2026_10_10/VOLLEY_Final_Review_2026-10-10.pptx
+++ b/university/final_review_2026_10_10/VOLLEY_Final_Review_2026-10-10.pptx
@@ -3297,9 +3297,45 @@
           </a:p>
         </p:txBody>
       </p:sp>
+      <p:sp>
+        <p:nvSpPr>
+          <p:cNvPr id="7" name="TextBox 6"/>
+          <p:cNvSpPr txBox="1"/>
+          <p:nvPr/>
+        </p:nvSpPr>
+        <p:spPr>
+          <a:xfrm>
+            <a:off x="1097280" y="2002536"/>
+            <a:ext cx="9994392" cy="329184"/>
+          </a:xfrm>
+          <a:prstGeom prst="rect">
+            <a:avLst/>
+          </a:prstGeom>
+          <a:noFill/>
+        </p:spPr>
+        <p:txBody>
+          <a:bodyPr wrap="square" lIns="54864" rIns="54864" tIns="54864" bIns="54864" anchor="t">
+            <a:spAutoFit/>
+          </a:bodyPr>
+          <a:lstStyle/>
+          <a:p>
+            <a:pPr algn="ctr">
+              <a:defRPr sz="1700" b="1">
+                <a:solidFill>
+                  <a:srgbClr val="234D81"/>
+                </a:solidFill>
+                <a:latin typeface="Aptos"/>
+              </a:defRPr>
+            </a:pPr>
+            <a:r>
+              <a:t>Completed Gen5 system-level computational evaluation</a:t>
+            </a:r>
+          </a:p>
+        </p:txBody>
+      </p:sp>
       <p:pic>
         <p:nvPicPr>
-          <p:cNvPr id="7" name="Picture 6" descr="sit-logo.jpg"/>
+          <p:cNvPr id="8" name="Picture 7" descr="sit-logo.jpg"/>
           <p:cNvPicPr>
             <a:picLocks noChangeAspect="1"/>
           </p:cNvPicPr>
@@ -3313,8 +3349,8 @@
         </p:blipFill>
         <p:spPr>
           <a:xfrm>
-            <a:off x="5276088" y="2148840"/>
-            <a:ext cx="1645920" cy="1645920"/>
+            <a:off x="5413248" y="2377440"/>
+            <a:ext cx="1371600" cy="1371600"/>
           </a:xfrm>
           <a:prstGeom prst="rect">
             <a:avLst/>
@@ -3323,7 +3359,7 @@
       </p:pic>
       <p:sp>
         <p:nvSpPr>
-          <p:cNvPr id="8" name="TextBox 7"/>
+          <p:cNvPr id="9" name="TextBox 8"/>
           <p:cNvSpPr txBox="1"/>
           <p:nvPr/>
         </p:nvSpPr>
@@ -3359,7 +3395,7 @@
       </p:sp>
       <p:sp>
         <p:nvSpPr>
-          <p:cNvPr id="9" name="TextBox 8"/>
+          <p:cNvPr id="10" name="TextBox 9"/>
           <p:cNvSpPr txBox="1"/>
           <p:nvPr/>
         </p:nvSpPr>
@@ -3395,7 +3431,7 @@
       </p:sp>
       <p:sp>
         <p:nvSpPr>
-          <p:cNvPr id="10" name="TextBox 9"/>
+          <p:cNvPr id="11" name="TextBox 10"/>
           <p:cNvSpPr txBox="1"/>
           <p:nvPr/>
         </p:nvSpPr>
@@ -3431,7 +3467,7 @@
       </p:sp>
       <p:sp>
         <p:nvSpPr>
-          <p:cNvPr id="11" name="TextBox 10"/>
+          <p:cNvPr id="12" name="TextBox 11"/>
           <p:cNvSpPr txBox="1"/>
           <p:nvPr/>
         </p:nvSpPr>
@@ -3467,7 +3503,7 @@
       </p:sp>
       <p:sp>
         <p:nvSpPr>
-          <p:cNvPr id="12" name="TextBox 11"/>
+          <p:cNvPr id="13" name="TextBox 12"/>
           <p:cNvSpPr txBox="1"/>
           <p:nvPr/>
         </p:nvSpPr>
@@ -3503,7 +3539,7 @@
       </p:sp>
       <p:sp>
         <p:nvSpPr>
-          <p:cNvPr id="13" name="TextBox 12"/>
+          <p:cNvPr id="14" name="TextBox 13"/>
           <p:cNvSpPr txBox="1"/>
           <p:nvPr/>
         </p:nvSpPr>
@@ -3539,7 +3575,7 @@
       </p:sp>
       <p:sp>
         <p:nvSpPr>
-          <p:cNvPr id="14" name="TextBox 13"/>
+          <p:cNvPr id="15" name="TextBox 14"/>
           <p:cNvSpPr txBox="1"/>
           <p:nvPr/>
         </p:nvSpPr>
@@ -3710,7 +3746,7 @@
               </a:defRPr>
             </a:pPr>
             <a:r>
-              <a:t>Next work is gated by evidence, not an invented date</a:t>
+              <a:t>2026 findings were incorporated in the final baseline</a:t>
             </a:r>
           </a:p>
         </p:txBody>
@@ -3782,7 +3818,7 @@
               </a:defRPr>
             </a:pPr>
             <a:r>
-              <a:t>GEN6 PLAN • NOT COMPLETED</a:t>
+              <a:t>GEN5 MODEL STUDY</a:t>
             </a:r>
           </a:p>
         </p:txBody>
@@ -3818,7 +3854,7 @@
               </a:defRPr>
             </a:pPr>
             <a:r>
-              <a:t>CURRENT PLAN AND STATUS — PLAN-R2, 29 Sep 2026</a:t>
+              <a:t>HISTORY.md; PROVENANCE.md; thesis manuscript, Limitations</a:t>
             </a:r>
           </a:p>
         </p:txBody>
@@ -3933,7 +3969,7 @@
               </a:defRPr>
             </a:pPr>
             <a:r>
-              <a:t>N0</a:t>
+              <a:t>Jul</a:t>
             </a:r>
           </a:p>
         </p:txBody>
@@ -4012,7 +4048,7 @@
               </a:defRPr>
             </a:pPr>
             <a:r>
-              <a:t>Freeze mission, payload and host envelope</a:t>
+              <a:t>CAD-derived sled mass replaced an optimistic parametric estimate</a:t>
             </a:r>
           </a:p>
         </p:txBody>
@@ -4091,7 +4127,7 @@
               </a:defRPr>
             </a:pPr>
             <a:r>
-              <a:t>N1</a:t>
+              <a:t>Aug</a:t>
             </a:r>
           </a:p>
         </p:txBody>
@@ -4170,7 +4206,7 @@
               </a:defRPr>
             </a:pPr>
             <a:r>
-              <a:t>Run coupled multi-payload mission cases</a:t>
+              <a:t>Depth-resolved thrust calculation lowered the rated speed</a:t>
             </a:r>
           </a:p>
         </p:txBody>
@@ -4249,7 +4285,7 @@
               </a:defRPr>
             </a:pPr>
             <a:r>
-              <a:t>N2</a:t>
+              <a:t>Aug</a:t>
             </a:r>
           </a:p>
         </p:txBody>
@@ -4328,7 +4364,7 @@
               </a:defRPr>
             </a:pPr>
             <a:r>
-              <a:t>Reject or select mechanisms on common criteria</a:t>
+              <a:t>Enclosure buildup exposed the full 3U mass penalty</a:t>
             </a:r>
           </a:p>
         </p:txBody>
@@ -4407,7 +4443,7 @@
               </a:defRPr>
             </a:pPr>
             <a:r>
-              <a:t>N3–N4</a:t>
+              <a:t>2026</a:t>
             </a:r>
           </a:p>
         </p:txBody>
@@ -4486,7 +4522,7 @@
               </a:defRPr>
             </a:pPr>
             <a:r>
-              <a:t>Close installed burden, faults and BOLLEY drive</a:t>
+              <a:t>Independent orbit checks rejected a solar-invariance claim</a:t>
             </a:r>
           </a:p>
         </p:txBody>
@@ -4565,7 +4601,7 @@
               </a:defRPr>
             </a:pPr>
             <a:r>
-              <a:t>N5</a:t>
+              <a:t>Final</a:t>
             </a:r>
           </a:p>
         </p:txBody>
@@ -4644,7 +4680,7 @@
               </a:defRPr>
             </a:pPr>
             <a:r>
-              <a:t>Prepare first-test package and review</a:t>
+              <a:t>Results and failures retained in the submitted thesis record</a:t>
             </a:r>
           </a:p>
         </p:txBody>
@@ -4786,7 +4822,7 @@
               </a:defRPr>
             </a:pPr>
             <a:r>
-              <a:t>A mature analytical record; physical evidence still needed</a:t>
+              <a:t>The thesis deliverables are complete and traceable</a:t>
             </a:r>
           </a:p>
         </p:txBody>
@@ -4894,7 +4930,7 @@
               </a:defRPr>
             </a:pPr>
             <a:r>
-              <a:t>Thesis README; PROVENANCE.md; PLAN-R2</a:t>
+              <a:t>Thesis README; BASELINE.md; PROVENANCE.md; validation register</a:t>
             </a:r>
           </a:p>
         </p:txBody>
@@ -5054,7 +5090,7 @@
               </a:defRPr>
             </a:pPr>
             <a:r>
-              <a:t>Produced</a:t>
+              <a:t>Design delivered</a:t>
             </a:r>
           </a:p>
         </p:txBody>
@@ -5090,7 +5126,7 @@
               </a:defRPr>
             </a:pPr>
             <a:r>
-              <a:t>Manuscript, CAD, scripts and figures, validation sheets, provenance and defect register.</a:t>
+              <a:t>Gen5 CAD, magazine and release architecture, subsystem models and system mass rollup.</a:t>
             </a:r>
           </a:p>
         </p:txBody>
@@ -5155,7 +5191,7 @@
             <a:avLst/>
           </a:prstGeom>
           <a:solidFill>
-            <a:srgbClr val="D78F2B"/>
+            <a:srgbClr val="0096A0"/>
           </a:solidFill>
           <a:ln>
             <a:noFill/>
@@ -5214,7 +5250,7 @@
               </a:defRPr>
             </a:pPr>
             <a:r>
-              <a:t>Analysed</a:t>
+              <a:t>Analysis delivered</a:t>
             </a:r>
           </a:p>
         </p:txBody>
@@ -5250,7 +5286,7 @@
               </a:defRPr>
             </a:pPr>
             <a:r>
-              <a:t>Gen5 shot, circuit, mass, thermal, structural and orbit cases. Failed criteria are retained.</a:t>
+              <a:t>Shot, control, circuit, structure, thermal, orbit and alternative-case results.</a:t>
             </a:r>
           </a:p>
         </p:txBody>
@@ -5315,7 +5351,7 @@
             <a:avLst/>
           </a:prstGeom>
           <a:solidFill>
-            <a:srgbClr val="B94141"/>
+            <a:srgbClr val="0096A0"/>
           </a:solidFill>
           <a:ln>
             <a:noFill/>
@@ -5374,7 +5410,7 @@
               </a:defRPr>
             </a:pPr>
             <a:r>
-              <a:t>Still open</a:t>
+              <a:t>Evidence delivered</a:t>
             </a:r>
           </a:p>
         </p:txBody>
@@ -5410,7 +5446,7 @@
               </a:defRPr>
             </a:pPr>
             <a:r>
-              <a:t>Hardware tests, provider interfaces, payload qualification, measured reliability and build release.</a:t>
+              <a:t>Manuscript, figures, scripts, numerical checks, provenance and defect register.</a:t>
             </a:r>
           </a:p>
         </p:txBody>
@@ -5446,7 +5482,7 @@
               </a:defRPr>
             </a:pPr>
             <a:r>
-              <a:t>The presentation does not assign a percentage complete from document count.</a:t>
+              <a:t>Scope: completed computational thesis; physical qualification belongs to a later development phase.</a:t>
             </a:r>
           </a:p>
         </p:txBody>
@@ -8761,7 +8797,7 @@
               </a:defRPr>
             </a:pPr>
             <a:r>
-              <a:t>The unresolved physical questions determine viability</a:t>
+              <a:t>The study ends with a clear engineering decision</a:t>
             </a:r>
           </a:p>
         </p:txBody>
@@ -8970,7 +9006,7 @@
             <a:avLst/>
           </a:prstGeom>
           <a:solidFill>
-            <a:srgbClr val="B94141"/>
+            <a:srgbClr val="0096A0"/>
           </a:solidFill>
           <a:ln>
             <a:noFill/>
@@ -9029,7 +9065,7 @@
               </a:defRPr>
             </a:pPr>
             <a:r>
-              <a:t>Payload interface</a:t>
+              <a:t>Supported</a:t>
             </a:r>
           </a:p>
         </p:txBody>
@@ -9065,7 +9101,7 @@
               </a:defRPr>
             </a:pPr>
             <a:r>
-              <a:t>Arrest loads, contact and magnetic cleanliness need payload-specific evaluation.</a:t>
+              <a:t>Modelled commandable release and a conditional orbital-energy benefit.</a:t>
             </a:r>
           </a:p>
         </p:txBody>
@@ -9130,7 +9166,7 @@
             <a:avLst/>
           </a:prstGeom>
           <a:solidFill>
-            <a:srgbClr val="D78F2B"/>
+            <a:srgbClr val="B94141"/>
           </a:solidFill>
           <a:ln>
             <a:noFill/>
@@ -9189,7 +9225,7 @@
               </a:defRPr>
             </a:pPr>
             <a:r>
-              <a:t>Shared reliability</a:t>
+              <a:t>Rejected for 3U</a:t>
             </a:r>
           </a:p>
         </p:txBody>
@@ -9225,7 +9261,7 @@
               </a:defRPr>
             </a:pPr>
             <a:r>
-              <a:t>A failed retention or reload element can affect the remaining manifest.</a:t>
+              <a:t>The complete Gen5 configuration misses the preset spring-mass parity target.</a:t>
             </a:r>
           </a:p>
         </p:txBody>
@@ -9290,7 +9326,7 @@
             <a:avLst/>
           </a:prstGeom>
           <a:solidFill>
-            <a:srgbClr val="B94141"/>
+            <a:srgbClr val="D78F2B"/>
           </a:solidFill>
           <a:ln>
             <a:noFill/>
@@ -9349,7 +9385,7 @@
               </a:defRPr>
             </a:pPr>
             <a:r>
-              <a:t>Host compatibility</a:t>
+              <a:t>Unverified</a:t>
             </a:r>
           </a:p>
         </p:txBody>
@@ -9385,7 +9421,7 @@
               </a:defRPr>
             </a:pPr>
             <a:r>
-              <a:t>No launch provider has supplied an approved accommodation or operating interface.</a:t>
+              <a:t>Payload loads, magnetic cleanliness, cycle life and host interfaces require tests.</a:t>
             </a:r>
           </a:p>
         </p:txBody>
@@ -9413,7 +9449,7 @@
           <a:lstStyle/>
           <a:p>
             <a:pPr algn="ctr">
-              <a:defRPr sz="2200" b="1">
+              <a:defRPr sz="2100" b="1">
                 <a:solidFill>
                   <a:srgbClr val="0D2035"/>
                 </a:solidFill>
@@ -9421,7 +9457,7 @@
               </a:defRPr>
             </a:pPr>
             <a:r>
-              <a:t>FEM, CFD and CAD are numerical evidence. No prototype has been built or tested.</a:t>
+              <a:t>Decision: retain the numerically checked model; do not select Gen5 as a 3U flight configuration.</a:t>
             </a:r>
           </a:p>
         </p:txBody>
@@ -10127,7 +10163,7 @@
               </a:defRPr>
             </a:pPr>
             <a:r>
-              <a:t>What this final review can defend</a:t>
+              <a:t>The research question has a completed answer</a:t>
             </a:r>
           </a:p>
         </p:txBody>
@@ -10310,7 +10346,7 @@
               </a:defRPr>
             </a:pPr>
             <a:r>
-              <a:t>•  Gen5 predicts commandable 16.0 m/s deployment for a 3U payload and a case-dependent orbital benefit.</a:t>
+              <a:t>•  The Gen5 system-level model predicts 16.0 m/s 3U release and a conditional orbital benefit.</a:t>
             </a:r>
           </a:p>
           <a:p>
@@ -10326,7 +10362,7 @@
               </a:defRPr>
             </a:pPr>
             <a:r>
-              <a:t>•  The modelled full system is 76% heavier per 3U customer than the spring comparator.</a:t>
+              <a:t>•  The complete modelled system is 76% heavier per 3U customer than the spring comparator.</a:t>
             </a:r>
           </a:p>
           <a:p>
@@ -10342,7 +10378,7 @@
               </a:defRPr>
             </a:pPr>
             <a:r>
-              <a:t>•  Numerical checks strengthen specific models, while hardware behavior and interfaces remain unmeasured.</a:t>
+              <a:t>•  Independent numerical checks corrected the baseline and defined the limits of its claims.</a:t>
             </a:r>
           </a:p>
           <a:p>
@@ -10358,7 +10394,7 @@
               </a:defRPr>
             </a:pPr>
             <a:r>
-              <a:t>•  Gen5 is a documented design study; the next configuration must earn a test-article decision.</a:t>
+              <a:t>•  Conclusion: the analytical objective is complete; Gen5 does not pass the 3U selection criterion.</a:t>
             </a:r>
           </a:p>
         </p:txBody>
@@ -13839,7 +13875,7 @@
               </a:defRPr>
             </a:pPr>
             <a:r>
-              <a:t>The deployment problem starts after rideshare reaches orbit</a:t>
+              <a:t>The thesis answers an orbital-delivery trade question</a:t>
             </a:r>
           </a:p>
         </p:txBody>
@@ -14491,7 +14527,7 @@
           <a:lstStyle/>
           <a:p>
             <a:pPr algn="ctr">
-              <a:defRPr sz="2200" b="1">
+              <a:defRPr sz="2100" b="1">
                 <a:solidFill>
                   <a:srgbClr val="0D2035"/>
                 </a:solidFill>
@@ -14499,7 +14535,7 @@
               </a:defRPr>
             </a:pPr>
             <a:r>
-              <a:t>Mission split: host = coarse orbital repositioning  •  deployer = each satellite's release condition</a:t>
+              <a:t>Study outcome: useful modelled orbital change, but an unfavourable 3U mass trade</a:t>
             </a:r>
           </a:p>
         </p:txBody>
@@ -16821,7 +16857,7 @@
               </a:defRPr>
             </a:pPr>
             <a:r>
-              <a:t>What was achieved, and what remains open</a:t>
+              <a:t>The analytical research objectives have outcomes</a:t>
             </a:r>
           </a:p>
         </p:txBody>
@@ -16929,7 +16965,7 @@
               </a:defRPr>
             </a:pPr>
             <a:r>
-              <a:t>Thesis manuscript and PLAN-R2; objectives synthesized for this presentation</a:t>
+              <a:t>Thesis manuscript, BASELINE.md and PROVENANCE.md; presentation synthesis</a:t>
             </a:r>
           </a:p>
         </p:txBody>
@@ -17044,7 +17080,7 @@
               </a:defRPr>
             </a:pPr>
             <a:r>
-              <a:t>Objective</a:t>
+              <a:t>Research objective</a:t>
             </a:r>
           </a:p>
         </p:txBody>
@@ -17123,7 +17159,7 @@
               </a:defRPr>
             </a:pPr>
             <a:r>
-              <a:t>Evidence at final review</a:t>
+              <a:t>Final thesis outcome</a:t>
             </a:r>
           </a:p>
         </p:txBody>
@@ -17204,7 +17240,7 @@
               </a:defRPr>
             </a:pPr>
             <a:r>
-              <a:t>Architecture for an unmodified 3U</a:t>
+              <a:t>Design a commandable 3U system</a:t>
             </a:r>
           </a:p>
         </p:txBody>
@@ -17285,7 +17321,7 @@
               </a:defRPr>
             </a:pPr>
             <a:r>
-              <a:t>Gen5 CAD/model; payload qualification open</a:t>
+              <a:t>Gen5 CAD and complete subsystem architecture documented</a:t>
             </a:r>
           </a:p>
         </p:txBody>
@@ -17366,7 +17402,7 @@
               </a:defRPr>
             </a:pPr>
             <a:r>
-              <a:t>Quantify shot and commanded speed</a:t>
+              <a:t>Calculate shot and control performance</a:t>
             </a:r>
           </a:p>
         </p:txBody>
@@ -17447,7 +17483,7 @@
               </a:defRPr>
             </a:pPr>
             <a:r>
-              <a:t>Shot/circuit/control simulations; no measured shot</a:t>
+              <a:t>Rated shot, power and dispersion models completed</a:t>
             </a:r>
           </a:p>
         </p:txBody>
@@ -17528,7 +17564,7 @@
               </a:defRPr>
             </a:pPr>
             <a:r>
-              <a:t>Quantify orbital utility</a:t>
+              <a:t>Evaluate orbital utility</a:t>
             </a:r>
           </a:p>
         </p:txBody>
@@ -17609,7 +17645,7 @@
               </a:defRPr>
             </a:pPr>
             <a:r>
-              <a:t>Modelled benefit and numerical cross-checks; atmospheric limits</a:t>
+              <a:t>Predicted energy and lifetime benefit for stated cases</a:t>
             </a:r>
           </a:p>
         </p:txBody>
@@ -17690,7 +17726,7 @@
               </a:defRPr>
             </a:pPr>
             <a:r>
-              <a:t>Compare full system burden</a:t>
+              <a:t>Count full installed burden</a:t>
             </a:r>
           </a:p>
         </p:txBody>
@@ -17771,7 +17807,7 @@
               </a:defRPr>
             </a:pPr>
             <a:r>
-              <a:t>Mass and alternatives analysed; 3U mass criterion fails</a:t>
+              <a:t>Mass rollup completed; 3U parity criterion failed</a:t>
             </a:r>
           </a:p>
         </p:txBody>
@@ -17852,7 +17888,7 @@
               </a:defRPr>
             </a:pPr>
             <a:r>
-              <a:t>Define next test path</a:t>
+              <a:t>Test credibility of key claims</a:t>
             </a:r>
           </a:p>
         </p:txBody>
@@ -17933,7 +17969,7 @@
               </a:defRPr>
             </a:pPr>
             <a:r>
-              <a:t>Gen6 gates set; mechanism and build release open</a:t>
+              <a:t>Numerical cross-checks and limits recorded</a:t>
             </a:r>
           </a:p>
         </p:txBody>
@@ -18075,7 +18111,7 @@
               </a:defRPr>
             </a:pPr>
             <a:r>
-              <a:t>Requirements → model → challenge → revise</a:t>
+              <a:t>A completed analysis chain from mission to decision</a:t>
             </a:r>
           </a:p>
         </p:txBody>
@@ -18988,7 +19024,7 @@
               </a:defRPr>
             </a:pPr>
             <a:r>
-              <a:t>Numerical cross-checks verify particular models. Experimental validation has not yet begun.</a:t>
+              <a:t>Models were challenged and revised; hardware performance remains outside this thesis's evidence.</a:t>
             </a:r>
           </a:p>
         </p:txBody>
@@ -19130,7 +19166,7 @@
               </a:defRPr>
             </a:pPr>
             <a:r>
-              <a:t>The models answer specific questions, with specific limits</a:t>
+              <a:t>Numerical checks strengthened the final baseline</a:t>
             </a:r>
           </a:p>
         </p:txBody>
@@ -21452,7 +21488,7 @@
               </a:defRPr>
             </a:pPr>
             <a:r>
-              <a:t>Sep 2026 →</a:t>
+              <a:t>Oct 2026</a:t>
             </a:r>
           </a:p>
         </p:txBody>
@@ -21488,7 +21524,7 @@
               </a:defRPr>
             </a:pPr>
             <a:r>
-              <a:t>Gen6 trade</a:t>
+              <a:t>Final review</a:t>
             </a:r>
           </a:p>
         </p:txBody>
@@ -21524,7 +21560,7 @@
               </a:defRPr>
             </a:pPr>
             <a:r>
-              <a:t>Mechanism choice and mission envelope reopened</a:t>
+              <a:t>Gen5 results, failed criterion and thesis record presented</a:t>
             </a:r>
           </a:p>
         </p:txBody>

</xml_diff>

<commit_message>
Publish self-contained Gen5 thesis and corrected review pack
</commit_message>
<xml_diff>
--- a/university/final_review_2026_10_10/VOLLEY_Final_Review_2026-10-10.pptx
+++ b/university/final_review_2026_10_10/VOLLEY_Final_Review_2026-10-10.pptx
@@ -3170,7 +3170,7 @@
           <a:noFill/>
         </p:spPr>
         <p:txBody>
-          <a:bodyPr wrap="square" lIns="54864" rIns="54864" tIns="54864" bIns="54864" anchor="t">
+          <a:bodyPr wrap="square" lIns="13716" rIns="13716" tIns="13716" bIns="13716" anchor="t">
             <a:spAutoFit/>
           </a:bodyPr>
           <a:lstStyle/>
@@ -3206,7 +3206,7 @@
           <a:noFill/>
         </p:spPr>
         <p:txBody>
-          <a:bodyPr wrap="square" lIns="54864" rIns="54864" tIns="54864" bIns="54864" anchor="t">
+          <a:bodyPr wrap="square" lIns="13716" rIns="13716" tIns="13716" bIns="13716" anchor="t">
             <a:spAutoFit/>
           </a:bodyPr>
           <a:lstStyle/>
@@ -3242,7 +3242,7 @@
           <a:noFill/>
         </p:spPr>
         <p:txBody>
-          <a:bodyPr wrap="square" lIns="54864" rIns="54864" tIns="54864" bIns="54864" anchor="t">
+          <a:bodyPr wrap="square" lIns="13716" rIns="13716" tIns="13716" bIns="13716" anchor="t">
             <a:spAutoFit/>
           </a:bodyPr>
           <a:lstStyle/>
@@ -3278,7 +3278,7 @@
           <a:noFill/>
         </p:spPr>
         <p:txBody>
-          <a:bodyPr wrap="square" lIns="54864" rIns="54864" tIns="54864" bIns="54864" anchor="t">
+          <a:bodyPr wrap="square" lIns="13716" rIns="13716" tIns="13716" bIns="13716" anchor="t">
             <a:spAutoFit/>
           </a:bodyPr>
           <a:lstStyle/>
@@ -3314,7 +3314,7 @@
           <a:noFill/>
         </p:spPr>
         <p:txBody>
-          <a:bodyPr wrap="square" lIns="54864" rIns="54864" tIns="54864" bIns="54864" anchor="t">
+          <a:bodyPr wrap="square" lIns="13716" rIns="13716" tIns="13716" bIns="13716" anchor="t">
             <a:spAutoFit/>
           </a:bodyPr>
           <a:lstStyle/>
@@ -3374,7 +3374,7 @@
           <a:noFill/>
         </p:spPr>
         <p:txBody>
-          <a:bodyPr wrap="square" lIns="54864" rIns="54864" tIns="54864" bIns="54864" anchor="t">
+          <a:bodyPr wrap="square" lIns="13716" rIns="13716" tIns="13716" bIns="13716" anchor="t">
             <a:spAutoFit/>
           </a:bodyPr>
           <a:lstStyle/>
@@ -3410,7 +3410,7 @@
           <a:noFill/>
         </p:spPr>
         <p:txBody>
-          <a:bodyPr wrap="square" lIns="54864" rIns="54864" tIns="54864" bIns="54864" anchor="t">
+          <a:bodyPr wrap="square" lIns="13716" rIns="13716" tIns="13716" bIns="13716" anchor="t">
             <a:spAutoFit/>
           </a:bodyPr>
           <a:lstStyle/>
@@ -3446,7 +3446,7 @@
           <a:noFill/>
         </p:spPr>
         <p:txBody>
-          <a:bodyPr wrap="square" lIns="54864" rIns="54864" tIns="54864" bIns="54864" anchor="t">
+          <a:bodyPr wrap="square" lIns="13716" rIns="13716" tIns="13716" bIns="13716" anchor="t">
             <a:spAutoFit/>
           </a:bodyPr>
           <a:lstStyle/>
@@ -3482,7 +3482,7 @@
           <a:noFill/>
         </p:spPr>
         <p:txBody>
-          <a:bodyPr wrap="square" lIns="54864" rIns="54864" tIns="54864" bIns="54864" anchor="t">
+          <a:bodyPr wrap="square" lIns="13716" rIns="13716" tIns="13716" bIns="13716" anchor="t">
             <a:spAutoFit/>
           </a:bodyPr>
           <a:lstStyle/>
@@ -3518,7 +3518,7 @@
           <a:noFill/>
         </p:spPr>
         <p:txBody>
-          <a:bodyPr wrap="square" lIns="54864" rIns="54864" tIns="54864" bIns="54864" anchor="t">
+          <a:bodyPr wrap="square" lIns="13716" rIns="13716" tIns="13716" bIns="13716" anchor="t">
             <a:spAutoFit/>
           </a:bodyPr>
           <a:lstStyle/>
@@ -3554,7 +3554,7 @@
           <a:noFill/>
         </p:spPr>
         <p:txBody>
-          <a:bodyPr wrap="square" lIns="54864" rIns="54864" tIns="54864" bIns="54864" anchor="t">
+          <a:bodyPr wrap="square" lIns="13716" rIns="13716" tIns="13716" bIns="13716" anchor="t">
             <a:spAutoFit/>
           </a:bodyPr>
           <a:lstStyle/>
@@ -3590,7 +3590,7 @@
           <a:noFill/>
         </p:spPr>
         <p:txBody>
-          <a:bodyPr wrap="square" lIns="54864" rIns="54864" tIns="54864" bIns="54864" anchor="t">
+          <a:bodyPr wrap="square" lIns="13716" rIns="13716" tIns="13716" bIns="13716" anchor="t">
             <a:spAutoFit/>
           </a:bodyPr>
           <a:lstStyle/>
@@ -3732,7 +3732,7 @@
           <a:noFill/>
         </p:spPr>
         <p:txBody>
-          <a:bodyPr wrap="square" lIns="54864" rIns="54864" tIns="54864" bIns="54864" anchor="t">
+          <a:bodyPr wrap="square" lIns="13716" rIns="13716" tIns="13716" bIns="13716" anchor="t">
             <a:spAutoFit/>
           </a:bodyPr>
           <a:lstStyle/>
@@ -3768,7 +3768,7 @@
           <a:noFill/>
         </p:spPr>
         <p:txBody>
-          <a:bodyPr wrap="square" lIns="54864" rIns="54864" tIns="54864" bIns="54864" anchor="t">
+          <a:bodyPr wrap="square" lIns="13716" rIns="13716" tIns="13716" bIns="13716" anchor="t">
             <a:spAutoFit/>
           </a:bodyPr>
           <a:lstStyle/>
@@ -3804,7 +3804,7 @@
           <a:noFill/>
         </p:spPr>
         <p:txBody>
-          <a:bodyPr wrap="square" lIns="54864" rIns="54864" tIns="54864" bIns="54864" anchor="t">
+          <a:bodyPr wrap="square" lIns="13716" rIns="13716" tIns="13716" bIns="13716" anchor="t">
             <a:spAutoFit/>
           </a:bodyPr>
           <a:lstStyle/>
@@ -3840,7 +3840,7 @@
           <a:noFill/>
         </p:spPr>
         <p:txBody>
-          <a:bodyPr wrap="square" lIns="54864" rIns="54864" tIns="54864" bIns="54864" anchor="t">
+          <a:bodyPr wrap="square" lIns="13716" rIns="13716" tIns="13716" bIns="13716" anchor="t">
             <a:spAutoFit/>
           </a:bodyPr>
           <a:lstStyle/>
@@ -3876,7 +3876,7 @@
           <a:noFill/>
         </p:spPr>
         <p:txBody>
-          <a:bodyPr wrap="square" lIns="54864" rIns="54864" tIns="54864" bIns="54864" anchor="t">
+          <a:bodyPr wrap="square" lIns="13716" rIns="13716" tIns="13716" bIns="13716" anchor="t">
             <a:spAutoFit/>
           </a:bodyPr>
           <a:lstStyle/>
@@ -3955,7 +3955,7 @@
           <a:noFill/>
         </p:spPr>
         <p:txBody>
-          <a:bodyPr wrap="square" lIns="54864" rIns="54864" tIns="54864" bIns="54864" anchor="t">
+          <a:bodyPr wrap="square" lIns="13716" rIns="13716" tIns="13716" bIns="13716" anchor="t">
             <a:spAutoFit/>
           </a:bodyPr>
           <a:lstStyle/>
@@ -4034,7 +4034,7 @@
           <a:noFill/>
         </p:spPr>
         <p:txBody>
-          <a:bodyPr wrap="square" lIns="54864" rIns="54864" tIns="54864" bIns="54864" anchor="t">
+          <a:bodyPr wrap="square" lIns="13716" rIns="13716" tIns="13716" bIns="13716" anchor="t">
             <a:spAutoFit/>
           </a:bodyPr>
           <a:lstStyle/>
@@ -4113,7 +4113,7 @@
           <a:noFill/>
         </p:spPr>
         <p:txBody>
-          <a:bodyPr wrap="square" lIns="54864" rIns="54864" tIns="54864" bIns="54864" anchor="t">
+          <a:bodyPr wrap="square" lIns="13716" rIns="13716" tIns="13716" bIns="13716" anchor="t">
             <a:spAutoFit/>
           </a:bodyPr>
           <a:lstStyle/>
@@ -4192,7 +4192,7 @@
           <a:noFill/>
         </p:spPr>
         <p:txBody>
-          <a:bodyPr wrap="square" lIns="54864" rIns="54864" tIns="54864" bIns="54864" anchor="t">
+          <a:bodyPr wrap="square" lIns="13716" rIns="13716" tIns="13716" bIns="13716" anchor="t">
             <a:spAutoFit/>
           </a:bodyPr>
           <a:lstStyle/>
@@ -4271,7 +4271,7 @@
           <a:noFill/>
         </p:spPr>
         <p:txBody>
-          <a:bodyPr wrap="square" lIns="54864" rIns="54864" tIns="54864" bIns="54864" anchor="t">
+          <a:bodyPr wrap="square" lIns="13716" rIns="13716" tIns="13716" bIns="13716" anchor="t">
             <a:spAutoFit/>
           </a:bodyPr>
           <a:lstStyle/>
@@ -4350,7 +4350,7 @@
           <a:noFill/>
         </p:spPr>
         <p:txBody>
-          <a:bodyPr wrap="square" lIns="54864" rIns="54864" tIns="54864" bIns="54864" anchor="t">
+          <a:bodyPr wrap="square" lIns="13716" rIns="13716" tIns="13716" bIns="13716" anchor="t">
             <a:spAutoFit/>
           </a:bodyPr>
           <a:lstStyle/>
@@ -4429,7 +4429,7 @@
           <a:noFill/>
         </p:spPr>
         <p:txBody>
-          <a:bodyPr wrap="square" lIns="54864" rIns="54864" tIns="54864" bIns="54864" anchor="t">
+          <a:bodyPr wrap="square" lIns="13716" rIns="13716" tIns="13716" bIns="13716" anchor="t">
             <a:spAutoFit/>
           </a:bodyPr>
           <a:lstStyle/>
@@ -4508,7 +4508,7 @@
           <a:noFill/>
         </p:spPr>
         <p:txBody>
-          <a:bodyPr wrap="square" lIns="54864" rIns="54864" tIns="54864" bIns="54864" anchor="t">
+          <a:bodyPr wrap="square" lIns="13716" rIns="13716" tIns="13716" bIns="13716" anchor="t">
             <a:spAutoFit/>
           </a:bodyPr>
           <a:lstStyle/>
@@ -4587,7 +4587,7 @@
           <a:noFill/>
         </p:spPr>
         <p:txBody>
-          <a:bodyPr wrap="square" lIns="54864" rIns="54864" tIns="54864" bIns="54864" anchor="t">
+          <a:bodyPr wrap="square" lIns="13716" rIns="13716" tIns="13716" bIns="13716" anchor="t">
             <a:spAutoFit/>
           </a:bodyPr>
           <a:lstStyle/>
@@ -4666,7 +4666,7 @@
           <a:noFill/>
         </p:spPr>
         <p:txBody>
-          <a:bodyPr wrap="square" lIns="54864" rIns="54864" tIns="54864" bIns="54864" anchor="t">
+          <a:bodyPr wrap="square" lIns="13716" rIns="13716" tIns="13716" bIns="13716" anchor="t">
             <a:spAutoFit/>
           </a:bodyPr>
           <a:lstStyle/>
@@ -4808,7 +4808,7 @@
           <a:noFill/>
         </p:spPr>
         <p:txBody>
-          <a:bodyPr wrap="square" lIns="54864" rIns="54864" tIns="54864" bIns="54864" anchor="t">
+          <a:bodyPr wrap="square" lIns="13716" rIns="13716" tIns="13716" bIns="13716" anchor="t">
             <a:spAutoFit/>
           </a:bodyPr>
           <a:lstStyle/>
@@ -4844,7 +4844,7 @@
           <a:noFill/>
         </p:spPr>
         <p:txBody>
-          <a:bodyPr wrap="square" lIns="54864" rIns="54864" tIns="54864" bIns="54864" anchor="t">
+          <a:bodyPr wrap="square" lIns="13716" rIns="13716" tIns="13716" bIns="13716" anchor="t">
             <a:spAutoFit/>
           </a:bodyPr>
           <a:lstStyle/>
@@ -4880,7 +4880,7 @@
           <a:noFill/>
         </p:spPr>
         <p:txBody>
-          <a:bodyPr wrap="square" lIns="54864" rIns="54864" tIns="54864" bIns="54864" anchor="t">
+          <a:bodyPr wrap="square" lIns="13716" rIns="13716" tIns="13716" bIns="13716" anchor="t">
             <a:spAutoFit/>
           </a:bodyPr>
           <a:lstStyle/>
@@ -4916,7 +4916,7 @@
           <a:noFill/>
         </p:spPr>
         <p:txBody>
-          <a:bodyPr wrap="square" lIns="54864" rIns="54864" tIns="54864" bIns="54864" anchor="t">
+          <a:bodyPr wrap="square" lIns="13716" rIns="13716" tIns="13716" bIns="13716" anchor="t">
             <a:spAutoFit/>
           </a:bodyPr>
           <a:lstStyle/>
@@ -4952,7 +4952,7 @@
           <a:noFill/>
         </p:spPr>
         <p:txBody>
-          <a:bodyPr wrap="square" lIns="54864" rIns="54864" tIns="54864" bIns="54864" anchor="t">
+          <a:bodyPr wrap="square" lIns="13716" rIns="13716" tIns="13716" bIns="13716" anchor="t">
             <a:spAutoFit/>
           </a:bodyPr>
           <a:lstStyle/>
@@ -5076,7 +5076,7 @@
           <a:noFill/>
         </p:spPr>
         <p:txBody>
-          <a:bodyPr wrap="square" lIns="54864" rIns="54864" tIns="54864" bIns="54864" anchor="t">
+          <a:bodyPr wrap="square" lIns="13716" rIns="13716" tIns="13716" bIns="13716" anchor="t">
             <a:spAutoFit/>
           </a:bodyPr>
           <a:lstStyle/>
@@ -5112,7 +5112,7 @@
           <a:noFill/>
         </p:spPr>
         <p:txBody>
-          <a:bodyPr wrap="square" lIns="54864" rIns="54864" tIns="54864" bIns="54864" anchor="t">
+          <a:bodyPr wrap="square" lIns="13716" rIns="13716" tIns="13716" bIns="13716" anchor="t">
             <a:spAutoFit/>
           </a:bodyPr>
           <a:lstStyle/>
@@ -5236,7 +5236,7 @@
           <a:noFill/>
         </p:spPr>
         <p:txBody>
-          <a:bodyPr wrap="square" lIns="54864" rIns="54864" tIns="54864" bIns="54864" anchor="t">
+          <a:bodyPr wrap="square" lIns="13716" rIns="13716" tIns="13716" bIns="13716" anchor="t">
             <a:spAutoFit/>
           </a:bodyPr>
           <a:lstStyle/>
@@ -5272,7 +5272,7 @@
           <a:noFill/>
         </p:spPr>
         <p:txBody>
-          <a:bodyPr wrap="square" lIns="54864" rIns="54864" tIns="54864" bIns="54864" anchor="t">
+          <a:bodyPr wrap="square" lIns="13716" rIns="13716" tIns="13716" bIns="13716" anchor="t">
             <a:spAutoFit/>
           </a:bodyPr>
           <a:lstStyle/>
@@ -5396,7 +5396,7 @@
           <a:noFill/>
         </p:spPr>
         <p:txBody>
-          <a:bodyPr wrap="square" lIns="54864" rIns="54864" tIns="54864" bIns="54864" anchor="t">
+          <a:bodyPr wrap="square" lIns="13716" rIns="13716" tIns="13716" bIns="13716" anchor="t">
             <a:spAutoFit/>
           </a:bodyPr>
           <a:lstStyle/>
@@ -5432,7 +5432,7 @@
           <a:noFill/>
         </p:spPr>
         <p:txBody>
-          <a:bodyPr wrap="square" lIns="54864" rIns="54864" tIns="54864" bIns="54864" anchor="t">
+          <a:bodyPr wrap="square" lIns="13716" rIns="13716" tIns="13716" bIns="13716" anchor="t">
             <a:spAutoFit/>
           </a:bodyPr>
           <a:lstStyle/>
@@ -5468,7 +5468,7 @@
           <a:noFill/>
         </p:spPr>
         <p:txBody>
-          <a:bodyPr wrap="square" lIns="54864" rIns="54864" tIns="54864" bIns="54864" anchor="t">
+          <a:bodyPr wrap="square" lIns="13716" rIns="13716" tIns="13716" bIns="13716" anchor="t">
             <a:spAutoFit/>
           </a:bodyPr>
           <a:lstStyle/>
@@ -5610,7 +5610,7 @@
           <a:noFill/>
         </p:spPr>
         <p:txBody>
-          <a:bodyPr wrap="square" lIns="54864" rIns="54864" tIns="54864" bIns="54864" anchor="t">
+          <a:bodyPr wrap="square" lIns="13716" rIns="13716" tIns="13716" bIns="13716" anchor="t">
             <a:spAutoFit/>
           </a:bodyPr>
           <a:lstStyle/>
@@ -5646,7 +5646,7 @@
           <a:noFill/>
         </p:spPr>
         <p:txBody>
-          <a:bodyPr wrap="square" lIns="54864" rIns="54864" tIns="54864" bIns="54864" anchor="t">
+          <a:bodyPr wrap="square" lIns="13716" rIns="13716" tIns="13716" bIns="13716" anchor="t">
             <a:spAutoFit/>
           </a:bodyPr>
           <a:lstStyle/>
@@ -5682,7 +5682,7 @@
           <a:noFill/>
         </p:spPr>
         <p:txBody>
-          <a:bodyPr wrap="square" lIns="54864" rIns="54864" tIns="54864" bIns="54864" anchor="t">
+          <a:bodyPr wrap="square" lIns="13716" rIns="13716" tIns="13716" bIns="13716" anchor="t">
             <a:spAutoFit/>
           </a:bodyPr>
           <a:lstStyle/>
@@ -5718,7 +5718,7 @@
           <a:noFill/>
         </p:spPr>
         <p:txBody>
-          <a:bodyPr wrap="square" lIns="54864" rIns="54864" tIns="54864" bIns="54864" anchor="t">
+          <a:bodyPr wrap="square" lIns="13716" rIns="13716" tIns="13716" bIns="13716" anchor="t">
             <a:spAutoFit/>
           </a:bodyPr>
           <a:lstStyle/>
@@ -5754,7 +5754,7 @@
           <a:noFill/>
         </p:spPr>
         <p:txBody>
-          <a:bodyPr wrap="square" lIns="54864" rIns="54864" tIns="54864" bIns="54864" anchor="t">
+          <a:bodyPr wrap="square" lIns="13716" rIns="13716" tIns="13716" bIns="13716" anchor="t">
             <a:spAutoFit/>
           </a:bodyPr>
           <a:lstStyle/>
@@ -6007,7 +6007,7 @@
           <a:noFill/>
         </p:spPr>
         <p:txBody>
-          <a:bodyPr wrap="square" lIns="54864" rIns="54864" tIns="54864" bIns="54864" anchor="t">
+          <a:bodyPr wrap="square" lIns="13716" rIns="13716" tIns="13716" bIns="13716" anchor="t">
             <a:spAutoFit/>
           </a:bodyPr>
           <a:lstStyle/>
@@ -6043,7 +6043,7 @@
           <a:noFill/>
         </p:spPr>
         <p:txBody>
-          <a:bodyPr wrap="square" lIns="54864" rIns="54864" tIns="54864" bIns="54864" anchor="t">
+          <a:bodyPr wrap="square" lIns="13716" rIns="13716" tIns="13716" bIns="13716" anchor="t">
             <a:spAutoFit/>
           </a:bodyPr>
           <a:lstStyle/>
@@ -6079,7 +6079,7 @@
           <a:noFill/>
         </p:spPr>
         <p:txBody>
-          <a:bodyPr wrap="square" lIns="54864" rIns="54864" tIns="54864" bIns="54864" anchor="t">
+          <a:bodyPr wrap="square" lIns="13716" rIns="13716" tIns="13716" bIns="13716" anchor="t">
             <a:spAutoFit/>
           </a:bodyPr>
           <a:lstStyle/>
@@ -6115,7 +6115,7 @@
           <a:noFill/>
         </p:spPr>
         <p:txBody>
-          <a:bodyPr wrap="square" lIns="54864" rIns="54864" tIns="54864" bIns="54864" anchor="t">
+          <a:bodyPr wrap="square" lIns="13716" rIns="13716" tIns="13716" bIns="13716" anchor="t">
             <a:spAutoFit/>
           </a:bodyPr>
           <a:lstStyle/>
@@ -6151,7 +6151,7 @@
           <a:noFill/>
         </p:spPr>
         <p:txBody>
-          <a:bodyPr wrap="square" lIns="54864" rIns="54864" tIns="54864" bIns="54864" anchor="t">
+          <a:bodyPr wrap="square" lIns="13716" rIns="13716" tIns="13716" bIns="13716" anchor="t">
             <a:spAutoFit/>
           </a:bodyPr>
           <a:lstStyle/>
@@ -6254,7 +6254,7 @@
           <a:noFill/>
         </p:spPr>
         <p:txBody>
-          <a:bodyPr wrap="square" lIns="54864" rIns="54864" tIns="54864" bIns="54864" anchor="t">
+          <a:bodyPr wrap="square" lIns="13716" rIns="13716" tIns="13716" bIns="13716" anchor="t">
             <a:spAutoFit/>
           </a:bodyPr>
           <a:lstStyle/>
@@ -6290,7 +6290,7 @@
           <a:noFill/>
         </p:spPr>
         <p:txBody>
-          <a:bodyPr wrap="square" lIns="54864" rIns="54864" tIns="54864" bIns="54864" anchor="t">
+          <a:bodyPr wrap="square" lIns="13716" rIns="13716" tIns="13716" bIns="13716" anchor="t">
             <a:spAutoFit/>
           </a:bodyPr>
           <a:lstStyle/>
@@ -6369,7 +6369,7 @@
           <a:noFill/>
         </p:spPr>
         <p:txBody>
-          <a:bodyPr wrap="square" lIns="54864" rIns="54864" tIns="54864" bIns="54864" anchor="t">
+          <a:bodyPr wrap="square" lIns="13716" rIns="13716" tIns="13716" bIns="13716" anchor="t">
             <a:spAutoFit/>
           </a:bodyPr>
           <a:lstStyle/>
@@ -6405,7 +6405,7 @@
           <a:noFill/>
         </p:spPr>
         <p:txBody>
-          <a:bodyPr wrap="square" lIns="54864" rIns="54864" tIns="54864" bIns="54864" anchor="t">
+          <a:bodyPr wrap="square" lIns="13716" rIns="13716" tIns="13716" bIns="13716" anchor="t">
             <a:spAutoFit/>
           </a:bodyPr>
           <a:lstStyle/>
@@ -6484,7 +6484,7 @@
           <a:noFill/>
         </p:spPr>
         <p:txBody>
-          <a:bodyPr wrap="square" lIns="54864" rIns="54864" tIns="54864" bIns="54864" anchor="t">
+          <a:bodyPr wrap="square" lIns="13716" rIns="13716" tIns="13716" bIns="13716" anchor="t">
             <a:spAutoFit/>
           </a:bodyPr>
           <a:lstStyle/>
@@ -6520,7 +6520,7 @@
           <a:noFill/>
         </p:spPr>
         <p:txBody>
-          <a:bodyPr wrap="square" lIns="54864" rIns="54864" tIns="54864" bIns="54864" anchor="t">
+          <a:bodyPr wrap="square" lIns="13716" rIns="13716" tIns="13716" bIns="13716" anchor="t">
             <a:spAutoFit/>
           </a:bodyPr>
           <a:lstStyle/>
@@ -6599,7 +6599,7 @@
           <a:noFill/>
         </p:spPr>
         <p:txBody>
-          <a:bodyPr wrap="square" lIns="54864" rIns="54864" tIns="54864" bIns="54864" anchor="t">
+          <a:bodyPr wrap="square" lIns="13716" rIns="13716" tIns="13716" bIns="13716" anchor="t">
             <a:spAutoFit/>
           </a:bodyPr>
           <a:lstStyle/>
@@ -6635,7 +6635,7 @@
           <a:noFill/>
         </p:spPr>
         <p:txBody>
-          <a:bodyPr wrap="square" lIns="54864" rIns="54864" tIns="54864" bIns="54864" anchor="t">
+          <a:bodyPr wrap="square" lIns="13716" rIns="13716" tIns="13716" bIns="13716" anchor="t">
             <a:spAutoFit/>
           </a:bodyPr>
           <a:lstStyle/>
@@ -6777,7 +6777,7 @@
           <a:noFill/>
         </p:spPr>
         <p:txBody>
-          <a:bodyPr wrap="square" lIns="54864" rIns="54864" tIns="54864" bIns="54864" anchor="t">
+          <a:bodyPr wrap="square" lIns="13716" rIns="13716" tIns="13716" bIns="13716" anchor="t">
             <a:spAutoFit/>
           </a:bodyPr>
           <a:lstStyle/>
@@ -6813,7 +6813,7 @@
           <a:noFill/>
         </p:spPr>
         <p:txBody>
-          <a:bodyPr wrap="square" lIns="54864" rIns="54864" tIns="54864" bIns="54864" anchor="t">
+          <a:bodyPr wrap="square" lIns="13716" rIns="13716" tIns="13716" bIns="13716" anchor="t">
             <a:spAutoFit/>
           </a:bodyPr>
           <a:lstStyle/>
@@ -6849,7 +6849,7 @@
           <a:noFill/>
         </p:spPr>
         <p:txBody>
-          <a:bodyPr wrap="square" lIns="54864" rIns="54864" tIns="54864" bIns="54864" anchor="t">
+          <a:bodyPr wrap="square" lIns="13716" rIns="13716" tIns="13716" bIns="13716" anchor="t">
             <a:spAutoFit/>
           </a:bodyPr>
           <a:lstStyle/>
@@ -6885,7 +6885,7 @@
           <a:noFill/>
         </p:spPr>
         <p:txBody>
-          <a:bodyPr wrap="square" lIns="54864" rIns="54864" tIns="54864" bIns="54864" anchor="t">
+          <a:bodyPr wrap="square" lIns="13716" rIns="13716" tIns="13716" bIns="13716" anchor="t">
             <a:spAutoFit/>
           </a:bodyPr>
           <a:lstStyle/>
@@ -6921,7 +6921,7 @@
           <a:noFill/>
         </p:spPr>
         <p:txBody>
-          <a:bodyPr wrap="square" lIns="54864" rIns="54864" tIns="54864" bIns="54864" anchor="t">
+          <a:bodyPr wrap="square" lIns="13716" rIns="13716" tIns="13716" bIns="13716" anchor="t">
             <a:spAutoFit/>
           </a:bodyPr>
           <a:lstStyle/>
@@ -7069,7 +7069,7 @@
           <a:noFill/>
         </p:spPr>
         <p:txBody>
-          <a:bodyPr wrap="square" lIns="54864" rIns="54864" tIns="54864" bIns="54864" anchor="t">
+          <a:bodyPr wrap="square" lIns="13716" rIns="13716" tIns="13716" bIns="13716" anchor="t">
             <a:spAutoFit/>
           </a:bodyPr>
           <a:lstStyle/>
@@ -7105,7 +7105,7 @@
           <a:noFill/>
         </p:spPr>
         <p:txBody>
-          <a:bodyPr wrap="square" lIns="54864" rIns="54864" tIns="54864" bIns="54864" anchor="t">
+          <a:bodyPr wrap="square" lIns="13716" rIns="13716" tIns="13716" bIns="13716" anchor="t">
             <a:spAutoFit/>
           </a:bodyPr>
           <a:lstStyle/>
@@ -7229,7 +7229,7 @@
           <a:noFill/>
         </p:spPr>
         <p:txBody>
-          <a:bodyPr wrap="square" lIns="54864" rIns="54864" tIns="54864" bIns="54864" anchor="t">
+          <a:bodyPr wrap="square" lIns="13716" rIns="13716" tIns="13716" bIns="13716" anchor="t">
             <a:spAutoFit/>
           </a:bodyPr>
           <a:lstStyle/>
@@ -7265,7 +7265,7 @@
           <a:noFill/>
         </p:spPr>
         <p:txBody>
-          <a:bodyPr wrap="square" lIns="54864" rIns="54864" tIns="54864" bIns="54864" anchor="t">
+          <a:bodyPr wrap="square" lIns="13716" rIns="13716" tIns="13716" bIns="13716" anchor="t">
             <a:spAutoFit/>
           </a:bodyPr>
           <a:lstStyle/>
@@ -7407,7 +7407,7 @@
           <a:noFill/>
         </p:spPr>
         <p:txBody>
-          <a:bodyPr wrap="square" lIns="54864" rIns="54864" tIns="54864" bIns="54864" anchor="t">
+          <a:bodyPr wrap="square" lIns="13716" rIns="13716" tIns="13716" bIns="13716" anchor="t">
             <a:spAutoFit/>
           </a:bodyPr>
           <a:lstStyle/>
@@ -7443,7 +7443,7 @@
           <a:noFill/>
         </p:spPr>
         <p:txBody>
-          <a:bodyPr wrap="square" lIns="54864" rIns="54864" tIns="54864" bIns="54864" anchor="t">
+          <a:bodyPr wrap="square" lIns="13716" rIns="13716" tIns="13716" bIns="13716" anchor="t">
             <a:spAutoFit/>
           </a:bodyPr>
           <a:lstStyle/>
@@ -7479,7 +7479,7 @@
           <a:noFill/>
         </p:spPr>
         <p:txBody>
-          <a:bodyPr wrap="square" lIns="54864" rIns="54864" tIns="54864" bIns="54864" anchor="t">
+          <a:bodyPr wrap="square" lIns="13716" rIns="13716" tIns="13716" bIns="13716" anchor="t">
             <a:spAutoFit/>
           </a:bodyPr>
           <a:lstStyle/>
@@ -7515,7 +7515,7 @@
           <a:noFill/>
         </p:spPr>
         <p:txBody>
-          <a:bodyPr wrap="square" lIns="54864" rIns="54864" tIns="54864" bIns="54864" anchor="t">
+          <a:bodyPr wrap="square" lIns="13716" rIns="13716" tIns="13716" bIns="13716" anchor="t">
             <a:spAutoFit/>
           </a:bodyPr>
           <a:lstStyle/>
@@ -7551,7 +7551,7 @@
           <a:noFill/>
         </p:spPr>
         <p:txBody>
-          <a:bodyPr wrap="square" lIns="54864" rIns="54864" tIns="54864" bIns="54864" anchor="t">
+          <a:bodyPr wrap="square" lIns="13716" rIns="13716" tIns="13716" bIns="13716" anchor="t">
             <a:spAutoFit/>
           </a:bodyPr>
           <a:lstStyle/>
@@ -7699,7 +7699,7 @@
           <a:noFill/>
         </p:spPr>
         <p:txBody>
-          <a:bodyPr wrap="square" lIns="54864" rIns="54864" tIns="54864" bIns="54864" anchor="t">
+          <a:bodyPr wrap="square" lIns="13716" rIns="13716" tIns="13716" bIns="13716" anchor="t">
             <a:spAutoFit/>
           </a:bodyPr>
           <a:lstStyle/>
@@ -7735,7 +7735,7 @@
           <a:noFill/>
         </p:spPr>
         <p:txBody>
-          <a:bodyPr wrap="square" lIns="54864" rIns="54864" tIns="54864" bIns="54864" anchor="t">
+          <a:bodyPr wrap="square" lIns="13716" rIns="13716" tIns="13716" bIns="13716" anchor="t">
             <a:spAutoFit/>
           </a:bodyPr>
           <a:lstStyle/>
@@ -7859,7 +7859,7 @@
           <a:noFill/>
         </p:spPr>
         <p:txBody>
-          <a:bodyPr wrap="square" lIns="54864" rIns="54864" tIns="54864" bIns="54864" anchor="t">
+          <a:bodyPr wrap="square" lIns="13716" rIns="13716" tIns="13716" bIns="13716" anchor="t">
             <a:spAutoFit/>
           </a:bodyPr>
           <a:lstStyle/>
@@ -7895,7 +7895,7 @@
           <a:noFill/>
         </p:spPr>
         <p:txBody>
-          <a:bodyPr wrap="square" lIns="54864" rIns="54864" tIns="54864" bIns="54864" anchor="t">
+          <a:bodyPr wrap="square" lIns="13716" rIns="13716" tIns="13716" bIns="13716" anchor="t">
             <a:spAutoFit/>
           </a:bodyPr>
           <a:lstStyle/>
@@ -7931,7 +7931,7 @@
           <a:noFill/>
         </p:spPr>
         <p:txBody>
-          <a:bodyPr wrap="square" lIns="54864" rIns="54864" tIns="54864" bIns="54864" anchor="t">
+          <a:bodyPr wrap="square" lIns="13716" rIns="13716" tIns="13716" bIns="13716" anchor="t">
             <a:spAutoFit/>
           </a:bodyPr>
           <a:lstStyle/>
@@ -7945,7 +7945,7 @@
               </a:defRPr>
             </a:pPr>
             <a:r>
-              <a:t>Timing alone can create in-track phase; this result concerns orbital energy.</a:t>
+              <a:t>Persistent phasing requires a relative state change; this result concerns orbital energy.</a:t>
             </a:r>
           </a:p>
         </p:txBody>
@@ -8073,7 +8073,7 @@
           <a:noFill/>
         </p:spPr>
         <p:txBody>
-          <a:bodyPr wrap="square" lIns="54864" rIns="54864" tIns="54864" bIns="54864" anchor="t">
+          <a:bodyPr wrap="square" lIns="13716" rIns="13716" tIns="13716" bIns="13716" anchor="t">
             <a:spAutoFit/>
           </a:bodyPr>
           <a:lstStyle/>
@@ -8109,7 +8109,7 @@
           <a:noFill/>
         </p:spPr>
         <p:txBody>
-          <a:bodyPr wrap="square" lIns="54864" rIns="54864" tIns="54864" bIns="54864" anchor="t">
+          <a:bodyPr wrap="square" lIns="13716" rIns="13716" tIns="13716" bIns="13716" anchor="t">
             <a:spAutoFit/>
           </a:bodyPr>
           <a:lstStyle/>
@@ -8145,7 +8145,7 @@
           <a:noFill/>
         </p:spPr>
         <p:txBody>
-          <a:bodyPr wrap="square" lIns="54864" rIns="54864" tIns="54864" bIns="54864" anchor="t">
+          <a:bodyPr wrap="square" lIns="13716" rIns="13716" tIns="13716" bIns="13716" anchor="t">
             <a:spAutoFit/>
           </a:bodyPr>
           <a:lstStyle/>
@@ -8181,7 +8181,7 @@
           <a:noFill/>
         </p:spPr>
         <p:txBody>
-          <a:bodyPr wrap="square" lIns="54864" rIns="54864" tIns="54864" bIns="54864" anchor="t">
+          <a:bodyPr wrap="square" lIns="13716" rIns="13716" tIns="13716" bIns="13716" anchor="t">
             <a:spAutoFit/>
           </a:bodyPr>
           <a:lstStyle/>
@@ -8217,7 +8217,7 @@
           <a:noFill/>
         </p:spPr>
         <p:txBody>
-          <a:bodyPr wrap="square" lIns="54864" rIns="54864" tIns="54864" bIns="54864" anchor="t">
+          <a:bodyPr wrap="square" lIns="13716" rIns="13716" tIns="13716" bIns="13716" anchor="t">
             <a:spAutoFit/>
           </a:bodyPr>
           <a:lstStyle/>
@@ -8253,7 +8253,7 @@
           <a:noFill/>
         </p:spPr>
         <p:txBody>
-          <a:bodyPr wrap="square" lIns="54864" rIns="54864" tIns="54864" bIns="54864" anchor="t">
+          <a:bodyPr wrap="square" lIns="13716" rIns="13716" tIns="13716" bIns="13716" anchor="t">
             <a:spAutoFit/>
           </a:bodyPr>
           <a:lstStyle/>
@@ -8332,7 +8332,7 @@
           <a:noFill/>
         </p:spPr>
         <p:txBody>
-          <a:bodyPr wrap="square" lIns="54864" rIns="54864" tIns="54864" bIns="54864" anchor="t">
+          <a:bodyPr wrap="square" lIns="13716" rIns="13716" tIns="13716" bIns="13716" anchor="t">
             <a:spAutoFit/>
           </a:bodyPr>
           <a:lstStyle/>
@@ -8368,7 +8368,7 @@
           <a:noFill/>
         </p:spPr>
         <p:txBody>
-          <a:bodyPr wrap="square" lIns="54864" rIns="54864" tIns="54864" bIns="54864" anchor="t">
+          <a:bodyPr wrap="square" lIns="13716" rIns="13716" tIns="13716" bIns="13716" anchor="t">
             <a:spAutoFit/>
           </a:bodyPr>
           <a:lstStyle/>
@@ -8447,7 +8447,7 @@
           <a:noFill/>
         </p:spPr>
         <p:txBody>
-          <a:bodyPr wrap="square" lIns="54864" rIns="54864" tIns="54864" bIns="54864" anchor="t">
+          <a:bodyPr wrap="square" lIns="13716" rIns="13716" tIns="13716" bIns="13716" anchor="t">
             <a:spAutoFit/>
           </a:bodyPr>
           <a:lstStyle/>
@@ -8483,7 +8483,7 @@
           <a:noFill/>
         </p:spPr>
         <p:txBody>
-          <a:bodyPr wrap="square" lIns="54864" rIns="54864" tIns="54864" bIns="54864" anchor="t">
+          <a:bodyPr wrap="square" lIns="13716" rIns="13716" tIns="13716" bIns="13716" anchor="t">
             <a:spAutoFit/>
           </a:bodyPr>
           <a:lstStyle/>
@@ -8562,7 +8562,7 @@
           <a:noFill/>
         </p:spPr>
         <p:txBody>
-          <a:bodyPr wrap="square" lIns="54864" rIns="54864" tIns="54864" bIns="54864" anchor="t">
+          <a:bodyPr wrap="square" lIns="13716" rIns="13716" tIns="13716" bIns="13716" anchor="t">
             <a:spAutoFit/>
           </a:bodyPr>
           <a:lstStyle/>
@@ -8641,7 +8641,7 @@
           <a:noFill/>
         </p:spPr>
         <p:txBody>
-          <a:bodyPr wrap="square" lIns="54864" rIns="54864" tIns="54864" bIns="54864" anchor="t">
+          <a:bodyPr wrap="square" lIns="13716" rIns="13716" tIns="13716" bIns="13716" anchor="t">
             <a:spAutoFit/>
           </a:bodyPr>
           <a:lstStyle/>
@@ -8783,7 +8783,7 @@
           <a:noFill/>
         </p:spPr>
         <p:txBody>
-          <a:bodyPr wrap="square" lIns="54864" rIns="54864" tIns="54864" bIns="54864" anchor="t">
+          <a:bodyPr wrap="square" lIns="13716" rIns="13716" tIns="13716" bIns="13716" anchor="t">
             <a:spAutoFit/>
           </a:bodyPr>
           <a:lstStyle/>
@@ -8819,7 +8819,7 @@
           <a:noFill/>
         </p:spPr>
         <p:txBody>
-          <a:bodyPr wrap="square" lIns="54864" rIns="54864" tIns="54864" bIns="54864" anchor="t">
+          <a:bodyPr wrap="square" lIns="13716" rIns="13716" tIns="13716" bIns="13716" anchor="t">
             <a:spAutoFit/>
           </a:bodyPr>
           <a:lstStyle/>
@@ -8855,7 +8855,7 @@
           <a:noFill/>
         </p:spPr>
         <p:txBody>
-          <a:bodyPr wrap="square" lIns="54864" rIns="54864" tIns="54864" bIns="54864" anchor="t">
+          <a:bodyPr wrap="square" lIns="13716" rIns="13716" tIns="13716" bIns="13716" anchor="t">
             <a:spAutoFit/>
           </a:bodyPr>
           <a:lstStyle/>
@@ -8891,7 +8891,7 @@
           <a:noFill/>
         </p:spPr>
         <p:txBody>
-          <a:bodyPr wrap="square" lIns="54864" rIns="54864" tIns="54864" bIns="54864" anchor="t">
+          <a:bodyPr wrap="square" lIns="13716" rIns="13716" tIns="13716" bIns="13716" anchor="t">
             <a:spAutoFit/>
           </a:bodyPr>
           <a:lstStyle/>
@@ -8927,7 +8927,7 @@
           <a:noFill/>
         </p:spPr>
         <p:txBody>
-          <a:bodyPr wrap="square" lIns="54864" rIns="54864" tIns="54864" bIns="54864" anchor="t">
+          <a:bodyPr wrap="square" lIns="13716" rIns="13716" tIns="13716" bIns="13716" anchor="t">
             <a:spAutoFit/>
           </a:bodyPr>
           <a:lstStyle/>
@@ -9051,7 +9051,7 @@
           <a:noFill/>
         </p:spPr>
         <p:txBody>
-          <a:bodyPr wrap="square" lIns="54864" rIns="54864" tIns="54864" bIns="54864" anchor="t">
+          <a:bodyPr wrap="square" lIns="13716" rIns="13716" tIns="13716" bIns="13716" anchor="t">
             <a:spAutoFit/>
           </a:bodyPr>
           <a:lstStyle/>
@@ -9087,7 +9087,7 @@
           <a:noFill/>
         </p:spPr>
         <p:txBody>
-          <a:bodyPr wrap="square" lIns="54864" rIns="54864" tIns="54864" bIns="54864" anchor="t">
+          <a:bodyPr wrap="square" lIns="13716" rIns="13716" tIns="13716" bIns="13716" anchor="t">
             <a:spAutoFit/>
           </a:bodyPr>
           <a:lstStyle/>
@@ -9211,7 +9211,7 @@
           <a:noFill/>
         </p:spPr>
         <p:txBody>
-          <a:bodyPr wrap="square" lIns="54864" rIns="54864" tIns="54864" bIns="54864" anchor="t">
+          <a:bodyPr wrap="square" lIns="13716" rIns="13716" tIns="13716" bIns="13716" anchor="t">
             <a:spAutoFit/>
           </a:bodyPr>
           <a:lstStyle/>
@@ -9247,7 +9247,7 @@
           <a:noFill/>
         </p:spPr>
         <p:txBody>
-          <a:bodyPr wrap="square" lIns="54864" rIns="54864" tIns="54864" bIns="54864" anchor="t">
+          <a:bodyPr wrap="square" lIns="13716" rIns="13716" tIns="13716" bIns="13716" anchor="t">
             <a:spAutoFit/>
           </a:bodyPr>
           <a:lstStyle/>
@@ -9371,7 +9371,7 @@
           <a:noFill/>
         </p:spPr>
         <p:txBody>
-          <a:bodyPr wrap="square" lIns="54864" rIns="54864" tIns="54864" bIns="54864" anchor="t">
+          <a:bodyPr wrap="square" lIns="13716" rIns="13716" tIns="13716" bIns="13716" anchor="t">
             <a:spAutoFit/>
           </a:bodyPr>
           <a:lstStyle/>
@@ -9407,7 +9407,7 @@
           <a:noFill/>
         </p:spPr>
         <p:txBody>
-          <a:bodyPr wrap="square" lIns="54864" rIns="54864" tIns="54864" bIns="54864" anchor="t">
+          <a:bodyPr wrap="square" lIns="13716" rIns="13716" tIns="13716" bIns="13716" anchor="t">
             <a:spAutoFit/>
           </a:bodyPr>
           <a:lstStyle/>
@@ -9443,7 +9443,7 @@
           <a:noFill/>
         </p:spPr>
         <p:txBody>
-          <a:bodyPr wrap="square" lIns="54864" rIns="54864" tIns="54864" bIns="54864" anchor="t">
+          <a:bodyPr wrap="square" lIns="13716" rIns="13716" tIns="13716" bIns="13716" anchor="t">
             <a:spAutoFit/>
           </a:bodyPr>
           <a:lstStyle/>
@@ -9585,7 +9585,7 @@
           <a:noFill/>
         </p:spPr>
         <p:txBody>
-          <a:bodyPr wrap="square" lIns="54864" rIns="54864" tIns="54864" bIns="54864" anchor="t">
+          <a:bodyPr wrap="square" lIns="13716" rIns="13716" tIns="13716" bIns="13716" anchor="t">
             <a:spAutoFit/>
           </a:bodyPr>
           <a:lstStyle/>
@@ -9621,7 +9621,7 @@
           <a:noFill/>
         </p:spPr>
         <p:txBody>
-          <a:bodyPr wrap="square" lIns="54864" rIns="54864" tIns="54864" bIns="54864" anchor="t">
+          <a:bodyPr wrap="square" lIns="13716" rIns="13716" tIns="13716" bIns="13716" anchor="t">
             <a:spAutoFit/>
           </a:bodyPr>
           <a:lstStyle/>
@@ -9657,7 +9657,7 @@
           <a:noFill/>
         </p:spPr>
         <p:txBody>
-          <a:bodyPr wrap="square" lIns="54864" rIns="54864" tIns="54864" bIns="54864" anchor="t">
+          <a:bodyPr wrap="square" lIns="13716" rIns="13716" tIns="13716" bIns="13716" anchor="t">
             <a:spAutoFit/>
           </a:bodyPr>
           <a:lstStyle/>
@@ -9693,7 +9693,7 @@
           <a:noFill/>
         </p:spPr>
         <p:txBody>
-          <a:bodyPr wrap="square" lIns="54864" rIns="54864" tIns="54864" bIns="54864" anchor="t">
+          <a:bodyPr wrap="square" lIns="13716" rIns="13716" tIns="13716" bIns="13716" anchor="t">
             <a:spAutoFit/>
           </a:bodyPr>
           <a:lstStyle/>
@@ -9729,7 +9729,7 @@
           <a:noFill/>
         </p:spPr>
         <p:txBody>
-          <a:bodyPr wrap="square" lIns="54864" rIns="54864" tIns="54864" bIns="54864" anchor="t">
+          <a:bodyPr wrap="square" lIns="13716" rIns="13716" tIns="13716" bIns="13716" anchor="t">
             <a:spAutoFit/>
           </a:bodyPr>
           <a:lstStyle/>
@@ -9851,7 +9851,7 @@
           <a:noFill/>
         </p:spPr>
         <p:txBody>
-          <a:bodyPr wrap="square" lIns="54864" rIns="54864" tIns="54864" bIns="54864" anchor="t">
+          <a:bodyPr wrap="square" lIns="13716" rIns="13716" tIns="13716" bIns="13716" anchor="t">
             <a:spAutoFit/>
           </a:bodyPr>
           <a:lstStyle/>
@@ -9887,7 +9887,7 @@
           <a:noFill/>
         </p:spPr>
         <p:txBody>
-          <a:bodyPr wrap="square" lIns="54864" rIns="54864" tIns="54864" bIns="54864" anchor="t">
+          <a:bodyPr wrap="square" lIns="13716" rIns="13716" tIns="13716" bIns="13716" anchor="t">
             <a:spAutoFit/>
           </a:bodyPr>
           <a:lstStyle/>
@@ -9971,7 +9971,7 @@
           <a:noFill/>
         </p:spPr>
         <p:txBody>
-          <a:bodyPr wrap="square" lIns="54864" rIns="54864" tIns="54864" bIns="54864" anchor="t">
+          <a:bodyPr wrap="square" lIns="13716" rIns="13716" tIns="13716" bIns="13716" anchor="t">
             <a:spAutoFit/>
           </a:bodyPr>
           <a:lstStyle/>
@@ -10007,7 +10007,7 @@
           <a:noFill/>
         </p:spPr>
         <p:txBody>
-          <a:bodyPr wrap="square" lIns="54864" rIns="54864" tIns="54864" bIns="54864" anchor="t">
+          <a:bodyPr wrap="square" lIns="13716" rIns="13716" tIns="13716" bIns="13716" anchor="t">
             <a:spAutoFit/>
           </a:bodyPr>
           <a:lstStyle/>
@@ -10149,7 +10149,7 @@
           <a:noFill/>
         </p:spPr>
         <p:txBody>
-          <a:bodyPr wrap="square" lIns="54864" rIns="54864" tIns="54864" bIns="54864" anchor="t">
+          <a:bodyPr wrap="square" lIns="13716" rIns="13716" tIns="13716" bIns="13716" anchor="t">
             <a:spAutoFit/>
           </a:bodyPr>
           <a:lstStyle/>
@@ -10185,7 +10185,7 @@
           <a:noFill/>
         </p:spPr>
         <p:txBody>
-          <a:bodyPr wrap="square" lIns="54864" rIns="54864" tIns="54864" bIns="54864" anchor="t">
+          <a:bodyPr wrap="square" lIns="13716" rIns="13716" tIns="13716" bIns="13716" anchor="t">
             <a:spAutoFit/>
           </a:bodyPr>
           <a:lstStyle/>
@@ -10221,7 +10221,7 @@
           <a:noFill/>
         </p:spPr>
         <p:txBody>
-          <a:bodyPr wrap="square" lIns="54864" rIns="54864" tIns="54864" bIns="54864" anchor="t">
+          <a:bodyPr wrap="square" lIns="13716" rIns="13716" tIns="13716" bIns="13716" anchor="t">
             <a:spAutoFit/>
           </a:bodyPr>
           <a:lstStyle/>
@@ -10257,7 +10257,7 @@
           <a:noFill/>
         </p:spPr>
         <p:txBody>
-          <a:bodyPr wrap="square" lIns="54864" rIns="54864" tIns="54864" bIns="54864" anchor="t">
+          <a:bodyPr wrap="square" lIns="13716" rIns="13716" tIns="13716" bIns="13716" anchor="t">
             <a:spAutoFit/>
           </a:bodyPr>
           <a:lstStyle/>
@@ -10293,7 +10293,7 @@
           <a:noFill/>
         </p:spPr>
         <p:txBody>
-          <a:bodyPr wrap="square" lIns="54864" rIns="54864" tIns="54864" bIns="54864" anchor="t">
+          <a:bodyPr wrap="square" lIns="13716" rIns="13716" tIns="13716" bIns="13716" anchor="t">
             <a:spAutoFit/>
           </a:bodyPr>
           <a:lstStyle/>
@@ -10522,7 +10522,7 @@
           <a:noFill/>
         </p:spPr>
         <p:txBody>
-          <a:bodyPr wrap="square" lIns="54864" rIns="54864" tIns="54864" bIns="54864" anchor="t">
+          <a:bodyPr wrap="square" lIns="13716" rIns="13716" tIns="13716" bIns="13716" anchor="t">
             <a:spAutoFit/>
           </a:bodyPr>
           <a:lstStyle/>
@@ -10558,7 +10558,7 @@
           <a:noFill/>
         </p:spPr>
         <p:txBody>
-          <a:bodyPr wrap="square" lIns="54864" rIns="54864" tIns="54864" bIns="54864" anchor="t">
+          <a:bodyPr wrap="square" lIns="13716" rIns="13716" tIns="13716" bIns="13716" anchor="t">
             <a:spAutoFit/>
           </a:bodyPr>
           <a:lstStyle/>
@@ -10594,7 +10594,7 @@
           <a:noFill/>
         </p:spPr>
         <p:txBody>
-          <a:bodyPr wrap="square" lIns="54864" rIns="54864" tIns="54864" bIns="54864" anchor="t">
+          <a:bodyPr wrap="square" lIns="13716" rIns="13716" tIns="13716" bIns="13716" anchor="t">
             <a:spAutoFit/>
           </a:bodyPr>
           <a:lstStyle/>
@@ -10630,7 +10630,7 @@
           <a:noFill/>
         </p:spPr>
         <p:txBody>
-          <a:bodyPr wrap="square" lIns="54864" rIns="54864" tIns="54864" bIns="54864" anchor="t">
+          <a:bodyPr wrap="square" lIns="13716" rIns="13716" tIns="13716" bIns="13716" anchor="t">
             <a:spAutoFit/>
           </a:bodyPr>
           <a:lstStyle/>
@@ -10666,7 +10666,7 @@
           <a:noFill/>
         </p:spPr>
         <p:txBody>
-          <a:bodyPr wrap="square" lIns="54864" rIns="54864" tIns="54864" bIns="54864" anchor="t">
+          <a:bodyPr wrap="square" lIns="13716" rIns="13716" tIns="13716" bIns="13716" anchor="t">
             <a:spAutoFit/>
           </a:bodyPr>
           <a:lstStyle/>
@@ -10745,7 +10745,7 @@
           <a:noFill/>
         </p:spPr>
         <p:txBody>
-          <a:bodyPr wrap="square" lIns="54864" rIns="54864" tIns="54864" bIns="54864" anchor="t">
+          <a:bodyPr wrap="square" lIns="13716" rIns="13716" tIns="13716" bIns="13716" anchor="t">
             <a:spAutoFit/>
           </a:bodyPr>
           <a:lstStyle/>
@@ -10824,7 +10824,7 @@
           <a:noFill/>
         </p:spPr>
         <p:txBody>
-          <a:bodyPr wrap="square" lIns="54864" rIns="54864" tIns="54864" bIns="54864" anchor="t">
+          <a:bodyPr wrap="square" lIns="13716" rIns="13716" tIns="13716" bIns="13716" anchor="t">
             <a:spAutoFit/>
           </a:bodyPr>
           <a:lstStyle/>
@@ -10903,7 +10903,7 @@
           <a:noFill/>
         </p:spPr>
         <p:txBody>
-          <a:bodyPr wrap="square" lIns="54864" rIns="54864" tIns="54864" bIns="54864" anchor="t">
+          <a:bodyPr wrap="square" lIns="13716" rIns="13716" tIns="13716" bIns="13716" anchor="t">
             <a:spAutoFit/>
           </a:bodyPr>
           <a:lstStyle/>
@@ -10982,7 +10982,7 @@
           <a:noFill/>
         </p:spPr>
         <p:txBody>
-          <a:bodyPr wrap="square" lIns="54864" rIns="54864" tIns="54864" bIns="54864" anchor="t">
+          <a:bodyPr wrap="square" lIns="13716" rIns="13716" tIns="13716" bIns="13716" anchor="t">
             <a:spAutoFit/>
           </a:bodyPr>
           <a:lstStyle/>
@@ -11061,7 +11061,7 @@
           <a:noFill/>
         </p:spPr>
         <p:txBody>
-          <a:bodyPr wrap="square" lIns="54864" rIns="54864" tIns="54864" bIns="54864" anchor="t">
+          <a:bodyPr wrap="square" lIns="13716" rIns="13716" tIns="13716" bIns="13716" anchor="t">
             <a:spAutoFit/>
           </a:bodyPr>
           <a:lstStyle/>
@@ -11140,7 +11140,7 @@
           <a:noFill/>
         </p:spPr>
         <p:txBody>
-          <a:bodyPr wrap="square" lIns="54864" rIns="54864" tIns="54864" bIns="54864" anchor="t">
+          <a:bodyPr wrap="square" lIns="13716" rIns="13716" tIns="13716" bIns="13716" anchor="t">
             <a:spAutoFit/>
           </a:bodyPr>
           <a:lstStyle/>
@@ -11219,7 +11219,7 @@
           <a:noFill/>
         </p:spPr>
         <p:txBody>
-          <a:bodyPr wrap="square" lIns="54864" rIns="54864" tIns="54864" bIns="54864" anchor="t">
+          <a:bodyPr wrap="square" lIns="13716" rIns="13716" tIns="13716" bIns="13716" anchor="t">
             <a:spAutoFit/>
           </a:bodyPr>
           <a:lstStyle/>
@@ -11298,7 +11298,7 @@
           <a:noFill/>
         </p:spPr>
         <p:txBody>
-          <a:bodyPr wrap="square" lIns="54864" rIns="54864" tIns="54864" bIns="54864" anchor="t">
+          <a:bodyPr wrap="square" lIns="13716" rIns="13716" tIns="13716" bIns="13716" anchor="t">
             <a:spAutoFit/>
           </a:bodyPr>
           <a:lstStyle/>
@@ -11377,7 +11377,7 @@
           <a:noFill/>
         </p:spPr>
         <p:txBody>
-          <a:bodyPr wrap="square" lIns="54864" rIns="54864" tIns="54864" bIns="54864" anchor="t">
+          <a:bodyPr wrap="square" lIns="13716" rIns="13716" tIns="13716" bIns="13716" anchor="t">
             <a:spAutoFit/>
           </a:bodyPr>
           <a:lstStyle/>
@@ -11456,7 +11456,7 @@
           <a:noFill/>
         </p:spPr>
         <p:txBody>
-          <a:bodyPr wrap="square" lIns="54864" rIns="54864" tIns="54864" bIns="54864" anchor="t">
+          <a:bodyPr wrap="square" lIns="13716" rIns="13716" tIns="13716" bIns="13716" anchor="t">
             <a:spAutoFit/>
           </a:bodyPr>
           <a:lstStyle/>
@@ -11535,7 +11535,7 @@
           <a:noFill/>
         </p:spPr>
         <p:txBody>
-          <a:bodyPr wrap="square" lIns="54864" rIns="54864" tIns="54864" bIns="54864" anchor="t">
+          <a:bodyPr wrap="square" lIns="13716" rIns="13716" tIns="13716" bIns="13716" anchor="t">
             <a:spAutoFit/>
           </a:bodyPr>
           <a:lstStyle/>
@@ -11677,7 +11677,7 @@
           <a:noFill/>
         </p:spPr>
         <p:txBody>
-          <a:bodyPr wrap="square" lIns="54864" rIns="54864" tIns="54864" bIns="54864" anchor="t">
+          <a:bodyPr wrap="square" lIns="13716" rIns="13716" tIns="13716" bIns="13716" anchor="t">
             <a:spAutoFit/>
           </a:bodyPr>
           <a:lstStyle/>
@@ -11713,7 +11713,7 @@
           <a:noFill/>
         </p:spPr>
         <p:txBody>
-          <a:bodyPr wrap="square" lIns="54864" rIns="54864" tIns="54864" bIns="54864" anchor="t">
+          <a:bodyPr wrap="square" lIns="13716" rIns="13716" tIns="13716" bIns="13716" anchor="t">
             <a:spAutoFit/>
           </a:bodyPr>
           <a:lstStyle/>
@@ -11749,7 +11749,7 @@
           <a:noFill/>
         </p:spPr>
         <p:txBody>
-          <a:bodyPr wrap="square" lIns="54864" rIns="54864" tIns="54864" bIns="54864" anchor="t">
+          <a:bodyPr wrap="square" lIns="13716" rIns="13716" tIns="13716" bIns="13716" anchor="t">
             <a:spAutoFit/>
           </a:bodyPr>
           <a:lstStyle/>
@@ -11785,7 +11785,7 @@
           <a:noFill/>
         </p:spPr>
         <p:txBody>
-          <a:bodyPr wrap="square" lIns="54864" rIns="54864" tIns="54864" bIns="54864" anchor="t">
+          <a:bodyPr wrap="square" lIns="13716" rIns="13716" tIns="13716" bIns="13716" anchor="t">
             <a:spAutoFit/>
           </a:bodyPr>
           <a:lstStyle/>
@@ -11821,7 +11821,7 @@
           <a:noFill/>
         </p:spPr>
         <p:txBody>
-          <a:bodyPr wrap="square" lIns="54864" rIns="54864" tIns="54864" bIns="54864" anchor="t">
+          <a:bodyPr wrap="square" lIns="13716" rIns="13716" tIns="13716" bIns="13716" anchor="t">
             <a:spAutoFit/>
           </a:bodyPr>
           <a:lstStyle/>
@@ -11900,7 +11900,7 @@
           <a:noFill/>
         </p:spPr>
         <p:txBody>
-          <a:bodyPr wrap="square" lIns="54864" rIns="54864" tIns="54864" bIns="54864" anchor="t">
+          <a:bodyPr wrap="square" lIns="13716" rIns="13716" tIns="13716" bIns="13716" anchor="t">
             <a:spAutoFit/>
           </a:bodyPr>
           <a:lstStyle/>
@@ -11914,7 +11914,7 @@
               </a:defRPr>
             </a:pPr>
             <a:r>
-              <a:t>One reusable path • sequential supported CubeSat sizes • individually commanded release</a:t>
+              <a:t>One shared path • sequential feed • commanded release for each CubeSat</a:t>
             </a:r>
           </a:p>
         </p:txBody>
@@ -12007,7 +12007,7 @@
           <a:noFill/>
         </p:spPr>
         <p:txBody>
-          <a:bodyPr wrap="square" lIns="54864" rIns="54864" tIns="54864" bIns="54864" anchor="t">
+          <a:bodyPr wrap="square" lIns="13716" rIns="13716" tIns="13716" bIns="13716" anchor="t">
             <a:spAutoFit/>
           </a:bodyPr>
           <a:lstStyle/>
@@ -12149,7 +12149,7 @@
           <a:noFill/>
         </p:spPr>
         <p:txBody>
-          <a:bodyPr wrap="square" lIns="54864" rIns="54864" tIns="54864" bIns="54864" anchor="t">
+          <a:bodyPr wrap="square" lIns="13716" rIns="13716" tIns="13716" bIns="13716" anchor="t">
             <a:spAutoFit/>
           </a:bodyPr>
           <a:lstStyle/>
@@ -12185,7 +12185,7 @@
           <a:noFill/>
         </p:spPr>
         <p:txBody>
-          <a:bodyPr wrap="square" lIns="54864" rIns="54864" tIns="54864" bIns="54864" anchor="t">
+          <a:bodyPr wrap="square" lIns="13716" rIns="13716" tIns="13716" bIns="13716" anchor="t">
             <a:spAutoFit/>
           </a:bodyPr>
           <a:lstStyle/>
@@ -12221,7 +12221,7 @@
           <a:noFill/>
         </p:spPr>
         <p:txBody>
-          <a:bodyPr wrap="square" lIns="54864" rIns="54864" tIns="54864" bIns="54864" anchor="t">
+          <a:bodyPr wrap="square" lIns="13716" rIns="13716" tIns="13716" bIns="13716" anchor="t">
             <a:spAutoFit/>
           </a:bodyPr>
           <a:lstStyle/>
@@ -12257,7 +12257,7 @@
           <a:noFill/>
         </p:spPr>
         <p:txBody>
-          <a:bodyPr wrap="square" lIns="54864" rIns="54864" tIns="54864" bIns="54864" anchor="t">
+          <a:bodyPr wrap="square" lIns="13716" rIns="13716" tIns="13716" bIns="13716" anchor="t">
             <a:spAutoFit/>
           </a:bodyPr>
           <a:lstStyle/>
@@ -12293,7 +12293,7 @@
           <a:noFill/>
         </p:spPr>
         <p:txBody>
-          <a:bodyPr wrap="square" lIns="54864" rIns="54864" tIns="54864" bIns="54864" anchor="t">
+          <a:bodyPr wrap="square" lIns="13716" rIns="13716" tIns="13716" bIns="13716" anchor="t">
             <a:spAutoFit/>
           </a:bodyPr>
           <a:lstStyle/>
@@ -12372,7 +12372,7 @@
           <a:noFill/>
         </p:spPr>
         <p:txBody>
-          <a:bodyPr wrap="square" lIns="54864" rIns="54864" tIns="54864" bIns="54864" anchor="t">
+          <a:bodyPr wrap="square" lIns="13716" rIns="13716" tIns="13716" bIns="13716" anchor="t">
             <a:spAutoFit/>
           </a:bodyPr>
           <a:lstStyle/>
@@ -12451,7 +12451,7 @@
           <a:noFill/>
         </p:spPr>
         <p:txBody>
-          <a:bodyPr wrap="square" lIns="54864" rIns="54864" tIns="54864" bIns="54864" anchor="t">
+          <a:bodyPr wrap="square" lIns="13716" rIns="13716" tIns="13716" bIns="13716" anchor="t">
             <a:spAutoFit/>
           </a:bodyPr>
           <a:lstStyle/>
@@ -12530,7 +12530,7 @@
           <a:noFill/>
         </p:spPr>
         <p:txBody>
-          <a:bodyPr wrap="square" lIns="54864" rIns="54864" tIns="54864" bIns="54864" anchor="t">
+          <a:bodyPr wrap="square" lIns="13716" rIns="13716" tIns="13716" bIns="13716" anchor="t">
             <a:spAutoFit/>
           </a:bodyPr>
           <a:lstStyle/>
@@ -12609,7 +12609,7 @@
           <a:noFill/>
         </p:spPr>
         <p:txBody>
-          <a:bodyPr wrap="square" lIns="54864" rIns="54864" tIns="54864" bIns="54864" anchor="t">
+          <a:bodyPr wrap="square" lIns="13716" rIns="13716" tIns="13716" bIns="13716" anchor="t">
             <a:spAutoFit/>
           </a:bodyPr>
           <a:lstStyle/>
@@ -12688,7 +12688,7 @@
           <a:noFill/>
         </p:spPr>
         <p:txBody>
-          <a:bodyPr wrap="square" lIns="54864" rIns="54864" tIns="54864" bIns="54864" anchor="t">
+          <a:bodyPr wrap="square" lIns="13716" rIns="13716" tIns="13716" bIns="13716" anchor="t">
             <a:spAutoFit/>
           </a:bodyPr>
           <a:lstStyle/>
@@ -12767,7 +12767,7 @@
           <a:noFill/>
         </p:spPr>
         <p:txBody>
-          <a:bodyPr wrap="square" lIns="54864" rIns="54864" tIns="54864" bIns="54864" anchor="t">
+          <a:bodyPr wrap="square" lIns="13716" rIns="13716" tIns="13716" bIns="13716" anchor="t">
             <a:spAutoFit/>
           </a:bodyPr>
           <a:lstStyle/>
@@ -12846,7 +12846,7 @@
           <a:noFill/>
         </p:spPr>
         <p:txBody>
-          <a:bodyPr wrap="square" lIns="54864" rIns="54864" tIns="54864" bIns="54864" anchor="t">
+          <a:bodyPr wrap="square" lIns="13716" rIns="13716" tIns="13716" bIns="13716" anchor="t">
             <a:spAutoFit/>
           </a:bodyPr>
           <a:lstStyle/>
@@ -12925,7 +12925,7 @@
           <a:noFill/>
         </p:spPr>
         <p:txBody>
-          <a:bodyPr wrap="square" lIns="54864" rIns="54864" tIns="54864" bIns="54864" anchor="t">
+          <a:bodyPr wrap="square" lIns="13716" rIns="13716" tIns="13716" bIns="13716" anchor="t">
             <a:spAutoFit/>
           </a:bodyPr>
           <a:lstStyle/>
@@ -13067,7 +13067,7 @@
           <a:noFill/>
         </p:spPr>
         <p:txBody>
-          <a:bodyPr wrap="square" lIns="54864" rIns="54864" tIns="54864" bIns="54864" anchor="t">
+          <a:bodyPr wrap="square" lIns="13716" rIns="13716" tIns="13716" bIns="13716" anchor="t">
             <a:spAutoFit/>
           </a:bodyPr>
           <a:lstStyle/>
@@ -13103,7 +13103,7 @@
           <a:noFill/>
         </p:spPr>
         <p:txBody>
-          <a:bodyPr wrap="square" lIns="54864" rIns="54864" tIns="54864" bIns="54864" anchor="t">
+          <a:bodyPr wrap="square" lIns="13716" rIns="13716" tIns="13716" bIns="13716" anchor="t">
             <a:spAutoFit/>
           </a:bodyPr>
           <a:lstStyle/>
@@ -13139,7 +13139,7 @@
           <a:noFill/>
         </p:spPr>
         <p:txBody>
-          <a:bodyPr wrap="square" lIns="54864" rIns="54864" tIns="54864" bIns="54864" anchor="t">
+          <a:bodyPr wrap="square" lIns="13716" rIns="13716" tIns="13716" bIns="13716" anchor="t">
             <a:spAutoFit/>
           </a:bodyPr>
           <a:lstStyle/>
@@ -13175,7 +13175,7 @@
           <a:noFill/>
         </p:spPr>
         <p:txBody>
-          <a:bodyPr wrap="square" lIns="54864" rIns="54864" tIns="54864" bIns="54864" anchor="t">
+          <a:bodyPr wrap="square" lIns="13716" rIns="13716" tIns="13716" bIns="13716" anchor="t">
             <a:spAutoFit/>
           </a:bodyPr>
           <a:lstStyle/>
@@ -13211,7 +13211,7 @@
           <a:noFill/>
         </p:spPr>
         <p:txBody>
-          <a:bodyPr wrap="square" lIns="54864" rIns="54864" tIns="54864" bIns="54864" anchor="t">
+          <a:bodyPr wrap="square" lIns="13716" rIns="13716" tIns="13716" bIns="13716" anchor="t">
             <a:spAutoFit/>
           </a:bodyPr>
           <a:lstStyle/>
@@ -13456,7 +13456,7 @@
           <a:noFill/>
         </p:spPr>
         <p:txBody>
-          <a:bodyPr wrap="square" lIns="54864" rIns="54864" tIns="54864" bIns="54864" anchor="t">
+          <a:bodyPr wrap="square" lIns="13716" rIns="13716" tIns="13716" bIns="13716" anchor="t">
             <a:spAutoFit/>
           </a:bodyPr>
           <a:lstStyle/>
@@ -13492,7 +13492,7 @@
           <a:noFill/>
         </p:spPr>
         <p:txBody>
-          <a:bodyPr wrap="square" lIns="54864" rIns="54864" tIns="54864" bIns="54864" anchor="t">
+          <a:bodyPr wrap="square" lIns="13716" rIns="13716" tIns="13716" bIns="13716" anchor="t">
             <a:spAutoFit/>
           </a:bodyPr>
           <a:lstStyle/>
@@ -13528,7 +13528,7 @@
           <a:noFill/>
         </p:spPr>
         <p:txBody>
-          <a:bodyPr wrap="square" lIns="54864" rIns="54864" tIns="54864" bIns="54864" anchor="t">
+          <a:bodyPr wrap="square" lIns="13716" rIns="13716" tIns="13716" bIns="13716" anchor="t">
             <a:spAutoFit/>
           </a:bodyPr>
           <a:lstStyle/>
@@ -13564,7 +13564,7 @@
           <a:noFill/>
         </p:spPr>
         <p:txBody>
-          <a:bodyPr wrap="square" lIns="54864" rIns="54864" tIns="54864" bIns="54864" anchor="t">
+          <a:bodyPr wrap="square" lIns="13716" rIns="13716" tIns="13716" bIns="13716" anchor="t">
             <a:spAutoFit/>
           </a:bodyPr>
           <a:lstStyle/>
@@ -13600,7 +13600,7 @@
           <a:noFill/>
         </p:spPr>
         <p:txBody>
-          <a:bodyPr wrap="square" lIns="54864" rIns="54864" tIns="54864" bIns="54864" anchor="t">
+          <a:bodyPr wrap="square" lIns="13716" rIns="13716" tIns="13716" bIns="13716" anchor="t">
             <a:spAutoFit/>
           </a:bodyPr>
           <a:lstStyle/>
@@ -13861,7 +13861,7 @@
           <a:noFill/>
         </p:spPr>
         <p:txBody>
-          <a:bodyPr wrap="square" lIns="54864" rIns="54864" tIns="54864" bIns="54864" anchor="t">
+          <a:bodyPr wrap="square" lIns="13716" rIns="13716" tIns="13716" bIns="13716" anchor="t">
             <a:spAutoFit/>
           </a:bodyPr>
           <a:lstStyle/>
@@ -13897,7 +13897,7 @@
           <a:noFill/>
         </p:spPr>
         <p:txBody>
-          <a:bodyPr wrap="square" lIns="54864" rIns="54864" tIns="54864" bIns="54864" anchor="t">
+          <a:bodyPr wrap="square" lIns="13716" rIns="13716" tIns="13716" bIns="13716" anchor="t">
             <a:spAutoFit/>
           </a:bodyPr>
           <a:lstStyle/>
@@ -13933,7 +13933,7 @@
           <a:noFill/>
         </p:spPr>
         <p:txBody>
-          <a:bodyPr wrap="square" lIns="54864" rIns="54864" tIns="54864" bIns="54864" anchor="t">
+          <a:bodyPr wrap="square" lIns="13716" rIns="13716" tIns="13716" bIns="13716" anchor="t">
             <a:spAutoFit/>
           </a:bodyPr>
           <a:lstStyle/>
@@ -13969,7 +13969,7 @@
           <a:noFill/>
         </p:spPr>
         <p:txBody>
-          <a:bodyPr wrap="square" lIns="54864" rIns="54864" tIns="54864" bIns="54864" anchor="t">
+          <a:bodyPr wrap="square" lIns="13716" rIns="13716" tIns="13716" bIns="13716" anchor="t">
             <a:spAutoFit/>
           </a:bodyPr>
           <a:lstStyle/>
@@ -14005,7 +14005,7 @@
           <a:noFill/>
         </p:spPr>
         <p:txBody>
-          <a:bodyPr wrap="square" lIns="54864" rIns="54864" tIns="54864" bIns="54864" anchor="t">
+          <a:bodyPr wrap="square" lIns="13716" rIns="13716" tIns="13716" bIns="13716" anchor="t">
             <a:spAutoFit/>
           </a:bodyPr>
           <a:lstStyle/>
@@ -14129,7 +14129,7 @@
           <a:noFill/>
         </p:spPr>
         <p:txBody>
-          <a:bodyPr wrap="square" lIns="54864" rIns="54864" tIns="54864" bIns="54864" anchor="t">
+          <a:bodyPr wrap="square" lIns="13716" rIns="13716" tIns="13716" bIns="13716" anchor="t">
             <a:spAutoFit/>
           </a:bodyPr>
           <a:lstStyle/>
@@ -14165,7 +14165,7 @@
           <a:noFill/>
         </p:spPr>
         <p:txBody>
-          <a:bodyPr wrap="square" lIns="54864" rIns="54864" tIns="54864" bIns="54864" anchor="t">
+          <a:bodyPr wrap="square" lIns="13716" rIns="13716" tIns="13716" bIns="13716" anchor="t">
             <a:spAutoFit/>
           </a:bodyPr>
           <a:lstStyle/>
@@ -14289,7 +14289,7 @@
           <a:noFill/>
         </p:spPr>
         <p:txBody>
-          <a:bodyPr wrap="square" lIns="54864" rIns="54864" tIns="54864" bIns="54864" anchor="t">
+          <a:bodyPr wrap="square" lIns="13716" rIns="13716" tIns="13716" bIns="13716" anchor="t">
             <a:spAutoFit/>
           </a:bodyPr>
           <a:lstStyle/>
@@ -14325,7 +14325,7 @@
           <a:noFill/>
         </p:spPr>
         <p:txBody>
-          <a:bodyPr wrap="square" lIns="54864" rIns="54864" tIns="54864" bIns="54864" anchor="t">
+          <a:bodyPr wrap="square" lIns="13716" rIns="13716" tIns="13716" bIns="13716" anchor="t">
             <a:spAutoFit/>
           </a:bodyPr>
           <a:lstStyle/>
@@ -14339,7 +14339,7 @@
               </a:defRPr>
             </a:pPr>
             <a:r>
-              <a:t>Spring deployers separate payloads at about 1–2 m/s; release timing helps in-track phasing.</a:t>
+              <a:t>Spring deployers provide a small relative impulse. Subsequent orbit or drag differences can produce phasing.</a:t>
             </a:r>
           </a:p>
         </p:txBody>
@@ -14449,7 +14449,7 @@
           <a:noFill/>
         </p:spPr>
         <p:txBody>
-          <a:bodyPr wrap="square" lIns="54864" rIns="54864" tIns="54864" bIns="54864" anchor="t">
+          <a:bodyPr wrap="square" lIns="13716" rIns="13716" tIns="13716" bIns="13716" anchor="t">
             <a:spAutoFit/>
           </a:bodyPr>
           <a:lstStyle/>
@@ -14485,7 +14485,7 @@
           <a:noFill/>
         </p:spPr>
         <p:txBody>
-          <a:bodyPr wrap="square" lIns="54864" rIns="54864" tIns="54864" bIns="54864" anchor="t">
+          <a:bodyPr wrap="square" lIns="13716" rIns="13716" tIns="13716" bIns="13716" anchor="t">
             <a:spAutoFit/>
           </a:bodyPr>
           <a:lstStyle/>
@@ -14521,7 +14521,7 @@
           <a:noFill/>
         </p:spPr>
         <p:txBody>
-          <a:bodyPr wrap="square" lIns="54864" rIns="54864" tIns="54864" bIns="54864" anchor="t">
+          <a:bodyPr wrap="square" lIns="13716" rIns="13716" tIns="13716" bIns="13716" anchor="t">
             <a:spAutoFit/>
           </a:bodyPr>
           <a:lstStyle/>
@@ -14663,7 +14663,7 @@
           <a:noFill/>
         </p:spPr>
         <p:txBody>
-          <a:bodyPr wrap="square" lIns="54864" rIns="54864" tIns="54864" bIns="54864" anchor="t">
+          <a:bodyPr wrap="square" lIns="13716" rIns="13716" tIns="13716" bIns="13716" anchor="t">
             <a:spAutoFit/>
           </a:bodyPr>
           <a:lstStyle/>
@@ -14699,7 +14699,7 @@
           <a:noFill/>
         </p:spPr>
         <p:txBody>
-          <a:bodyPr wrap="square" lIns="54864" rIns="54864" tIns="54864" bIns="54864" anchor="t">
+          <a:bodyPr wrap="square" lIns="13716" rIns="13716" tIns="13716" bIns="13716" anchor="t">
             <a:spAutoFit/>
           </a:bodyPr>
           <a:lstStyle/>
@@ -14735,7 +14735,7 @@
           <a:noFill/>
         </p:spPr>
         <p:txBody>
-          <a:bodyPr wrap="square" lIns="54864" rIns="54864" tIns="54864" bIns="54864" anchor="t">
+          <a:bodyPr wrap="square" lIns="13716" rIns="13716" tIns="13716" bIns="13716" anchor="t">
             <a:spAutoFit/>
           </a:bodyPr>
           <a:lstStyle/>
@@ -14771,7 +14771,7 @@
           <a:noFill/>
         </p:spPr>
         <p:txBody>
-          <a:bodyPr wrap="square" lIns="54864" rIns="54864" tIns="54864" bIns="54864" anchor="t">
+          <a:bodyPr wrap="square" lIns="13716" rIns="13716" tIns="13716" bIns="13716" anchor="t">
             <a:spAutoFit/>
           </a:bodyPr>
           <a:lstStyle/>
@@ -14807,7 +14807,7 @@
           <a:noFill/>
         </p:spPr>
         <p:txBody>
-          <a:bodyPr wrap="square" lIns="54864" rIns="54864" tIns="54864" bIns="54864" anchor="t">
+          <a:bodyPr wrap="square" lIns="13716" rIns="13716" tIns="13716" bIns="13716" anchor="t">
             <a:spAutoFit/>
           </a:bodyPr>
           <a:lstStyle/>
@@ -14886,7 +14886,7 @@
           <a:noFill/>
         </p:spPr>
         <p:txBody>
-          <a:bodyPr wrap="square" lIns="54864" rIns="54864" tIns="54864" bIns="54864" anchor="t">
+          <a:bodyPr wrap="square" lIns="13716" rIns="13716" tIns="13716" bIns="13716" anchor="t">
             <a:spAutoFit/>
           </a:bodyPr>
           <a:lstStyle/>
@@ -14965,7 +14965,7 @@
           <a:noFill/>
         </p:spPr>
         <p:txBody>
-          <a:bodyPr wrap="square" lIns="54864" rIns="54864" tIns="54864" bIns="54864" anchor="t">
+          <a:bodyPr wrap="square" lIns="13716" rIns="13716" tIns="13716" bIns="13716" anchor="t">
             <a:spAutoFit/>
           </a:bodyPr>
           <a:lstStyle/>
@@ -15044,7 +15044,7 @@
           <a:noFill/>
         </p:spPr>
         <p:txBody>
-          <a:bodyPr wrap="square" lIns="54864" rIns="54864" tIns="54864" bIns="54864" anchor="t">
+          <a:bodyPr wrap="square" lIns="13716" rIns="13716" tIns="13716" bIns="13716" anchor="t">
             <a:spAutoFit/>
           </a:bodyPr>
           <a:lstStyle/>
@@ -15125,7 +15125,7 @@
           <a:noFill/>
         </p:spPr>
         <p:txBody>
-          <a:bodyPr wrap="square" lIns="54864" rIns="54864" tIns="54864" bIns="54864" anchor="t">
+          <a:bodyPr wrap="square" lIns="13716" rIns="13716" tIns="13716" bIns="13716" anchor="t">
             <a:spAutoFit/>
           </a:bodyPr>
           <a:lstStyle/>
@@ -15206,7 +15206,7 @@
           <a:noFill/>
         </p:spPr>
         <p:txBody>
-          <a:bodyPr wrap="square" lIns="54864" rIns="54864" tIns="54864" bIns="54864" anchor="t">
+          <a:bodyPr wrap="square" lIns="13716" rIns="13716" tIns="13716" bIns="13716" anchor="t">
             <a:spAutoFit/>
           </a:bodyPr>
           <a:lstStyle/>
@@ -15287,7 +15287,7 @@
           <a:noFill/>
         </p:spPr>
         <p:txBody>
-          <a:bodyPr wrap="square" lIns="54864" rIns="54864" tIns="54864" bIns="54864" anchor="t">
+          <a:bodyPr wrap="square" lIns="13716" rIns="13716" tIns="13716" bIns="13716" anchor="t">
             <a:spAutoFit/>
           </a:bodyPr>
           <a:lstStyle/>
@@ -15368,7 +15368,7 @@
           <a:noFill/>
         </p:spPr>
         <p:txBody>
-          <a:bodyPr wrap="square" lIns="54864" rIns="54864" tIns="54864" bIns="54864" anchor="t">
+          <a:bodyPr wrap="square" lIns="13716" rIns="13716" tIns="13716" bIns="13716" anchor="t">
             <a:spAutoFit/>
           </a:bodyPr>
           <a:lstStyle/>
@@ -15382,7 +15382,7 @@
               </a:defRPr>
             </a:pPr>
             <a:r>
-              <a:t>Timed release / drag</a:t>
+              <a:t>Spring release / drag</a:t>
             </a:r>
           </a:p>
         </p:txBody>
@@ -15449,7 +15449,7 @@
           <a:noFill/>
         </p:spPr>
         <p:txBody>
-          <a:bodyPr wrap="square" lIns="54864" rIns="54864" tIns="54864" bIns="54864" anchor="t">
+          <a:bodyPr wrap="square" lIns="13716" rIns="13716" tIns="13716" bIns="13716" anchor="t">
             <a:spAutoFit/>
           </a:bodyPr>
           <a:lstStyle/>
@@ -15463,7 +15463,7 @@
               </a:defRPr>
             </a:pPr>
             <a:r>
-              <a:t>In-track phase without a high impulse</a:t>
+              <a:t>Relative state or drag can create phasing</a:t>
             </a:r>
           </a:p>
         </p:txBody>
@@ -15530,7 +15530,7 @@
           <a:noFill/>
         </p:spPr>
         <p:txBody>
-          <a:bodyPr wrap="square" lIns="54864" rIns="54864" tIns="54864" bIns="54864" anchor="t">
+          <a:bodyPr wrap="square" lIns="13716" rIns="13716" tIns="13716" bIns="13716" anchor="t">
             <a:spAutoFit/>
           </a:bodyPr>
           <a:lstStyle/>
@@ -15544,7 +15544,7 @@
               </a:defRPr>
             </a:pPr>
             <a:r>
-              <a:t>Does not quickly change orbital energy</a:t>
+              <a:t>Timing alone, with no relative state change, cannot</a:t>
             </a:r>
           </a:p>
         </p:txBody>
@@ -15611,7 +15611,7 @@
           <a:noFill/>
         </p:spPr>
         <p:txBody>
-          <a:bodyPr wrap="square" lIns="54864" rIns="54864" tIns="54864" bIns="54864" anchor="t">
+          <a:bodyPr wrap="square" lIns="13716" rIns="13716" tIns="13716" bIns="13716" anchor="t">
             <a:spAutoFit/>
           </a:bodyPr>
           <a:lstStyle/>
@@ -15692,7 +15692,7 @@
           <a:noFill/>
         </p:spPr>
         <p:txBody>
-          <a:bodyPr wrap="square" lIns="54864" rIns="54864" tIns="54864" bIns="54864" anchor="t">
+          <a:bodyPr wrap="square" lIns="13716" rIns="13716" tIns="13716" bIns="13716" anchor="t">
             <a:spAutoFit/>
           </a:bodyPr>
           <a:lstStyle/>
@@ -15773,7 +15773,7 @@
           <a:noFill/>
         </p:spPr>
         <p:txBody>
-          <a:bodyPr wrap="square" lIns="54864" rIns="54864" tIns="54864" bIns="54864" anchor="t">
+          <a:bodyPr wrap="square" lIns="13716" rIns="13716" tIns="13716" bIns="13716" anchor="t">
             <a:spAutoFit/>
           </a:bodyPr>
           <a:lstStyle/>
@@ -15854,7 +15854,7 @@
           <a:noFill/>
         </p:spPr>
         <p:txBody>
-          <a:bodyPr wrap="square" lIns="54864" rIns="54864" tIns="54864" bIns="54864" anchor="t">
+          <a:bodyPr wrap="square" lIns="13716" rIns="13716" tIns="13716" bIns="13716" anchor="t">
             <a:spAutoFit/>
           </a:bodyPr>
           <a:lstStyle/>
@@ -15935,7 +15935,7 @@
           <a:noFill/>
         </p:spPr>
         <p:txBody>
-          <a:bodyPr wrap="square" lIns="54864" rIns="54864" tIns="54864" bIns="54864" anchor="t">
+          <a:bodyPr wrap="square" lIns="13716" rIns="13716" tIns="13716" bIns="13716" anchor="t">
             <a:spAutoFit/>
           </a:bodyPr>
           <a:lstStyle/>
@@ -16016,7 +16016,7 @@
           <a:noFill/>
         </p:spPr>
         <p:txBody>
-          <a:bodyPr wrap="square" lIns="54864" rIns="54864" tIns="54864" bIns="54864" anchor="t">
+          <a:bodyPr wrap="square" lIns="13716" rIns="13716" tIns="13716" bIns="13716" anchor="t">
             <a:spAutoFit/>
           </a:bodyPr>
           <a:lstStyle/>
@@ -16158,7 +16158,7 @@
           <a:noFill/>
         </p:spPr>
         <p:txBody>
-          <a:bodyPr wrap="square" lIns="54864" rIns="54864" tIns="54864" bIns="54864" anchor="t">
+          <a:bodyPr wrap="square" lIns="13716" rIns="13716" tIns="13716" bIns="13716" anchor="t">
             <a:spAutoFit/>
           </a:bodyPr>
           <a:lstStyle/>
@@ -16194,7 +16194,7 @@
           <a:noFill/>
         </p:spPr>
         <p:txBody>
-          <a:bodyPr wrap="square" lIns="54864" rIns="54864" tIns="54864" bIns="54864" anchor="t">
+          <a:bodyPr wrap="square" lIns="13716" rIns="13716" tIns="13716" bIns="13716" anchor="t">
             <a:spAutoFit/>
           </a:bodyPr>
           <a:lstStyle/>
@@ -16230,7 +16230,7 @@
           <a:noFill/>
         </p:spPr>
         <p:txBody>
-          <a:bodyPr wrap="square" lIns="54864" rIns="54864" tIns="54864" bIns="54864" anchor="t">
+          <a:bodyPr wrap="square" lIns="13716" rIns="13716" tIns="13716" bIns="13716" anchor="t">
             <a:spAutoFit/>
           </a:bodyPr>
           <a:lstStyle/>
@@ -16266,7 +16266,7 @@
           <a:noFill/>
         </p:spPr>
         <p:txBody>
-          <a:bodyPr wrap="square" lIns="54864" rIns="54864" tIns="54864" bIns="54864" anchor="t">
+          <a:bodyPr wrap="square" lIns="13716" rIns="13716" tIns="13716" bIns="13716" anchor="t">
             <a:spAutoFit/>
           </a:bodyPr>
           <a:lstStyle/>
@@ -16302,7 +16302,7 @@
           <a:noFill/>
         </p:spPr>
         <p:txBody>
-          <a:bodyPr wrap="square" lIns="54864" rIns="54864" tIns="54864" bIns="54864" anchor="t">
+          <a:bodyPr wrap="square" lIns="13716" rIns="13716" tIns="13716" bIns="13716" anchor="t">
             <a:spAutoFit/>
           </a:bodyPr>
           <a:lstStyle/>
@@ -16381,7 +16381,7 @@
           <a:noFill/>
         </p:spPr>
         <p:txBody>
-          <a:bodyPr wrap="square" lIns="54864" rIns="54864" tIns="54864" bIns="54864" anchor="t">
+          <a:bodyPr wrap="square" lIns="13716" rIns="13716" tIns="13716" bIns="13716" anchor="t">
             <a:spAutoFit/>
           </a:bodyPr>
           <a:lstStyle/>
@@ -16505,7 +16505,7 @@
           <a:noFill/>
         </p:spPr>
         <p:txBody>
-          <a:bodyPr wrap="square" lIns="54864" rIns="54864" tIns="54864" bIns="54864" anchor="t">
+          <a:bodyPr wrap="square" lIns="13716" rIns="13716" tIns="13716" bIns="13716" anchor="t">
             <a:spAutoFit/>
           </a:bodyPr>
           <a:lstStyle/>
@@ -16541,7 +16541,7 @@
           <a:noFill/>
         </p:spPr>
         <p:txBody>
-          <a:bodyPr wrap="square" lIns="54864" rIns="54864" tIns="54864" bIns="54864" anchor="t">
+          <a:bodyPr wrap="square" lIns="13716" rIns="13716" tIns="13716" bIns="13716" anchor="t">
             <a:spAutoFit/>
           </a:bodyPr>
           <a:lstStyle/>
@@ -16665,7 +16665,7 @@
           <a:noFill/>
         </p:spPr>
         <p:txBody>
-          <a:bodyPr wrap="square" lIns="54864" rIns="54864" tIns="54864" bIns="54864" anchor="t">
+          <a:bodyPr wrap="square" lIns="13716" rIns="13716" tIns="13716" bIns="13716" anchor="t">
             <a:spAutoFit/>
           </a:bodyPr>
           <a:lstStyle/>
@@ -16701,7 +16701,7 @@
           <a:noFill/>
         </p:spPr>
         <p:txBody>
-          <a:bodyPr wrap="square" lIns="54864" rIns="54864" tIns="54864" bIns="54864" anchor="t">
+          <a:bodyPr wrap="square" lIns="13716" rIns="13716" tIns="13716" bIns="13716" anchor="t">
             <a:spAutoFit/>
           </a:bodyPr>
           <a:lstStyle/>
@@ -16843,7 +16843,7 @@
           <a:noFill/>
         </p:spPr>
         <p:txBody>
-          <a:bodyPr wrap="square" lIns="54864" rIns="54864" tIns="54864" bIns="54864" anchor="t">
+          <a:bodyPr wrap="square" lIns="13716" rIns="13716" tIns="13716" bIns="13716" anchor="t">
             <a:spAutoFit/>
           </a:bodyPr>
           <a:lstStyle/>
@@ -16879,7 +16879,7 @@
           <a:noFill/>
         </p:spPr>
         <p:txBody>
-          <a:bodyPr wrap="square" lIns="54864" rIns="54864" tIns="54864" bIns="54864" anchor="t">
+          <a:bodyPr wrap="square" lIns="13716" rIns="13716" tIns="13716" bIns="13716" anchor="t">
             <a:spAutoFit/>
           </a:bodyPr>
           <a:lstStyle/>
@@ -16915,7 +16915,7 @@
           <a:noFill/>
         </p:spPr>
         <p:txBody>
-          <a:bodyPr wrap="square" lIns="54864" rIns="54864" tIns="54864" bIns="54864" anchor="t">
+          <a:bodyPr wrap="square" lIns="13716" rIns="13716" tIns="13716" bIns="13716" anchor="t">
             <a:spAutoFit/>
           </a:bodyPr>
           <a:lstStyle/>
@@ -16951,7 +16951,7 @@
           <a:noFill/>
         </p:spPr>
         <p:txBody>
-          <a:bodyPr wrap="square" lIns="54864" rIns="54864" tIns="54864" bIns="54864" anchor="t">
+          <a:bodyPr wrap="square" lIns="13716" rIns="13716" tIns="13716" bIns="13716" anchor="t">
             <a:spAutoFit/>
           </a:bodyPr>
           <a:lstStyle/>
@@ -16987,7 +16987,7 @@
           <a:noFill/>
         </p:spPr>
         <p:txBody>
-          <a:bodyPr wrap="square" lIns="54864" rIns="54864" tIns="54864" bIns="54864" anchor="t">
+          <a:bodyPr wrap="square" lIns="13716" rIns="13716" tIns="13716" bIns="13716" anchor="t">
             <a:spAutoFit/>
           </a:bodyPr>
           <a:lstStyle/>
@@ -17066,7 +17066,7 @@
           <a:noFill/>
         </p:spPr>
         <p:txBody>
-          <a:bodyPr wrap="square" lIns="54864" rIns="54864" tIns="54864" bIns="54864" anchor="t">
+          <a:bodyPr wrap="square" lIns="13716" rIns="13716" tIns="13716" bIns="13716" anchor="t">
             <a:spAutoFit/>
           </a:bodyPr>
           <a:lstStyle/>
@@ -17145,7 +17145,7 @@
           <a:noFill/>
         </p:spPr>
         <p:txBody>
-          <a:bodyPr wrap="square" lIns="54864" rIns="54864" tIns="54864" bIns="54864" anchor="t">
+          <a:bodyPr wrap="square" lIns="13716" rIns="13716" tIns="13716" bIns="13716" anchor="t">
             <a:spAutoFit/>
           </a:bodyPr>
           <a:lstStyle/>
@@ -17226,7 +17226,7 @@
           <a:noFill/>
         </p:spPr>
         <p:txBody>
-          <a:bodyPr wrap="square" lIns="54864" rIns="54864" tIns="54864" bIns="54864" anchor="t">
+          <a:bodyPr wrap="square" lIns="13716" rIns="13716" tIns="13716" bIns="13716" anchor="t">
             <a:spAutoFit/>
           </a:bodyPr>
           <a:lstStyle/>
@@ -17307,7 +17307,7 @@
           <a:noFill/>
         </p:spPr>
         <p:txBody>
-          <a:bodyPr wrap="square" lIns="54864" rIns="54864" tIns="54864" bIns="54864" anchor="t">
+          <a:bodyPr wrap="square" lIns="13716" rIns="13716" tIns="13716" bIns="13716" anchor="t">
             <a:spAutoFit/>
           </a:bodyPr>
           <a:lstStyle/>
@@ -17388,7 +17388,7 @@
           <a:noFill/>
         </p:spPr>
         <p:txBody>
-          <a:bodyPr wrap="square" lIns="54864" rIns="54864" tIns="54864" bIns="54864" anchor="t">
+          <a:bodyPr wrap="square" lIns="13716" rIns="13716" tIns="13716" bIns="13716" anchor="t">
             <a:spAutoFit/>
           </a:bodyPr>
           <a:lstStyle/>
@@ -17469,7 +17469,7 @@
           <a:noFill/>
         </p:spPr>
         <p:txBody>
-          <a:bodyPr wrap="square" lIns="54864" rIns="54864" tIns="54864" bIns="54864" anchor="t">
+          <a:bodyPr wrap="square" lIns="13716" rIns="13716" tIns="13716" bIns="13716" anchor="t">
             <a:spAutoFit/>
           </a:bodyPr>
           <a:lstStyle/>
@@ -17550,7 +17550,7 @@
           <a:noFill/>
         </p:spPr>
         <p:txBody>
-          <a:bodyPr wrap="square" lIns="54864" rIns="54864" tIns="54864" bIns="54864" anchor="t">
+          <a:bodyPr wrap="square" lIns="13716" rIns="13716" tIns="13716" bIns="13716" anchor="t">
             <a:spAutoFit/>
           </a:bodyPr>
           <a:lstStyle/>
@@ -17631,7 +17631,7 @@
           <a:noFill/>
         </p:spPr>
         <p:txBody>
-          <a:bodyPr wrap="square" lIns="54864" rIns="54864" tIns="54864" bIns="54864" anchor="t">
+          <a:bodyPr wrap="square" lIns="13716" rIns="13716" tIns="13716" bIns="13716" anchor="t">
             <a:spAutoFit/>
           </a:bodyPr>
           <a:lstStyle/>
@@ -17712,7 +17712,7 @@
           <a:noFill/>
         </p:spPr>
         <p:txBody>
-          <a:bodyPr wrap="square" lIns="54864" rIns="54864" tIns="54864" bIns="54864" anchor="t">
+          <a:bodyPr wrap="square" lIns="13716" rIns="13716" tIns="13716" bIns="13716" anchor="t">
             <a:spAutoFit/>
           </a:bodyPr>
           <a:lstStyle/>
@@ -17793,7 +17793,7 @@
           <a:noFill/>
         </p:spPr>
         <p:txBody>
-          <a:bodyPr wrap="square" lIns="54864" rIns="54864" tIns="54864" bIns="54864" anchor="t">
+          <a:bodyPr wrap="square" lIns="13716" rIns="13716" tIns="13716" bIns="13716" anchor="t">
             <a:spAutoFit/>
           </a:bodyPr>
           <a:lstStyle/>
@@ -17874,7 +17874,7 @@
           <a:noFill/>
         </p:spPr>
         <p:txBody>
-          <a:bodyPr wrap="square" lIns="54864" rIns="54864" tIns="54864" bIns="54864" anchor="t">
+          <a:bodyPr wrap="square" lIns="13716" rIns="13716" tIns="13716" bIns="13716" anchor="t">
             <a:spAutoFit/>
           </a:bodyPr>
           <a:lstStyle/>
@@ -17955,7 +17955,7 @@
           <a:noFill/>
         </p:spPr>
         <p:txBody>
-          <a:bodyPr wrap="square" lIns="54864" rIns="54864" tIns="54864" bIns="54864" anchor="t">
+          <a:bodyPr wrap="square" lIns="13716" rIns="13716" tIns="13716" bIns="13716" anchor="t">
             <a:spAutoFit/>
           </a:bodyPr>
           <a:lstStyle/>
@@ -18097,7 +18097,7 @@
           <a:noFill/>
         </p:spPr>
         <p:txBody>
-          <a:bodyPr wrap="square" lIns="54864" rIns="54864" tIns="54864" bIns="54864" anchor="t">
+          <a:bodyPr wrap="square" lIns="13716" rIns="13716" tIns="13716" bIns="13716" anchor="t">
             <a:spAutoFit/>
           </a:bodyPr>
           <a:lstStyle/>
@@ -18133,7 +18133,7 @@
           <a:noFill/>
         </p:spPr>
         <p:txBody>
-          <a:bodyPr wrap="square" lIns="54864" rIns="54864" tIns="54864" bIns="54864" anchor="t">
+          <a:bodyPr wrap="square" lIns="13716" rIns="13716" tIns="13716" bIns="13716" anchor="t">
             <a:spAutoFit/>
           </a:bodyPr>
           <a:lstStyle/>
@@ -18169,7 +18169,7 @@
           <a:noFill/>
         </p:spPr>
         <p:txBody>
-          <a:bodyPr wrap="square" lIns="54864" rIns="54864" tIns="54864" bIns="54864" anchor="t">
+          <a:bodyPr wrap="square" lIns="13716" rIns="13716" tIns="13716" bIns="13716" anchor="t">
             <a:spAutoFit/>
           </a:bodyPr>
           <a:lstStyle/>
@@ -18205,7 +18205,7 @@
           <a:noFill/>
         </p:spPr>
         <p:txBody>
-          <a:bodyPr wrap="square" lIns="54864" rIns="54864" tIns="54864" bIns="54864" anchor="t">
+          <a:bodyPr wrap="square" lIns="13716" rIns="13716" tIns="13716" bIns="13716" anchor="t">
             <a:spAutoFit/>
           </a:bodyPr>
           <a:lstStyle/>
@@ -18241,7 +18241,7 @@
           <a:noFill/>
         </p:spPr>
         <p:txBody>
-          <a:bodyPr wrap="square" lIns="54864" rIns="54864" tIns="54864" bIns="54864" anchor="t">
+          <a:bodyPr wrap="square" lIns="13716" rIns="13716" tIns="13716" bIns="13716" anchor="t">
             <a:spAutoFit/>
           </a:bodyPr>
           <a:lstStyle/>
@@ -18322,7 +18322,7 @@
           <a:noFill/>
         </p:spPr>
         <p:txBody>
-          <a:bodyPr wrap="square" lIns="54864" rIns="54864" tIns="54864" bIns="54864" anchor="t">
+          <a:bodyPr wrap="square" lIns="13716" rIns="13716" tIns="13716" bIns="13716" anchor="t">
             <a:spAutoFit/>
           </a:bodyPr>
           <a:lstStyle/>
@@ -18362,7 +18362,7 @@
           <a:noFill/>
         </p:spPr>
         <p:txBody>
-          <a:bodyPr wrap="square" lIns="54864" rIns="54864" tIns="54864" bIns="54864" anchor="t">
+          <a:bodyPr wrap="square" lIns="13716" rIns="13716" tIns="13716" bIns="13716" anchor="t">
             <a:spAutoFit/>
           </a:bodyPr>
           <a:lstStyle/>
@@ -18443,7 +18443,7 @@
           <a:noFill/>
         </p:spPr>
         <p:txBody>
-          <a:bodyPr wrap="square" lIns="54864" rIns="54864" tIns="54864" bIns="54864" anchor="t">
+          <a:bodyPr wrap="square" lIns="13716" rIns="13716" tIns="13716" bIns="13716" anchor="t">
             <a:spAutoFit/>
           </a:bodyPr>
           <a:lstStyle/>
@@ -18483,7 +18483,7 @@
           <a:noFill/>
         </p:spPr>
         <p:txBody>
-          <a:bodyPr wrap="square" lIns="54864" rIns="54864" tIns="54864" bIns="54864" anchor="t">
+          <a:bodyPr wrap="square" lIns="13716" rIns="13716" tIns="13716" bIns="13716" anchor="t">
             <a:spAutoFit/>
           </a:bodyPr>
           <a:lstStyle/>
@@ -18564,7 +18564,7 @@
           <a:noFill/>
         </p:spPr>
         <p:txBody>
-          <a:bodyPr wrap="square" lIns="54864" rIns="54864" tIns="54864" bIns="54864" anchor="t">
+          <a:bodyPr wrap="square" lIns="13716" rIns="13716" tIns="13716" bIns="13716" anchor="t">
             <a:spAutoFit/>
           </a:bodyPr>
           <a:lstStyle/>
@@ -18604,7 +18604,7 @@
           <a:noFill/>
         </p:spPr>
         <p:txBody>
-          <a:bodyPr wrap="square" lIns="54864" rIns="54864" tIns="54864" bIns="54864" anchor="t">
+          <a:bodyPr wrap="square" lIns="13716" rIns="13716" tIns="13716" bIns="13716" anchor="t">
             <a:spAutoFit/>
           </a:bodyPr>
           <a:lstStyle/>
@@ -18685,7 +18685,7 @@
           <a:noFill/>
         </p:spPr>
         <p:txBody>
-          <a:bodyPr wrap="square" lIns="54864" rIns="54864" tIns="54864" bIns="54864" anchor="t">
+          <a:bodyPr wrap="square" lIns="13716" rIns="13716" tIns="13716" bIns="13716" anchor="t">
             <a:spAutoFit/>
           </a:bodyPr>
           <a:lstStyle/>
@@ -18725,7 +18725,7 @@
           <a:noFill/>
         </p:spPr>
         <p:txBody>
-          <a:bodyPr wrap="square" lIns="54864" rIns="54864" tIns="54864" bIns="54864" anchor="t">
+          <a:bodyPr wrap="square" lIns="13716" rIns="13716" tIns="13716" bIns="13716" anchor="t">
             <a:spAutoFit/>
           </a:bodyPr>
           <a:lstStyle/>
@@ -18806,7 +18806,7 @@
           <a:noFill/>
         </p:spPr>
         <p:txBody>
-          <a:bodyPr wrap="square" lIns="54864" rIns="54864" tIns="54864" bIns="54864" anchor="t">
+          <a:bodyPr wrap="square" lIns="13716" rIns="13716" tIns="13716" bIns="13716" anchor="t">
             <a:spAutoFit/>
           </a:bodyPr>
           <a:lstStyle/>
@@ -18846,7 +18846,7 @@
           <a:noFill/>
         </p:spPr>
         <p:txBody>
-          <a:bodyPr wrap="square" lIns="54864" rIns="54864" tIns="54864" bIns="54864" anchor="t">
+          <a:bodyPr wrap="square" lIns="13716" rIns="13716" tIns="13716" bIns="13716" anchor="t">
             <a:spAutoFit/>
           </a:bodyPr>
           <a:lstStyle/>
@@ -18927,7 +18927,7 @@
           <a:noFill/>
         </p:spPr>
         <p:txBody>
-          <a:bodyPr wrap="square" lIns="54864" rIns="54864" tIns="54864" bIns="54864" anchor="t">
+          <a:bodyPr wrap="square" lIns="13716" rIns="13716" tIns="13716" bIns="13716" anchor="t">
             <a:spAutoFit/>
           </a:bodyPr>
           <a:lstStyle/>
@@ -19010,7 +19010,7 @@
           <a:noFill/>
         </p:spPr>
         <p:txBody>
-          <a:bodyPr wrap="square" lIns="54864" rIns="54864" tIns="54864" bIns="54864" anchor="t">
+          <a:bodyPr wrap="square" lIns="13716" rIns="13716" tIns="13716" bIns="13716" anchor="t">
             <a:spAutoFit/>
           </a:bodyPr>
           <a:lstStyle/>
@@ -19152,7 +19152,7 @@
           <a:noFill/>
         </p:spPr>
         <p:txBody>
-          <a:bodyPr wrap="square" lIns="54864" rIns="54864" tIns="54864" bIns="54864" anchor="t">
+          <a:bodyPr wrap="square" lIns="13716" rIns="13716" tIns="13716" bIns="13716" anchor="t">
             <a:spAutoFit/>
           </a:bodyPr>
           <a:lstStyle/>
@@ -19188,7 +19188,7 @@
           <a:noFill/>
         </p:spPr>
         <p:txBody>
-          <a:bodyPr wrap="square" lIns="54864" rIns="54864" tIns="54864" bIns="54864" anchor="t">
+          <a:bodyPr wrap="square" lIns="13716" rIns="13716" tIns="13716" bIns="13716" anchor="t">
             <a:spAutoFit/>
           </a:bodyPr>
           <a:lstStyle/>
@@ -19224,7 +19224,7 @@
           <a:noFill/>
         </p:spPr>
         <p:txBody>
-          <a:bodyPr wrap="square" lIns="54864" rIns="54864" tIns="54864" bIns="54864" anchor="t">
+          <a:bodyPr wrap="square" lIns="13716" rIns="13716" tIns="13716" bIns="13716" anchor="t">
             <a:spAutoFit/>
           </a:bodyPr>
           <a:lstStyle/>
@@ -19260,7 +19260,7 @@
           <a:noFill/>
         </p:spPr>
         <p:txBody>
-          <a:bodyPr wrap="square" lIns="54864" rIns="54864" tIns="54864" bIns="54864" anchor="t">
+          <a:bodyPr wrap="square" lIns="13716" rIns="13716" tIns="13716" bIns="13716" anchor="t">
             <a:spAutoFit/>
           </a:bodyPr>
           <a:lstStyle/>
@@ -19296,7 +19296,7 @@
           <a:noFill/>
         </p:spPr>
         <p:txBody>
-          <a:bodyPr wrap="square" lIns="54864" rIns="54864" tIns="54864" bIns="54864" anchor="t">
+          <a:bodyPr wrap="square" lIns="13716" rIns="13716" tIns="13716" bIns="13716" anchor="t">
             <a:spAutoFit/>
           </a:bodyPr>
           <a:lstStyle/>
@@ -19375,7 +19375,7 @@
           <a:noFill/>
         </p:spPr>
         <p:txBody>
-          <a:bodyPr wrap="square" lIns="54864" rIns="54864" tIns="54864" bIns="54864" anchor="t">
+          <a:bodyPr wrap="square" lIns="13716" rIns="13716" tIns="13716" bIns="13716" anchor="t">
             <a:spAutoFit/>
           </a:bodyPr>
           <a:lstStyle/>
@@ -19454,7 +19454,7 @@
           <a:noFill/>
         </p:spPr>
         <p:txBody>
-          <a:bodyPr wrap="square" lIns="54864" rIns="54864" tIns="54864" bIns="54864" anchor="t">
+          <a:bodyPr wrap="square" lIns="13716" rIns="13716" tIns="13716" bIns="13716" anchor="t">
             <a:spAutoFit/>
           </a:bodyPr>
           <a:lstStyle/>
@@ -19533,7 +19533,7 @@
           <a:noFill/>
         </p:spPr>
         <p:txBody>
-          <a:bodyPr wrap="square" lIns="54864" rIns="54864" tIns="54864" bIns="54864" anchor="t">
+          <a:bodyPr wrap="square" lIns="13716" rIns="13716" tIns="13716" bIns="13716" anchor="t">
             <a:spAutoFit/>
           </a:bodyPr>
           <a:lstStyle/>
@@ -19614,7 +19614,7 @@
           <a:noFill/>
         </p:spPr>
         <p:txBody>
-          <a:bodyPr wrap="square" lIns="54864" rIns="54864" tIns="54864" bIns="54864" anchor="t">
+          <a:bodyPr wrap="square" lIns="13716" rIns="13716" tIns="13716" bIns="13716" anchor="t">
             <a:spAutoFit/>
           </a:bodyPr>
           <a:lstStyle/>
@@ -19695,7 +19695,7 @@
           <a:noFill/>
         </p:spPr>
         <p:txBody>
-          <a:bodyPr wrap="square" lIns="54864" rIns="54864" tIns="54864" bIns="54864" anchor="t">
+          <a:bodyPr wrap="square" lIns="13716" rIns="13716" tIns="13716" bIns="13716" anchor="t">
             <a:spAutoFit/>
           </a:bodyPr>
           <a:lstStyle/>
@@ -19776,7 +19776,7 @@
           <a:noFill/>
         </p:spPr>
         <p:txBody>
-          <a:bodyPr wrap="square" lIns="54864" rIns="54864" tIns="54864" bIns="54864" anchor="t">
+          <a:bodyPr wrap="square" lIns="13716" rIns="13716" tIns="13716" bIns="13716" anchor="t">
             <a:spAutoFit/>
           </a:bodyPr>
           <a:lstStyle/>
@@ -19857,7 +19857,7 @@
           <a:noFill/>
         </p:spPr>
         <p:txBody>
-          <a:bodyPr wrap="square" lIns="54864" rIns="54864" tIns="54864" bIns="54864" anchor="t">
+          <a:bodyPr wrap="square" lIns="13716" rIns="13716" tIns="13716" bIns="13716" anchor="t">
             <a:spAutoFit/>
           </a:bodyPr>
           <a:lstStyle/>
@@ -19938,7 +19938,7 @@
           <a:noFill/>
         </p:spPr>
         <p:txBody>
-          <a:bodyPr wrap="square" lIns="54864" rIns="54864" tIns="54864" bIns="54864" anchor="t">
+          <a:bodyPr wrap="square" lIns="13716" rIns="13716" tIns="13716" bIns="13716" anchor="t">
             <a:spAutoFit/>
           </a:bodyPr>
           <a:lstStyle/>
@@ -20019,7 +20019,7 @@
           <a:noFill/>
         </p:spPr>
         <p:txBody>
-          <a:bodyPr wrap="square" lIns="54864" rIns="54864" tIns="54864" bIns="54864" anchor="t">
+          <a:bodyPr wrap="square" lIns="13716" rIns="13716" tIns="13716" bIns="13716" anchor="t">
             <a:spAutoFit/>
           </a:bodyPr>
           <a:lstStyle/>
@@ -20100,7 +20100,7 @@
           <a:noFill/>
         </p:spPr>
         <p:txBody>
-          <a:bodyPr wrap="square" lIns="54864" rIns="54864" tIns="54864" bIns="54864" anchor="t">
+          <a:bodyPr wrap="square" lIns="13716" rIns="13716" tIns="13716" bIns="13716" anchor="t">
             <a:spAutoFit/>
           </a:bodyPr>
           <a:lstStyle/>
@@ -20181,7 +20181,7 @@
           <a:noFill/>
         </p:spPr>
         <p:txBody>
-          <a:bodyPr wrap="square" lIns="54864" rIns="54864" tIns="54864" bIns="54864" anchor="t">
+          <a:bodyPr wrap="square" lIns="13716" rIns="13716" tIns="13716" bIns="13716" anchor="t">
             <a:spAutoFit/>
           </a:bodyPr>
           <a:lstStyle/>
@@ -20262,7 +20262,7 @@
           <a:noFill/>
         </p:spPr>
         <p:txBody>
-          <a:bodyPr wrap="square" lIns="54864" rIns="54864" tIns="54864" bIns="54864" anchor="t">
+          <a:bodyPr wrap="square" lIns="13716" rIns="13716" tIns="13716" bIns="13716" anchor="t">
             <a:spAutoFit/>
           </a:bodyPr>
           <a:lstStyle/>
@@ -20343,7 +20343,7 @@
           <a:noFill/>
         </p:spPr>
         <p:txBody>
-          <a:bodyPr wrap="square" lIns="54864" rIns="54864" tIns="54864" bIns="54864" anchor="t">
+          <a:bodyPr wrap="square" lIns="13716" rIns="13716" tIns="13716" bIns="13716" anchor="t">
             <a:spAutoFit/>
           </a:bodyPr>
           <a:lstStyle/>
@@ -20424,7 +20424,7 @@
           <a:noFill/>
         </p:spPr>
         <p:txBody>
-          <a:bodyPr wrap="square" lIns="54864" rIns="54864" tIns="54864" bIns="54864" anchor="t">
+          <a:bodyPr wrap="square" lIns="13716" rIns="13716" tIns="13716" bIns="13716" anchor="t">
             <a:spAutoFit/>
           </a:bodyPr>
           <a:lstStyle/>
@@ -20505,7 +20505,7 @@
           <a:noFill/>
         </p:spPr>
         <p:txBody>
-          <a:bodyPr wrap="square" lIns="54864" rIns="54864" tIns="54864" bIns="54864" anchor="t">
+          <a:bodyPr wrap="square" lIns="13716" rIns="13716" tIns="13716" bIns="13716" anchor="t">
             <a:spAutoFit/>
           </a:bodyPr>
           <a:lstStyle/>
@@ -20647,7 +20647,7 @@
           <a:noFill/>
         </p:spPr>
         <p:txBody>
-          <a:bodyPr wrap="square" lIns="54864" rIns="54864" tIns="54864" bIns="54864" anchor="t">
+          <a:bodyPr wrap="square" lIns="13716" rIns="13716" tIns="13716" bIns="13716" anchor="t">
             <a:spAutoFit/>
           </a:bodyPr>
           <a:lstStyle/>
@@ -20683,7 +20683,7 @@
           <a:noFill/>
         </p:spPr>
         <p:txBody>
-          <a:bodyPr wrap="square" lIns="54864" rIns="54864" tIns="54864" bIns="54864" anchor="t">
+          <a:bodyPr wrap="square" lIns="13716" rIns="13716" tIns="13716" bIns="13716" anchor="t">
             <a:spAutoFit/>
           </a:bodyPr>
           <a:lstStyle/>
@@ -20719,7 +20719,7 @@
           <a:noFill/>
         </p:spPr>
         <p:txBody>
-          <a:bodyPr wrap="square" lIns="54864" rIns="54864" tIns="54864" bIns="54864" anchor="t">
+          <a:bodyPr wrap="square" lIns="13716" rIns="13716" tIns="13716" bIns="13716" anchor="t">
             <a:spAutoFit/>
           </a:bodyPr>
           <a:lstStyle/>
@@ -20755,7 +20755,7 @@
           <a:noFill/>
         </p:spPr>
         <p:txBody>
-          <a:bodyPr wrap="square" lIns="54864" rIns="54864" tIns="54864" bIns="54864" anchor="t">
+          <a:bodyPr wrap="square" lIns="13716" rIns="13716" tIns="13716" bIns="13716" anchor="t">
             <a:spAutoFit/>
           </a:bodyPr>
           <a:lstStyle/>
@@ -20791,7 +20791,7 @@
           <a:noFill/>
         </p:spPr>
         <p:txBody>
-          <a:bodyPr wrap="square" lIns="54864" rIns="54864" tIns="54864" bIns="54864" anchor="t">
+          <a:bodyPr wrap="square" lIns="13716" rIns="13716" tIns="13716" bIns="13716" anchor="t">
             <a:spAutoFit/>
           </a:bodyPr>
           <a:lstStyle/>
@@ -20870,7 +20870,7 @@
           <a:noFill/>
         </p:spPr>
         <p:txBody>
-          <a:bodyPr wrap="square" lIns="54864" rIns="54864" tIns="54864" bIns="54864" anchor="t">
+          <a:bodyPr wrap="square" lIns="13716" rIns="13716" tIns="13716" bIns="13716" anchor="t">
             <a:spAutoFit/>
           </a:bodyPr>
           <a:lstStyle/>
@@ -20906,7 +20906,7 @@
           <a:noFill/>
         </p:spPr>
         <p:txBody>
-          <a:bodyPr wrap="square" lIns="54864" rIns="54864" tIns="54864" bIns="54864" anchor="t">
+          <a:bodyPr wrap="square" lIns="13716" rIns="13716" tIns="13716" bIns="13716" anchor="t">
             <a:spAutoFit/>
           </a:bodyPr>
           <a:lstStyle/>
@@ -20942,7 +20942,7 @@
           <a:noFill/>
         </p:spPr>
         <p:txBody>
-          <a:bodyPr wrap="square" lIns="54864" rIns="54864" tIns="54864" bIns="54864" anchor="t">
+          <a:bodyPr wrap="square" lIns="13716" rIns="13716" tIns="13716" bIns="13716" anchor="t">
             <a:spAutoFit/>
           </a:bodyPr>
           <a:lstStyle/>
@@ -21021,7 +21021,7 @@
           <a:noFill/>
         </p:spPr>
         <p:txBody>
-          <a:bodyPr wrap="square" lIns="54864" rIns="54864" tIns="54864" bIns="54864" anchor="t">
+          <a:bodyPr wrap="square" lIns="13716" rIns="13716" tIns="13716" bIns="13716" anchor="t">
             <a:spAutoFit/>
           </a:bodyPr>
           <a:lstStyle/>
@@ -21057,7 +21057,7 @@
           <a:noFill/>
         </p:spPr>
         <p:txBody>
-          <a:bodyPr wrap="square" lIns="54864" rIns="54864" tIns="54864" bIns="54864" anchor="t">
+          <a:bodyPr wrap="square" lIns="13716" rIns="13716" tIns="13716" bIns="13716" anchor="t">
             <a:spAutoFit/>
           </a:bodyPr>
           <a:lstStyle/>
@@ -21093,7 +21093,7 @@
           <a:noFill/>
         </p:spPr>
         <p:txBody>
-          <a:bodyPr wrap="square" lIns="54864" rIns="54864" tIns="54864" bIns="54864" anchor="t">
+          <a:bodyPr wrap="square" lIns="13716" rIns="13716" tIns="13716" bIns="13716" anchor="t">
             <a:spAutoFit/>
           </a:bodyPr>
           <a:lstStyle/>
@@ -21172,7 +21172,7 @@
           <a:noFill/>
         </p:spPr>
         <p:txBody>
-          <a:bodyPr wrap="square" lIns="54864" rIns="54864" tIns="54864" bIns="54864" anchor="t">
+          <a:bodyPr wrap="square" lIns="13716" rIns="13716" tIns="13716" bIns="13716" anchor="t">
             <a:spAutoFit/>
           </a:bodyPr>
           <a:lstStyle/>
@@ -21208,7 +21208,7 @@
           <a:noFill/>
         </p:spPr>
         <p:txBody>
-          <a:bodyPr wrap="square" lIns="54864" rIns="54864" tIns="54864" bIns="54864" anchor="t">
+          <a:bodyPr wrap="square" lIns="13716" rIns="13716" tIns="13716" bIns="13716" anchor="t">
             <a:spAutoFit/>
           </a:bodyPr>
           <a:lstStyle/>
@@ -21244,7 +21244,7 @@
           <a:noFill/>
         </p:spPr>
         <p:txBody>
-          <a:bodyPr wrap="square" lIns="54864" rIns="54864" tIns="54864" bIns="54864" anchor="t">
+          <a:bodyPr wrap="square" lIns="13716" rIns="13716" tIns="13716" bIns="13716" anchor="t">
             <a:spAutoFit/>
           </a:bodyPr>
           <a:lstStyle/>
@@ -21323,7 +21323,7 @@
           <a:noFill/>
         </p:spPr>
         <p:txBody>
-          <a:bodyPr wrap="square" lIns="54864" rIns="54864" tIns="54864" bIns="54864" anchor="t">
+          <a:bodyPr wrap="square" lIns="13716" rIns="13716" tIns="13716" bIns="13716" anchor="t">
             <a:spAutoFit/>
           </a:bodyPr>
           <a:lstStyle/>
@@ -21359,7 +21359,7 @@
           <a:noFill/>
         </p:spPr>
         <p:txBody>
-          <a:bodyPr wrap="square" lIns="54864" rIns="54864" tIns="54864" bIns="54864" anchor="t">
+          <a:bodyPr wrap="square" lIns="13716" rIns="13716" tIns="13716" bIns="13716" anchor="t">
             <a:spAutoFit/>
           </a:bodyPr>
           <a:lstStyle/>
@@ -21395,7 +21395,7 @@
           <a:noFill/>
         </p:spPr>
         <p:txBody>
-          <a:bodyPr wrap="square" lIns="54864" rIns="54864" tIns="54864" bIns="54864" anchor="t">
+          <a:bodyPr wrap="square" lIns="13716" rIns="13716" tIns="13716" bIns="13716" anchor="t">
             <a:spAutoFit/>
           </a:bodyPr>
           <a:lstStyle/>
@@ -21474,7 +21474,7 @@
           <a:noFill/>
         </p:spPr>
         <p:txBody>
-          <a:bodyPr wrap="square" lIns="54864" rIns="54864" tIns="54864" bIns="54864" anchor="t">
+          <a:bodyPr wrap="square" lIns="13716" rIns="13716" tIns="13716" bIns="13716" anchor="t">
             <a:spAutoFit/>
           </a:bodyPr>
           <a:lstStyle/>
@@ -21510,7 +21510,7 @@
           <a:noFill/>
         </p:spPr>
         <p:txBody>
-          <a:bodyPr wrap="square" lIns="54864" rIns="54864" tIns="54864" bIns="54864" anchor="t">
+          <a:bodyPr wrap="square" lIns="13716" rIns="13716" tIns="13716" bIns="13716" anchor="t">
             <a:spAutoFit/>
           </a:bodyPr>
           <a:lstStyle/>
@@ -21546,7 +21546,7 @@
           <a:noFill/>
         </p:spPr>
         <p:txBody>
-          <a:bodyPr wrap="square" lIns="54864" rIns="54864" tIns="54864" bIns="54864" anchor="t">
+          <a:bodyPr wrap="square" lIns="13716" rIns="13716" tIns="13716" bIns="13716" anchor="t">
             <a:spAutoFit/>
           </a:bodyPr>
           <a:lstStyle/>
@@ -21582,7 +21582,7 @@
           <a:noFill/>
         </p:spPr>
         <p:txBody>
-          <a:bodyPr wrap="square" lIns="54864" rIns="54864" tIns="54864" bIns="54864" anchor="t">
+          <a:bodyPr wrap="square" lIns="13716" rIns="13716" tIns="13716" bIns="13716" anchor="t">
             <a:spAutoFit/>
           </a:bodyPr>
           <a:lstStyle/>

</xml_diff>

<commit_message>
Align thesis CAD provenance and rebuild final review downloads
</commit_message>
<xml_diff>
--- a/university/final_review_2026_10_10/VOLLEY_Final_Review_2026-10-10.pptx
+++ b/university/final_review_2026_10_10/VOLLEY_Final_Review_2026-10-10.pptx
@@ -8238,14 +8238,131 @@
       </p:sp>
       <p:sp>
         <p:nvSpPr>
-          <p:cNvPr id="9" name="TextBox 8"/>
-          <p:cNvSpPr txBox="1"/>
-          <p:nvPr/>
-        </p:nvSpPr>
-        <p:spPr>
-          <a:xfrm>
-            <a:off x="822960" y="1773936"/>
-            <a:ext cx="2514600" cy="411480"/>
+          <p:cNvPr id="9" name="Rounded Rectangle 8"/>
+          <p:cNvSpPr/>
+          <p:nvPr/>
+        </p:nvSpPr>
+        <p:spPr>
+          <a:xfrm>
+            <a:off x="777240" y="1572768"/>
+            <a:ext cx="10744200" cy="932688"/>
+          </a:xfrm>
+          <a:prstGeom prst="roundRect">
+            <a:avLst/>
+          </a:prstGeom>
+          <a:solidFill>
+            <a:srgbClr val="F6F9FB"/>
+          </a:solidFill>
+          <a:ln>
+            <a:solidFill>
+              <a:srgbClr val="DDE7EC"/>
+            </a:solidFill>
+          </a:ln>
+        </p:spPr>
+        <p:style>
+          <a:lnRef idx="1">
+            <a:schemeClr val="accent1"/>
+          </a:lnRef>
+          <a:fillRef idx="3">
+            <a:schemeClr val="accent1"/>
+          </a:fillRef>
+          <a:effectRef idx="2">
+            <a:schemeClr val="accent1"/>
+          </a:effectRef>
+          <a:fontRef idx="minor">
+            <a:schemeClr val="lt1"/>
+          </a:fontRef>
+        </p:style>
+        <p:txBody>
+          <a:bodyPr rtlCol="0" anchor="ctr"/>
+          <a:lstStyle/>
+          <a:p>
+            <a:pPr algn="ctr"/>
+          </a:p>
+        </p:txBody>
+      </p:sp>
+      <p:sp>
+        <p:nvSpPr>
+          <p:cNvPr id="10" name="TextBox 9"/>
+          <p:cNvSpPr txBox="1"/>
+          <p:nvPr/>
+        </p:nvSpPr>
+        <p:spPr>
+          <a:xfrm>
+            <a:off x="1005840" y="1819656"/>
+            <a:ext cx="6766560" cy="393192"/>
+          </a:xfrm>
+          <a:prstGeom prst="rect">
+            <a:avLst/>
+          </a:prstGeom>
+          <a:noFill/>
+        </p:spPr>
+        <p:txBody>
+          <a:bodyPr wrap="square" lIns="13716" rIns="13716" tIns="13716" bIns="13716" anchor="t">
+            <a:spAutoFit/>
+          </a:bodyPr>
+          <a:lstStyle/>
+          <a:p>
+            <a:pPr algn="l">
+              <a:defRPr sz="2000" b="1">
+                <a:solidFill>
+                  <a:srgbClr val="0D2035"/>
+                </a:solidFill>
+                <a:latin typeface="Aptos"/>
+              </a:defRPr>
+            </a:pPr>
+            <a:r>
+              <a:t>Modeled dry mass, 12 slots</a:t>
+            </a:r>
+          </a:p>
+        </p:txBody>
+      </p:sp>
+      <p:sp>
+        <p:nvSpPr>
+          <p:cNvPr id="11" name="TextBox 10"/>
+          <p:cNvSpPr txBox="1"/>
+          <p:nvPr/>
+        </p:nvSpPr>
+        <p:spPr>
+          <a:xfrm>
+            <a:off x="8823960" y="1819656"/>
+            <a:ext cx="2377440" cy="393192"/>
+          </a:xfrm>
+          <a:prstGeom prst="rect">
+            <a:avLst/>
+          </a:prstGeom>
+          <a:noFill/>
+        </p:spPr>
+        <p:txBody>
+          <a:bodyPr wrap="square" lIns="13716" rIns="13716" tIns="13716" bIns="13716" anchor="t">
+            <a:spAutoFit/>
+          </a:bodyPr>
+          <a:lstStyle/>
+          <a:p>
+            <a:pPr algn="r">
+              <a:defRPr sz="2100" b="1">
+                <a:solidFill>
+                  <a:srgbClr val="0D2035"/>
+                </a:solidFill>
+                <a:latin typeface="Aptos"/>
+              </a:defRPr>
+            </a:pPr>
+            <a:r>
+              <a:t>126.6 kg</a:t>
+            </a:r>
+          </a:p>
+        </p:txBody>
+      </p:sp>
+      <p:sp>
+        <p:nvSpPr>
+          <p:cNvPr id="12" name="TextBox 11"/>
+          <p:cNvSpPr txBox="1"/>
+          <p:nvPr/>
+        </p:nvSpPr>
+        <p:spPr>
+          <a:xfrm>
+            <a:off x="822960" y="2743200"/>
+            <a:ext cx="2926080" cy="411480"/>
           </a:xfrm>
           <a:prstGeom prst="rect">
             <a:avLst/>
@@ -8267,21 +8384,21 @@
               </a:defRPr>
             </a:pPr>
             <a:r>
-              <a:t>Dry system</a:t>
-            </a:r>
-          </a:p>
-        </p:txBody>
-      </p:sp>
-      <p:sp>
-        <p:nvSpPr>
-          <p:cNvPr id="10" name="Rectangle 9"/>
+              <a:t>Gen5 per 3U</a:t>
+            </a:r>
+          </a:p>
+        </p:txBody>
+      </p:sp>
+      <p:sp>
+        <p:nvSpPr>
+          <p:cNvPr id="13" name="Rectangle 12"/>
           <p:cNvSpPr/>
           <p:nvPr/>
         </p:nvSpPr>
         <p:spPr>
           <a:xfrm>
-            <a:off x="3200400" y="1810512"/>
-            <a:ext cx="7498079" cy="438912"/>
+            <a:off x="3886200" y="2770632"/>
+            <a:ext cx="6309360" cy="438912"/>
           </a:xfrm>
           <a:prstGeom prst="rect">
             <a:avLst/>
@@ -8317,14 +8434,14 @@
       </p:sp>
       <p:sp>
         <p:nvSpPr>
-          <p:cNvPr id="11" name="TextBox 10"/>
-          <p:cNvSpPr txBox="1"/>
-          <p:nvPr/>
-        </p:nvSpPr>
-        <p:spPr>
-          <a:xfrm>
-            <a:off x="9235440" y="1810512"/>
-            <a:ext cx="2011680" cy="384048"/>
+          <p:cNvPr id="14" name="TextBox 13"/>
+          <p:cNvSpPr txBox="1"/>
+          <p:nvPr/>
+        </p:nvSpPr>
+        <p:spPr>
+          <a:xfrm>
+            <a:off x="10287000" y="2761488"/>
+            <a:ext cx="1051560" cy="384048"/>
           </a:xfrm>
           <a:prstGeom prst="rect">
             <a:avLst/>
@@ -8346,21 +8463,21 @@
               </a:defRPr>
             </a:pPr>
             <a:r>
-              <a:t>126.6 kg</a:t>
-            </a:r>
-          </a:p>
-        </p:txBody>
-      </p:sp>
-      <p:sp>
-        <p:nvSpPr>
-          <p:cNvPr id="12" name="TextBox 11"/>
-          <p:cNvSpPr txBox="1"/>
-          <p:nvPr/>
-        </p:nvSpPr>
-        <p:spPr>
-          <a:xfrm>
-            <a:off x="822960" y="2743200"/>
-            <a:ext cx="2514600" cy="411480"/>
+              <a:t>10.55 kg</a:t>
+            </a:r>
+          </a:p>
+        </p:txBody>
+      </p:sp>
+      <p:sp>
+        <p:nvSpPr>
+          <p:cNvPr id="15" name="TextBox 14"/>
+          <p:cNvSpPr txBox="1"/>
+          <p:nvPr/>
+        </p:nvSpPr>
+        <p:spPr>
+          <a:xfrm>
+            <a:off x="822960" y="3657600"/>
+            <a:ext cx="2926080" cy="411480"/>
           </a:xfrm>
           <a:prstGeom prst="rect">
             <a:avLst/>
@@ -8382,121 +8499,6 @@
               </a:defRPr>
             </a:pPr>
             <a:r>
-              <a:t>Gen5 per 3U</a:t>
-            </a:r>
-          </a:p>
-        </p:txBody>
-      </p:sp>
-      <p:sp>
-        <p:nvSpPr>
-          <p:cNvPr id="13" name="Rectangle 12"/>
-          <p:cNvSpPr/>
-          <p:nvPr/>
-        </p:nvSpPr>
-        <p:spPr>
-          <a:xfrm>
-            <a:off x="3200400" y="2770632"/>
-            <a:ext cx="6309360" cy="438912"/>
-          </a:xfrm>
-          <a:prstGeom prst="rect">
-            <a:avLst/>
-          </a:prstGeom>
-          <a:solidFill>
-            <a:srgbClr val="0096A0"/>
-          </a:solidFill>
-          <a:ln>
-            <a:noFill/>
-          </a:ln>
-        </p:spPr>
-        <p:style>
-          <a:lnRef idx="1">
-            <a:schemeClr val="accent1"/>
-          </a:lnRef>
-          <a:fillRef idx="3">
-            <a:schemeClr val="accent1"/>
-          </a:fillRef>
-          <a:effectRef idx="2">
-            <a:schemeClr val="accent1"/>
-          </a:effectRef>
-          <a:fontRef idx="minor">
-            <a:schemeClr val="lt1"/>
-          </a:fontRef>
-        </p:style>
-        <p:txBody>
-          <a:bodyPr rtlCol="0" anchor="ctr"/>
-          <a:lstStyle/>
-          <a:p>
-            <a:pPr algn="ctr"/>
-          </a:p>
-        </p:txBody>
-      </p:sp>
-      <p:sp>
-        <p:nvSpPr>
-          <p:cNvPr id="14" name="TextBox 13"/>
-          <p:cNvSpPr txBox="1"/>
-          <p:nvPr/>
-        </p:nvSpPr>
-        <p:spPr>
-          <a:xfrm>
-            <a:off x="9491472" y="2761488"/>
-            <a:ext cx="1828800" cy="384048"/>
-          </a:xfrm>
-          <a:prstGeom prst="rect">
-            <a:avLst/>
-          </a:prstGeom>
-          <a:noFill/>
-        </p:spPr>
-        <p:txBody>
-          <a:bodyPr wrap="square" lIns="13716" rIns="13716" tIns="13716" bIns="13716" anchor="t">
-            <a:spAutoFit/>
-          </a:bodyPr>
-          <a:lstStyle/>
-          <a:p>
-            <a:pPr algn="r">
-              <a:defRPr sz="2000" b="1">
-                <a:solidFill>
-                  <a:srgbClr val="0D2035"/>
-                </a:solidFill>
-                <a:latin typeface="Aptos"/>
-              </a:defRPr>
-            </a:pPr>
-            <a:r>
-              <a:t>10.55 kg</a:t>
-            </a:r>
-          </a:p>
-        </p:txBody>
-      </p:sp>
-      <p:sp>
-        <p:nvSpPr>
-          <p:cNvPr id="15" name="TextBox 14"/>
-          <p:cNvSpPr txBox="1"/>
-          <p:nvPr/>
-        </p:nvSpPr>
-        <p:spPr>
-          <a:xfrm>
-            <a:off x="822960" y="3657600"/>
-            <a:ext cx="2514600" cy="411480"/>
-          </a:xfrm>
-          <a:prstGeom prst="rect">
-            <a:avLst/>
-          </a:prstGeom>
-          <a:noFill/>
-        </p:spPr>
-        <p:txBody>
-          <a:bodyPr wrap="square" lIns="13716" rIns="13716" tIns="13716" bIns="13716" anchor="t">
-            <a:spAutoFit/>
-          </a:bodyPr>
-          <a:lstStyle/>
-          <a:p>
-            <a:pPr algn="l">
-              <a:defRPr sz="2100" b="1">
-                <a:solidFill>
-                  <a:srgbClr val="0D2035"/>
-                </a:solidFill>
-                <a:latin typeface="Aptos"/>
-              </a:defRPr>
-            </a:pPr>
-            <a:r>
               <a:t>Spring comparator</a:t>
             </a:r>
           </a:p>
@@ -8510,7 +8512,7 @@
         </p:nvSpPr>
         <p:spPr>
           <a:xfrm>
-            <a:off x="3200400" y="3685032"/>
+            <a:off x="3886200" y="3685032"/>
             <a:ext cx="3584448" cy="438912"/>
           </a:xfrm>
           <a:prstGeom prst="rect">
@@ -8553,8 +8555,8 @@
         </p:nvSpPr>
         <p:spPr>
           <a:xfrm>
-            <a:off x="9491472" y="3675887"/>
-            <a:ext cx="1828800" cy="384048"/>
+            <a:off x="10287000" y="3675887"/>
+            <a:ext cx="1051560" cy="384048"/>
           </a:xfrm>
           <a:prstGeom prst="rect">
             <a:avLst/>

</xml_diff>

<commit_message>
Integrate audited market fit into Gen5 academic review
</commit_message>
<xml_diff>
--- a/university/final_review_2026_10_10/VOLLEY_Final_Review_2026-10-10.pptx
+++ b/university/final_review_2026_10_10/VOLLEY_Final_Review_2026-10-10.pptx
@@ -13877,7 +13877,7 @@
               </a:defRPr>
             </a:pPr>
             <a:r>
-              <a:t>The thesis answers an orbital-delivery trade question</a:t>
+              <a:t>Which missions might value orbital choice?</a:t>
             </a:r>
           </a:p>
         </p:txBody>
@@ -13985,7 +13985,7 @@
               </a:defRPr>
             </a:pPr>
             <a:r>
-              <a:t>Thesis manuscript, Introduction; JAXA J-SSOD; EXOpod documentation</a:t>
+              <a:t>NASA 2026 Small Spacecraft SoA; Planet and Spire filings; local market audit</a:t>
             </a:r>
           </a:p>
         </p:txBody>
@@ -14145,7 +14145,7 @@
               </a:defRPr>
             </a:pPr>
             <a:r>
-              <a:t>Shared destination</a:t>
+              <a:t>Repeat fleets</a:t>
             </a:r>
           </a:p>
         </p:txBody>
@@ -14181,7 +14181,7 @@
               </a:defRPr>
             </a:pPr>
             <a:r>
-              <a:t>Secondary CubeSats inherit the orbit chosen for the primary customer.</a:t>
+              <a:t>Configurable smallsat families and replenishment exist. That context does not establish demand for VOLLEY.</a:t>
             </a:r>
           </a:p>
         </p:txBody>
@@ -14305,7 +14305,7 @@
               </a:defRPr>
             </a:pPr>
             <a:r>
-              <a:t>Conventional release</a:t>
+              <a:t>Delivery buyer</a:t>
             </a:r>
           </a:p>
         </p:txBody>
@@ -14341,7 +14341,7 @@
               </a:defRPr>
             </a:pPr>
             <a:r>
-              <a:t>Spring deployers provide a small relative impulse. Subsequent orbit or drag differences can produce phasing.</a:t>
+              <a:t>A carrier, rideshare integrator or fleet operator might need several distinct release states from one host.</a:t>
             </a:r>
           </a:p>
         </p:txBody>
@@ -14465,7 +14465,7 @@
               </a:defRPr>
             </a:pPr>
             <a:r>
-              <a:t>VOLLEY question</a:t>
+              <a:t>Gen5 test</a:t>
             </a:r>
           </a:p>
         </p:txBody>
@@ -14501,7 +14501,7 @@
               </a:defRPr>
             </a:pPr>
             <a:r>
-              <a:t>Can commanded release provide useful orbital choice at an acceptable installed cost?</a:t>
+              <a:t>Compare commanded release with springs, host manoeuvres, transport and onboard propulsion on the same mission.</a:t>
             </a:r>
           </a:p>
         </p:txBody>
@@ -14537,7 +14537,7 @@
               </a:defRPr>
             </a:pPr>
             <a:r>
-              <a:t>Study outcome: useful modelled orbital change, but an unfavourable 3U mass trade</a:t>
+              <a:t>No customer is confirmed; modeled Gen5 3U mass fails its preset criterion.</a:t>
             </a:r>
           </a:p>
         </p:txBody>

</xml_diff>

<commit_message>
Publish Gen5 final-year report, review presentation, and native CAD evidence
</commit_message>
<xml_diff>
--- a/university/final_review_2026_10_10/VOLLEY_Final_Review_2026-10-10.pptx
+++ b/university/final_review_2026_10_10/VOLLEY_Final_Review_2026-10-10.pptx
@@ -4822,7 +4822,7 @@
               </a:defRPr>
             </a:pPr>
             <a:r>
-              <a:t>The thesis deliverables are complete and traceable</a:t>
+              <a:t>The current review package is assembled and traceable</a:t>
             </a:r>
           </a:p>
         </p:txBody>
@@ -5482,7 +5482,7 @@
               </a:defRPr>
             </a:pPr>
             <a:r>
-              <a:t>Scope: completed computational thesis; physical qualification belongs to a later development phase.</a:t>
+              <a:t>Scope: fixed computational study with failed design gates; no physical qualification claim.</a:t>
             </a:r>
           </a:p>
         </p:txBody>
@@ -5624,7 +5624,7 @@
               </a:defRPr>
             </a:pPr>
             <a:r>
-              <a:t>Gen5: complete computational system configuration</a:t>
+              <a:t>Gen5: fixed reference geometry, feeder fit still open</a:t>
             </a:r>
           </a:p>
         </p:txBody>
@@ -5879,7 +5879,7 @@
               </a:defRPr>
             </a:pPr>
             <a:r>
-              <a:t>•  Pulse bank, restraint and eddy-current arrest</a:t>
+              <a:t>•  FreeCAD STEP assembly: side-fed placement clashes</a:t>
             </a:r>
           </a:p>
         </p:txBody>
@@ -7421,7 +7421,7 @@
               </a:defRPr>
             </a:pPr>
             <a:r>
-              <a:t>Commanded velocity can change orbital energy</a:t>
+              <a:t>Rated orbit geometry now has a separate numerical check</a:t>
             </a:r>
           </a:p>
         </p:txBody>
@@ -7493,7 +7493,7 @@
               </a:defRPr>
             </a:pPr>
             <a:r>
-              <a:t>GEN5 MODEL PREDICTION</a:t>
+              <a:t>GEN5 TWO-BODY CHECK</a:t>
             </a:r>
           </a:p>
         </p:txBody>
@@ -7529,7 +7529,7 @@
               </a:defRPr>
             </a:pPr>
             <a:r>
-              <a:t>Thesis manuscript, Astrodynamic Utility and Limitations; F04_life.png</a:t>
+              <a:t>P115 Cartesian orbit check; manuscript Astrodynamic Utility</a:t>
             </a:r>
           </a:p>
         </p:txBody>
@@ -7572,7 +7572,7 @@
       </p:sp>
       <p:pic>
         <p:nvPicPr>
-          <p:cNvPr id="9" name="Picture 8" descr="F04_life.png"/>
+          <p:cNvPr id="9" name="Picture 8" descr="rated_orbit_crosscheck.png"/>
           <p:cNvPicPr>
             <a:picLocks noChangeAspect="1"/>
           </p:cNvPicPr>
@@ -7586,8 +7586,8 @@
         </p:blipFill>
         <p:spPr>
           <a:xfrm>
-            <a:off x="595536" y="1645920"/>
-            <a:ext cx="6937942" cy="4270248"/>
+            <a:off x="566927" y="2018018"/>
+            <a:ext cx="6995160" cy="3526051"/>
           </a:xfrm>
           <a:prstGeom prst="rect">
             <a:avLst/>
@@ -7705,7 +7705,7 @@
           <a:lstStyle/>
           <a:p>
             <a:pPr algn="l">
-              <a:defRPr sz="2700" b="1">
+              <a:defRPr sz="2500" b="1">
                 <a:solidFill>
                   <a:srgbClr val="0D2035"/>
                 </a:solidFill>
@@ -7713,7 +7713,7 @@
               </a:defRPr>
             </a:pPr>
             <a:r>
-              <a:t>+28.8 km</a:t>
+              <a:t>+28.8008 km</a:t>
             </a:r>
           </a:p>
         </p:txBody>
@@ -7749,7 +7749,7 @@
               </a:defRPr>
             </a:pPr>
             <a:r>
-              <a:t>Predicted semi-major-axis rise for one maximum-velocity release.</a:t>
+              <a:t>Immediate two-body axis rise at the rated 16.029 m/s input.</a:t>
             </a:r>
           </a:p>
         </p:txBody>
@@ -7865,7 +7865,7 @@
           <a:lstStyle/>
           <a:p>
             <a:pPr algn="l">
-              <a:defRPr sz="2700" b="1">
+              <a:defRPr sz="2200" b="1">
                 <a:solidFill>
                   <a:srgbClr val="0D2035"/>
                 </a:solidFill>
@@ -7873,7 +7873,7 @@
               </a:defRPr>
             </a:pPr>
             <a:r>
-              <a:t>1.60×</a:t>
+              <a:t>1.60× open</a:t>
             </a:r>
           </a:p>
         </p:txBody>
@@ -7909,7 +7909,7 @@
               </a:defRPr>
             </a:pPr>
             <a:r>
-              <a:t>Predicted lifetime at stated mean solar activity; atmosphere-dependent.</a:t>
+              <a:t>Lifetime remains atmosphere-dependent without a current rated independent rerun.</a:t>
             </a:r>
           </a:p>
         </p:txBody>
@@ -8799,7 +8799,7 @@
               </a:defRPr>
             </a:pPr>
             <a:r>
-              <a:t>The study ends with a clear engineering decision</a:t>
+              <a:t>The current side-fed assembly fails a geometric fit check</a:t>
             </a:r>
           </a:p>
         </p:txBody>
@@ -8871,7 +8871,7 @@
               </a:defRPr>
             </a:pPr>
             <a:r>
-              <a:t>EVIDENCE BOUNDARY</a:t>
+              <a:t>CAD INTERFERENCE • OPEN</a:t>
             </a:r>
           </a:p>
         </p:txBody>
@@ -8907,7 +8907,7 @@
               </a:defRPr>
             </a:pPr>
             <a:r>
-              <a:t>Thesis OPEN_PROBLEMS.md; PROVENANCE.md; manuscript Limitations</a:t>
+              <a:t>FreeCAD Gen5 Review.FCStd; P116 assembly packaging report</a:t>
             </a:r>
           </a:p>
         </p:txBody>
@@ -8948,16 +8948,40 @@
           </a:p>
         </p:txBody>
       </p:sp>
-      <p:sp>
-        <p:nvSpPr>
-          <p:cNvPr id="9" name="Rounded Rectangle 8"/>
+      <p:pic>
+        <p:nvPicPr>
+          <p:cNvPr id="9" name="Picture 8" descr="gen5_packaging_section.png"/>
+          <p:cNvPicPr>
+            <a:picLocks noChangeAspect="1"/>
+          </p:cNvPicPr>
+          <p:nvPr/>
+        </p:nvPicPr>
+        <p:blipFill>
+          <a:blip r:embed="rId2"/>
+          <a:stretch>
+            <a:fillRect/>
+          </a:stretch>
+        </p:blipFill>
+        <p:spPr>
+          <a:xfrm>
+            <a:off x="1826699" y="1627632"/>
+            <a:ext cx="3323473" cy="4498848"/>
+          </a:xfrm>
+          <a:prstGeom prst="rect">
+            <a:avLst/>
+          </a:prstGeom>
+        </p:spPr>
+      </p:pic>
+      <p:sp>
+        <p:nvSpPr>
+          <p:cNvPr id="10" name="Rounded Rectangle 9"/>
           <p:cNvSpPr/>
           <p:nvPr/>
         </p:nvSpPr>
         <p:spPr>
           <a:xfrm>
-            <a:off x="621792" y="1673352"/>
-            <a:ext cx="3520440" cy="3200400"/>
+            <a:off x="6601968" y="1755648"/>
+            <a:ext cx="4709160" cy="1691640"/>
           </a:xfrm>
           <a:prstGeom prst="roundRect">
             <a:avLst/>
@@ -8995,20 +9019,20 @@
       </p:sp>
       <p:sp>
         <p:nvSpPr>
-          <p:cNvPr id="10" name="Rectangle 9"/>
+          <p:cNvPr id="11" name="Rectangle 10"/>
           <p:cNvSpPr/>
           <p:nvPr/>
         </p:nvSpPr>
         <p:spPr>
           <a:xfrm>
-            <a:off x="621792" y="1673352"/>
-            <a:ext cx="73152" cy="3200400"/>
+            <a:off x="6601968" y="1755648"/>
+            <a:ext cx="73152" cy="1691640"/>
           </a:xfrm>
           <a:prstGeom prst="rect">
             <a:avLst/>
           </a:prstGeom>
           <a:solidFill>
-            <a:srgbClr val="0096A0"/>
+            <a:srgbClr val="B94141"/>
           </a:solidFill>
           <a:ln>
             <a:noFill/>
@@ -9038,14 +9062,14 @@
       </p:sp>
       <p:sp>
         <p:nvSpPr>
-          <p:cNvPr id="11" name="TextBox 10"/>
-          <p:cNvSpPr txBox="1"/>
-          <p:nvPr/>
-        </p:nvSpPr>
-        <p:spPr>
-          <a:xfrm>
-            <a:off x="832104" y="1819656"/>
-            <a:ext cx="3154680" cy="502920"/>
+          <p:cNvPr id="12" name="TextBox 11"/>
+          <p:cNvSpPr txBox="1"/>
+          <p:nvPr/>
+        </p:nvSpPr>
+        <p:spPr>
+          <a:xfrm>
+            <a:off x="6812280" y="1901952"/>
+            <a:ext cx="4343400" cy="502920"/>
           </a:xfrm>
           <a:prstGeom prst="rect">
             <a:avLst/>
@@ -9059,7 +9083,7 @@
           <a:lstStyle/>
           <a:p>
             <a:pPr algn="l">
-              <a:defRPr sz="2000" b="1">
+              <a:defRPr sz="2500" b="1">
                 <a:solidFill>
                   <a:srgbClr val="0D2035"/>
                 </a:solidFill>
@@ -9067,21 +9091,21 @@
               </a:defRPr>
             </a:pPr>
             <a:r>
-              <a:t>Supported</a:t>
-            </a:r>
-          </a:p>
-        </p:txBody>
-      </p:sp>
-      <p:sp>
-        <p:nvSpPr>
-          <p:cNvPr id="12" name="TextBox 11"/>
-          <p:cNvSpPr txBox="1"/>
-          <p:nvPr/>
-        </p:nvSpPr>
-        <p:spPr>
-          <a:xfrm>
-            <a:off x="832104" y="2423160"/>
-            <a:ext cx="3136392" cy="2286000"/>
+              <a:t>11 mm short</a:t>
+            </a:r>
+          </a:p>
+        </p:txBody>
+      </p:sp>
+      <p:sp>
+        <p:nvSpPr>
+          <p:cNvPr id="13" name="TextBox 12"/>
+          <p:cNvSpPr txBox="1"/>
+          <p:nvPr/>
+        </p:nvSpPr>
+        <p:spPr>
+          <a:xfrm>
+            <a:off x="6812280" y="2505456"/>
+            <a:ext cx="4325112" cy="777240"/>
           </a:xfrm>
           <a:prstGeom prst="rect">
             <a:avLst/>
@@ -9095,7 +9119,7 @@
           <a:lstStyle/>
           <a:p>
             <a:pPr algn="l">
-              <a:defRPr sz="1800" b="0">
+              <a:defRPr sz="1500" b="0">
                 <a:solidFill>
                   <a:srgbClr val="1E3144"/>
                 </a:solidFill>
@@ -9103,21 +9127,21 @@
               </a:defRPr>
             </a:pPr>
             <a:r>
-              <a:t>Modelled commandable release and a conditional orbital-energy benefit.</a:t>
-            </a:r>
-          </a:p>
-        </p:txBody>
-      </p:sp>
-      <p:sp>
-        <p:nvSpPr>
-          <p:cNvPr id="13" name="Rounded Rectangle 12"/>
+              <a:t>537 mm of track and cassette width inside 526 mm of usable enclosure width.</a:t>
+            </a:r>
+          </a:p>
+        </p:txBody>
+      </p:sp>
+      <p:sp>
+        <p:nvSpPr>
+          <p:cNvPr id="14" name="Rounded Rectangle 13"/>
           <p:cNvSpPr/>
           <p:nvPr/>
         </p:nvSpPr>
         <p:spPr>
           <a:xfrm>
-            <a:off x="4334256" y="1673352"/>
-            <a:ext cx="3520440" cy="3200400"/>
+            <a:off x="6601968" y="3675887"/>
+            <a:ext cx="4709160" cy="1691640"/>
           </a:xfrm>
           <a:prstGeom prst="roundRect">
             <a:avLst/>
@@ -9155,174 +9179,14 @@
       </p:sp>
       <p:sp>
         <p:nvSpPr>
-          <p:cNvPr id="14" name="Rectangle 13"/>
+          <p:cNvPr id="15" name="Rectangle 14"/>
           <p:cNvSpPr/>
           <p:nvPr/>
         </p:nvSpPr>
         <p:spPr>
           <a:xfrm>
-            <a:off x="4334256" y="1673352"/>
-            <a:ext cx="73152" cy="3200400"/>
-          </a:xfrm>
-          <a:prstGeom prst="rect">
-            <a:avLst/>
-          </a:prstGeom>
-          <a:solidFill>
-            <a:srgbClr val="B94141"/>
-          </a:solidFill>
-          <a:ln>
-            <a:noFill/>
-          </a:ln>
-        </p:spPr>
-        <p:style>
-          <a:lnRef idx="1">
-            <a:schemeClr val="accent1"/>
-          </a:lnRef>
-          <a:fillRef idx="3">
-            <a:schemeClr val="accent1"/>
-          </a:fillRef>
-          <a:effectRef idx="2">
-            <a:schemeClr val="accent1"/>
-          </a:effectRef>
-          <a:fontRef idx="minor">
-            <a:schemeClr val="lt1"/>
-          </a:fontRef>
-        </p:style>
-        <p:txBody>
-          <a:bodyPr rtlCol="0" anchor="ctr"/>
-          <a:lstStyle/>
-          <a:p>
-            <a:pPr algn="ctr"/>
-          </a:p>
-        </p:txBody>
-      </p:sp>
-      <p:sp>
-        <p:nvSpPr>
-          <p:cNvPr id="15" name="TextBox 14"/>
-          <p:cNvSpPr txBox="1"/>
-          <p:nvPr/>
-        </p:nvSpPr>
-        <p:spPr>
-          <a:xfrm>
-            <a:off x="4544568" y="1819656"/>
-            <a:ext cx="3154680" cy="502920"/>
-          </a:xfrm>
-          <a:prstGeom prst="rect">
-            <a:avLst/>
-          </a:prstGeom>
-          <a:noFill/>
-        </p:spPr>
-        <p:txBody>
-          <a:bodyPr wrap="square" lIns="13716" rIns="13716" tIns="13716" bIns="13716" anchor="t">
-            <a:spAutoFit/>
-          </a:bodyPr>
-          <a:lstStyle/>
-          <a:p>
-            <a:pPr algn="l">
-              <a:defRPr sz="2000" b="1">
-                <a:solidFill>
-                  <a:srgbClr val="0D2035"/>
-                </a:solidFill>
-                <a:latin typeface="Aptos"/>
-              </a:defRPr>
-            </a:pPr>
-            <a:r>
-              <a:t>Rejected for 3U</a:t>
-            </a:r>
-          </a:p>
-        </p:txBody>
-      </p:sp>
-      <p:sp>
-        <p:nvSpPr>
-          <p:cNvPr id="16" name="TextBox 15"/>
-          <p:cNvSpPr txBox="1"/>
-          <p:nvPr/>
-        </p:nvSpPr>
-        <p:spPr>
-          <a:xfrm>
-            <a:off x="4544568" y="2423160"/>
-            <a:ext cx="3136392" cy="2286000"/>
-          </a:xfrm>
-          <a:prstGeom prst="rect">
-            <a:avLst/>
-          </a:prstGeom>
-          <a:noFill/>
-        </p:spPr>
-        <p:txBody>
-          <a:bodyPr wrap="square" lIns="13716" rIns="13716" tIns="13716" bIns="13716" anchor="t">
-            <a:spAutoFit/>
-          </a:bodyPr>
-          <a:lstStyle/>
-          <a:p>
-            <a:pPr algn="l">
-              <a:defRPr sz="1800" b="0">
-                <a:solidFill>
-                  <a:srgbClr val="1E3144"/>
-                </a:solidFill>
-                <a:latin typeface="Aptos"/>
-              </a:defRPr>
-            </a:pPr>
-            <a:r>
-              <a:t>The complete Gen5 configuration misses the preset spring-mass parity target.</a:t>
-            </a:r>
-          </a:p>
-        </p:txBody>
-      </p:sp>
-      <p:sp>
-        <p:nvSpPr>
-          <p:cNvPr id="17" name="Rounded Rectangle 16"/>
-          <p:cNvSpPr/>
-          <p:nvPr/>
-        </p:nvSpPr>
-        <p:spPr>
-          <a:xfrm>
-            <a:off x="8046720" y="1673352"/>
-            <a:ext cx="3520440" cy="3200400"/>
-          </a:xfrm>
-          <a:prstGeom prst="roundRect">
-            <a:avLst/>
-          </a:prstGeom>
-          <a:solidFill>
-            <a:srgbClr val="F6F9FB"/>
-          </a:solidFill>
-          <a:ln>
-            <a:solidFill>
-              <a:srgbClr val="DDE7EC"/>
-            </a:solidFill>
-          </a:ln>
-        </p:spPr>
-        <p:style>
-          <a:lnRef idx="1">
-            <a:schemeClr val="accent1"/>
-          </a:lnRef>
-          <a:fillRef idx="3">
-            <a:schemeClr val="accent1"/>
-          </a:fillRef>
-          <a:effectRef idx="2">
-            <a:schemeClr val="accent1"/>
-          </a:effectRef>
-          <a:fontRef idx="minor">
-            <a:schemeClr val="lt1"/>
-          </a:fontRef>
-        </p:style>
-        <p:txBody>
-          <a:bodyPr rtlCol="0" anchor="ctr"/>
-          <a:lstStyle/>
-          <a:p>
-            <a:pPr algn="ctr"/>
-          </a:p>
-        </p:txBody>
-      </p:sp>
-      <p:sp>
-        <p:nvSpPr>
-          <p:cNvPr id="18" name="Rectangle 17"/>
-          <p:cNvSpPr/>
-          <p:nvPr/>
-        </p:nvSpPr>
-        <p:spPr>
-          <a:xfrm>
-            <a:off x="8046720" y="1673352"/>
-            <a:ext cx="73152" cy="3200400"/>
+            <a:off x="6601968" y="3675887"/>
+            <a:ext cx="73152" cy="1691640"/>
           </a:xfrm>
           <a:prstGeom prst="rect">
             <a:avLst/>
@@ -9358,14 +9222,14 @@
       </p:sp>
       <p:sp>
         <p:nvSpPr>
-          <p:cNvPr id="19" name="TextBox 18"/>
-          <p:cNvSpPr txBox="1"/>
-          <p:nvPr/>
-        </p:nvSpPr>
-        <p:spPr>
-          <a:xfrm>
-            <a:off x="8257032" y="1819656"/>
-            <a:ext cx="3154680" cy="502920"/>
+          <p:cNvPr id="16" name="TextBox 15"/>
+          <p:cNvSpPr txBox="1"/>
+          <p:nvPr/>
+        </p:nvSpPr>
+        <p:spPr>
+          <a:xfrm>
+            <a:off x="6812280" y="3822191"/>
+            <a:ext cx="4343400" cy="502920"/>
           </a:xfrm>
           <a:prstGeom prst="rect">
             <a:avLst/>
@@ -9379,7 +9243,7 @@
           <a:lstStyle/>
           <a:p>
             <a:pPr algn="l">
-              <a:defRPr sz="2000" b="1">
+              <a:defRPr sz="2300" b="1">
                 <a:solidFill>
                   <a:srgbClr val="0D2035"/>
                 </a:solidFill>
@@ -9387,21 +9251,21 @@
               </a:defRPr>
             </a:pPr>
             <a:r>
-              <a:t>Unverified</a:t>
-            </a:r>
-          </a:p>
-        </p:txBody>
-      </p:sp>
-      <p:sp>
-        <p:nvSpPr>
-          <p:cNvPr id="20" name="TextBox 19"/>
-          <p:cNvSpPr txBox="1"/>
-          <p:nvPr/>
-        </p:nvSpPr>
-        <p:spPr>
-          <a:xfrm>
-            <a:off x="8257032" y="2423160"/>
-            <a:ext cx="3136392" cy="2286000"/>
+              <a:t>32,915 mm³</a:t>
+            </a:r>
+          </a:p>
+        </p:txBody>
+      </p:sp>
+      <p:sp>
+        <p:nvSpPr>
+          <p:cNvPr id="17" name="TextBox 16"/>
+          <p:cNvSpPr txBox="1"/>
+          <p:nvPr/>
+        </p:nvSpPr>
+        <p:spPr>
+          <a:xfrm>
+            <a:off x="6812280" y="4425696"/>
+            <a:ext cx="4325112" cy="777240"/>
           </a:xfrm>
           <a:prstGeom prst="rect">
             <a:avLst/>
@@ -9415,7 +9279,7 @@
           <a:lstStyle/>
           <a:p>
             <a:pPr algn="l">
-              <a:defRPr sz="1800" b="0">
+              <a:defRPr sz="1500" b="0">
                 <a:solidFill>
                   <a:srgbClr val="1E3144"/>
                 </a:solidFill>
@@ -9423,21 +9287,21 @@
               </a:defRPr>
             </a:pPr>
             <a:r>
-              <a:t>Payload loads, magnetic cleanliness, cycle life and host interfaces require tests.</a:t>
-            </a:r>
-          </a:p>
-        </p:txBody>
-      </p:sp>
-      <p:sp>
-        <p:nvSpPr>
-          <p:cNvPr id="21" name="TextBox 20"/>
-          <p:cNvSpPr txBox="1"/>
-          <p:nvPr/>
-        </p:nvSpPr>
-        <p:spPr>
-          <a:xfrm>
-            <a:off x="777240" y="5340096"/>
-            <a:ext cx="10698480" cy="658368"/>
+              <a:t>Exact track/cassette clash on each side; CadQuery and FreeCAD agree.</a:t>
+            </a:r>
+          </a:p>
+        </p:txBody>
+      </p:sp>
+      <p:sp>
+        <p:nvSpPr>
+          <p:cNvPr id="18" name="TextBox 17"/>
+          <p:cNvSpPr txBox="1"/>
+          <p:nvPr/>
+        </p:nvSpPr>
+        <p:spPr>
+          <a:xfrm>
+            <a:off x="804672" y="6025896"/>
+            <a:ext cx="10561320" cy="274320"/>
           </a:xfrm>
           <a:prstGeom prst="rect">
             <a:avLst/>
@@ -9451,7 +9315,7 @@
           <a:lstStyle/>
           <a:p>
             <a:pPr algn="ctr">
-              <a:defRPr sz="2100" b="1">
+              <a:defRPr sz="1400" b="1">
                 <a:solidFill>
                   <a:srgbClr val="0D2035"/>
                 </a:solidFill>
@@ -9459,7 +9323,7 @@
               </a:defRPr>
             </a:pPr>
             <a:r>
-              <a:t>Decision: retain the numerically checked model; do not select Gen5 as a 3U flight configuration.</a:t>
+              <a:t>Reference placement only: a new feeder or enclosure would need a new configuration and rerun.</a:t>
             </a:r>
           </a:p>
         </p:txBody>
@@ -9934,7 +9798,7 @@
       </p:pic>
       <p:pic>
         <p:nvPicPr>
-          <p:cNvPr id="14" name="Picture 13" descr="F04_life.png"/>
+          <p:cNvPr id="14" name="Picture 13" descr="rated_orbit_crosscheck.png"/>
           <p:cNvPicPr>
             <a:picLocks noChangeAspect="1"/>
           </p:cNvPicPr>
@@ -9948,8 +9812,8 @@
         </p:blipFill>
         <p:spPr>
           <a:xfrm>
-            <a:off x="6620670" y="2286000"/>
-            <a:ext cx="4754050" cy="2926080"/>
+            <a:off x="6528816" y="2504551"/>
+            <a:ext cx="4937760" cy="2488977"/>
           </a:xfrm>
           <a:prstGeom prst="rect">
             <a:avLst/>
@@ -10364,7 +10228,7 @@
               </a:defRPr>
             </a:pPr>
             <a:r>
-              <a:t>•  The complete modelled system is 76% heavier per 3U customer than the spring comparator.</a:t>
+              <a:t>•  The model is 76% heavier per 3U customer and the side-fed CAD reference also clashes.</a:t>
             </a:r>
           </a:p>
           <a:p>

</xml_diff>

<commit_message>
Publish audited Gen5 thesis review pack and computational evidence
</commit_message>
<xml_diff>
--- a/university/final_review_2026_10_10/VOLLEY_Final_Review_2026-10-10.pptx
+++ b/university/final_review_2026_10_10/VOLLEY_Final_Review_2026-10-10.pptx
@@ -6129,7 +6129,7 @@
               </a:defRPr>
             </a:pPr>
             <a:r>
-              <a:t>Thesis BASELINE.md; F01_shot.png</a:t>
+              <a:t>Thesis BASELINE.md; F01_shot.png; P117 energy audit</a:t>
             </a:r>
           </a:p>
         </p:txBody>
@@ -6650,6 +6650,42 @@
             </a:pPr>
             <a:r>
               <a:t>net efficiency</a:t>
+            </a:r>
+          </a:p>
+        </p:txBody>
+      </p:sp>
+      <p:sp>
+        <p:nvSpPr>
+          <p:cNvPr id="22" name="TextBox 21"/>
+          <p:cNvSpPr txBox="1"/>
+          <p:nvPr/>
+        </p:nvSpPr>
+        <p:spPr>
+          <a:xfrm>
+            <a:off x="777240" y="6080760"/>
+            <a:ext cx="10881360" cy="256032"/>
+          </a:xfrm>
+          <a:prstGeom prst="rect">
+            <a:avLst/>
+          </a:prstGeom>
+          <a:noFill/>
+        </p:spPr>
+        <p:txBody>
+          <a:bodyPr wrap="square" lIns="13716" rIns="13716" tIns="13716" bIns="13716" anchor="t">
+            <a:spAutoFit/>
+          </a:bodyPr>
+          <a:lstStyle/>
+          <a:p>
+            <a:pPr algn="l">
+              <a:defRPr sz="1300" b="0">
+                <a:solidFill>
+                  <a:srgbClr val="637684"/>
+                </a:solidFill>
+                <a:latin typeface="Aptos"/>
+              </a:defRPr>
+            </a:pPr>
+            <a:r>
+              <a:t>Audit boundary: 124.5 J (4.47%) of gross draw is not itemized in the compact result ledger.</a:t>
             </a:r>
           </a:p>
         </p:txBody>

</xml_diff>

<commit_message>
Prepare honest Gen5 final-review presentation and offline pack
</commit_message>
<xml_diff>
--- a/university/final_review_2026_10_10/VOLLEY_Final_Review_2026-10-10.pptx
+++ b/university/final_review_2026_10_10/VOLLEY_Final_Review_2026-10-10.pptx
@@ -3331,7 +3331,7 @@
               </a:defRPr>
             </a:pPr>
             <a:r>
-              <a:t>Completed Gen5 system-level computational evaluation</a:t>
+              <a:t>Gen5 computational feasibility review</a:t>
             </a:r>
           </a:p>
         </p:txBody>
@@ -3749,7 +3749,7 @@
               </a:defRPr>
             </a:pPr>
             <a:r>
-              <a:t>2026 findings were incorporated in the final baseline</a:t>
+              <a:t>2026 findings changed the review baseline</a:t>
             </a:r>
           </a:p>
         </p:txBody>
@@ -5093,7 +5093,7 @@
               </a:defRPr>
             </a:pPr>
             <a:r>
-              <a:t>Design delivered</a:t>
+              <a:t>Design documented</a:t>
             </a:r>
           </a:p>
         </p:txBody>
@@ -5129,7 +5129,7 @@
               </a:defRPr>
             </a:pPr>
             <a:r>
-              <a:t>Gen5 CAD, magazine and release architecture, subsystem models and system mass rollup.</a:t>
+              <a:t>Gen5 reference CAD, magazine and release concepts, subsystem models and system mass rollup.</a:t>
             </a:r>
           </a:p>
         </p:txBody>
@@ -5834,7 +5834,7 @@
               </a:defRPr>
             </a:pPr>
             <a:r>
-              <a:t>•  1.5 m linear-motor track and double-sided Halbach arrays</a:t>
+              <a:t>•  1.3 m powered stroke; 1.5 m release station</a:t>
             </a:r>
           </a:p>
           <a:p>
@@ -11991,7 +11991,7 @@
               </a:defRPr>
             </a:pPr>
             <a:r>
-              <a:t>Computational demonstration: from shot to orbit</a:t>
+              <a:t>Computational demonstration: from force to mission decision</a:t>
             </a:r>
           </a:p>
         </p:txBody>
@@ -12099,7 +12099,7 @@
               </a:defRPr>
             </a:pPr>
             <a:r>
-              <a:t>Thesis analysis/results; BASELINE.md; manuscript Astrodynamic Utility</a:t>
+              <a:t>P118 finite-force run; matched-mission reference; thesis analysis/results</a:t>
             </a:r>
           </a:p>
         </p:txBody>
@@ -12257,7 +12257,7 @@
               </a:defRPr>
             </a:pPr>
             <a:r>
-              <a:t>1. Simulate a 3U shot → 16.0 m/s</a:t>
+              <a:t>1. Finite-force geometry screen</a:t>
             </a:r>
           </a:p>
         </p:txBody>
@@ -12293,14 +12293,14 @@
               </a:defRPr>
             </a:pPr>
             <a:r>
-              <a:t>2. Model the orbital response</a:t>
+              <a:t>2. Matched mission screen</a:t>
             </a:r>
           </a:p>
         </p:txBody>
       </p:sp>
       <p:pic>
         <p:nvPicPr>
-          <p:cNvPr id="13" name="Picture 12" descr="F01_shot.png"/>
+          <p:cNvPr id="13" name="Picture 12" descr="gen5_finite_force_map.png"/>
           <p:cNvPicPr>
             <a:picLocks noChangeAspect="1"/>
           </p:cNvPicPr>
@@ -12314,8 +12314,8 @@
         </p:blipFill>
         <p:spPr>
           <a:xfrm>
-            <a:off x="713232" y="2806692"/>
-            <a:ext cx="4956048" cy="1884694"/>
+            <a:off x="713232" y="2482494"/>
+            <a:ext cx="4956048" cy="2533091"/>
           </a:xfrm>
           <a:prstGeom prst="rect">
             <a:avLst/>
@@ -12324,7 +12324,7 @@
       </p:pic>
       <p:pic>
         <p:nvPicPr>
-          <p:cNvPr id="14" name="Picture 13" descr="rated_orbit_crosscheck.png"/>
+          <p:cNvPr id="14" name="Picture 13" descr="matched_mission_reference.png"/>
           <p:cNvPicPr>
             <a:picLocks noChangeAspect="1"/>
           </p:cNvPicPr>
@@ -12338,8 +12338,8 @@
         </p:blipFill>
         <p:spPr>
           <a:xfrm>
-            <a:off x="6528816" y="2504551"/>
-            <a:ext cx="4937760" cy="2488977"/>
+            <a:off x="6528816" y="2712110"/>
+            <a:ext cx="4937760" cy="2073859"/>
           </a:xfrm>
           <a:prstGeom prst="rect">
             <a:avLst/>
@@ -12413,7 +12413,7 @@
               </a:defRPr>
             </a:pPr>
             <a:r>
-              <a:t>Compare predicted orbital change and full installed mass with the spring baseline. Simulation, not physical demonstration.</a:t>
+              <a:t>P118 challenges the shot; compare finite-force, installed mass and matched mission before any performance claim.</a:t>
             </a:r>
           </a:p>
         </p:txBody>
@@ -12883,7 +12883,7 @@
               </a:defRPr>
             </a:pPr>
             <a:r>
-              <a:t>Ideal host propellant for one matched inertial target: spring versus finite Gen5.</a:t>
+              <a:t>Ideal one-event host propellant: spring versus Gen5's ideal finite-force upper screen.</a:t>
             </a:r>
           </a:p>
         </p:txBody>
@@ -13221,7 +13221,7 @@
               </a:defRPr>
             </a:pPr>
             <a:r>
-              <a:t>The research question has a completed answer</a:t>
+              <a:t>This Gen5 configuration does not pass selection</a:t>
             </a:r>
           </a:p>
         </p:txBody>
@@ -19224,7 +19224,7 @@
               </a:defRPr>
             </a:pPr>
             <a:r>
-              <a:t>Gen5 CAD and complete subsystem architecture documented</a:t>
+              <a:t>Reference CAD and subsystem concepts documented; feed remains open</a:t>
             </a:r>
           </a:p>
         </p:txBody>
@@ -19386,7 +19386,7 @@
               </a:defRPr>
             </a:pPr>
             <a:r>
-              <a:t>Rated shot, power and dispersion models completed</a:t>
+              <a:t>Historical model completed; finite force screen challenges its rating</a:t>
             </a:r>
           </a:p>
         </p:txBody>
@@ -19548,7 +19548,7 @@
               </a:defRPr>
             </a:pPr>
             <a:r>
-              <a:t>Predicted energy and lifetime benefit for stated cases</a:t>
+              <a:t>Conditional orbit results; current lifetime not independently closed</a:t>
             </a:r>
           </a:p>
         </p:txBody>
@@ -20014,7 +20014,7 @@
               </a:defRPr>
             </a:pPr>
             <a:r>
-              <a:t>A completed analysis chain from mission to decision</a:t>
+              <a:t>The analysis chain from mission to decision</a:t>
             </a:r>
           </a:p>
         </p:txBody>
@@ -21069,7 +21069,7 @@
               </a:defRPr>
             </a:pPr>
             <a:r>
-              <a:t>Numerical checks strengthened the final baseline</a:t>
+              <a:t>Numerical checks changed the review baseline</a:t>
             </a:r>
           </a:p>
         </p:txBody>
@@ -21612,7 +21612,7 @@
               </a:defRPr>
             </a:pPr>
             <a:r>
-              <a:t>Analytic winding; magpylib; FEM</a:t>
+              <a:t>Analytic field; field-point FEM; finite force screen</a:t>
             </a:r>
           </a:p>
         </p:txBody>
@@ -21693,7 +21693,7 @@
               </a:defRPr>
             </a:pPr>
             <a:r>
-              <a:t>No measured thrust constant</a:t>
+              <a:t>No independent integrated-thrust FEM or measurement</a:t>
             </a:r>
           </a:p>
         </p:txBody>

</xml_diff>

<commit_message>
Correct thesis presentation evidence and rebuild review pack
</commit_message>
<xml_diff>
--- a/university/final_review_2026_10_10/VOLLEY_Final_Review_2026-10-10.pptx
+++ b/university/final_review_2026_10_10/VOLLEY_Final_Review_2026-10-10.pptx
@@ -4209,7 +4209,7 @@
               </a:defRPr>
             </a:pPr>
             <a:r>
-              <a:t>Depth-resolved thrust calculation lowered the rated speed</a:t>
+              <a:t>Depth-resolved thrust calculation lowered the historical model speed</a:t>
             </a:r>
           </a:p>
         </p:txBody>
@@ -8126,7 +8126,7 @@
               </a:defRPr>
             </a:pPr>
             <a:r>
-              <a:t>Historical rated orbit input has a separate geometry check</a:t>
+              <a:t>Historical orbit input has a separate geometry check</a:t>
             </a:r>
           </a:p>
         </p:txBody>
@@ -8454,7 +8454,7 @@
               </a:defRPr>
             </a:pPr>
             <a:r>
-              <a:t>Immediate two-body axis rise at the rated 16.029 m/s input.</a:t>
+              <a:t>Immediate two-body axis rise for an assumed historical 16.029 m/s input.</a:t>
             </a:r>
           </a:p>
         </p:txBody>
@@ -8614,7 +8614,7 @@
               </a:defRPr>
             </a:pPr>
             <a:r>
-              <a:t>Lifetime remains atmosphere-dependent without a current rated independent rerun.</a:t>
+              <a:t>Lifetime remains atmosphere-dependent and lacks an independent rerun for this input.</a:t>
             </a:r>
           </a:p>
         </p:txBody>

</xml_diff>

<commit_message>
Refresh final-review pack with finite-force cross-checks
</commit_message>
<xml_diff>
--- a/university/final_review_2026_10_10/VOLLEY_Final_Review_2026-10-10.pptx
+++ b/university/final_review_2026_10_10/VOLLEY_Final_Review_2026-10-10.pptx
@@ -6688,7 +6688,7 @@
               </a:defRPr>
             </a:pPr>
             <a:r>
-              <a:t>P118 finite geometry challenges 16.0 m/s; 124.5 J of gross draw is also unitemized.</a:t>
+              <a:t>P118 challenges 16.0 m/s; P117 reconciles 124.5 J to assumed model terms.</a:t>
             </a:r>
           </a:p>
         </p:txBody>
@@ -6830,7 +6830,7 @@
               </a:defRPr>
             </a:pPr>
             <a:r>
-              <a:t>Finite-array force integration changes the speed verdict</a:t>
+              <a:t>Independent 2-D FEM confirms the finite-force decline</a:t>
             </a:r>
           </a:p>
         </p:txBody>
@@ -6902,7 +6902,7 @@
               </a:defRPr>
             </a:pPr>
             <a:r>
-              <a:t>ADVERSE MODEL FINDING</a:t>
+              <a:t>COMPUTATIONAL CROSS-CHECK</a:t>
             </a:r>
           </a:p>
         </p:txBody>
@@ -6938,7 +6938,7 @@
               </a:defRPr>
             </a:pPr>
             <a:r>
-              <a:t>P118 finite 3-D analytic force map and convergence; not independent FEM</a:t>
+              <a:t>P118 3-D analytic; P119 2-D FEM; P120 assumed bank rerun</a:t>
             </a:r>
           </a:p>
         </p:txBody>
@@ -6981,7 +6981,7 @@
       </p:sp>
       <p:pic>
         <p:nvPicPr>
-          <p:cNvPr id="9" name="Picture 8" descr="gen5_finite_force_map.png"/>
+          <p:cNvPr id="9" name="Picture 8" descr="gen5_finite_force_fem2d.png"/>
           <p:cNvPicPr>
             <a:picLocks noChangeAspect="1"/>
           </p:cNvPicPr>
@@ -7114,7 +7114,7 @@
           <a:lstStyle/>
           <a:p>
             <a:pPr algn="l">
-              <a:defRPr sz="2400" b="1">
+              <a:defRPr sz="2000" b="1">
                 <a:solidFill>
                   <a:srgbClr val="0D2035"/>
                 </a:solidFill>
@@ -7122,7 +7122,7 @@
               </a:defRPr>
             </a:pPr>
             <a:r>
-              <a:t>1.042 kJ</a:t>
+              <a:t>1.042 / 1.082 kJ</a:t>
             </a:r>
           </a:p>
         </p:txBody>
@@ -7150,7 +7150,7 @@
           <a:lstStyle/>
           <a:p>
             <a:pPr algn="l">
-              <a:defRPr sz="1600" b="0">
+              <a:defRPr sz="1500" b="0">
                 <a:solidFill>
                   <a:srgbClr val="1E3144"/>
                 </a:solidFill>
@@ -7158,7 +7158,7 @@
               </a:defRPr>
             </a:pPr>
             <a:r>
-              <a:t>Ideal work from the finite 162-belt force map with optimized phase.</a:t>
+              <a:t>Ideal work: 3-D analytic / 2-D FEM. The FEM omits magnet-depth end effects.</a:t>
             </a:r>
           </a:p>
         </p:txBody>
@@ -7282,7 +7282,7 @@
               </a:defRPr>
             </a:pPr>
             <a:r>
-              <a:t>12.448 m/s</a:t>
+              <a:t>2.099 kJ</a:t>
             </a:r>
           </a:p>
         </p:txBody>
@@ -7318,7 +7318,7 @@
               </a:defRPr>
             </a:pPr>
             <a:r>
-              <a:t>Geometry-only speed before circuit and friction losses; historical model reports 16.029 m/s.</a:t>
+              <a:t>P120 gross bank draw with assumed full winding and ideal phase; not a selected rating.</a:t>
             </a:r>
           </a:p>
         </p:txBody>
@@ -7354,7 +7354,7 @@
               </a:defRPr>
             </a:pPr>
             <a:r>
-              <a:t>Array/stator direct overlap ends after 1.066 m, before the 1.300 m powered stroke ends.</a:t>
+              <a:t>Historical 16.029 m/s is challenged; no measured force or selected inverter exists.</a:t>
             </a:r>
           </a:p>
         </p:txBody>
@@ -12099,7 +12099,7 @@
               </a:defRPr>
             </a:pPr>
             <a:r>
-              <a:t>P118 finite-force run; matched-mission reference; thesis analysis/results</a:t>
+              <a:t>P118–P120 finite-force/assumed bank; matched-mission reference</a:t>
             </a:r>
           </a:p>
         </p:txBody>
@@ -12300,7 +12300,7 @@
       </p:sp>
       <p:pic>
         <p:nvPicPr>
-          <p:cNvPr id="13" name="Picture 12" descr="gen5_finite_force_map.png"/>
+          <p:cNvPr id="13" name="Picture 12" descr="gen5_finite_force_fem2d.png"/>
           <p:cNvPicPr>
             <a:picLocks noChangeAspect="1"/>
           </p:cNvPicPr>
@@ -12413,7 +12413,7 @@
               </a:defRPr>
             </a:pPr>
             <a:r>
-              <a:t>P118 challenges the shot; compare finite-force, installed mass and matched mission before any performance claim.</a:t>
+              <a:t>P119 checks force; P120 reruns bank assumptions; no twelve-shot mission case closes.</a:t>
             </a:r>
           </a:p>
         </p:txBody>

</xml_diff>

<commit_message>
Update college review pack with 3-D force cross-check
</commit_message>
<xml_diff>
--- a/university/final_review_2026_10_10/VOLLEY_Final_Review_2026-10-10.pptx
+++ b/university/final_review_2026_10_10/VOLLEY_Final_Review_2026-10-10.pptx
@@ -6830,7 +6830,7 @@
               </a:defRPr>
             </a:pPr>
             <a:r>
-              <a:t>Independent 2-D FEM confirms the finite-force decline</a:t>
+              <a:t>Independent 3-D check confirms ideal finite-force work</a:t>
             </a:r>
           </a:p>
         </p:txBody>
@@ -6938,7 +6938,7 @@
               </a:defRPr>
             </a:pPr>
             <a:r>
-              <a:t>P118 3-D analytic; P119 2-D FEM; P120 assumed bank rerun</a:t>
+              <a:t>P118 analytic; P119 2-D FEM; P121 3-D numerical; P122 gap sensitivity</a:t>
             </a:r>
           </a:p>
         </p:txBody>
@@ -6981,7 +6981,7 @@
       </p:sp>
       <p:pic>
         <p:nvPicPr>
-          <p:cNvPr id="9" name="Picture 8" descr="gen5_finite_force_fem2d.png"/>
+          <p:cNvPr id="9" name="Picture 8" descr="gen5_finite_force_sensitivity.png"/>
           <p:cNvPicPr>
             <a:picLocks noChangeAspect="1"/>
           </p:cNvPicPr>
@@ -6995,8 +6995,8 @@
         </p:blipFill>
         <p:spPr>
           <a:xfrm>
-            <a:off x="502920" y="2007108"/>
-            <a:ext cx="6995160" cy="3575304"/>
+            <a:off x="502920" y="2395728"/>
+            <a:ext cx="6995160" cy="2798064"/>
           </a:xfrm>
           <a:prstGeom prst="rect">
             <a:avLst/>
@@ -7114,7 +7114,7 @@
           <a:lstStyle/>
           <a:p>
             <a:pPr algn="l">
-              <a:defRPr sz="2000" b="1">
+              <a:defRPr sz="2300" b="1">
                 <a:solidFill>
                   <a:srgbClr val="0D2035"/>
                 </a:solidFill>
@@ -7122,7 +7122,7 @@
               </a:defRPr>
             </a:pPr>
             <a:r>
-              <a:t>1.042 / 1.082 kJ</a:t>
+              <a:t>1.042 kJ</a:t>
             </a:r>
           </a:p>
         </p:txBody>
@@ -7158,7 +7158,7 @@
               </a:defRPr>
             </a:pPr>
             <a:r>
-              <a:t>Ideal work: 3-D analytic / 2-D FEM. The FEM omits magnet-depth end effects.</a:t>
+              <a:t>Ideal 3-D work: independent surface-charge formulation agrees with P118 under shared inputs.</a:t>
             </a:r>
           </a:p>
         </p:txBody>
@@ -7282,7 +7282,7 @@
               </a:defRPr>
             </a:pPr>
             <a:r>
-              <a:t>2.099 kJ</a:t>
+              <a:t>−13% work</a:t>
             </a:r>
           </a:p>
         </p:txBody>
@@ -7318,7 +7318,7 @@
               </a:defRPr>
             </a:pPr>
             <a:r>
-              <a:t>P120 gross bank draw with assumed full winding and ideal phase; not a selected rating.</a:t>
+              <a:t>Illustrative 12-to-14 mm magnet gap change; not a measured tolerance or motor rating.</a:t>
             </a:r>
           </a:p>
         </p:txBody>
@@ -7354,7 +7354,7 @@
               </a:defRPr>
             </a:pPr>
             <a:r>
-              <a:t>Historical 16.029 m/s is challenged; no measured force or selected inverter exists.</a:t>
+              <a:t>No measured force, selected inverter or demonstrated release speed exists.</a:t>
             </a:r>
           </a:p>
         </p:txBody>

</xml_diff>

<commit_message>
Integrate STEP renders into thesis and final review deck
</commit_message>
<xml_diff>
--- a/university/final_review_2026_10_10/VOLLEY_Final_Review_2026-10-10.pptx
+++ b/university/final_review_2026_10_10/VOLLEY_Final_Review_2026-10-10.pptx
@@ -4933,7 +4933,7 @@
               </a:defRPr>
             </a:pPr>
             <a:r>
-              <a:t>Thesis README; BASELINE.md; PROVENANCE.md; validation register</a:t>
+              <a:t>Thesis README; validation register; STEP view provenance</a:t>
             </a:r>
           </a:p>
         </p:txBody>
@@ -4974,16 +4974,76 @@
           </a:p>
         </p:txBody>
       </p:sp>
-      <p:sp>
-        <p:nvSpPr>
-          <p:cNvPr id="9" name="Rounded Rectangle 8"/>
+      <p:pic>
+        <p:nvPicPr>
+          <p:cNvPr id="9" name="Picture 8" descr="gen5_reference_closed.jpg"/>
+          <p:cNvPicPr>
+            <a:picLocks noChangeAspect="1"/>
+          </p:cNvPicPr>
+          <p:nvPr/>
+        </p:nvPicPr>
+        <p:blipFill>
+          <a:blip r:embed="rId2"/>
+          <a:stretch>
+            <a:fillRect/>
+          </a:stretch>
+        </p:blipFill>
+        <p:spPr>
+          <a:xfrm>
+            <a:off x="621792" y="2050948"/>
+            <a:ext cx="4983480" cy="2801823"/>
+          </a:xfrm>
+          <a:prstGeom prst="rect">
+            <a:avLst/>
+          </a:prstGeom>
+        </p:spPr>
+      </p:pic>
+      <p:sp>
+        <p:nvSpPr>
+          <p:cNvPr id="10" name="TextBox 9"/>
+          <p:cNvSpPr txBox="1"/>
+          <p:nvPr/>
+        </p:nvSpPr>
+        <p:spPr>
+          <a:xfrm>
+            <a:off x="658368" y="5294376"/>
+            <a:ext cx="4910328" cy="384048"/>
+          </a:xfrm>
+          <a:prstGeom prst="rect">
+            <a:avLst/>
+          </a:prstGeom>
+          <a:noFill/>
+        </p:spPr>
+        <p:txBody>
+          <a:bodyPr wrap="square" lIns="13716" rIns="13716" tIns="13716" bIns="13716" anchor="t">
+            <a:spAutoFit/>
+          </a:bodyPr>
+          <a:lstStyle/>
+          <a:p>
+            <a:pPr algn="ctr">
+              <a:defRPr sz="1300" b="1">
+                <a:solidFill>
+                  <a:srgbClr val="0D2035"/>
+                </a:solidFill>
+                <a:latin typeface="Aptos"/>
+              </a:defRPr>
+            </a:pPr>
+            <a:r>
+              <a:t>FreeCAD-linked STEP envelope; internal interference is concealed.</a:t>
+            </a:r>
+          </a:p>
+        </p:txBody>
+      </p:sp>
+      <p:sp>
+        <p:nvSpPr>
+          <p:cNvPr id="11" name="Rounded Rectangle 10"/>
           <p:cNvSpPr/>
           <p:nvPr/>
         </p:nvSpPr>
         <p:spPr>
           <a:xfrm>
-            <a:off x="640080" y="1709928"/>
-            <a:ext cx="3502152" cy="3547872"/>
+            <a:off x="5797296" y="1673352"/>
+            <a:ext cx="5669280" cy="1664208"/>
           </a:xfrm>
           <a:prstGeom prst="roundRect">
             <a:avLst/>
@@ -5021,14 +5081,14 @@
       </p:sp>
       <p:sp>
         <p:nvSpPr>
-          <p:cNvPr id="10" name="Rectangle 9"/>
+          <p:cNvPr id="12" name="Rectangle 11"/>
           <p:cNvSpPr/>
           <p:nvPr/>
         </p:nvSpPr>
         <p:spPr>
           <a:xfrm>
-            <a:off x="640080" y="1709928"/>
-            <a:ext cx="73152" cy="3547872"/>
+            <a:off x="5797296" y="1673352"/>
+            <a:ext cx="73152" cy="1664208"/>
           </a:xfrm>
           <a:prstGeom prst="rect">
             <a:avLst/>
@@ -5064,14 +5124,14 @@
       </p:sp>
       <p:sp>
         <p:nvSpPr>
-          <p:cNvPr id="11" name="TextBox 10"/>
-          <p:cNvSpPr txBox="1"/>
-          <p:nvPr/>
-        </p:nvSpPr>
-        <p:spPr>
-          <a:xfrm>
-            <a:off x="850392" y="1856232"/>
-            <a:ext cx="3136392" cy="502920"/>
+          <p:cNvPr id="13" name="TextBox 12"/>
+          <p:cNvSpPr txBox="1"/>
+          <p:nvPr/>
+        </p:nvSpPr>
+        <p:spPr>
+          <a:xfrm>
+            <a:off x="6007608" y="1819656"/>
+            <a:ext cx="5303520" cy="502920"/>
           </a:xfrm>
           <a:prstGeom prst="rect">
             <a:avLst/>
@@ -5085,7 +5145,7 @@
           <a:lstStyle/>
           <a:p>
             <a:pPr algn="l">
-              <a:defRPr sz="2200" b="1">
+              <a:defRPr sz="2000" b="1">
                 <a:solidFill>
                   <a:srgbClr val="0D2035"/>
                 </a:solidFill>
@@ -5093,21 +5153,21 @@
               </a:defRPr>
             </a:pPr>
             <a:r>
-              <a:t>Design documented</a:t>
-            </a:r>
-          </a:p>
-        </p:txBody>
-      </p:sp>
-      <p:sp>
-        <p:nvSpPr>
-          <p:cNvPr id="12" name="TextBox 11"/>
-          <p:cNvSpPr txBox="1"/>
-          <p:nvPr/>
-        </p:nvSpPr>
-        <p:spPr>
-          <a:xfrm>
-            <a:off x="850392" y="2459736"/>
-            <a:ext cx="3118104" cy="2633472"/>
+              <a:t>Analysis delivered</a:t>
+            </a:r>
+          </a:p>
+        </p:txBody>
+      </p:sp>
+      <p:sp>
+        <p:nvSpPr>
+          <p:cNvPr id="14" name="TextBox 13"/>
+          <p:cNvSpPr txBox="1"/>
+          <p:nvPr/>
+        </p:nvSpPr>
+        <p:spPr>
+          <a:xfrm>
+            <a:off x="6007608" y="2423160"/>
+            <a:ext cx="5285232" cy="749808"/>
           </a:xfrm>
           <a:prstGeom prst="rect">
             <a:avLst/>
@@ -5121,7 +5181,7 @@
           <a:lstStyle/>
           <a:p>
             <a:pPr algn="l">
-              <a:defRPr sz="1900" b="0">
+              <a:defRPr sz="1600" b="0">
                 <a:solidFill>
                   <a:srgbClr val="1E3144"/>
                 </a:solidFill>
@@ -5129,21 +5189,21 @@
               </a:defRPr>
             </a:pPr>
             <a:r>
-              <a:t>Gen5 reference CAD, magazine and release concepts, subsystem models and system mass rollup.</a:t>
-            </a:r>
-          </a:p>
-        </p:txBody>
-      </p:sp>
-      <p:sp>
-        <p:nvSpPr>
-          <p:cNvPr id="13" name="Rounded Rectangle 12"/>
+              <a:t>Shot, circuit, structural, thermal, orbit and alternative-case models.</a:t>
+            </a:r>
+          </a:p>
+        </p:txBody>
+      </p:sp>
+      <p:sp>
+        <p:nvSpPr>
+          <p:cNvPr id="15" name="Rounded Rectangle 14"/>
           <p:cNvSpPr/>
           <p:nvPr/>
         </p:nvSpPr>
         <p:spPr>
           <a:xfrm>
-            <a:off x="4334256" y="1709928"/>
-            <a:ext cx="3502152" cy="3547872"/>
+            <a:off x="5797296" y="3547872"/>
+            <a:ext cx="5669280" cy="1664208"/>
           </a:xfrm>
           <a:prstGeom prst="roundRect">
             <a:avLst/>
@@ -5181,14 +5241,14 @@
       </p:sp>
       <p:sp>
         <p:nvSpPr>
-          <p:cNvPr id="14" name="Rectangle 13"/>
+          <p:cNvPr id="16" name="Rectangle 15"/>
           <p:cNvSpPr/>
           <p:nvPr/>
         </p:nvSpPr>
         <p:spPr>
           <a:xfrm>
-            <a:off x="4334256" y="1709928"/>
-            <a:ext cx="73152" cy="3547872"/>
+            <a:off x="5797296" y="3547872"/>
+            <a:ext cx="73152" cy="1664208"/>
           </a:xfrm>
           <a:prstGeom prst="rect">
             <a:avLst/>
@@ -5224,14 +5284,14 @@
       </p:sp>
       <p:sp>
         <p:nvSpPr>
-          <p:cNvPr id="15" name="TextBox 14"/>
-          <p:cNvSpPr txBox="1"/>
-          <p:nvPr/>
-        </p:nvSpPr>
-        <p:spPr>
-          <a:xfrm>
-            <a:off x="4544568" y="1856232"/>
-            <a:ext cx="3136392" cy="502920"/>
+          <p:cNvPr id="17" name="TextBox 16"/>
+          <p:cNvSpPr txBox="1"/>
+          <p:nvPr/>
+        </p:nvSpPr>
+        <p:spPr>
+          <a:xfrm>
+            <a:off x="6007608" y="3694176"/>
+            <a:ext cx="5303520" cy="502920"/>
           </a:xfrm>
           <a:prstGeom prst="rect">
             <a:avLst/>
@@ -5245,7 +5305,7 @@
           <a:lstStyle/>
           <a:p>
             <a:pPr algn="l">
-              <a:defRPr sz="2200" b="1">
+              <a:defRPr sz="2000" b="1">
                 <a:solidFill>
                   <a:srgbClr val="0D2035"/>
                 </a:solidFill>
@@ -5253,21 +5313,21 @@
               </a:defRPr>
             </a:pPr>
             <a:r>
-              <a:t>Analysis delivered</a:t>
-            </a:r>
-          </a:p>
-        </p:txBody>
-      </p:sp>
-      <p:sp>
-        <p:nvSpPr>
-          <p:cNvPr id="16" name="TextBox 15"/>
-          <p:cNvSpPr txBox="1"/>
-          <p:nvPr/>
-        </p:nvSpPr>
-        <p:spPr>
-          <a:xfrm>
-            <a:off x="4544568" y="2459736"/>
-            <a:ext cx="3118104" cy="2633472"/>
+              <a:t>Evidence delivered</a:t>
+            </a:r>
+          </a:p>
+        </p:txBody>
+      </p:sp>
+      <p:sp>
+        <p:nvSpPr>
+          <p:cNvPr id="18" name="TextBox 17"/>
+          <p:cNvSpPr txBox="1"/>
+          <p:nvPr/>
+        </p:nvSpPr>
+        <p:spPr>
+          <a:xfrm>
+            <a:off x="6007608" y="4297680"/>
+            <a:ext cx="5285232" cy="749808"/>
           </a:xfrm>
           <a:prstGeom prst="rect">
             <a:avLst/>
@@ -5281,7 +5341,7 @@
           <a:lstStyle/>
           <a:p>
             <a:pPr algn="l">
-              <a:defRPr sz="1900" b="0">
+              <a:defRPr sz="1600" b="0">
                 <a:solidFill>
                   <a:srgbClr val="1E3144"/>
                 </a:solidFill>
@@ -5289,96 +5349,8 @@
               </a:defRPr>
             </a:pPr>
             <a:r>
-              <a:t>Shot, control, circuit, structure, thermal, orbit and alternative-case results.</a:t>
-            </a:r>
-          </a:p>
-        </p:txBody>
-      </p:sp>
-      <p:sp>
-        <p:nvSpPr>
-          <p:cNvPr id="17" name="Rounded Rectangle 16"/>
-          <p:cNvSpPr/>
-          <p:nvPr/>
-        </p:nvSpPr>
-        <p:spPr>
-          <a:xfrm>
-            <a:off x="8028431" y="1709928"/>
-            <a:ext cx="3502152" cy="3547872"/>
-          </a:xfrm>
-          <a:prstGeom prst="roundRect">
-            <a:avLst/>
-          </a:prstGeom>
-          <a:solidFill>
-            <a:srgbClr val="F6F9FB"/>
-          </a:solidFill>
-          <a:ln>
-            <a:solidFill>
-              <a:srgbClr val="DDE7EC"/>
-            </a:solidFill>
-          </a:ln>
-        </p:spPr>
-        <p:style>
-          <a:lnRef idx="1">
-            <a:schemeClr val="accent1"/>
-          </a:lnRef>
-          <a:fillRef idx="3">
-            <a:schemeClr val="accent1"/>
-          </a:fillRef>
-          <a:effectRef idx="2">
-            <a:schemeClr val="accent1"/>
-          </a:effectRef>
-          <a:fontRef idx="minor">
-            <a:schemeClr val="lt1"/>
-          </a:fontRef>
-        </p:style>
-        <p:txBody>
-          <a:bodyPr rtlCol="0" anchor="ctr"/>
-          <a:lstStyle/>
-          <a:p>
-            <a:pPr algn="ctr"/>
-          </a:p>
-        </p:txBody>
-      </p:sp>
-      <p:sp>
-        <p:nvSpPr>
-          <p:cNvPr id="18" name="Rectangle 17"/>
-          <p:cNvSpPr/>
-          <p:nvPr/>
-        </p:nvSpPr>
-        <p:spPr>
-          <a:xfrm>
-            <a:off x="8028431" y="1709928"/>
-            <a:ext cx="73152" cy="3547872"/>
-          </a:xfrm>
-          <a:prstGeom prst="rect">
-            <a:avLst/>
-          </a:prstGeom>
-          <a:solidFill>
-            <a:srgbClr val="0096A0"/>
-          </a:solidFill>
-          <a:ln>
-            <a:noFill/>
-          </a:ln>
-        </p:spPr>
-        <p:style>
-          <a:lnRef idx="1">
-            <a:schemeClr val="accent1"/>
-          </a:lnRef>
-          <a:fillRef idx="3">
-            <a:schemeClr val="accent1"/>
-          </a:fillRef>
-          <a:effectRef idx="2">
-            <a:schemeClr val="accent1"/>
-          </a:effectRef>
-          <a:fontRef idx="minor">
-            <a:schemeClr val="lt1"/>
-          </a:fontRef>
-        </p:style>
-        <p:txBody>
-          <a:bodyPr rtlCol="0" anchor="ctr"/>
-          <a:lstStyle/>
-          <a:p>
-            <a:pPr algn="ctr"/>
+              <a:t>Manuscript, STEP, scripts, numerical checks and defect register.</a:t>
+            </a:r>
           </a:p>
         </p:txBody>
       </p:sp>
@@ -5390,22 +5362,22 @@
         </p:nvSpPr>
         <p:spPr>
           <a:xfrm>
-            <a:off x="8238744" y="1856232"/>
-            <a:ext cx="3136392" cy="502920"/>
-          </a:xfrm>
-          <a:prstGeom prst="rect">
-            <a:avLst/>
-          </a:prstGeom>
-          <a:noFill/>
-        </p:spPr>
-        <p:txBody>
-          <a:bodyPr wrap="square" lIns="13716" rIns="13716" tIns="13716" bIns="13716" anchor="t">
-            <a:spAutoFit/>
-          </a:bodyPr>
-          <a:lstStyle/>
-          <a:p>
-            <a:pPr algn="l">
-              <a:defRPr sz="2200" b="1">
+            <a:off x="777240" y="5861304"/>
+            <a:ext cx="10698480" cy="356616"/>
+          </a:xfrm>
+          <a:prstGeom prst="rect">
+            <a:avLst/>
+          </a:prstGeom>
+          <a:noFill/>
+        </p:spPr>
+        <p:txBody>
+          <a:bodyPr wrap="square" lIns="13716" rIns="13716" tIns="13716" bIns="13716" anchor="t">
+            <a:spAutoFit/>
+          </a:bodyPr>
+          <a:lstStyle/>
+          <a:p>
+            <a:pPr algn="ctr">
+              <a:defRPr sz="1700" b="1">
                 <a:solidFill>
                   <a:srgbClr val="0D2035"/>
                 </a:solidFill>
@@ -5413,79 +5385,7 @@
               </a:defRPr>
             </a:pPr>
             <a:r>
-              <a:t>Evidence delivered</a:t>
-            </a:r>
-          </a:p>
-        </p:txBody>
-      </p:sp>
-      <p:sp>
-        <p:nvSpPr>
-          <p:cNvPr id="20" name="TextBox 19"/>
-          <p:cNvSpPr txBox="1"/>
-          <p:nvPr/>
-        </p:nvSpPr>
-        <p:spPr>
-          <a:xfrm>
-            <a:off x="8238744" y="2459736"/>
-            <a:ext cx="3118104" cy="2633472"/>
-          </a:xfrm>
-          <a:prstGeom prst="rect">
-            <a:avLst/>
-          </a:prstGeom>
-          <a:noFill/>
-        </p:spPr>
-        <p:txBody>
-          <a:bodyPr wrap="square" lIns="13716" rIns="13716" tIns="13716" bIns="13716" anchor="t">
-            <a:spAutoFit/>
-          </a:bodyPr>
-          <a:lstStyle/>
-          <a:p>
-            <a:pPr algn="l">
-              <a:defRPr sz="1900" b="0">
-                <a:solidFill>
-                  <a:srgbClr val="1E3144"/>
-                </a:solidFill>
-                <a:latin typeface="Aptos"/>
-              </a:defRPr>
-            </a:pPr>
-            <a:r>
-              <a:t>Manuscript, figures, scripts, numerical checks, provenance and defect register.</a:t>
-            </a:r>
-          </a:p>
-        </p:txBody>
-      </p:sp>
-      <p:sp>
-        <p:nvSpPr>
-          <p:cNvPr id="21" name="TextBox 20"/>
-          <p:cNvSpPr txBox="1"/>
-          <p:nvPr/>
-        </p:nvSpPr>
-        <p:spPr>
-          <a:xfrm>
-            <a:off x="777240" y="5522976"/>
-            <a:ext cx="10698480" cy="438912"/>
-          </a:xfrm>
-          <a:prstGeom prst="rect">
-            <a:avLst/>
-          </a:prstGeom>
-          <a:noFill/>
-        </p:spPr>
-        <p:txBody>
-          <a:bodyPr wrap="square" lIns="13716" rIns="13716" tIns="13716" bIns="13716" anchor="t">
-            <a:spAutoFit/>
-          </a:bodyPr>
-          <a:lstStyle/>
-          <a:p>
-            <a:pPr algn="ctr">
-              <a:defRPr sz="1800" b="1">
-                <a:solidFill>
-                  <a:srgbClr val="0D2035"/>
-                </a:solidFill>
-                <a:latin typeface="Aptos"/>
-              </a:defRPr>
-            </a:pPr>
-            <a:r>
-              <a:t>Scope: fixed computational study with failed design gates; no physical qualification claim.</a:t>
+              <a:t>Fixed computational study with failed design gates; no physical qualification claim.</a:t>
             </a:r>
           </a:p>
         </p:txBody>
@@ -5735,7 +5635,7 @@
               </a:defRPr>
             </a:pPr>
             <a:r>
-              <a:t>Thesis manuscript, System Architecture; CAD render</a:t>
+              <a:t>FreeCAD Gen5 STEP reference; view provenance and P116</a:t>
             </a:r>
           </a:p>
         </p:txBody>
@@ -5778,7 +5678,7 @@
       </p:sp>
       <p:pic>
         <p:nvPicPr>
-          <p:cNvPr id="9" name="Picture 8" descr="exploded.png"/>
+          <p:cNvPr id="9" name="Picture 8" descr="gen5_reference_open.jpg"/>
           <p:cNvPicPr>
             <a:picLocks noChangeAspect="1"/>
           </p:cNvPicPr>
@@ -5792,8 +5692,8 @@
         </p:blipFill>
         <p:spPr>
           <a:xfrm>
-            <a:off x="457199" y="1794510"/>
-            <a:ext cx="6400800" cy="4000500"/>
+            <a:off x="457200" y="1995424"/>
+            <a:ext cx="6400800" cy="3598671"/>
           </a:xfrm>
           <a:prstGeom prst="rect">
             <a:avLst/>
@@ -5883,6 +5783,42 @@
             </a:pPr>
             <a:r>
               <a:t>•  FreeCAD STEP assembly: side-fed placement clashes</a:t>
+            </a:r>
+          </a:p>
+        </p:txBody>
+      </p:sp>
+      <p:sp>
+        <p:nvSpPr>
+          <p:cNvPr id="11" name="TextBox 10"/>
+          <p:cNvSpPr txBox="1"/>
+          <p:nvPr/>
+        </p:nvSpPr>
+        <p:spPr>
+          <a:xfrm>
+            <a:off x="640080" y="6053328"/>
+            <a:ext cx="6172200" cy="283464"/>
+          </a:xfrm>
+          <a:prstGeom prst="rect">
+            <a:avLst/>
+          </a:prstGeom>
+          <a:noFill/>
+        </p:spPr>
+        <p:txBody>
+          <a:bodyPr wrap="square" lIns="13716" rIns="13716" tIns="13716" bIns="13716" anchor="t">
+            <a:spAutoFit/>
+          </a:bodyPr>
+          <a:lstStyle/>
+          <a:p>
+            <a:pPr algn="ctr">
+              <a:defRPr sz="1200" b="1">
+                <a:solidFill>
+                  <a:srgbClr val="0D2035"/>
+                </a:solidFill>
+                <a:latin typeface="Aptos"/>
+              </a:defRPr>
+            </a:pPr>
+            <a:r>
+              <a:t>Enclosure hidden for visibility; no fabricated article.</a:t>
             </a:r>
           </a:p>
         </p:txBody>
@@ -10278,7 +10214,7 @@
               </a:defRPr>
             </a:pPr>
             <a:r>
-              <a:t>FreeCAD R1 document and STEP; exact-solid route ledger</a:t>
+              <a:t>FreeCAD R1 STEP candidate; exact-solid route ledger</a:t>
             </a:r>
           </a:p>
         </p:txBody>
@@ -10321,7 +10257,7 @@
       </p:sp>
       <p:pic>
         <p:nvPicPr>
-          <p:cNvPr id="9" name="Picture 8" descr="gen5_feeder_candidate_r1.png"/>
+          <p:cNvPr id="9" name="Picture 8" descr="r1_candidate_open.jpg"/>
           <p:cNvPicPr>
             <a:picLocks noChangeAspect="1"/>
           </p:cNvPicPr>
@@ -10335,8 +10271,8 @@
         </p:blipFill>
         <p:spPr>
           <a:xfrm>
-            <a:off x="706447" y="1600200"/>
-            <a:ext cx="6359504" cy="4480560"/>
+            <a:off x="502920" y="1938324"/>
+            <a:ext cx="6766560" cy="3804310"/>
           </a:xfrm>
           <a:prstGeom prst="rect">
             <a:avLst/>
@@ -13329,7 +13265,7 @@
               </a:defRPr>
             </a:pPr>
             <a:r>
-              <a:t>Thesis manuscript, Conclusion; BASELINE.md; PROVENANCE.md</a:t>
+              <a:t>Thesis conclusion; P116; matched mission; STEP view provenance</a:t>
             </a:r>
           </a:p>
         </p:txBody>
@@ -13378,8 +13314,8 @@
         </p:nvSpPr>
         <p:spPr>
           <a:xfrm>
-            <a:off x="868680" y="1737360"/>
-            <a:ext cx="10652760" cy="4389120"/>
+            <a:off x="685800" y="1664208"/>
+            <a:ext cx="5669280" cy="4434840"/>
           </a:xfrm>
           <a:prstGeom prst="rect">
             <a:avLst/>
@@ -13394,9 +13330,9 @@
           <a:p>
             <a:pPr>
               <a:spcAft>
-                <a:spcPts val="2100"/>
+                <a:spcPts val="1800"/>
               </a:spcAft>
-              <a:defRPr sz="2200">
+              <a:defRPr sz="1900">
                 <a:solidFill>
                   <a:srgbClr val="1E3144"/>
                 </a:solidFill>
@@ -13410,9 +13346,9 @@
           <a:p>
             <a:pPr>
               <a:spcAft>
-                <a:spcPts val="2100"/>
+                <a:spcPts val="1800"/>
               </a:spcAft>
-              <a:defRPr sz="2200">
+              <a:defRPr sz="1900">
                 <a:solidFill>
                   <a:srgbClr val="1E3144"/>
                 </a:solidFill>
@@ -13426,9 +13362,9 @@
           <a:p>
             <a:pPr>
               <a:spcAft>
-                <a:spcPts val="2100"/>
+                <a:spcPts val="1800"/>
               </a:spcAft>
-              <a:defRPr sz="2200">
+              <a:defRPr sz="1900">
                 <a:solidFill>
                   <a:srgbClr val="1E3144"/>
                 </a:solidFill>
@@ -13442,9 +13378,9 @@
           <a:p>
             <a:pPr>
               <a:spcAft>
-                <a:spcPts val="2100"/>
+                <a:spcPts val="1800"/>
               </a:spcAft>
-              <a:defRPr sz="2200">
+              <a:defRPr sz="1900">
                 <a:solidFill>
                   <a:srgbClr val="1E3144"/>
                 </a:solidFill>
@@ -13453,6 +13389,66 @@
             </a:pPr>
             <a:r>
               <a:t>•  No matched twelve-shot reference closes; Gen5 is a documented negative design study.</a:t>
+            </a:r>
+          </a:p>
+        </p:txBody>
+      </p:sp>
+      <p:pic>
+        <p:nvPicPr>
+          <p:cNvPr id="10" name="Picture 9" descr="gen5_reference_open.jpg"/>
+          <p:cNvPicPr>
+            <a:picLocks noChangeAspect="1"/>
+          </p:cNvPicPr>
+          <p:nvPr/>
+        </p:nvPicPr>
+        <p:blipFill>
+          <a:blip r:embed="rId2"/>
+          <a:stretch>
+            <a:fillRect/>
+          </a:stretch>
+        </p:blipFill>
+        <p:spPr>
+          <a:xfrm>
+            <a:off x="6492240" y="2080971"/>
+            <a:ext cx="5120640" cy="2878937"/>
+          </a:xfrm>
+          <a:prstGeom prst="rect">
+            <a:avLst/>
+          </a:prstGeom>
+        </p:spPr>
+      </p:pic>
+      <p:sp>
+        <p:nvSpPr>
+          <p:cNvPr id="11" name="TextBox 10"/>
+          <p:cNvSpPr txBox="1"/>
+          <p:nvPr/>
+        </p:nvSpPr>
+        <p:spPr>
+          <a:xfrm>
+            <a:off x="6510528" y="5449824"/>
+            <a:ext cx="5074920" cy="438912"/>
+          </a:xfrm>
+          <a:prstGeom prst="rect">
+            <a:avLst/>
+          </a:prstGeom>
+          <a:noFill/>
+        </p:spPr>
+        <p:txBody>
+          <a:bodyPr wrap="square" lIns="13716" rIns="13716" tIns="13716" bIns="13716" anchor="t">
+            <a:spAutoFit/>
+          </a:bodyPr>
+          <a:lstStyle/>
+          <a:p>
+            <a:pPr algn="ctr">
+              <a:defRPr sz="1300" b="1">
+                <a:solidFill>
+                  <a:srgbClr val="0D2035"/>
+                </a:solidFill>
+                <a:latin typeface="Aptos"/>
+              </a:defRPr>
+            </a:pPr>
+            <a:r>
+              <a:t>STEP reference, enclosure hidden; fit fails. No physical test.</a:t>
             </a:r>
           </a:p>
         </p:txBody>
@@ -15886,7 +15882,7 @@
               </a:defRPr>
             </a:pPr>
             <a:r>
-              <a:t>NASA 2026 Small Spacecraft SoA; Planet and Spire filings; local market audit</a:t>
+              <a:t>NASA 2026 Small Spacecraft SoA; local market audit; STEP-derived Gen5 CAD</a:t>
             </a:r>
           </a:p>
         </p:txBody>
@@ -15935,8 +15931,8 @@
         </p:nvSpPr>
         <p:spPr>
           <a:xfrm>
-            <a:off x="594360" y="1664208"/>
-            <a:ext cx="3520440" cy="3182112"/>
+            <a:off x="594360" y="1627632"/>
+            <a:ext cx="4736592" cy="1664208"/>
           </a:xfrm>
           <a:prstGeom prst="roundRect">
             <a:avLst/>
@@ -15980,8 +15976,8 @@
         </p:nvSpPr>
         <p:spPr>
           <a:xfrm>
-            <a:off x="594360" y="1664208"/>
-            <a:ext cx="73152" cy="3182112"/>
+            <a:off x="594360" y="1627632"/>
+            <a:ext cx="73152" cy="1664208"/>
           </a:xfrm>
           <a:prstGeom prst="rect">
             <a:avLst/>
@@ -16023,8 +16019,8 @@
         </p:nvSpPr>
         <p:spPr>
           <a:xfrm>
-            <a:off x="804672" y="1810512"/>
-            <a:ext cx="3154680" cy="502920"/>
+            <a:off x="804672" y="1773936"/>
+            <a:ext cx="4370831" cy="502920"/>
           </a:xfrm>
           <a:prstGeom prst="rect">
             <a:avLst/>
@@ -16038,7 +16034,7 @@
           <a:lstStyle/>
           <a:p>
             <a:pPr algn="l">
-              <a:defRPr sz="2100" b="1">
+              <a:defRPr sz="2000" b="1">
                 <a:solidFill>
                   <a:srgbClr val="0D2035"/>
                 </a:solidFill>
@@ -16059,8 +16055,8 @@
         </p:nvSpPr>
         <p:spPr>
           <a:xfrm>
-            <a:off x="804672" y="2414016"/>
-            <a:ext cx="3136392" cy="2267712"/>
+            <a:off x="804672" y="2377440"/>
+            <a:ext cx="4352544" cy="749808"/>
           </a:xfrm>
           <a:prstGeom prst="rect">
             <a:avLst/>
@@ -16074,7 +16070,7 @@
           <a:lstStyle/>
           <a:p>
             <a:pPr algn="l">
-              <a:defRPr sz="1700" b="0">
+              <a:defRPr sz="1600" b="0">
                 <a:solidFill>
                   <a:srgbClr val="1E3144"/>
                 </a:solidFill>
@@ -16082,7 +16078,7 @@
               </a:defRPr>
             </a:pPr>
             <a:r>
-              <a:t>Configurable smallsat families and replenishment exist. That context does not establish demand for VOLLEY.</a:t>
+              <a:t>Configurable satellite fleets exist; demand for VOLLEY is unconfirmed.</a:t>
             </a:r>
           </a:p>
         </p:txBody>
@@ -16095,8 +16091,8 @@
         </p:nvSpPr>
         <p:spPr>
           <a:xfrm>
-            <a:off x="4343400" y="1664208"/>
-            <a:ext cx="3520440" cy="3182112"/>
+            <a:off x="594360" y="3465576"/>
+            <a:ext cx="4736592" cy="1664208"/>
           </a:xfrm>
           <a:prstGeom prst="roundRect">
             <a:avLst/>
@@ -16140,8 +16136,8 @@
         </p:nvSpPr>
         <p:spPr>
           <a:xfrm>
-            <a:off x="4343400" y="1664208"/>
-            <a:ext cx="73152" cy="3182112"/>
+            <a:off x="594360" y="3465576"/>
+            <a:ext cx="73152" cy="1664208"/>
           </a:xfrm>
           <a:prstGeom prst="rect">
             <a:avLst/>
@@ -16183,8 +16179,8 @@
         </p:nvSpPr>
         <p:spPr>
           <a:xfrm>
-            <a:off x="4553712" y="1810512"/>
-            <a:ext cx="3154680" cy="502920"/>
+            <a:off x="804672" y="3611880"/>
+            <a:ext cx="4370831" cy="502920"/>
           </a:xfrm>
           <a:prstGeom prst="rect">
             <a:avLst/>
@@ -16198,7 +16194,7 @@
           <a:lstStyle/>
           <a:p>
             <a:pPr algn="l">
-              <a:defRPr sz="2100" b="1">
+              <a:defRPr sz="2000" b="1">
                 <a:solidFill>
                   <a:srgbClr val="0D2035"/>
                 </a:solidFill>
@@ -16219,8 +16215,8 @@
         </p:nvSpPr>
         <p:spPr>
           <a:xfrm>
-            <a:off x="4553712" y="2414016"/>
-            <a:ext cx="3136392" cy="2267712"/>
+            <a:off x="804672" y="4215384"/>
+            <a:ext cx="4352544" cy="749808"/>
           </a:xfrm>
           <a:prstGeom prst="rect">
             <a:avLst/>
@@ -16234,7 +16230,7 @@
           <a:lstStyle/>
           <a:p>
             <a:pPr algn="l">
-              <a:defRPr sz="1700" b="0">
+              <a:defRPr sz="1600" b="0">
                 <a:solidFill>
                   <a:srgbClr val="1E3144"/>
                 </a:solidFill>
@@ -16242,96 +16238,68 @@
               </a:defRPr>
             </a:pPr>
             <a:r>
-              <a:t>A carrier, rideshare integrator or fleet operator might need several distinct release states from one host.</a:t>
-            </a:r>
-          </a:p>
-        </p:txBody>
-      </p:sp>
-      <p:sp>
-        <p:nvSpPr>
-          <p:cNvPr id="17" name="Rounded Rectangle 16"/>
-          <p:cNvSpPr/>
-          <p:nvPr/>
-        </p:nvSpPr>
-        <p:spPr>
-          <a:xfrm>
-            <a:off x="8092440" y="1664208"/>
-            <a:ext cx="3520440" cy="3182112"/>
-          </a:xfrm>
-          <a:prstGeom prst="roundRect">
-            <a:avLst/>
-          </a:prstGeom>
-          <a:solidFill>
-            <a:srgbClr val="F6F9FB"/>
-          </a:solidFill>
-          <a:ln>
-            <a:solidFill>
-              <a:srgbClr val="DDE7EC"/>
-            </a:solidFill>
-          </a:ln>
-        </p:spPr>
-        <p:style>
-          <a:lnRef idx="1">
-            <a:schemeClr val="accent1"/>
-          </a:lnRef>
-          <a:fillRef idx="3">
-            <a:schemeClr val="accent1"/>
-          </a:fillRef>
-          <a:effectRef idx="2">
-            <a:schemeClr val="accent1"/>
-          </a:effectRef>
-          <a:fontRef idx="minor">
-            <a:schemeClr val="lt1"/>
-          </a:fontRef>
-        </p:style>
-        <p:txBody>
-          <a:bodyPr rtlCol="0" anchor="ctr"/>
-          <a:lstStyle/>
-          <a:p>
-            <a:pPr algn="ctr"/>
-          </a:p>
-        </p:txBody>
-      </p:sp>
-      <p:sp>
-        <p:nvSpPr>
-          <p:cNvPr id="18" name="Rectangle 17"/>
-          <p:cNvSpPr/>
-          <p:nvPr/>
-        </p:nvSpPr>
-        <p:spPr>
-          <a:xfrm>
-            <a:off x="8092440" y="1664208"/>
-            <a:ext cx="73152" cy="3182112"/>
-          </a:xfrm>
-          <a:prstGeom prst="rect">
-            <a:avLst/>
-          </a:prstGeom>
-          <a:solidFill>
-            <a:srgbClr val="D78F2B"/>
-          </a:solidFill>
-          <a:ln>
-            <a:noFill/>
-          </a:ln>
-        </p:spPr>
-        <p:style>
-          <a:lnRef idx="1">
-            <a:schemeClr val="accent1"/>
-          </a:lnRef>
-          <a:fillRef idx="3">
-            <a:schemeClr val="accent1"/>
-          </a:fillRef>
-          <a:effectRef idx="2">
-            <a:schemeClr val="accent1"/>
-          </a:effectRef>
-          <a:fontRef idx="minor">
-            <a:schemeClr val="lt1"/>
-          </a:fontRef>
-        </p:style>
-        <p:txBody>
-          <a:bodyPr rtlCol="0" anchor="ctr"/>
-          <a:lstStyle/>
-          <a:p>
-            <a:pPr algn="ctr"/>
+              <a:t>A carrier or fleet operator might seek several release states from one host.</a:t>
+            </a:r>
+          </a:p>
+        </p:txBody>
+      </p:sp>
+      <p:pic>
+        <p:nvPicPr>
+          <p:cNvPr id="17" name="Picture 16" descr="gen5_reference_open.jpg"/>
+          <p:cNvPicPr>
+            <a:picLocks noChangeAspect="1"/>
+          </p:cNvPicPr>
+          <p:nvPr/>
+        </p:nvPicPr>
+        <p:blipFill>
+          <a:blip r:embed="rId2"/>
+          <a:stretch>
+            <a:fillRect/>
+          </a:stretch>
+        </p:blipFill>
+        <p:spPr>
+          <a:xfrm>
+            <a:off x="5577840" y="1638767"/>
+            <a:ext cx="6108192" cy="3434161"/>
+          </a:xfrm>
+          <a:prstGeom prst="rect">
+            <a:avLst/>
+          </a:prstGeom>
+        </p:spPr>
+      </p:pic>
+      <p:sp>
+        <p:nvSpPr>
+          <p:cNvPr id="18" name="TextBox 17"/>
+          <p:cNvSpPr txBox="1"/>
+          <p:nvPr/>
+        </p:nvSpPr>
+        <p:spPr>
+          <a:xfrm>
+            <a:off x="5715000" y="5148072"/>
+            <a:ext cx="5806440" cy="402336"/>
+          </a:xfrm>
+          <a:prstGeom prst="rect">
+            <a:avLst/>
+          </a:prstGeom>
+          <a:noFill/>
+        </p:spPr>
+        <p:txBody>
+          <a:bodyPr wrap="square" lIns="13716" rIns="13716" tIns="13716" bIns="13716" anchor="t">
+            <a:spAutoFit/>
+          </a:bodyPr>
+          <a:lstStyle/>
+          <a:p>
+            <a:pPr algn="ctr">
+              <a:defRPr sz="1300" b="1">
+                <a:solidFill>
+                  <a:srgbClr val="0D2035"/>
+                </a:solidFill>
+                <a:latin typeface="Aptos"/>
+              </a:defRPr>
+            </a:pPr>
+            <a:r>
+              <a:t>STEP-derived Gen5 reference; side-fed placement fails its fit check.</a:t>
+            </a:r>
           </a:p>
         </p:txBody>
       </p:sp>
@@ -16343,22 +16311,22 @@
         </p:nvSpPr>
         <p:spPr>
           <a:xfrm>
-            <a:off x="8302752" y="1810512"/>
-            <a:ext cx="3154680" cy="502920"/>
-          </a:xfrm>
-          <a:prstGeom prst="rect">
-            <a:avLst/>
-          </a:prstGeom>
-          <a:noFill/>
-        </p:spPr>
-        <p:txBody>
-          <a:bodyPr wrap="square" lIns="13716" rIns="13716" tIns="13716" bIns="13716" anchor="t">
-            <a:spAutoFit/>
-          </a:bodyPr>
-          <a:lstStyle/>
-          <a:p>
-            <a:pPr algn="l">
-              <a:defRPr sz="2100" b="1">
+            <a:off x="731520" y="5833872"/>
+            <a:ext cx="10744200" cy="411480"/>
+          </a:xfrm>
+          <a:prstGeom prst="rect">
+            <a:avLst/>
+          </a:prstGeom>
+          <a:noFill/>
+        </p:spPr>
+        <p:txBody>
+          <a:bodyPr wrap="square" lIns="13716" rIns="13716" tIns="13716" bIns="13716" anchor="t">
+            <a:spAutoFit/>
+          </a:bodyPr>
+          <a:lstStyle/>
+          <a:p>
+            <a:pPr algn="ctr">
+              <a:defRPr sz="1700" b="1">
                 <a:solidFill>
                   <a:srgbClr val="0D2035"/>
                 </a:solidFill>
@@ -16366,79 +16334,7 @@
               </a:defRPr>
             </a:pPr>
             <a:r>
-              <a:t>Gen5 test</a:t>
-            </a:r>
-          </a:p>
-        </p:txBody>
-      </p:sp>
-      <p:sp>
-        <p:nvSpPr>
-          <p:cNvPr id="20" name="TextBox 19"/>
-          <p:cNvSpPr txBox="1"/>
-          <p:nvPr/>
-        </p:nvSpPr>
-        <p:spPr>
-          <a:xfrm>
-            <a:off x="8302752" y="2414016"/>
-            <a:ext cx="3136392" cy="2267712"/>
-          </a:xfrm>
-          <a:prstGeom prst="rect">
-            <a:avLst/>
-          </a:prstGeom>
-          <a:noFill/>
-        </p:spPr>
-        <p:txBody>
-          <a:bodyPr wrap="square" lIns="13716" rIns="13716" tIns="13716" bIns="13716" anchor="t">
-            <a:spAutoFit/>
-          </a:bodyPr>
-          <a:lstStyle/>
-          <a:p>
-            <a:pPr algn="l">
-              <a:defRPr sz="1700" b="0">
-                <a:solidFill>
-                  <a:srgbClr val="1E3144"/>
-                </a:solidFill>
-                <a:latin typeface="Aptos"/>
-              </a:defRPr>
-            </a:pPr>
-            <a:r>
-              <a:t>Compare commanded release with springs, host manoeuvres, transport and onboard propulsion on the same mission.</a:t>
-            </a:r>
-          </a:p>
-        </p:txBody>
-      </p:sp>
-      <p:sp>
-        <p:nvSpPr>
-          <p:cNvPr id="21" name="TextBox 20"/>
-          <p:cNvSpPr txBox="1"/>
-          <p:nvPr/>
-        </p:nvSpPr>
-        <p:spPr>
-          <a:xfrm>
-            <a:off x="731520" y="5276088"/>
-            <a:ext cx="10744200" cy="566928"/>
-          </a:xfrm>
-          <a:prstGeom prst="rect">
-            <a:avLst/>
-          </a:prstGeom>
-          <a:noFill/>
-        </p:spPr>
-        <p:txBody>
-          <a:bodyPr wrap="square" lIns="13716" rIns="13716" tIns="13716" bIns="13716" anchor="t">
-            <a:spAutoFit/>
-          </a:bodyPr>
-          <a:lstStyle/>
-          <a:p>
-            <a:pPr algn="ctr">
-              <a:defRPr sz="2100" b="1">
-                <a:solidFill>
-                  <a:srgbClr val="0D2035"/>
-                </a:solidFill>
-                <a:latin typeface="Aptos"/>
-              </a:defRPr>
-            </a:pPr>
-            <a:r>
-              <a:t>No customer is confirmed; modeled Gen5 3U mass fails its preset criterion.</a:t>
+              <a:t>Test on one matched mission against springs, host manoeuvres, transport and onboard propulsion.</a:t>
             </a:r>
           </a:p>
         </p:txBody>
@@ -21612,7 +21508,7 @@
               </a:defRPr>
             </a:pPr>
             <a:r>
-              <a:t>Analytic field; field-point FEM; finite force screen</a:t>
+              <a:t>Analytic; 2-D FEM; independent 3-D numerical force</a:t>
             </a:r>
           </a:p>
         </p:txBody>
@@ -21693,7 +21589,7 @@
               </a:defRPr>
             </a:pPr>
             <a:r>
-              <a:t>No independent integrated-thrust FEM or measurement</a:t>
+              <a:t>Shared ideal inputs; no motor measurement</a:t>
             </a:r>
           </a:p>
         </p:txBody>

</xml_diff>

<commit_message>
Synchronize thesis review with mass and prototype requirements
</commit_message>
<xml_diff>
--- a/university/final_review_2026_10_10/VOLLEY_Final_Review_2026-10-10.pptx
+++ b/university/final_review_2026_10_10/VOLLEY_Final_Review_2026-10-10.pptx
@@ -12724,7 +12724,7 @@
             <a:avLst/>
           </a:prstGeom>
           <a:solidFill>
-            <a:srgbClr val="0096A0"/>
+            <a:srgbClr val="B94141"/>
           </a:solidFill>
           <a:ln>
             <a:noFill/>
@@ -12783,7 +12783,7 @@
               </a:defRPr>
             </a:pPr>
             <a:r>
-              <a:t>2.69 vs 0.83 kg</a:t>
+              <a:t>+52.7 kg</a:t>
             </a:r>
           </a:p>
         </p:txBody>
@@ -12819,7 +12819,7 @@
               </a:defRPr>
             </a:pPr>
             <a:r>
-              <a:t>Ideal one-event host propellant: spring versus Gen5's ideal finite-force upper screen.</a:t>
+              <a:t>One-event device plus resized fuel: Gen5 exceeds spring despite an ideal 1.87 kg fuel saving (P123).</a:t>
             </a:r>
           </a:p>
         </p:txBody>
@@ -13698,7 +13698,7 @@
               </a:defRPr>
             </a:pPr>
             <a:r>
-              <a:t>CURRENT PLAN AND STATUS — PLAN-R2, 29 Sep 2026</a:t>
+              <a:t>P124 ideal stroke screen; Gen6 prototype specification remains open</a:t>
             </a:r>
           </a:p>
         </p:txBody>
@@ -13739,25 +13739,51 @@
           </a:p>
         </p:txBody>
       </p:sp>
-      <p:sp>
-        <p:nvSpPr>
-          <p:cNvPr id="9" name="Rounded Rectangle 8"/>
+      <p:pic>
+        <p:nvPicPr>
+          <p:cNvPr id="9" name="Picture 8" descr="precision_delivery_design_space.png"/>
+          <p:cNvPicPr>
+            <a:picLocks noChangeAspect="1"/>
+          </p:cNvPicPr>
+          <p:nvPr/>
+        </p:nvPicPr>
+        <p:blipFill>
+          <a:blip r:embed="rId2"/>
+          <a:stretch>
+            <a:fillRect/>
+          </a:stretch>
+        </p:blipFill>
+        <p:spPr>
+          <a:xfrm>
+            <a:off x="438912" y="1426464"/>
+            <a:ext cx="6675120" cy="4005072"/>
+          </a:xfrm>
+          <a:prstGeom prst="rect">
+            <a:avLst/>
+          </a:prstGeom>
+        </p:spPr>
+      </p:pic>
+      <p:sp>
+        <p:nvSpPr>
+          <p:cNvPr id="10" name="Rounded Rectangle 9"/>
           <p:cNvSpPr/>
           <p:nvPr/>
         </p:nvSpPr>
         <p:spPr>
           <a:xfrm>
-            <a:off x="731520" y="1645920"/>
-            <a:ext cx="10698480" cy="1069848"/>
+            <a:off x="7370064" y="1645920"/>
+            <a:ext cx="4151376" cy="1719072"/>
           </a:xfrm>
           <a:prstGeom prst="roundRect">
             <a:avLst/>
           </a:prstGeom>
           <a:solidFill>
-            <a:srgbClr val="E8F6F6"/>
+            <a:srgbClr val="F6F9FB"/>
           </a:solidFill>
           <a:ln>
-            <a:noFill/>
+            <a:solidFill>
+              <a:srgbClr val="DDE7EC"/>
+            </a:solidFill>
           </a:ln>
         </p:spPr>
         <p:style>
@@ -13784,14 +13810,289 @@
       </p:sp>
       <p:sp>
         <p:nvSpPr>
-          <p:cNvPr id="10" name="TextBox 9"/>
-          <p:cNvSpPr txBox="1"/>
-          <p:nvPr/>
-        </p:nvSpPr>
-        <p:spPr>
-          <a:xfrm>
-            <a:off x="914400" y="1920240"/>
-            <a:ext cx="10378440" cy="502920"/>
+          <p:cNvPr id="11" name="Rectangle 10"/>
+          <p:cNvSpPr/>
+          <p:nvPr/>
+        </p:nvSpPr>
+        <p:spPr>
+          <a:xfrm>
+            <a:off x="7370064" y="1645920"/>
+            <a:ext cx="73152" cy="1719072"/>
+          </a:xfrm>
+          <a:prstGeom prst="rect">
+            <a:avLst/>
+          </a:prstGeom>
+          <a:solidFill>
+            <a:srgbClr val="0096A0"/>
+          </a:solidFill>
+          <a:ln>
+            <a:noFill/>
+          </a:ln>
+        </p:spPr>
+        <p:style>
+          <a:lnRef idx="1">
+            <a:schemeClr val="accent1"/>
+          </a:lnRef>
+          <a:fillRef idx="3">
+            <a:schemeClr val="accent1"/>
+          </a:fillRef>
+          <a:effectRef idx="2">
+            <a:schemeClr val="accent1"/>
+          </a:effectRef>
+          <a:fontRef idx="minor">
+            <a:schemeClr val="lt1"/>
+          </a:fontRef>
+        </p:style>
+        <p:txBody>
+          <a:bodyPr rtlCol="0" anchor="ctr"/>
+          <a:lstStyle/>
+          <a:p>
+            <a:pPr algn="ctr"/>
+          </a:p>
+        </p:txBody>
+      </p:sp>
+      <p:sp>
+        <p:nvSpPr>
+          <p:cNvPr id="12" name="TextBox 11"/>
+          <p:cNvSpPr txBox="1"/>
+          <p:nvPr/>
+        </p:nvSpPr>
+        <p:spPr>
+          <a:xfrm>
+            <a:off x="7580376" y="1792224"/>
+            <a:ext cx="3785615" cy="502920"/>
+          </a:xfrm>
+          <a:prstGeom prst="rect">
+            <a:avLst/>
+          </a:prstGeom>
+          <a:noFill/>
+        </p:spPr>
+        <p:txBody>
+          <a:bodyPr wrap="square" lIns="13716" rIns="13716" tIns="13716" bIns="13716" anchor="t">
+            <a:spAutoFit/>
+          </a:bodyPr>
+          <a:lstStyle/>
+          <a:p>
+            <a:pPr algn="l">
+              <a:defRPr sz="1800" b="1">
+                <a:solidFill>
+                  <a:srgbClr val="0D2035"/>
+                </a:solidFill>
+                <a:latin typeface="Aptos"/>
+              </a:defRPr>
+            </a:pPr>
+            <a:r>
+              <a:t>Start with the mission</a:t>
+            </a:r>
+          </a:p>
+        </p:txBody>
+      </p:sp>
+      <p:sp>
+        <p:nvSpPr>
+          <p:cNvPr id="13" name="TextBox 12"/>
+          <p:cNvSpPr txBox="1"/>
+          <p:nvPr/>
+        </p:nvSpPr>
+        <p:spPr>
+          <a:xfrm>
+            <a:off x="7580376" y="2395728"/>
+            <a:ext cx="3767328" cy="804671"/>
+          </a:xfrm>
+          <a:prstGeom prst="rect">
+            <a:avLst/>
+          </a:prstGeom>
+          <a:noFill/>
+        </p:spPr>
+        <p:txBody>
+          <a:bodyPr wrap="square" lIns="13716" rIns="13716" tIns="13716" bIns="13716" anchor="t">
+            <a:spAutoFit/>
+          </a:bodyPr>
+          <a:lstStyle/>
+          <a:p>
+            <a:pPr algn="l">
+              <a:defRPr sz="1500" b="0">
+                <a:solidFill>
+                  <a:srgbClr val="1E3144"/>
+                </a:solidFill>
+                <a:latin typeface="Aptos"/>
+              </a:defRPr>
+            </a:pPr>
+            <a:r>
+              <a:t>Specify a delivered state, tolerance, host and payload load before choosing release speed.</a:t>
+            </a:r>
+          </a:p>
+        </p:txBody>
+      </p:sp>
+      <p:sp>
+        <p:nvSpPr>
+          <p:cNvPr id="14" name="Rounded Rectangle 13"/>
+          <p:cNvSpPr/>
+          <p:nvPr/>
+        </p:nvSpPr>
+        <p:spPr>
+          <a:xfrm>
+            <a:off x="7370064" y="3566160"/>
+            <a:ext cx="4151376" cy="1719072"/>
+          </a:xfrm>
+          <a:prstGeom prst="roundRect">
+            <a:avLst/>
+          </a:prstGeom>
+          <a:solidFill>
+            <a:srgbClr val="F6F9FB"/>
+          </a:solidFill>
+          <a:ln>
+            <a:solidFill>
+              <a:srgbClr val="DDE7EC"/>
+            </a:solidFill>
+          </a:ln>
+        </p:spPr>
+        <p:style>
+          <a:lnRef idx="1">
+            <a:schemeClr val="accent1"/>
+          </a:lnRef>
+          <a:fillRef idx="3">
+            <a:schemeClr val="accent1"/>
+          </a:fillRef>
+          <a:effectRef idx="2">
+            <a:schemeClr val="accent1"/>
+          </a:effectRef>
+          <a:fontRef idx="minor">
+            <a:schemeClr val="lt1"/>
+          </a:fontRef>
+        </p:style>
+        <p:txBody>
+          <a:bodyPr rtlCol="0" anchor="ctr"/>
+          <a:lstStyle/>
+          <a:p>
+            <a:pPr algn="ctr"/>
+          </a:p>
+        </p:txBody>
+      </p:sp>
+      <p:sp>
+        <p:nvSpPr>
+          <p:cNvPr id="15" name="Rectangle 14"/>
+          <p:cNvSpPr/>
+          <p:nvPr/>
+        </p:nvSpPr>
+        <p:spPr>
+          <a:xfrm>
+            <a:off x="7370064" y="3566160"/>
+            <a:ext cx="73152" cy="1719072"/>
+          </a:xfrm>
+          <a:prstGeom prst="rect">
+            <a:avLst/>
+          </a:prstGeom>
+          <a:solidFill>
+            <a:srgbClr val="B94141"/>
+          </a:solidFill>
+          <a:ln>
+            <a:noFill/>
+          </a:ln>
+        </p:spPr>
+        <p:style>
+          <a:lnRef idx="1">
+            <a:schemeClr val="accent1"/>
+          </a:lnRef>
+          <a:fillRef idx="3">
+            <a:schemeClr val="accent1"/>
+          </a:fillRef>
+          <a:effectRef idx="2">
+            <a:schemeClr val="accent1"/>
+          </a:effectRef>
+          <a:fontRef idx="minor">
+            <a:schemeClr val="lt1"/>
+          </a:fontRef>
+        </p:style>
+        <p:txBody>
+          <a:bodyPr rtlCol="0" anchor="ctr"/>
+          <a:lstStyle/>
+          <a:p>
+            <a:pPr algn="ctr"/>
+          </a:p>
+        </p:txBody>
+      </p:sp>
+      <p:sp>
+        <p:nvSpPr>
+          <p:cNvPr id="16" name="TextBox 15"/>
+          <p:cNvSpPr txBox="1"/>
+          <p:nvPr/>
+        </p:nvSpPr>
+        <p:spPr>
+          <a:xfrm>
+            <a:off x="7580376" y="3712463"/>
+            <a:ext cx="3785615" cy="502920"/>
+          </a:xfrm>
+          <a:prstGeom prst="rect">
+            <a:avLst/>
+          </a:prstGeom>
+          <a:noFill/>
+        </p:spPr>
+        <p:txBody>
+          <a:bodyPr wrap="square" lIns="13716" rIns="13716" tIns="13716" bIns="13716" anchor="t">
+            <a:spAutoFit/>
+          </a:bodyPr>
+          <a:lstStyle/>
+          <a:p>
+            <a:pPr algn="l">
+              <a:defRPr sz="1800" b="1">
+                <a:solidFill>
+                  <a:srgbClr val="0D2035"/>
+                </a:solidFill>
+                <a:latin typeface="Aptos"/>
+              </a:defRPr>
+            </a:pPr>
+            <a:r>
+              <a:t>Separate the regimes</a:t>
+            </a:r>
+          </a:p>
+        </p:txBody>
+      </p:sp>
+      <p:sp>
+        <p:nvSpPr>
+          <p:cNvPr id="17" name="TextBox 16"/>
+          <p:cNvSpPr txBox="1"/>
+          <p:nvPr/>
+        </p:nvSpPr>
+        <p:spPr>
+          <a:xfrm>
+            <a:off x="7580376" y="4315968"/>
+            <a:ext cx="3767328" cy="804671"/>
+          </a:xfrm>
+          <a:prstGeom prst="rect">
+            <a:avLst/>
+          </a:prstGeom>
+          <a:noFill/>
+        </p:spPr>
+        <p:txBody>
+          <a:bodyPr wrap="square" lIns="13716" rIns="13716" tIns="13716" bIns="13716" anchor="t">
+            <a:spAutoFit/>
+          </a:bodyPr>
+          <a:lstStyle/>
+          <a:p>
+            <a:pPr algn="l">
+              <a:defRPr sz="1500" b="0">
+                <a:solidFill>
+                  <a:srgbClr val="1E3144"/>
+                </a:solidFill>
+                <a:latin typeface="Aptos"/>
+              </a:defRPr>
+            </a:pPr>
+            <a:r>
+              <a:t>1 km/s over 1.3 m implies ~39,220 g for 4 kg. It is not a first ordinary-3U prototype target.</a:t>
+            </a:r>
+          </a:p>
+        </p:txBody>
+      </p:sp>
+      <p:sp>
+        <p:nvSpPr>
+          <p:cNvPr id="18" name="TextBox 17"/>
+          <p:cNvSpPr txBox="1"/>
+          <p:nvPr/>
+        </p:nvSpPr>
+        <p:spPr>
+          <a:xfrm>
+            <a:off x="822960" y="5806440"/>
+            <a:ext cx="10561320" cy="393192"/>
           </a:xfrm>
           <a:prstGeom prst="rect">
             <a:avLst/>
@@ -13805,7 +14106,7 @@
           <a:lstStyle/>
           <a:p>
             <a:pPr algn="ctr">
-              <a:defRPr sz="2200" b="1">
+              <a:defRPr sz="1500" b="1">
                 <a:solidFill>
                   <a:srgbClr val="0D2035"/>
                 </a:solidFill>
@@ -13813,114 +14114,7 @@
               </a:defRPr>
             </a:pPr>
             <a:r>
-              <a:t>One shared path • sequential feed • commanded release for each CubeSat</a:t>
-            </a:r>
-          </a:p>
-        </p:txBody>
-      </p:sp>
-      <p:sp>
-        <p:nvSpPr>
-          <p:cNvPr id="11" name="TextBox 10"/>
-          <p:cNvSpPr txBox="1"/>
-          <p:nvPr/>
-        </p:nvSpPr>
-        <p:spPr>
-          <a:xfrm>
-            <a:off x="1051560" y="3017520"/>
-            <a:ext cx="10058400" cy="2240280"/>
-          </a:xfrm>
-          <a:prstGeom prst="rect">
-            <a:avLst/>
-          </a:prstGeom>
-          <a:noFill/>
-        </p:spPr>
-        <p:txBody>
-          <a:bodyPr wrap="square" lIns="73152" rIns="73152" tIns="36576" bIns="0">
-            <a:spAutoFit/>
-          </a:bodyPr>
-          <a:lstStyle/>
-          <a:p>
-            <a:pPr>
-              <a:spcAft>
-                <a:spcPts val="1900"/>
-              </a:spcAft>
-              <a:defRPr sz="2100">
-                <a:solidFill>
-                  <a:srgbClr val="1E3144"/>
-                </a:solidFill>
-                <a:latin typeface="Aptos"/>
-              </a:defRPr>
-            </a:pPr>
-            <a:r>
-              <a:t>•  Investigate approximately 1–2 m/s through 1 km/s across mission cases.</a:t>
-            </a:r>
-          </a:p>
-          <a:p>
-            <a:pPr>
-              <a:spcAft>
-                <a:spcPts val="1900"/>
-              </a:spcAft>
-              <a:defRPr sz="2100">
-                <a:solidFill>
-                  <a:srgbClr val="1E3144"/>
-                </a:solidFill>
-                <a:latin typeface="Aptos"/>
-              </a:defRPr>
-            </a:pPr>
-            <a:r>
-              <a:t>•  Compare electromagnetic, stored-energy, gas/fluid, hybrid, BOLLEY and conventional options.</a:t>
-            </a:r>
-          </a:p>
-          <a:p>
-            <a:pPr>
-              <a:spcAft>
-                <a:spcPts val="1900"/>
-              </a:spcAft>
-              <a:defRPr sz="2100">
-                <a:solidFill>
-                  <a:srgbClr val="1E3144"/>
-                </a:solidFill>
-                <a:latin typeface="Aptos"/>
-              </a:defRPr>
-            </a:pPr>
-            <a:r>
-              <a:t>•  Count feeder, retention, arrest, control, energy, thermal, host loads and shared faults.</a:t>
-            </a:r>
-          </a:p>
-        </p:txBody>
-      </p:sp>
-      <p:sp>
-        <p:nvSpPr>
-          <p:cNvPr id="12" name="TextBox 11"/>
-          <p:cNvSpPr txBox="1"/>
-          <p:nvPr/>
-        </p:nvSpPr>
-        <p:spPr>
-          <a:xfrm>
-            <a:off x="841248" y="5742432"/>
-            <a:ext cx="10561320" cy="475488"/>
-          </a:xfrm>
-          <a:prstGeom prst="rect">
-            <a:avLst/>
-          </a:prstGeom>
-          <a:noFill/>
-        </p:spPr>
-        <p:txBody>
-          <a:bodyPr wrap="square" lIns="13716" rIns="13716" tIns="13716" bIns="13716" anchor="t">
-            <a:spAutoFit/>
-          </a:bodyPr>
-          <a:lstStyle/>
-          <a:p>
-            <a:pPr algn="ctr">
-              <a:defRPr sz="1700" b="1">
-                <a:solidFill>
-                  <a:srgbClr val="B94141"/>
-                </a:solidFill>
-                <a:latin typeface="Aptos"/>
-              </a:defRPr>
-            </a:pPr>
-            <a:r>
-              <a:t>1 km/s is a research target, not demonstrated speed or payload/provider compatibility.</a:t>
+              <a:t>Ideal kinematics only; no commanded range, payload approval or motor rating established.</a:t>
             </a:r>
           </a:p>
         </p:txBody>

</xml_diff>

<commit_message>
Synchronize review PDFs and deck with source-power finding
</commit_message>
<xml_diff>
--- a/university/final_review_2026_10_10/VOLLEY_Final_Review_2026-10-10.pptx
+++ b/university/final_review_2026_10_10/VOLLEY_Final_Review_2026-10-10.pptx
@@ -10594,7 +10594,7 @@
               </a:defRPr>
             </a:pPr>
             <a:r>
-              <a:t>Wider enclosure; lift actuator, retention, tolerance and new mass budget open.</a:t>
+              <a:t>Wider enclosure; 0.5° assumed alignment stack fails its 5 mm gap; lift and retention still open.</a:t>
             </a:r>
           </a:p>
         </p:txBody>
@@ -12035,7 +12035,7 @@
               </a:defRPr>
             </a:pPr>
             <a:r>
-              <a:t>P118–P120 finite-force/assumed bank; matched-mission reference</a:t>
+              <a:t>P118–P127 finite force, source, tolerance and arrest; matched reference</a:t>
             </a:r>
           </a:p>
         </p:txBody>
@@ -12349,7 +12349,7 @@
               </a:defRPr>
             </a:pPr>
             <a:r>
-              <a:t>P119 checks force; P120 reruns bank assumptions; no twelve-shot mission case closes.</a:t>
+              <a:t>P125: single-string source power fails at the older commercial ESR bound; no twelve-shot case closes.</a:t>
             </a:r>
           </a:p>
         </p:txBody>
@@ -13340,7 +13340,7 @@
               </a:defRPr>
             </a:pPr>
             <a:r>
-              <a:t>•  Historical model reports 16.0 m/s; a finite force screen challenges that performance claim.</a:t>
+              <a:t>•  Historical 16.0 m/s is challenged; ideal 12.448 m/s lacks a sourceable single-string bank.</a:t>
             </a:r>
           </a:p>
           <a:p>
@@ -13372,7 +13372,7 @@
               </a:defRPr>
             </a:pPr>
             <a:r>
-              <a:t>•  R1 geometry clears a scripted path, but has no lift or launch retention design.</a:t>
+              <a:t>•  R1 paths clear nominally; an assumed 0.5° tolerance stack consumes the side gap.</a:t>
             </a:r>
           </a:p>
           <a:p>

</xml_diff>

<commit_message>
Release Go 3 academic review report and deck
</commit_message>
<xml_diff>
--- a/university/final_review_2026_10_10/VOLLEY_Final_Review_2026-10-10.pptx
+++ b/university/final_review_2026_10_10/VOLLEY_Final_Review_2026-10-10.pptx
@@ -13590,7 +13590,7 @@
               </a:defRPr>
             </a:pPr>
             <a:r>
-              <a:t>Gen6 reopens the mechanism and installed-system trade</a:t>
+              <a:t>Gen6 has a testable mission, but no selected article</a:t>
             </a:r>
           </a:p>
         </p:txBody>
@@ -13662,7 +13662,7 @@
               </a:defRPr>
             </a:pPr>
             <a:r>
-              <a:t>GEN6 PLAN • NOT ACHIEVED</a:t>
+              <a:t>GEN6 SCREEN • NOT ACHIEVED</a:t>
             </a:r>
           </a:p>
         </p:txBody>
@@ -13698,7 +13698,7 @@
               </a:defRPr>
             </a:pPr>
             <a:r>
-              <a:t>P124 ideal stroke screen; Gen6 prototype specification remains open</a:t>
+              <a:t>P130 matched four-release J2 screen; P131–P132 first-article bounds</a:t>
             </a:r>
           </a:p>
         </p:txBody>
@@ -13741,7 +13741,7 @@
       </p:sp>
       <p:pic>
         <p:nvPicPr>
-          <p:cNvPr id="9" name="Picture 8" descr="precision_delivery_design_space.png"/>
+          <p:cNvPr id="9" name="Picture 8" descr="gen6_matched_campaign.png"/>
           <p:cNvPicPr>
             <a:picLocks noChangeAspect="1"/>
           </p:cNvPicPr>
@@ -13755,8 +13755,8 @@
         </p:blipFill>
         <p:spPr>
           <a:xfrm>
-            <a:off x="438912" y="1426464"/>
-            <a:ext cx="6675120" cy="4005072"/>
+            <a:off x="438912" y="2260854"/>
+            <a:ext cx="6675120" cy="2336291"/>
           </a:xfrm>
           <a:prstGeom prst="rect">
             <a:avLst/>
@@ -13882,7 +13882,7 @@
               </a:defRPr>
             </a:pPr>
             <a:r>
-              <a:t>Start with the mission</a:t>
+              <a:t>Matched mission</a:t>
             </a:r>
           </a:p>
         </p:txBody>
@@ -13918,7 +13918,7 @@
               </a:defRPr>
             </a:pPr>
             <a:r>
-              <a:t>Specify a delivered state, tolerance, host and payload load before choosing release speed.</a:t>
+              <a:t>Two 1U + two 3U targets: both release choices reach ideal states. Assumed device + fuel favors springs by 10.72 kg.</a:t>
             </a:r>
           </a:p>
         </p:txBody>
@@ -14042,7 +14042,7 @@
               </a:defRPr>
             </a:pPr>
             <a:r>
-              <a:t>Separate the regimes</a:t>
+              <a:t>First-article gap</a:t>
             </a:r>
           </a:p>
         </p:txBody>
@@ -14078,7 +14078,7 @@
               </a:defRPr>
             </a:pPr>
             <a:r>
-              <a:t>1 km/s over 1.3 m implies ~39,220 g for 4 kg. It is not a first ordinary-3U prototype target.</a:t>
+              <a:t>Two STEP envelopes exist; ~9.35 kg remains for all omitted hardware under a surrogate parity screen.</a:t>
             </a:r>
           </a:p>
         </p:txBody>
@@ -14114,7 +14114,7 @@
               </a:defRPr>
             </a:pPr>
             <a:r>
-              <a:t>Ideal kinematics only; no commanded range, payload approval or motor rating established.</a:t>
+              <a:t>1 km/s remains separate long-range research; no command range or motor rating established.</a:t>
             </a:r>
           </a:p>
         </p:txBody>
@@ -14256,7 +14256,7 @@
               </a:defRPr>
             </a:pPr>
             <a:r>
-              <a:t>Next milestone: one reviewable first-test configuration</a:t>
+              <a:t>Next milestone: close G0 and G1 before any build</a:t>
             </a:r>
           </a:p>
         </p:txBody>
@@ -14364,7 +14364,7 @@
               </a:defRPr>
             </a:pPr>
             <a:r>
-              <a:t>PLAN-R2 N0–N5 and agreed near-term end goal</a:t>
+              <a:t>P130–P132; G0/G1 review gates; no construction authorization</a:t>
             </a:r>
           </a:p>
         </p:txBody>
@@ -14479,7 +14479,7 @@
               </a:defRPr>
             </a:pPr>
             <a:r>
-              <a:t>Freeze</a:t>
+              <a:t>Specify</a:t>
             </a:r>
           </a:p>
         </p:txBody>
@@ -14558,7 +14558,7 @@
               </a:defRPr>
             </a:pPr>
             <a:r>
-              <a:t>Named mission, payload and host surrogate</a:t>
+              <a:t>Real customer targets, tolerances and provider interface</a:t>
             </a:r>
           </a:p>
         </p:txBody>
@@ -14716,7 +14716,7 @@
               </a:defRPr>
             </a:pPr>
             <a:r>
-              <a:t>Fair mechanism and installed-burden trade</a:t>
+              <a:t>Complete motor, source, brake, contact and installed BOM</a:t>
             </a:r>
           </a:p>
         </p:txBody>

</xml_diff>

<commit_message>
Reconcile Gen5 report and review pack with Gen6 CAD study
</commit_message>
<xml_diff>
--- a/university/final_review_2026_10_10/VOLLEY_Final_Review_2026-10-10.pptx
+++ b/university/final_review_2026_10_10/VOLLEY_Final_Review_2026-10-10.pptx
@@ -31,6 +31,7 @@
     <p:sldId id="279" r:id="rId30"/>
     <p:sldId id="280" r:id="rId31"/>
     <p:sldId id="281" r:id="rId32"/>
+    <p:sldId id="282" r:id="rId33"/>
   </p:sldIdLst>
   <p:sldSz cx="12191695" cy="6858000" type="screen4x3"/>
   <p:notesSz cx="6858000" cy="9144000"/>
@@ -9928,7 +9929,7 @@
               </a:defRPr>
             </a:pPr>
             <a:r>
-              <a:t>Exact track/cassette clash on each side; CadQuery and FreeCAD agree.</a:t>
+              <a:t>Cassette/track clash per side. Full audit: 17 intersecting pairs, including sled/track and sled/stator.</a:t>
             </a:r>
           </a:p>
         </p:txBody>
@@ -10106,7 +10107,7 @@
               </a:defRPr>
             </a:pPr>
             <a:r>
-              <a:t>R1 clears a scripted path; the feeder is not designed</a:t>
+              <a:t>R1 clears cassette width, but still has assembly clashes</a:t>
             </a:r>
           </a:p>
         </p:txBody>
@@ -10434,7 +10435,7 @@
               </a:defRPr>
             </a:pPr>
             <a:r>
-              <a:t>Scripted 3U envelope routes and conservative fixed-part swept boxes clear.</a:t>
+              <a:t>Selected scripted 3U paths clear; a whole-assembly audit still finds five intersecting solid pairs.</a:t>
             </a:r>
           </a:p>
         </p:txBody>
@@ -13372,7 +13373,7 @@
               </a:defRPr>
             </a:pPr>
             <a:r>
-              <a:t>•  R1 paths clear nominally; an assumed 0.5° tolerance stack consumes the side gap.</a:t>
+              <a:t>•  R1 retains sled/track and sled/stator clashes; its assumed 0.5° gap stack fails.</a:t>
             </a:r>
           </a:p>
           <a:p>
@@ -14256,7 +14257,7 @@
               </a:defRPr>
             </a:pPr>
             <a:r>
-              <a:t>Next milestone: close G0 and G1 before any build</a:t>
+              <a:t>Paired cells improve the nominal acceleration path</a:t>
             </a:r>
           </a:p>
         </p:txBody>
@@ -14328,7 +14329,7 @@
               </a:defRPr>
             </a:pPr>
             <a:r>
-              <a:t>GEN6 PLAN • NOT ACHIEVED</a:t>
+              <a:t>GEN6 GEOMETRY • UNSELECTED</a:t>
             </a:r>
           </a:p>
         </p:txBody>
@@ -14364,7 +14365,7 @@
               </a:defRPr>
             </a:pPr>
             <a:r>
-              <a:t>P130–P132; G0/G1 review gates; no construction authorization</a:t>
+              <a:t>FreeCAD/STEP R0 packaging comparison; no feeder mechanism selected</a:t>
             </a:r>
           </a:p>
         </p:txBody>
@@ -14405,18 +14406,247 @@
           </a:p>
         </p:txBody>
       </p:sp>
-      <p:sp>
-        <p:nvSpPr>
-          <p:cNvPr id="9" name="Rounded Rectangle 8"/>
+      <p:pic>
+        <p:nvPicPr>
+          <p:cNvPr id="9" name="Picture 8" descr="Four_Cell_R0_Plan.png"/>
+          <p:cNvPicPr>
+            <a:picLocks noChangeAspect="1"/>
+          </p:cNvPicPr>
+          <p:nvPr/>
+        </p:nvPicPr>
+        <p:blipFill>
+          <a:blip r:embed="rId2"/>
+          <a:stretch>
+            <a:fillRect/>
+          </a:stretch>
+        </p:blipFill>
+        <p:spPr>
+          <a:xfrm>
+            <a:off x="475488" y="1991281"/>
+            <a:ext cx="7315200" cy="3094892"/>
+          </a:xfrm>
+          <a:prstGeom prst="rect">
+            <a:avLst/>
+          </a:prstGeom>
+        </p:spPr>
+      </p:pic>
+      <p:sp>
+        <p:nvSpPr>
+          <p:cNvPr id="10" name="Rounded Rectangle 9"/>
           <p:cNvSpPr/>
           <p:nvPr/>
         </p:nvSpPr>
         <p:spPr>
           <a:xfrm>
-            <a:off x="758952" y="1645920"/>
-            <a:ext cx="2011680" cy="768096"/>
+            <a:off x="7973568" y="1627632"/>
+            <a:ext cx="3584448" cy="1618488"/>
           </a:xfrm>
           <a:prstGeom prst="roundRect">
+            <a:avLst/>
+          </a:prstGeom>
+          <a:solidFill>
+            <a:srgbClr val="F6F9FB"/>
+          </a:solidFill>
+          <a:ln>
+            <a:solidFill>
+              <a:srgbClr val="DDE7EC"/>
+            </a:solidFill>
+          </a:ln>
+        </p:spPr>
+        <p:style>
+          <a:lnRef idx="1">
+            <a:schemeClr val="accent1"/>
+          </a:lnRef>
+          <a:fillRef idx="3">
+            <a:schemeClr val="accent1"/>
+          </a:fillRef>
+          <a:effectRef idx="2">
+            <a:schemeClr val="accent1"/>
+          </a:effectRef>
+          <a:fontRef idx="minor">
+            <a:schemeClr val="lt1"/>
+          </a:fontRef>
+        </p:style>
+        <p:txBody>
+          <a:bodyPr rtlCol="0" anchor="ctr"/>
+          <a:lstStyle/>
+          <a:p>
+            <a:pPr algn="ctr"/>
+          </a:p>
+        </p:txBody>
+      </p:sp>
+      <p:sp>
+        <p:nvSpPr>
+          <p:cNvPr id="11" name="Rectangle 10"/>
+          <p:cNvSpPr/>
+          <p:nvPr/>
+        </p:nvSpPr>
+        <p:spPr>
+          <a:xfrm>
+            <a:off x="7973568" y="1627632"/>
+            <a:ext cx="73152" cy="1618488"/>
+          </a:xfrm>
+          <a:prstGeom prst="rect">
+            <a:avLst/>
+          </a:prstGeom>
+          <a:solidFill>
+            <a:srgbClr val="B94141"/>
+          </a:solidFill>
+          <a:ln>
+            <a:noFill/>
+          </a:ln>
+        </p:spPr>
+        <p:style>
+          <a:lnRef idx="1">
+            <a:schemeClr val="accent1"/>
+          </a:lnRef>
+          <a:fillRef idx="3">
+            <a:schemeClr val="accent1"/>
+          </a:fillRef>
+          <a:effectRef idx="2">
+            <a:schemeClr val="accent1"/>
+          </a:effectRef>
+          <a:fontRef idx="minor">
+            <a:schemeClr val="lt1"/>
+          </a:fontRef>
+        </p:style>
+        <p:txBody>
+          <a:bodyPr rtlCol="0" anchor="ctr"/>
+          <a:lstStyle/>
+          <a:p>
+            <a:pPr algn="ctr"/>
+          </a:p>
+        </p:txBody>
+      </p:sp>
+      <p:sp>
+        <p:nvSpPr>
+          <p:cNvPr id="12" name="TextBox 11"/>
+          <p:cNvSpPr txBox="1"/>
+          <p:nvPr/>
+        </p:nvSpPr>
+        <p:spPr>
+          <a:xfrm>
+            <a:off x="8183880" y="1773936"/>
+            <a:ext cx="3218688" cy="502920"/>
+          </a:xfrm>
+          <a:prstGeom prst="rect">
+            <a:avLst/>
+          </a:prstGeom>
+          <a:noFill/>
+        </p:spPr>
+        <p:txBody>
+          <a:bodyPr wrap="square" lIns="13716" rIns="13716" tIns="13716" bIns="13716" anchor="t">
+            <a:spAutoFit/>
+          </a:bodyPr>
+          <a:lstStyle/>
+          <a:p>
+            <a:pPr algn="l">
+              <a:defRPr sz="1700" b="1">
+                <a:solidFill>
+                  <a:srgbClr val="0D2035"/>
+                </a:solidFill>
+                <a:latin typeface="Aptos"/>
+              </a:defRPr>
+            </a:pPr>
+            <a:r>
+              <a:t>Staggered</a:t>
+            </a:r>
+          </a:p>
+        </p:txBody>
+      </p:sp>
+      <p:sp>
+        <p:nvSpPr>
+          <p:cNvPr id="13" name="TextBox 12"/>
+          <p:cNvSpPr txBox="1"/>
+          <p:nvPr/>
+        </p:nvSpPr>
+        <p:spPr>
+          <a:xfrm>
+            <a:off x="8183880" y="2377440"/>
+            <a:ext cx="3200400" cy="704088"/>
+          </a:xfrm>
+          <a:prstGeom prst="rect">
+            <a:avLst/>
+          </a:prstGeom>
+          <a:noFill/>
+        </p:spPr>
+        <p:txBody>
+          <a:bodyPr wrap="square" lIns="13716" rIns="13716" tIns="13716" bIns="13716" anchor="t">
+            <a:spAutoFit/>
+          </a:bodyPr>
+          <a:lstStyle/>
+          <a:p>
+            <a:pPr algn="l">
+              <a:defRPr sz="1400" b="0">
+                <a:solidFill>
+                  <a:srgbClr val="1E3144"/>
+                </a:solidFill>
+                <a:latin typeface="Aptos"/>
+              </a:defRPr>
+            </a:pPr>
+            <a:r>
+              <a:t>Last cell: 330 mm to brake; 5.56 g ideal mean for 6 m/s.</a:t>
+            </a:r>
+          </a:p>
+        </p:txBody>
+      </p:sp>
+      <p:sp>
+        <p:nvSpPr>
+          <p:cNvPr id="14" name="Rounded Rectangle 13"/>
+          <p:cNvSpPr/>
+          <p:nvPr/>
+        </p:nvSpPr>
+        <p:spPr>
+          <a:xfrm>
+            <a:off x="7973568" y="3419856"/>
+            <a:ext cx="3584448" cy="1618488"/>
+          </a:xfrm>
+          <a:prstGeom prst="roundRect">
+            <a:avLst/>
+          </a:prstGeom>
+          <a:solidFill>
+            <a:srgbClr val="F6F9FB"/>
+          </a:solidFill>
+          <a:ln>
+            <a:solidFill>
+              <a:srgbClr val="DDE7EC"/>
+            </a:solidFill>
+          </a:ln>
+        </p:spPr>
+        <p:style>
+          <a:lnRef idx="1">
+            <a:schemeClr val="accent1"/>
+          </a:lnRef>
+          <a:fillRef idx="3">
+            <a:schemeClr val="accent1"/>
+          </a:fillRef>
+          <a:effectRef idx="2">
+            <a:schemeClr val="accent1"/>
+          </a:effectRef>
+          <a:fontRef idx="minor">
+            <a:schemeClr val="lt1"/>
+          </a:fontRef>
+        </p:style>
+        <p:txBody>
+          <a:bodyPr rtlCol="0" anchor="ctr"/>
+          <a:lstStyle/>
+          <a:p>
+            <a:pPr algn="ctr"/>
+          </a:p>
+        </p:txBody>
+      </p:sp>
+      <p:sp>
+        <p:nvSpPr>
+          <p:cNvPr id="15" name="Rectangle 14"/>
+          <p:cNvSpPr/>
+          <p:nvPr/>
+        </p:nvSpPr>
+        <p:spPr>
+          <a:xfrm>
+            <a:off x="7973568" y="3419856"/>
+            <a:ext cx="73152" cy="1618488"/>
+          </a:xfrm>
+          <a:prstGeom prst="rect">
             <a:avLst/>
           </a:prstGeom>
           <a:solidFill>
@@ -14450,14 +14680,86 @@
       </p:sp>
       <p:sp>
         <p:nvSpPr>
-          <p:cNvPr id="10" name="TextBox 9"/>
-          <p:cNvSpPr txBox="1"/>
-          <p:nvPr/>
-        </p:nvSpPr>
-        <p:spPr>
-          <a:xfrm>
-            <a:off x="941832" y="1810512"/>
-            <a:ext cx="1673352" cy="438912"/>
+          <p:cNvPr id="16" name="TextBox 15"/>
+          <p:cNvSpPr txBox="1"/>
+          <p:nvPr/>
+        </p:nvSpPr>
+        <p:spPr>
+          <a:xfrm>
+            <a:off x="8183880" y="3566160"/>
+            <a:ext cx="3218688" cy="502920"/>
+          </a:xfrm>
+          <a:prstGeom prst="rect">
+            <a:avLst/>
+          </a:prstGeom>
+          <a:noFill/>
+        </p:spPr>
+        <p:txBody>
+          <a:bodyPr wrap="square" lIns="13716" rIns="13716" tIns="13716" bIns="13716" anchor="t">
+            <a:spAutoFit/>
+          </a:bodyPr>
+          <a:lstStyle/>
+          <a:p>
+            <a:pPr algn="l">
+              <a:defRPr sz="1700" b="1">
+                <a:solidFill>
+                  <a:srgbClr val="0D2035"/>
+                </a:solidFill>
+                <a:latin typeface="Aptos"/>
+              </a:defRPr>
+            </a:pPr>
+            <a:r>
+              <a:t>Paired</a:t>
+            </a:r>
+          </a:p>
+        </p:txBody>
+      </p:sp>
+      <p:sp>
+        <p:nvSpPr>
+          <p:cNvPr id="17" name="TextBox 16"/>
+          <p:cNvSpPr txBox="1"/>
+          <p:nvPr/>
+        </p:nvSpPr>
+        <p:spPr>
+          <a:xfrm>
+            <a:off x="8183880" y="4169664"/>
+            <a:ext cx="3200400" cy="704088"/>
+          </a:xfrm>
+          <a:prstGeom prst="rect">
+            <a:avLst/>
+          </a:prstGeom>
+          <a:noFill/>
+        </p:spPr>
+        <p:txBody>
+          <a:bodyPr wrap="square" lIns="13716" rIns="13716" tIns="13716" bIns="13716" anchor="t">
+            <a:spAutoFit/>
+          </a:bodyPr>
+          <a:lstStyle/>
+          <a:p>
+            <a:pPr algn="l">
+              <a:defRPr sz="1400" b="0">
+                <a:solidFill>
+                  <a:srgbClr val="1E3144"/>
+                </a:solidFill>
+                <a:latin typeface="Aptos"/>
+              </a:defRPr>
+            </a:pPr>
+            <a:r>
+              <a:t>At least 900 mm per cell; 2.04 g largest ideal mean at 6 m/s.</a:t>
+            </a:r>
+          </a:p>
+        </p:txBody>
+      </p:sp>
+      <p:sp>
+        <p:nvSpPr>
+          <p:cNvPr id="18" name="TextBox 17"/>
+          <p:cNvSpPr txBox="1"/>
+          <p:nvPr/>
+        </p:nvSpPr>
+        <p:spPr>
+          <a:xfrm>
+            <a:off x="731520" y="5788152"/>
+            <a:ext cx="10881360" cy="457200"/>
           </a:xfrm>
           <a:prstGeom prst="rect">
             <a:avLst/>
@@ -14471,568 +14773,15 @@
           <a:lstStyle/>
           <a:p>
             <a:pPr algn="ctr">
-              <a:defRPr sz="2000" b="1">
-                <a:solidFill>
-                  <a:srgbClr val="FFFFFF"/>
-                </a:solidFill>
-                <a:latin typeface="Aptos"/>
-              </a:defRPr>
-            </a:pPr>
-            <a:r>
-              <a:t>Specify</a:t>
-            </a:r>
-          </a:p>
-        </p:txBody>
-      </p:sp>
-      <p:sp>
-        <p:nvSpPr>
-          <p:cNvPr id="11" name="Rounded Rectangle 10"/>
-          <p:cNvSpPr/>
-          <p:nvPr/>
-        </p:nvSpPr>
-        <p:spPr>
-          <a:xfrm>
-            <a:off x="2962656" y="1645920"/>
-            <a:ext cx="8229600" cy="768096"/>
-          </a:xfrm>
-          <a:prstGeom prst="roundRect">
-            <a:avLst/>
-          </a:prstGeom>
-          <a:solidFill>
-            <a:srgbClr val="F6F9FB"/>
-          </a:solidFill>
-          <a:ln>
-            <a:noFill/>
-          </a:ln>
-        </p:spPr>
-        <p:style>
-          <a:lnRef idx="1">
-            <a:schemeClr val="accent1"/>
-          </a:lnRef>
-          <a:fillRef idx="3">
-            <a:schemeClr val="accent1"/>
-          </a:fillRef>
-          <a:effectRef idx="2">
-            <a:schemeClr val="accent1"/>
-          </a:effectRef>
-          <a:fontRef idx="minor">
-            <a:schemeClr val="lt1"/>
-          </a:fontRef>
-        </p:style>
-        <p:txBody>
-          <a:bodyPr rtlCol="0" anchor="ctr"/>
-          <a:lstStyle/>
-          <a:p>
-            <a:pPr algn="ctr"/>
-          </a:p>
-        </p:txBody>
-      </p:sp>
-      <p:sp>
-        <p:nvSpPr>
-          <p:cNvPr id="12" name="TextBox 11"/>
-          <p:cNvSpPr txBox="1"/>
-          <p:nvPr/>
-        </p:nvSpPr>
-        <p:spPr>
-          <a:xfrm>
-            <a:off x="3246120" y="1810512"/>
-            <a:ext cx="7708392" cy="457200"/>
-          </a:xfrm>
-          <a:prstGeom prst="rect">
-            <a:avLst/>
-          </a:prstGeom>
-          <a:noFill/>
-        </p:spPr>
-        <p:txBody>
-          <a:bodyPr wrap="square" lIns="13716" rIns="13716" tIns="13716" bIns="13716" anchor="t">
-            <a:spAutoFit/>
-          </a:bodyPr>
-          <a:lstStyle/>
-          <a:p>
-            <a:pPr algn="l">
-              <a:defRPr sz="2000" b="0">
-                <a:solidFill>
-                  <a:srgbClr val="1E3144"/>
-                </a:solidFill>
-                <a:latin typeface="Aptos"/>
-              </a:defRPr>
-            </a:pPr>
-            <a:r>
-              <a:t>Real customer targets, tolerances and provider interface</a:t>
-            </a:r>
-          </a:p>
-        </p:txBody>
-      </p:sp>
-      <p:sp>
-        <p:nvSpPr>
-          <p:cNvPr id="13" name="Rounded Rectangle 12"/>
-          <p:cNvSpPr/>
-          <p:nvPr/>
-        </p:nvSpPr>
-        <p:spPr>
-          <a:xfrm>
-            <a:off x="758952" y="2697480"/>
-            <a:ext cx="2011680" cy="768096"/>
-          </a:xfrm>
-          <a:prstGeom prst="roundRect">
-            <a:avLst/>
-          </a:prstGeom>
-          <a:solidFill>
-            <a:srgbClr val="0096A0"/>
-          </a:solidFill>
-          <a:ln>
-            <a:noFill/>
-          </a:ln>
-        </p:spPr>
-        <p:style>
-          <a:lnRef idx="1">
-            <a:schemeClr val="accent1"/>
-          </a:lnRef>
-          <a:fillRef idx="3">
-            <a:schemeClr val="accent1"/>
-          </a:fillRef>
-          <a:effectRef idx="2">
-            <a:schemeClr val="accent1"/>
-          </a:effectRef>
-          <a:fontRef idx="minor">
-            <a:schemeClr val="lt1"/>
-          </a:fontRef>
-        </p:style>
-        <p:txBody>
-          <a:bodyPr rtlCol="0" anchor="ctr"/>
-          <a:lstStyle/>
-          <a:p>
-            <a:pPr algn="ctr"/>
-          </a:p>
-        </p:txBody>
-      </p:sp>
-      <p:sp>
-        <p:nvSpPr>
-          <p:cNvPr id="14" name="TextBox 13"/>
-          <p:cNvSpPr txBox="1"/>
-          <p:nvPr/>
-        </p:nvSpPr>
-        <p:spPr>
-          <a:xfrm>
-            <a:off x="941832" y="2862072"/>
-            <a:ext cx="1673352" cy="438912"/>
-          </a:xfrm>
-          <a:prstGeom prst="rect">
-            <a:avLst/>
-          </a:prstGeom>
-          <a:noFill/>
-        </p:spPr>
-        <p:txBody>
-          <a:bodyPr wrap="square" lIns="13716" rIns="13716" tIns="13716" bIns="13716" anchor="t">
-            <a:spAutoFit/>
-          </a:bodyPr>
-          <a:lstStyle/>
-          <a:p>
-            <a:pPr algn="ctr">
-              <a:defRPr sz="2000" b="1">
-                <a:solidFill>
-                  <a:srgbClr val="FFFFFF"/>
-                </a:solidFill>
-                <a:latin typeface="Aptos"/>
-              </a:defRPr>
-            </a:pPr>
-            <a:r>
-              <a:t>Decide</a:t>
-            </a:r>
-          </a:p>
-        </p:txBody>
-      </p:sp>
-      <p:sp>
-        <p:nvSpPr>
-          <p:cNvPr id="15" name="Rounded Rectangle 14"/>
-          <p:cNvSpPr/>
-          <p:nvPr/>
-        </p:nvSpPr>
-        <p:spPr>
-          <a:xfrm>
-            <a:off x="2962656" y="2697480"/>
-            <a:ext cx="8229600" cy="768096"/>
-          </a:xfrm>
-          <a:prstGeom prst="roundRect">
-            <a:avLst/>
-          </a:prstGeom>
-          <a:solidFill>
-            <a:srgbClr val="F6F9FB"/>
-          </a:solidFill>
-          <a:ln>
-            <a:noFill/>
-          </a:ln>
-        </p:spPr>
-        <p:style>
-          <a:lnRef idx="1">
-            <a:schemeClr val="accent1"/>
-          </a:lnRef>
-          <a:fillRef idx="3">
-            <a:schemeClr val="accent1"/>
-          </a:fillRef>
-          <a:effectRef idx="2">
-            <a:schemeClr val="accent1"/>
-          </a:effectRef>
-          <a:fontRef idx="minor">
-            <a:schemeClr val="lt1"/>
-          </a:fontRef>
-        </p:style>
-        <p:txBody>
-          <a:bodyPr rtlCol="0" anchor="ctr"/>
-          <a:lstStyle/>
-          <a:p>
-            <a:pPr algn="ctr"/>
-          </a:p>
-        </p:txBody>
-      </p:sp>
-      <p:sp>
-        <p:nvSpPr>
-          <p:cNvPr id="16" name="TextBox 15"/>
-          <p:cNvSpPr txBox="1"/>
-          <p:nvPr/>
-        </p:nvSpPr>
-        <p:spPr>
-          <a:xfrm>
-            <a:off x="3246120" y="2862072"/>
-            <a:ext cx="7708392" cy="457200"/>
-          </a:xfrm>
-          <a:prstGeom prst="rect">
-            <a:avLst/>
-          </a:prstGeom>
-          <a:noFill/>
-        </p:spPr>
-        <p:txBody>
-          <a:bodyPr wrap="square" lIns="13716" rIns="13716" tIns="13716" bIns="13716" anchor="t">
-            <a:spAutoFit/>
-          </a:bodyPr>
-          <a:lstStyle/>
-          <a:p>
-            <a:pPr algn="l">
-              <a:defRPr sz="2000" b="0">
-                <a:solidFill>
-                  <a:srgbClr val="1E3144"/>
-                </a:solidFill>
-                <a:latin typeface="Aptos"/>
-              </a:defRPr>
-            </a:pPr>
-            <a:r>
-              <a:t>Complete motor, source, brake, contact and installed BOM</a:t>
-            </a:r>
-          </a:p>
-        </p:txBody>
-      </p:sp>
-      <p:sp>
-        <p:nvSpPr>
-          <p:cNvPr id="17" name="Rounded Rectangle 16"/>
-          <p:cNvSpPr/>
-          <p:nvPr/>
-        </p:nvSpPr>
-        <p:spPr>
-          <a:xfrm>
-            <a:off x="758952" y="3749039"/>
-            <a:ext cx="2011680" cy="768096"/>
-          </a:xfrm>
-          <a:prstGeom prst="roundRect">
-            <a:avLst/>
-          </a:prstGeom>
-          <a:solidFill>
-            <a:srgbClr val="0096A0"/>
-          </a:solidFill>
-          <a:ln>
-            <a:noFill/>
-          </a:ln>
-        </p:spPr>
-        <p:style>
-          <a:lnRef idx="1">
-            <a:schemeClr val="accent1"/>
-          </a:lnRef>
-          <a:fillRef idx="3">
-            <a:schemeClr val="accent1"/>
-          </a:fillRef>
-          <a:effectRef idx="2">
-            <a:schemeClr val="accent1"/>
-          </a:effectRef>
-          <a:fontRef idx="minor">
-            <a:schemeClr val="lt1"/>
-          </a:fontRef>
-        </p:style>
-        <p:txBody>
-          <a:bodyPr rtlCol="0" anchor="ctr"/>
-          <a:lstStyle/>
-          <a:p>
-            <a:pPr algn="ctr"/>
-          </a:p>
-        </p:txBody>
-      </p:sp>
-      <p:sp>
-        <p:nvSpPr>
-          <p:cNvPr id="18" name="TextBox 17"/>
-          <p:cNvSpPr txBox="1"/>
-          <p:nvPr/>
-        </p:nvSpPr>
-        <p:spPr>
-          <a:xfrm>
-            <a:off x="941832" y="3913631"/>
-            <a:ext cx="1673352" cy="438912"/>
-          </a:xfrm>
-          <a:prstGeom prst="rect">
-            <a:avLst/>
-          </a:prstGeom>
-          <a:noFill/>
-        </p:spPr>
-        <p:txBody>
-          <a:bodyPr wrap="square" lIns="13716" rIns="13716" tIns="13716" bIns="13716" anchor="t">
-            <a:spAutoFit/>
-          </a:bodyPr>
-          <a:lstStyle/>
-          <a:p>
-            <a:pPr algn="ctr">
-              <a:defRPr sz="2000" b="1">
-                <a:solidFill>
-                  <a:srgbClr val="FFFFFF"/>
-                </a:solidFill>
-                <a:latin typeface="Aptos"/>
-              </a:defRPr>
-            </a:pPr>
-            <a:r>
-              <a:t>Measure</a:t>
-            </a:r>
-          </a:p>
-        </p:txBody>
-      </p:sp>
-      <p:sp>
-        <p:nvSpPr>
-          <p:cNvPr id="19" name="Rounded Rectangle 18"/>
-          <p:cNvSpPr/>
-          <p:nvPr/>
-        </p:nvSpPr>
-        <p:spPr>
-          <a:xfrm>
-            <a:off x="2962656" y="3749039"/>
-            <a:ext cx="8229600" cy="768096"/>
-          </a:xfrm>
-          <a:prstGeom prst="roundRect">
-            <a:avLst/>
-          </a:prstGeom>
-          <a:solidFill>
-            <a:srgbClr val="F6F9FB"/>
-          </a:solidFill>
-          <a:ln>
-            <a:noFill/>
-          </a:ln>
-        </p:spPr>
-        <p:style>
-          <a:lnRef idx="1">
-            <a:schemeClr val="accent1"/>
-          </a:lnRef>
-          <a:fillRef idx="3">
-            <a:schemeClr val="accent1"/>
-          </a:fillRef>
-          <a:effectRef idx="2">
-            <a:schemeClr val="accent1"/>
-          </a:effectRef>
-          <a:fontRef idx="minor">
-            <a:schemeClr val="lt1"/>
-          </a:fontRef>
-        </p:style>
-        <p:txBody>
-          <a:bodyPr rtlCol="0" anchor="ctr"/>
-          <a:lstStyle/>
-          <a:p>
-            <a:pPr algn="ctr"/>
-          </a:p>
-        </p:txBody>
-      </p:sp>
-      <p:sp>
-        <p:nvSpPr>
-          <p:cNvPr id="20" name="TextBox 19"/>
-          <p:cNvSpPr txBox="1"/>
-          <p:nvPr/>
-        </p:nvSpPr>
-        <p:spPr>
-          <a:xfrm>
-            <a:off x="3246120" y="3913631"/>
-            <a:ext cx="7708392" cy="457200"/>
-          </a:xfrm>
-          <a:prstGeom prst="rect">
-            <a:avLst/>
-          </a:prstGeom>
-          <a:noFill/>
-        </p:spPr>
-        <p:txBody>
-          <a:bodyPr wrap="square" lIns="13716" rIns="13716" tIns="13716" bIns="13716" anchor="t">
-            <a:spAutoFit/>
-          </a:bodyPr>
-          <a:lstStyle/>
-          <a:p>
-            <a:pPr algn="l">
-              <a:defRPr sz="2000" b="0">
-                <a:solidFill>
-                  <a:srgbClr val="1E3144"/>
-                </a:solidFill>
-                <a:latin typeface="Aptos"/>
-              </a:defRPr>
-            </a:pPr>
-            <a:r>
-              <a:t>Field, contact, release, arrest, loads and cycle behavior</a:t>
-            </a:r>
-          </a:p>
-        </p:txBody>
-      </p:sp>
-      <p:sp>
-        <p:nvSpPr>
-          <p:cNvPr id="21" name="Rounded Rectangle 20"/>
-          <p:cNvSpPr/>
-          <p:nvPr/>
-        </p:nvSpPr>
-        <p:spPr>
-          <a:xfrm>
-            <a:off x="758952" y="4800600"/>
-            <a:ext cx="2011680" cy="768096"/>
-          </a:xfrm>
-          <a:prstGeom prst="roundRect">
-            <a:avLst/>
-          </a:prstGeom>
-          <a:solidFill>
-            <a:srgbClr val="D78F2B"/>
-          </a:solidFill>
-          <a:ln>
-            <a:noFill/>
-          </a:ln>
-        </p:spPr>
-        <p:style>
-          <a:lnRef idx="1">
-            <a:schemeClr val="accent1"/>
-          </a:lnRef>
-          <a:fillRef idx="3">
-            <a:schemeClr val="accent1"/>
-          </a:fillRef>
-          <a:effectRef idx="2">
-            <a:schemeClr val="accent1"/>
-          </a:effectRef>
-          <a:fontRef idx="minor">
-            <a:schemeClr val="lt1"/>
-          </a:fontRef>
-        </p:style>
-        <p:txBody>
-          <a:bodyPr rtlCol="0" anchor="ctr"/>
-          <a:lstStyle/>
-          <a:p>
-            <a:pPr algn="ctr"/>
-          </a:p>
-        </p:txBody>
-      </p:sp>
-      <p:sp>
-        <p:nvSpPr>
-          <p:cNvPr id="22" name="TextBox 21"/>
-          <p:cNvSpPr txBox="1"/>
-          <p:nvPr/>
-        </p:nvSpPr>
-        <p:spPr>
-          <a:xfrm>
-            <a:off x="941832" y="4965192"/>
-            <a:ext cx="1673352" cy="438912"/>
-          </a:xfrm>
-          <a:prstGeom prst="rect">
-            <a:avLst/>
-          </a:prstGeom>
-          <a:noFill/>
-        </p:spPr>
-        <p:txBody>
-          <a:bodyPr wrap="square" lIns="13716" rIns="13716" tIns="13716" bIns="13716" anchor="t">
-            <a:spAutoFit/>
-          </a:bodyPr>
-          <a:lstStyle/>
-          <a:p>
-            <a:pPr algn="ctr">
-              <a:defRPr sz="2000" b="1">
-                <a:solidFill>
-                  <a:srgbClr val="FFFFFF"/>
-                </a:solidFill>
-                <a:latin typeface="Aptos"/>
-              </a:defRPr>
-            </a:pPr>
-            <a:r>
-              <a:t>Review</a:t>
-            </a:r>
-          </a:p>
-        </p:txBody>
-      </p:sp>
-      <p:sp>
-        <p:nvSpPr>
-          <p:cNvPr id="23" name="Rounded Rectangle 22"/>
-          <p:cNvSpPr/>
-          <p:nvPr/>
-        </p:nvSpPr>
-        <p:spPr>
-          <a:xfrm>
-            <a:off x="2962656" y="4800600"/>
-            <a:ext cx="8229600" cy="768096"/>
-          </a:xfrm>
-          <a:prstGeom prst="roundRect">
-            <a:avLst/>
-          </a:prstGeom>
-          <a:solidFill>
-            <a:srgbClr val="F6F9FB"/>
-          </a:solidFill>
-          <a:ln>
-            <a:noFill/>
-          </a:ln>
-        </p:spPr>
-        <p:style>
-          <a:lnRef idx="1">
-            <a:schemeClr val="accent1"/>
-          </a:lnRef>
-          <a:fillRef idx="3">
-            <a:schemeClr val="accent1"/>
-          </a:fillRef>
-          <a:effectRef idx="2">
-            <a:schemeClr val="accent1"/>
-          </a:effectRef>
-          <a:fontRef idx="minor">
-            <a:schemeClr val="lt1"/>
-          </a:fontRef>
-        </p:style>
-        <p:txBody>
-          <a:bodyPr rtlCol="0" anchor="ctr"/>
-          <a:lstStyle/>
-          <a:p>
-            <a:pPr algn="ctr"/>
-          </a:p>
-        </p:txBody>
-      </p:sp>
-      <p:sp>
-        <p:nvSpPr>
-          <p:cNvPr id="24" name="TextBox 23"/>
-          <p:cNvSpPr txBox="1"/>
-          <p:nvPr/>
-        </p:nvSpPr>
-        <p:spPr>
-          <a:xfrm>
-            <a:off x="3246120" y="4965192"/>
-            <a:ext cx="7708392" cy="457200"/>
-          </a:xfrm>
-          <a:prstGeom prst="rect">
-            <a:avLst/>
-          </a:prstGeom>
-          <a:noFill/>
-        </p:spPr>
-        <p:txBody>
-          <a:bodyPr wrap="square" lIns="13716" rIns="13716" tIns="13716" bIns="13716" anchor="t">
-            <a:spAutoFit/>
-          </a:bodyPr>
-          <a:lstStyle/>
-          <a:p>
-            <a:pPr algn="l">
-              <a:defRPr sz="2000" b="0">
-                <a:solidFill>
-                  <a:srgbClr val="1E3144"/>
-                </a:solidFill>
-                <a:latin typeface="Aptos"/>
-              </a:defRPr>
-            </a:pPr>
-            <a:r>
-              <a:t>Drawings, BOM, procedures, uncertainty and review decision</a:t>
+              <a:defRPr sz="1300" b="1">
+                <a:solidFill>
+                  <a:srgbClr val="0D2035"/>
+                </a:solidFill>
+                <a:latin typeface="Aptos"/>
+              </a:defRPr>
+            </a:pPr>
+            <a:r>
+              <a:t>26 nominal FreeCAD/STEP states pass represented-solid checks; locks, contact, docking and host fit remain open.</a:t>
             </a:r>
           </a:p>
         </p:txBody>
@@ -15174,7 +14923,7 @@
               </a:defRPr>
             </a:pPr>
             <a:r>
-              <a:t>Core literature and standards (1/2)</a:t>
+              <a:t>Next milestone: close G0 and G1 before any build</a:t>
             </a:r>
           </a:p>
         </p:txBody>
@@ -15210,7 +14959,7 @@
               </a:defRPr>
             </a:pPr>
             <a:r>
-              <a:t>REFERENCES</a:t>
+              <a:t>FUTURE WORK</a:t>
             </a:r>
           </a:p>
         </p:txBody>
@@ -15246,7 +14995,7 @@
               </a:defRPr>
             </a:pPr>
             <a:r>
-              <a:t>SOURCE LIST</a:t>
+              <a:t>GEN6 PLAN • NOT ACHIEVED</a:t>
             </a:r>
           </a:p>
         </p:txBody>
@@ -15282,7 +15031,7 @@
               </a:defRPr>
             </a:pPr>
             <a:r>
-              <a:t>Bibliography from VOLLEY-thesis/source/paper.tex</a:t>
+              <a:t>P130–P132; G0/G1 review gates; no construction authorization</a:t>
             </a:r>
           </a:p>
         </p:txBody>
@@ -15325,31 +15074,150 @@
       </p:sp>
       <p:sp>
         <p:nvSpPr>
-          <p:cNvPr id="9" name="TextBox 8"/>
-          <p:cNvSpPr txBox="1"/>
-          <p:nvPr/>
-        </p:nvSpPr>
-        <p:spPr>
-          <a:xfrm>
-            <a:off x="694944" y="1581912"/>
-            <a:ext cx="10881360" cy="4599432"/>
-          </a:xfrm>
-          <a:prstGeom prst="rect">
-            <a:avLst/>
-          </a:prstGeom>
-          <a:noFill/>
-        </p:spPr>
-        <p:txBody>
-          <a:bodyPr wrap="square" lIns="73152" rIns="73152" tIns="36576" bIns="0">
-            <a:spAutoFit/>
-          </a:bodyPr>
-          <a:lstStyle/>
-          <a:p>
-            <a:pPr>
-              <a:spcAft>
-                <a:spcPts val="1800"/>
-              </a:spcAft>
-              <a:defRPr sz="1700">
+          <p:cNvPr id="9" name="Rounded Rectangle 8"/>
+          <p:cNvSpPr/>
+          <p:nvPr/>
+        </p:nvSpPr>
+        <p:spPr>
+          <a:xfrm>
+            <a:off x="758952" y="1645920"/>
+            <a:ext cx="2011680" cy="768096"/>
+          </a:xfrm>
+          <a:prstGeom prst="roundRect">
+            <a:avLst/>
+          </a:prstGeom>
+          <a:solidFill>
+            <a:srgbClr val="0096A0"/>
+          </a:solidFill>
+          <a:ln>
+            <a:noFill/>
+          </a:ln>
+        </p:spPr>
+        <p:style>
+          <a:lnRef idx="1">
+            <a:schemeClr val="accent1"/>
+          </a:lnRef>
+          <a:fillRef idx="3">
+            <a:schemeClr val="accent1"/>
+          </a:fillRef>
+          <a:effectRef idx="2">
+            <a:schemeClr val="accent1"/>
+          </a:effectRef>
+          <a:fontRef idx="minor">
+            <a:schemeClr val="lt1"/>
+          </a:fontRef>
+        </p:style>
+        <p:txBody>
+          <a:bodyPr rtlCol="0" anchor="ctr"/>
+          <a:lstStyle/>
+          <a:p>
+            <a:pPr algn="ctr"/>
+          </a:p>
+        </p:txBody>
+      </p:sp>
+      <p:sp>
+        <p:nvSpPr>
+          <p:cNvPr id="10" name="TextBox 9"/>
+          <p:cNvSpPr txBox="1"/>
+          <p:nvPr/>
+        </p:nvSpPr>
+        <p:spPr>
+          <a:xfrm>
+            <a:off x="941832" y="1810512"/>
+            <a:ext cx="1673352" cy="438912"/>
+          </a:xfrm>
+          <a:prstGeom prst="rect">
+            <a:avLst/>
+          </a:prstGeom>
+          <a:noFill/>
+        </p:spPr>
+        <p:txBody>
+          <a:bodyPr wrap="square" lIns="13716" rIns="13716" tIns="13716" bIns="13716" anchor="t">
+            <a:spAutoFit/>
+          </a:bodyPr>
+          <a:lstStyle/>
+          <a:p>
+            <a:pPr algn="ctr">
+              <a:defRPr sz="2000" b="1">
+                <a:solidFill>
+                  <a:srgbClr val="FFFFFF"/>
+                </a:solidFill>
+                <a:latin typeface="Aptos"/>
+              </a:defRPr>
+            </a:pPr>
+            <a:r>
+              <a:t>Specify</a:t>
+            </a:r>
+          </a:p>
+        </p:txBody>
+      </p:sp>
+      <p:sp>
+        <p:nvSpPr>
+          <p:cNvPr id="11" name="Rounded Rectangle 10"/>
+          <p:cNvSpPr/>
+          <p:nvPr/>
+        </p:nvSpPr>
+        <p:spPr>
+          <a:xfrm>
+            <a:off x="2962656" y="1645920"/>
+            <a:ext cx="8229600" cy="768096"/>
+          </a:xfrm>
+          <a:prstGeom prst="roundRect">
+            <a:avLst/>
+          </a:prstGeom>
+          <a:solidFill>
+            <a:srgbClr val="F6F9FB"/>
+          </a:solidFill>
+          <a:ln>
+            <a:noFill/>
+          </a:ln>
+        </p:spPr>
+        <p:style>
+          <a:lnRef idx="1">
+            <a:schemeClr val="accent1"/>
+          </a:lnRef>
+          <a:fillRef idx="3">
+            <a:schemeClr val="accent1"/>
+          </a:fillRef>
+          <a:effectRef idx="2">
+            <a:schemeClr val="accent1"/>
+          </a:effectRef>
+          <a:fontRef idx="minor">
+            <a:schemeClr val="lt1"/>
+          </a:fontRef>
+        </p:style>
+        <p:txBody>
+          <a:bodyPr rtlCol="0" anchor="ctr"/>
+          <a:lstStyle/>
+          <a:p>
+            <a:pPr algn="ctr"/>
+          </a:p>
+        </p:txBody>
+      </p:sp>
+      <p:sp>
+        <p:nvSpPr>
+          <p:cNvPr id="12" name="TextBox 11"/>
+          <p:cNvSpPr txBox="1"/>
+          <p:nvPr/>
+        </p:nvSpPr>
+        <p:spPr>
+          <a:xfrm>
+            <a:off x="3246120" y="1810512"/>
+            <a:ext cx="7708392" cy="457200"/>
+          </a:xfrm>
+          <a:prstGeom prst="rect">
+            <a:avLst/>
+          </a:prstGeom>
+          <a:noFill/>
+        </p:spPr>
+        <p:txBody>
+          <a:bodyPr wrap="square" lIns="13716" rIns="13716" tIns="13716" bIns="13716" anchor="t">
+            <a:spAutoFit/>
+          </a:bodyPr>
+          <a:lstStyle/>
+          <a:p>
+            <a:pPr algn="l">
+              <a:defRPr sz="2000" b="0">
                 <a:solidFill>
                   <a:srgbClr val="1E3144"/>
                 </a:solidFill>
@@ -15357,15 +15225,157 @@
               </a:defRPr>
             </a:pPr>
             <a:r>
-              <a:t>•  [1] JAXA, JEM Payload Accommodation Handbook, Vol. 8: Small Satellite Deployment ICD.</a:t>
-            </a:r>
-          </a:p>
-          <a:p>
-            <a:pPr>
-              <a:spcAft>
-                <a:spcPts val="1800"/>
-              </a:spcAft>
-              <a:defRPr sz="1700">
+              <a:t>Real customer targets, tolerances and provider interface</a:t>
+            </a:r>
+          </a:p>
+        </p:txBody>
+      </p:sp>
+      <p:sp>
+        <p:nvSpPr>
+          <p:cNvPr id="13" name="Rounded Rectangle 12"/>
+          <p:cNvSpPr/>
+          <p:nvPr/>
+        </p:nvSpPr>
+        <p:spPr>
+          <a:xfrm>
+            <a:off x="758952" y="2697480"/>
+            <a:ext cx="2011680" cy="768096"/>
+          </a:xfrm>
+          <a:prstGeom prst="roundRect">
+            <a:avLst/>
+          </a:prstGeom>
+          <a:solidFill>
+            <a:srgbClr val="0096A0"/>
+          </a:solidFill>
+          <a:ln>
+            <a:noFill/>
+          </a:ln>
+        </p:spPr>
+        <p:style>
+          <a:lnRef idx="1">
+            <a:schemeClr val="accent1"/>
+          </a:lnRef>
+          <a:fillRef idx="3">
+            <a:schemeClr val="accent1"/>
+          </a:fillRef>
+          <a:effectRef idx="2">
+            <a:schemeClr val="accent1"/>
+          </a:effectRef>
+          <a:fontRef idx="minor">
+            <a:schemeClr val="lt1"/>
+          </a:fontRef>
+        </p:style>
+        <p:txBody>
+          <a:bodyPr rtlCol="0" anchor="ctr"/>
+          <a:lstStyle/>
+          <a:p>
+            <a:pPr algn="ctr"/>
+          </a:p>
+        </p:txBody>
+      </p:sp>
+      <p:sp>
+        <p:nvSpPr>
+          <p:cNvPr id="14" name="TextBox 13"/>
+          <p:cNvSpPr txBox="1"/>
+          <p:nvPr/>
+        </p:nvSpPr>
+        <p:spPr>
+          <a:xfrm>
+            <a:off x="941832" y="2862072"/>
+            <a:ext cx="1673352" cy="438912"/>
+          </a:xfrm>
+          <a:prstGeom prst="rect">
+            <a:avLst/>
+          </a:prstGeom>
+          <a:noFill/>
+        </p:spPr>
+        <p:txBody>
+          <a:bodyPr wrap="square" lIns="13716" rIns="13716" tIns="13716" bIns="13716" anchor="t">
+            <a:spAutoFit/>
+          </a:bodyPr>
+          <a:lstStyle/>
+          <a:p>
+            <a:pPr algn="ctr">
+              <a:defRPr sz="2000" b="1">
+                <a:solidFill>
+                  <a:srgbClr val="FFFFFF"/>
+                </a:solidFill>
+                <a:latin typeface="Aptos"/>
+              </a:defRPr>
+            </a:pPr>
+            <a:r>
+              <a:t>Decide</a:t>
+            </a:r>
+          </a:p>
+        </p:txBody>
+      </p:sp>
+      <p:sp>
+        <p:nvSpPr>
+          <p:cNvPr id="15" name="Rounded Rectangle 14"/>
+          <p:cNvSpPr/>
+          <p:nvPr/>
+        </p:nvSpPr>
+        <p:spPr>
+          <a:xfrm>
+            <a:off x="2962656" y="2697480"/>
+            <a:ext cx="8229600" cy="768096"/>
+          </a:xfrm>
+          <a:prstGeom prst="roundRect">
+            <a:avLst/>
+          </a:prstGeom>
+          <a:solidFill>
+            <a:srgbClr val="F6F9FB"/>
+          </a:solidFill>
+          <a:ln>
+            <a:noFill/>
+          </a:ln>
+        </p:spPr>
+        <p:style>
+          <a:lnRef idx="1">
+            <a:schemeClr val="accent1"/>
+          </a:lnRef>
+          <a:fillRef idx="3">
+            <a:schemeClr val="accent1"/>
+          </a:fillRef>
+          <a:effectRef idx="2">
+            <a:schemeClr val="accent1"/>
+          </a:effectRef>
+          <a:fontRef idx="minor">
+            <a:schemeClr val="lt1"/>
+          </a:fontRef>
+        </p:style>
+        <p:txBody>
+          <a:bodyPr rtlCol="0" anchor="ctr"/>
+          <a:lstStyle/>
+          <a:p>
+            <a:pPr algn="ctr"/>
+          </a:p>
+        </p:txBody>
+      </p:sp>
+      <p:sp>
+        <p:nvSpPr>
+          <p:cNvPr id="16" name="TextBox 15"/>
+          <p:cNvSpPr txBox="1"/>
+          <p:nvPr/>
+        </p:nvSpPr>
+        <p:spPr>
+          <a:xfrm>
+            <a:off x="3246120" y="2862072"/>
+            <a:ext cx="7708392" cy="457200"/>
+          </a:xfrm>
+          <a:prstGeom prst="rect">
+            <a:avLst/>
+          </a:prstGeom>
+          <a:noFill/>
+        </p:spPr>
+        <p:txBody>
+          <a:bodyPr wrap="square" lIns="13716" rIns="13716" tIns="13716" bIns="13716" anchor="t">
+            <a:spAutoFit/>
+          </a:bodyPr>
+          <a:lstStyle/>
+          <a:p>
+            <a:pPr algn="l">
+              <a:defRPr sz="2000" b="0">
                 <a:solidFill>
                   <a:srgbClr val="1E3144"/>
                 </a:solidFill>
@@ -15373,15 +15383,157 @@
               </a:defRPr>
             </a:pPr>
             <a:r>
-              <a:t>•  [2] Cal Poly, CubeSat Design Specification, Rev. 14, 2020.</a:t>
-            </a:r>
-          </a:p>
-          <a:p>
-            <a:pPr>
-              <a:spcAft>
-                <a:spcPts val="1800"/>
-              </a:spcAft>
-              <a:defRPr sz="1700">
+              <a:t>Complete motor, source, brake, contact and installed BOM</a:t>
+            </a:r>
+          </a:p>
+        </p:txBody>
+      </p:sp>
+      <p:sp>
+        <p:nvSpPr>
+          <p:cNvPr id="17" name="Rounded Rectangle 16"/>
+          <p:cNvSpPr/>
+          <p:nvPr/>
+        </p:nvSpPr>
+        <p:spPr>
+          <a:xfrm>
+            <a:off x="758952" y="3749039"/>
+            <a:ext cx="2011680" cy="768096"/>
+          </a:xfrm>
+          <a:prstGeom prst="roundRect">
+            <a:avLst/>
+          </a:prstGeom>
+          <a:solidFill>
+            <a:srgbClr val="0096A0"/>
+          </a:solidFill>
+          <a:ln>
+            <a:noFill/>
+          </a:ln>
+        </p:spPr>
+        <p:style>
+          <a:lnRef idx="1">
+            <a:schemeClr val="accent1"/>
+          </a:lnRef>
+          <a:fillRef idx="3">
+            <a:schemeClr val="accent1"/>
+          </a:fillRef>
+          <a:effectRef idx="2">
+            <a:schemeClr val="accent1"/>
+          </a:effectRef>
+          <a:fontRef idx="minor">
+            <a:schemeClr val="lt1"/>
+          </a:fontRef>
+        </p:style>
+        <p:txBody>
+          <a:bodyPr rtlCol="0" anchor="ctr"/>
+          <a:lstStyle/>
+          <a:p>
+            <a:pPr algn="ctr"/>
+          </a:p>
+        </p:txBody>
+      </p:sp>
+      <p:sp>
+        <p:nvSpPr>
+          <p:cNvPr id="18" name="TextBox 17"/>
+          <p:cNvSpPr txBox="1"/>
+          <p:nvPr/>
+        </p:nvSpPr>
+        <p:spPr>
+          <a:xfrm>
+            <a:off x="941832" y="3913631"/>
+            <a:ext cx="1673352" cy="438912"/>
+          </a:xfrm>
+          <a:prstGeom prst="rect">
+            <a:avLst/>
+          </a:prstGeom>
+          <a:noFill/>
+        </p:spPr>
+        <p:txBody>
+          <a:bodyPr wrap="square" lIns="13716" rIns="13716" tIns="13716" bIns="13716" anchor="t">
+            <a:spAutoFit/>
+          </a:bodyPr>
+          <a:lstStyle/>
+          <a:p>
+            <a:pPr algn="ctr">
+              <a:defRPr sz="2000" b="1">
+                <a:solidFill>
+                  <a:srgbClr val="FFFFFF"/>
+                </a:solidFill>
+                <a:latin typeface="Aptos"/>
+              </a:defRPr>
+            </a:pPr>
+            <a:r>
+              <a:t>Measure</a:t>
+            </a:r>
+          </a:p>
+        </p:txBody>
+      </p:sp>
+      <p:sp>
+        <p:nvSpPr>
+          <p:cNvPr id="19" name="Rounded Rectangle 18"/>
+          <p:cNvSpPr/>
+          <p:nvPr/>
+        </p:nvSpPr>
+        <p:spPr>
+          <a:xfrm>
+            <a:off x="2962656" y="3749039"/>
+            <a:ext cx="8229600" cy="768096"/>
+          </a:xfrm>
+          <a:prstGeom prst="roundRect">
+            <a:avLst/>
+          </a:prstGeom>
+          <a:solidFill>
+            <a:srgbClr val="F6F9FB"/>
+          </a:solidFill>
+          <a:ln>
+            <a:noFill/>
+          </a:ln>
+        </p:spPr>
+        <p:style>
+          <a:lnRef idx="1">
+            <a:schemeClr val="accent1"/>
+          </a:lnRef>
+          <a:fillRef idx="3">
+            <a:schemeClr val="accent1"/>
+          </a:fillRef>
+          <a:effectRef idx="2">
+            <a:schemeClr val="accent1"/>
+          </a:effectRef>
+          <a:fontRef idx="minor">
+            <a:schemeClr val="lt1"/>
+          </a:fontRef>
+        </p:style>
+        <p:txBody>
+          <a:bodyPr rtlCol="0" anchor="ctr"/>
+          <a:lstStyle/>
+          <a:p>
+            <a:pPr algn="ctr"/>
+          </a:p>
+        </p:txBody>
+      </p:sp>
+      <p:sp>
+        <p:nvSpPr>
+          <p:cNvPr id="20" name="TextBox 19"/>
+          <p:cNvSpPr txBox="1"/>
+          <p:nvPr/>
+        </p:nvSpPr>
+        <p:spPr>
+          <a:xfrm>
+            <a:off x="3246120" y="3913631"/>
+            <a:ext cx="7708392" cy="457200"/>
+          </a:xfrm>
+          <a:prstGeom prst="rect">
+            <a:avLst/>
+          </a:prstGeom>
+          <a:noFill/>
+        </p:spPr>
+        <p:txBody>
+          <a:bodyPr wrap="square" lIns="13716" rIns="13716" tIns="13716" bIns="13716" anchor="t">
+            <a:spAutoFit/>
+          </a:bodyPr>
+          <a:lstStyle/>
+          <a:p>
+            <a:pPr algn="l">
+              <a:defRPr sz="2000" b="0">
                 <a:solidFill>
                   <a:srgbClr val="1E3144"/>
                 </a:solidFill>
@@ -15389,15 +15541,157 @@
               </a:defRPr>
             </a:pPr>
             <a:r>
-              <a:t>•  [3] C. Foster et al., ‘Constellation phasing with differential drag on Planet Labs satellites,’ J. Spacecraft Rockets 55(2), 2018.</a:t>
-            </a:r>
-          </a:p>
-          <a:p>
-            <a:pPr>
-              <a:spcAft>
-                <a:spcPts val="1800"/>
-              </a:spcAft>
-              <a:defRPr sz="1700">
+              <a:t>Field, contact, release, arrest, loads and cycle behavior</a:t>
+            </a:r>
+          </a:p>
+        </p:txBody>
+      </p:sp>
+      <p:sp>
+        <p:nvSpPr>
+          <p:cNvPr id="21" name="Rounded Rectangle 20"/>
+          <p:cNvSpPr/>
+          <p:nvPr/>
+        </p:nvSpPr>
+        <p:spPr>
+          <a:xfrm>
+            <a:off x="758952" y="4800600"/>
+            <a:ext cx="2011680" cy="768096"/>
+          </a:xfrm>
+          <a:prstGeom prst="roundRect">
+            <a:avLst/>
+          </a:prstGeom>
+          <a:solidFill>
+            <a:srgbClr val="D78F2B"/>
+          </a:solidFill>
+          <a:ln>
+            <a:noFill/>
+          </a:ln>
+        </p:spPr>
+        <p:style>
+          <a:lnRef idx="1">
+            <a:schemeClr val="accent1"/>
+          </a:lnRef>
+          <a:fillRef idx="3">
+            <a:schemeClr val="accent1"/>
+          </a:fillRef>
+          <a:effectRef idx="2">
+            <a:schemeClr val="accent1"/>
+          </a:effectRef>
+          <a:fontRef idx="minor">
+            <a:schemeClr val="lt1"/>
+          </a:fontRef>
+        </p:style>
+        <p:txBody>
+          <a:bodyPr rtlCol="0" anchor="ctr"/>
+          <a:lstStyle/>
+          <a:p>
+            <a:pPr algn="ctr"/>
+          </a:p>
+        </p:txBody>
+      </p:sp>
+      <p:sp>
+        <p:nvSpPr>
+          <p:cNvPr id="22" name="TextBox 21"/>
+          <p:cNvSpPr txBox="1"/>
+          <p:nvPr/>
+        </p:nvSpPr>
+        <p:spPr>
+          <a:xfrm>
+            <a:off x="941832" y="4965192"/>
+            <a:ext cx="1673352" cy="438912"/>
+          </a:xfrm>
+          <a:prstGeom prst="rect">
+            <a:avLst/>
+          </a:prstGeom>
+          <a:noFill/>
+        </p:spPr>
+        <p:txBody>
+          <a:bodyPr wrap="square" lIns="13716" rIns="13716" tIns="13716" bIns="13716" anchor="t">
+            <a:spAutoFit/>
+          </a:bodyPr>
+          <a:lstStyle/>
+          <a:p>
+            <a:pPr algn="ctr">
+              <a:defRPr sz="2000" b="1">
+                <a:solidFill>
+                  <a:srgbClr val="FFFFFF"/>
+                </a:solidFill>
+                <a:latin typeface="Aptos"/>
+              </a:defRPr>
+            </a:pPr>
+            <a:r>
+              <a:t>Review</a:t>
+            </a:r>
+          </a:p>
+        </p:txBody>
+      </p:sp>
+      <p:sp>
+        <p:nvSpPr>
+          <p:cNvPr id="23" name="Rounded Rectangle 22"/>
+          <p:cNvSpPr/>
+          <p:nvPr/>
+        </p:nvSpPr>
+        <p:spPr>
+          <a:xfrm>
+            <a:off x="2962656" y="4800600"/>
+            <a:ext cx="8229600" cy="768096"/>
+          </a:xfrm>
+          <a:prstGeom prst="roundRect">
+            <a:avLst/>
+          </a:prstGeom>
+          <a:solidFill>
+            <a:srgbClr val="F6F9FB"/>
+          </a:solidFill>
+          <a:ln>
+            <a:noFill/>
+          </a:ln>
+        </p:spPr>
+        <p:style>
+          <a:lnRef idx="1">
+            <a:schemeClr val="accent1"/>
+          </a:lnRef>
+          <a:fillRef idx="3">
+            <a:schemeClr val="accent1"/>
+          </a:fillRef>
+          <a:effectRef idx="2">
+            <a:schemeClr val="accent1"/>
+          </a:effectRef>
+          <a:fontRef idx="minor">
+            <a:schemeClr val="lt1"/>
+          </a:fontRef>
+        </p:style>
+        <p:txBody>
+          <a:bodyPr rtlCol="0" anchor="ctr"/>
+          <a:lstStyle/>
+          <a:p>
+            <a:pPr algn="ctr"/>
+          </a:p>
+        </p:txBody>
+      </p:sp>
+      <p:sp>
+        <p:nvSpPr>
+          <p:cNvPr id="24" name="TextBox 23"/>
+          <p:cNvSpPr txBox="1"/>
+          <p:nvPr/>
+        </p:nvSpPr>
+        <p:spPr>
+          <a:xfrm>
+            <a:off x="3246120" y="4965192"/>
+            <a:ext cx="7708392" cy="457200"/>
+          </a:xfrm>
+          <a:prstGeom prst="rect">
+            <a:avLst/>
+          </a:prstGeom>
+          <a:noFill/>
+        </p:spPr>
+        <p:txBody>
+          <a:bodyPr wrap="square" lIns="13716" rIns="13716" tIns="13716" bIns="13716" anchor="t">
+            <a:spAutoFit/>
+          </a:bodyPr>
+          <a:lstStyle/>
+          <a:p>
+            <a:pPr algn="l">
+              <a:defRPr sz="2000" b="0">
                 <a:solidFill>
                   <a:srgbClr val="1E3144"/>
                 </a:solidFill>
@@ -15405,23 +15699,7 @@
               </a:defRPr>
             </a:pPr>
             <a:r>
-              <a:t>•  [4] H. Feng et al., ‘Design and reachable domain analysis of on-orbit electromagnetic launcher for CubeSats,’ Int. J. Aerospace Eng., 2025.</a:t>
-            </a:r>
-          </a:p>
-          <a:p>
-            <a:pPr>
-              <a:spcAft>
-                <a:spcPts val="1800"/>
-              </a:spcAft>
-              <a:defRPr sz="1700">
-                <a:solidFill>
-                  <a:srgbClr val="1E3144"/>
-                </a:solidFill>
-                <a:latin typeface="Aptos"/>
-              </a:defRPr>
-            </a:pPr>
-            <a:r>
-              <a:t>•  [5] Y. Zhao et al., ‘Design and analysis of a new deployer for the in-orbit release of multiple stacked CubeSats,’ Remote Sensing 14(17), 4205, 2022.</a:t>
+              <a:t>Drawings, BOM, procedures, uncertainty and review decision</a:t>
             </a:r>
           </a:p>
         </p:txBody>
@@ -15563,7 +15841,7 @@
               </a:defRPr>
             </a:pPr>
             <a:r>
-              <a:t>Methods and project records (2/2)</a:t>
+              <a:t>Core literature and standards (1/2)</a:t>
             </a:r>
           </a:p>
         </p:txBody>
@@ -15671,7 +15949,7 @@
               </a:defRPr>
             </a:pPr>
             <a:r>
-              <a:t>Bibliography from VOLLEY-thesis/source/paper.tex; project records</a:t>
+              <a:t>Bibliography from VOLLEY-thesis/source/paper.tex</a:t>
             </a:r>
           </a:p>
         </p:txBody>
@@ -15708,6 +15986,395 @@
             </a:pPr>
             <a:r>
               <a:t>26</a:t>
+            </a:r>
+          </a:p>
+        </p:txBody>
+      </p:sp>
+      <p:sp>
+        <p:nvSpPr>
+          <p:cNvPr id="9" name="TextBox 8"/>
+          <p:cNvSpPr txBox="1"/>
+          <p:nvPr/>
+        </p:nvSpPr>
+        <p:spPr>
+          <a:xfrm>
+            <a:off x="694944" y="1581912"/>
+            <a:ext cx="10881360" cy="4599432"/>
+          </a:xfrm>
+          <a:prstGeom prst="rect">
+            <a:avLst/>
+          </a:prstGeom>
+          <a:noFill/>
+        </p:spPr>
+        <p:txBody>
+          <a:bodyPr wrap="square" lIns="73152" rIns="73152" tIns="36576" bIns="0">
+            <a:spAutoFit/>
+          </a:bodyPr>
+          <a:lstStyle/>
+          <a:p>
+            <a:pPr>
+              <a:spcAft>
+                <a:spcPts val="1800"/>
+              </a:spcAft>
+              <a:defRPr sz="1700">
+                <a:solidFill>
+                  <a:srgbClr val="1E3144"/>
+                </a:solidFill>
+                <a:latin typeface="Aptos"/>
+              </a:defRPr>
+            </a:pPr>
+            <a:r>
+              <a:t>•  [1] JAXA, JEM Payload Accommodation Handbook, Vol. 8: Small Satellite Deployment ICD.</a:t>
+            </a:r>
+          </a:p>
+          <a:p>
+            <a:pPr>
+              <a:spcAft>
+                <a:spcPts val="1800"/>
+              </a:spcAft>
+              <a:defRPr sz="1700">
+                <a:solidFill>
+                  <a:srgbClr val="1E3144"/>
+                </a:solidFill>
+                <a:latin typeface="Aptos"/>
+              </a:defRPr>
+            </a:pPr>
+            <a:r>
+              <a:t>•  [2] Cal Poly, CubeSat Design Specification, Rev. 14, 2020.</a:t>
+            </a:r>
+          </a:p>
+          <a:p>
+            <a:pPr>
+              <a:spcAft>
+                <a:spcPts val="1800"/>
+              </a:spcAft>
+              <a:defRPr sz="1700">
+                <a:solidFill>
+                  <a:srgbClr val="1E3144"/>
+                </a:solidFill>
+                <a:latin typeface="Aptos"/>
+              </a:defRPr>
+            </a:pPr>
+            <a:r>
+              <a:t>•  [3] C. Foster et al., ‘Constellation phasing with differential drag on Planet Labs satellites,’ J. Spacecraft Rockets 55(2), 2018.</a:t>
+            </a:r>
+          </a:p>
+          <a:p>
+            <a:pPr>
+              <a:spcAft>
+                <a:spcPts val="1800"/>
+              </a:spcAft>
+              <a:defRPr sz="1700">
+                <a:solidFill>
+                  <a:srgbClr val="1E3144"/>
+                </a:solidFill>
+                <a:latin typeface="Aptos"/>
+              </a:defRPr>
+            </a:pPr>
+            <a:r>
+              <a:t>•  [4] H. Feng et al., ‘Design and reachable domain analysis of on-orbit electromagnetic launcher for CubeSats,’ Int. J. Aerospace Eng., 2025.</a:t>
+            </a:r>
+          </a:p>
+          <a:p>
+            <a:pPr>
+              <a:spcAft>
+                <a:spcPts val="1800"/>
+              </a:spcAft>
+              <a:defRPr sz="1700">
+                <a:solidFill>
+                  <a:srgbClr val="1E3144"/>
+                </a:solidFill>
+                <a:latin typeface="Aptos"/>
+              </a:defRPr>
+            </a:pPr>
+            <a:r>
+              <a:t>•  [5] Y. Zhao et al., ‘Design and analysis of a new deployer for the in-orbit release of multiple stacked CubeSats,’ Remote Sensing 14(17), 4205, 2022.</a:t>
+            </a:r>
+          </a:p>
+        </p:txBody>
+      </p:sp>
+    </p:spTree>
+  </p:cSld>
+  <p:clrMapOvr>
+    <a:masterClrMapping/>
+  </p:clrMapOvr>
+</p:sld>
+</file>
+
+<file path=ppt/slides/slide27.xml><?xml version="1.0" encoding="utf-8"?>
+<p:sld xmlns:a="http://schemas.openxmlformats.org/drawingml/2006/main" xmlns:p="http://schemas.openxmlformats.org/presentationml/2006/main" xmlns:r="http://schemas.openxmlformats.org/officeDocument/2006/relationships">
+  <p:cSld>
+    <p:spTree>
+      <p:nvGrpSpPr>
+        <p:cNvPr id="1" name=""/>
+        <p:cNvGrpSpPr/>
+        <p:nvPr/>
+      </p:nvGrpSpPr>
+      <p:grpSpPr/>
+      <p:sp>
+        <p:nvSpPr>
+          <p:cNvPr id="2" name="Rectangle 1"/>
+          <p:cNvSpPr/>
+          <p:nvPr/>
+        </p:nvSpPr>
+        <p:spPr>
+          <a:xfrm>
+            <a:off x="0" y="0"/>
+            <a:ext cx="12191695" cy="6858000"/>
+          </a:xfrm>
+          <a:prstGeom prst="rect">
+            <a:avLst/>
+          </a:prstGeom>
+          <a:solidFill>
+            <a:srgbClr val="FFFFFF"/>
+          </a:solidFill>
+          <a:ln>
+            <a:noFill/>
+          </a:ln>
+        </p:spPr>
+        <p:style>
+          <a:lnRef idx="1">
+            <a:schemeClr val="accent1"/>
+          </a:lnRef>
+          <a:fillRef idx="3">
+            <a:schemeClr val="accent1"/>
+          </a:fillRef>
+          <a:effectRef idx="2">
+            <a:schemeClr val="accent1"/>
+          </a:effectRef>
+          <a:fontRef idx="minor">
+            <a:schemeClr val="lt1"/>
+          </a:fontRef>
+        </p:style>
+        <p:txBody>
+          <a:bodyPr rtlCol="0" anchor="ctr"/>
+          <a:lstStyle/>
+          <a:p>
+            <a:pPr algn="ctr"/>
+          </a:p>
+        </p:txBody>
+      </p:sp>
+      <p:sp>
+        <p:nvSpPr>
+          <p:cNvPr id="3" name="Rectangle 2"/>
+          <p:cNvSpPr/>
+          <p:nvPr/>
+        </p:nvSpPr>
+        <p:spPr>
+          <a:xfrm>
+            <a:off x="0" y="0"/>
+            <a:ext cx="12191695" cy="713232"/>
+          </a:xfrm>
+          <a:prstGeom prst="rect">
+            <a:avLst/>
+          </a:prstGeom>
+          <a:solidFill>
+            <a:srgbClr val="4EACC2"/>
+          </a:solidFill>
+          <a:ln>
+            <a:solidFill>
+              <a:srgbClr val="0D2035"/>
+            </a:solidFill>
+          </a:ln>
+        </p:spPr>
+        <p:style>
+          <a:lnRef idx="1">
+            <a:schemeClr val="accent1"/>
+          </a:lnRef>
+          <a:fillRef idx="3">
+            <a:schemeClr val="accent1"/>
+          </a:fillRef>
+          <a:effectRef idx="2">
+            <a:schemeClr val="accent1"/>
+          </a:effectRef>
+          <a:fontRef idx="minor">
+            <a:schemeClr val="lt1"/>
+          </a:fontRef>
+        </p:style>
+        <p:txBody>
+          <a:bodyPr rtlCol="0" anchor="ctr"/>
+          <a:lstStyle/>
+          <a:p>
+            <a:pPr algn="ctr"/>
+          </a:p>
+        </p:txBody>
+      </p:sp>
+      <p:sp>
+        <p:nvSpPr>
+          <p:cNvPr id="4" name="TextBox 3"/>
+          <p:cNvSpPr txBox="1"/>
+          <p:nvPr/>
+        </p:nvSpPr>
+        <p:spPr>
+          <a:xfrm>
+            <a:off x="402336" y="146304"/>
+            <a:ext cx="11384280" cy="475488"/>
+          </a:xfrm>
+          <a:prstGeom prst="rect">
+            <a:avLst/>
+          </a:prstGeom>
+          <a:noFill/>
+        </p:spPr>
+        <p:txBody>
+          <a:bodyPr wrap="square" lIns="13716" rIns="13716" tIns="13716" bIns="13716" anchor="t">
+            <a:spAutoFit/>
+          </a:bodyPr>
+          <a:lstStyle/>
+          <a:p>
+            <a:pPr algn="l">
+              <a:defRPr sz="2500" b="1">
+                <a:solidFill>
+                  <a:srgbClr val="0D2035"/>
+                </a:solidFill>
+                <a:latin typeface="Aptos"/>
+              </a:defRPr>
+            </a:pPr>
+            <a:r>
+              <a:t>Methods and project records (2/2)</a:t>
+            </a:r>
+          </a:p>
+        </p:txBody>
+      </p:sp>
+      <p:sp>
+        <p:nvSpPr>
+          <p:cNvPr id="5" name="TextBox 4"/>
+          <p:cNvSpPr txBox="1"/>
+          <p:nvPr/>
+        </p:nvSpPr>
+        <p:spPr>
+          <a:xfrm>
+            <a:off x="457200" y="905256"/>
+            <a:ext cx="10789920" cy="256032"/>
+          </a:xfrm>
+          <a:prstGeom prst="rect">
+            <a:avLst/>
+          </a:prstGeom>
+          <a:noFill/>
+        </p:spPr>
+        <p:txBody>
+          <a:bodyPr wrap="square" lIns="13716" rIns="13716" tIns="13716" bIns="13716" anchor="t">
+            <a:spAutoFit/>
+          </a:bodyPr>
+          <a:lstStyle/>
+          <a:p>
+            <a:pPr algn="l">
+              <a:defRPr sz="1000" b="1">
+                <a:solidFill>
+                  <a:srgbClr val="0096A0"/>
+                </a:solidFill>
+                <a:latin typeface="Aptos"/>
+              </a:defRPr>
+            </a:pPr>
+            <a:r>
+              <a:t>REFERENCES</a:t>
+            </a:r>
+          </a:p>
+        </p:txBody>
+      </p:sp>
+      <p:sp>
+        <p:nvSpPr>
+          <p:cNvPr id="6" name="TextBox 5"/>
+          <p:cNvSpPr txBox="1"/>
+          <p:nvPr/>
+        </p:nvSpPr>
+        <p:spPr>
+          <a:xfrm>
+            <a:off x="402336" y="6537960"/>
+            <a:ext cx="2560320" cy="201168"/>
+          </a:xfrm>
+          <a:prstGeom prst="rect">
+            <a:avLst/>
+          </a:prstGeom>
+          <a:noFill/>
+        </p:spPr>
+        <p:txBody>
+          <a:bodyPr wrap="square" lIns="13716" rIns="13716" tIns="13716" bIns="13716" anchor="t">
+            <a:spAutoFit/>
+          </a:bodyPr>
+          <a:lstStyle/>
+          <a:p>
+            <a:pPr algn="l">
+              <a:defRPr sz="850" b="1">
+                <a:solidFill>
+                  <a:srgbClr val="637684"/>
+                </a:solidFill>
+                <a:latin typeface="Aptos"/>
+              </a:defRPr>
+            </a:pPr>
+            <a:r>
+              <a:t>SOURCE LIST</a:t>
+            </a:r>
+          </a:p>
+        </p:txBody>
+      </p:sp>
+      <p:sp>
+        <p:nvSpPr>
+          <p:cNvPr id="7" name="TextBox 6"/>
+          <p:cNvSpPr txBox="1"/>
+          <p:nvPr/>
+        </p:nvSpPr>
+        <p:spPr>
+          <a:xfrm>
+            <a:off x="2926080" y="6537960"/>
+            <a:ext cx="8138160" cy="201168"/>
+          </a:xfrm>
+          <a:prstGeom prst="rect">
+            <a:avLst/>
+          </a:prstGeom>
+          <a:noFill/>
+        </p:spPr>
+        <p:txBody>
+          <a:bodyPr wrap="square" lIns="13716" rIns="13716" tIns="13716" bIns="13716" anchor="t">
+            <a:spAutoFit/>
+          </a:bodyPr>
+          <a:lstStyle/>
+          <a:p>
+            <a:pPr algn="l">
+              <a:defRPr sz="850" b="0">
+                <a:solidFill>
+                  <a:srgbClr val="637684"/>
+                </a:solidFill>
+                <a:latin typeface="Aptos"/>
+              </a:defRPr>
+            </a:pPr>
+            <a:r>
+              <a:t>Bibliography from VOLLEY-thesis/source/paper.tex; project records</a:t>
+            </a:r>
+          </a:p>
+        </p:txBody>
+      </p:sp>
+      <p:sp>
+        <p:nvSpPr>
+          <p:cNvPr id="8" name="TextBox 7"/>
+          <p:cNvSpPr txBox="1"/>
+          <p:nvPr/>
+        </p:nvSpPr>
+        <p:spPr>
+          <a:xfrm>
+            <a:off x="11567160" y="6537960"/>
+            <a:ext cx="320040" cy="201168"/>
+          </a:xfrm>
+          <a:prstGeom prst="rect">
+            <a:avLst/>
+          </a:prstGeom>
+          <a:noFill/>
+        </p:spPr>
+        <p:txBody>
+          <a:bodyPr wrap="square" lIns="13716" rIns="13716" tIns="13716" bIns="13716" anchor="t">
+            <a:spAutoFit/>
+          </a:bodyPr>
+          <a:lstStyle/>
+          <a:p>
+            <a:pPr algn="r">
+              <a:defRPr sz="900" b="0">
+                <a:solidFill>
+                  <a:srgbClr val="637684"/>
+                </a:solidFill>
+                <a:latin typeface="Aptos"/>
+              </a:defRPr>
+            </a:pPr>
+            <a:r>
+              <a:t>27</a:t>
             </a:r>
           </a:p>
         </p:txBody>

</xml_diff>

<commit_message>
Reconcile Gen5 blackbook evidence, figures and limitations
</commit_message>
<xml_diff>
--- a/university/final_review_2026_10_10/VOLLEY_Final_Review_2026-10-10.pptx
+++ b/university/final_review_2026_10_10/VOLLEY_Final_Review_2026-10-10.pptx
@@ -32,6 +32,7 @@
     <p:sldId id="280" r:id="rId31"/>
     <p:sldId id="281" r:id="rId32"/>
     <p:sldId id="282" r:id="rId33"/>
+    <p:sldId id="283" r:id="rId34"/>
   </p:sldIdLst>
   <p:sldSz cx="12191695" cy="6858000" type="screen4x3"/>
   <p:notesSz cx="6858000" cy="9144000"/>
@@ -3536,7 +3537,7 @@
               </a:defRPr>
             </a:pPr>
             <a:r>
-              <a:t>Final review: 10 October 2026</a:t>
+              <a:t>Review candidate: 16 October 2026</a:t>
             </a:r>
           </a:p>
         </p:txBody>
@@ -8515,7 +8516,7 @@
               </a:defRPr>
             </a:pPr>
             <a:r>
-              <a:t>1.60× open</a:t>
+              <a:t>1.602 model</a:t>
             </a:r>
           </a:p>
         </p:txBody>
@@ -8551,7 +8552,7 @@
               </a:defRPr>
             </a:pPr>
             <a:r>
-              <a:t>Lifetime remains atmosphere-dependent and lacks an independent rerun for this input.</a:t>
+              <a:t>P134 checks the shared static atmosphere; actual lifetime and achieved release remain unvalidated.</a:t>
             </a:r>
           </a:p>
         </p:txBody>
@@ -16506,6 +16507,636 @@
 </p:sld>
 </file>
 
+<file path=ppt/slides/slide28.xml><?xml version="1.0" encoding="utf-8"?>
+<p:sld xmlns:a="http://schemas.openxmlformats.org/drawingml/2006/main" xmlns:p="http://schemas.openxmlformats.org/presentationml/2006/main" xmlns:r="http://schemas.openxmlformats.org/officeDocument/2006/relationships">
+  <p:cSld>
+    <p:spTree>
+      <p:nvGrpSpPr>
+        <p:cNvPr id="1" name=""/>
+        <p:cNvGrpSpPr/>
+        <p:nvPr/>
+      </p:nvGrpSpPr>
+      <p:grpSpPr/>
+      <p:sp>
+        <p:nvSpPr>
+          <p:cNvPr id="2" name="Rectangle 1"/>
+          <p:cNvSpPr/>
+          <p:nvPr/>
+        </p:nvSpPr>
+        <p:spPr>
+          <a:xfrm>
+            <a:off x="0" y="0"/>
+            <a:ext cx="12191695" cy="6858000"/>
+          </a:xfrm>
+          <a:prstGeom prst="rect">
+            <a:avLst/>
+          </a:prstGeom>
+          <a:solidFill>
+            <a:srgbClr val="FFFFFF"/>
+          </a:solidFill>
+          <a:ln>
+            <a:noFill/>
+          </a:ln>
+        </p:spPr>
+        <p:style>
+          <a:lnRef idx="1">
+            <a:schemeClr val="accent1"/>
+          </a:lnRef>
+          <a:fillRef idx="3">
+            <a:schemeClr val="accent1"/>
+          </a:fillRef>
+          <a:effectRef idx="2">
+            <a:schemeClr val="accent1"/>
+          </a:effectRef>
+          <a:fontRef idx="minor">
+            <a:schemeClr val="lt1"/>
+          </a:fontRef>
+        </p:style>
+        <p:txBody>
+          <a:bodyPr rtlCol="0" anchor="ctr"/>
+          <a:lstStyle/>
+          <a:p>
+            <a:pPr algn="ctr"/>
+          </a:p>
+        </p:txBody>
+      </p:sp>
+      <p:sp>
+        <p:nvSpPr>
+          <p:cNvPr id="3" name="Rectangle 2"/>
+          <p:cNvSpPr/>
+          <p:nvPr/>
+        </p:nvSpPr>
+        <p:spPr>
+          <a:xfrm>
+            <a:off x="0" y="0"/>
+            <a:ext cx="12191695" cy="713232"/>
+          </a:xfrm>
+          <a:prstGeom prst="rect">
+            <a:avLst/>
+          </a:prstGeom>
+          <a:solidFill>
+            <a:srgbClr val="4EACC2"/>
+          </a:solidFill>
+          <a:ln>
+            <a:solidFill>
+              <a:srgbClr val="0D2035"/>
+            </a:solidFill>
+          </a:ln>
+        </p:spPr>
+        <p:style>
+          <a:lnRef idx="1">
+            <a:schemeClr val="accent1"/>
+          </a:lnRef>
+          <a:fillRef idx="3">
+            <a:schemeClr val="accent1"/>
+          </a:fillRef>
+          <a:effectRef idx="2">
+            <a:schemeClr val="accent1"/>
+          </a:effectRef>
+          <a:fontRef idx="minor">
+            <a:schemeClr val="lt1"/>
+          </a:fontRef>
+        </p:style>
+        <p:txBody>
+          <a:bodyPr rtlCol="0" anchor="ctr"/>
+          <a:lstStyle/>
+          <a:p>
+            <a:pPr algn="ctr"/>
+          </a:p>
+        </p:txBody>
+      </p:sp>
+      <p:sp>
+        <p:nvSpPr>
+          <p:cNvPr id="4" name="TextBox 3"/>
+          <p:cNvSpPr txBox="1"/>
+          <p:nvPr/>
+        </p:nvSpPr>
+        <p:spPr>
+          <a:xfrm>
+            <a:off x="402336" y="146304"/>
+            <a:ext cx="11384280" cy="475488"/>
+          </a:xfrm>
+          <a:prstGeom prst="rect">
+            <a:avLst/>
+          </a:prstGeom>
+          <a:noFill/>
+        </p:spPr>
+        <p:txBody>
+          <a:bodyPr wrap="square" lIns="13716" rIns="13716" tIns="13716" bIns="13716" anchor="t">
+            <a:spAutoFit/>
+          </a:bodyPr>
+          <a:lstStyle/>
+          <a:p>
+            <a:pPr algn="l">
+              <a:defRPr sz="2500" b="1">
+                <a:solidFill>
+                  <a:srgbClr val="0D2035"/>
+                </a:solidFill>
+                <a:latin typeface="Aptos"/>
+              </a:defRPr>
+            </a:pPr>
+            <a:r>
+              <a:t>What the reconciled numerical record establishes</a:t>
+            </a:r>
+          </a:p>
+        </p:txBody>
+      </p:sp>
+      <p:sp>
+        <p:nvSpPr>
+          <p:cNvPr id="5" name="TextBox 4"/>
+          <p:cNvSpPr txBox="1"/>
+          <p:nvPr/>
+        </p:nvSpPr>
+        <p:spPr>
+          <a:xfrm>
+            <a:off x="457200" y="905256"/>
+            <a:ext cx="10789920" cy="256032"/>
+          </a:xfrm>
+          <a:prstGeom prst="rect">
+            <a:avLst/>
+          </a:prstGeom>
+          <a:noFill/>
+        </p:spPr>
+        <p:txBody>
+          <a:bodyPr wrap="square" lIns="13716" rIns="13716" tIns="13716" bIns="13716" anchor="t">
+            <a:spAutoFit/>
+          </a:bodyPr>
+          <a:lstStyle/>
+          <a:p>
+            <a:pPr algn="l">
+              <a:defRPr sz="1000" b="1">
+                <a:solidFill>
+                  <a:srgbClr val="0096A0"/>
+                </a:solidFill>
+                <a:latin typeface="Aptos"/>
+              </a:defRPr>
+            </a:pPr>
+            <a:r>
+              <a:t>EVIDENCE APPENDIX</a:t>
+            </a:r>
+          </a:p>
+        </p:txBody>
+      </p:sp>
+      <p:sp>
+        <p:nvSpPr>
+          <p:cNvPr id="6" name="TextBox 5"/>
+          <p:cNvSpPr txBox="1"/>
+          <p:nvPr/>
+        </p:nvSpPr>
+        <p:spPr>
+          <a:xfrm>
+            <a:off x="402336" y="6537960"/>
+            <a:ext cx="2560320" cy="201168"/>
+          </a:xfrm>
+          <a:prstGeom prst="rect">
+            <a:avLst/>
+          </a:prstGeom>
+          <a:noFill/>
+        </p:spPr>
+        <p:txBody>
+          <a:bodyPr wrap="square" lIns="13716" rIns="13716" tIns="13716" bIns="13716" anchor="t">
+            <a:spAutoFit/>
+          </a:bodyPr>
+          <a:lstStyle/>
+          <a:p>
+            <a:pPr algn="l">
+              <a:defRPr sz="850" b="1">
+                <a:solidFill>
+                  <a:srgbClr val="637684"/>
+                </a:solidFill>
+                <a:latin typeface="Aptos"/>
+              </a:defRPr>
+            </a:pPr>
+            <a:r>
+              <a:t>MODEL EVIDENCE ONLY</a:t>
+            </a:r>
+          </a:p>
+        </p:txBody>
+      </p:sp>
+      <p:sp>
+        <p:nvSpPr>
+          <p:cNvPr id="7" name="TextBox 6"/>
+          <p:cNvSpPr txBox="1"/>
+          <p:nvPr/>
+        </p:nvSpPr>
+        <p:spPr>
+          <a:xfrm>
+            <a:off x="2926080" y="6537960"/>
+            <a:ext cx="8138160" cy="201168"/>
+          </a:xfrm>
+          <a:prstGeom prst="rect">
+            <a:avLst/>
+          </a:prstGeom>
+          <a:noFill/>
+        </p:spPr>
+        <p:txBody>
+          <a:bodyPr wrap="square" lIns="13716" rIns="13716" tIns="13716" bIns="13716" anchor="t">
+            <a:spAutoFit/>
+          </a:bodyPr>
+          <a:lstStyle/>
+          <a:p>
+            <a:pPr algn="l">
+              <a:defRPr sz="850" b="0">
+                <a:solidFill>
+                  <a:srgbClr val="637684"/>
+                </a:solidFill>
+                <a:latin typeface="Aptos"/>
+              </a:defRPr>
+            </a:pPr>
+            <a:r>
+              <a:t>P133/P134 · technical evidence revision, 16 October 2026</a:t>
+            </a:r>
+          </a:p>
+        </p:txBody>
+      </p:sp>
+      <p:sp>
+        <p:nvSpPr>
+          <p:cNvPr id="8" name="TextBox 7"/>
+          <p:cNvSpPr txBox="1"/>
+          <p:nvPr/>
+        </p:nvSpPr>
+        <p:spPr>
+          <a:xfrm>
+            <a:off x="11567160" y="6537960"/>
+            <a:ext cx="320040" cy="201168"/>
+          </a:xfrm>
+          <a:prstGeom prst="rect">
+            <a:avLst/>
+          </a:prstGeom>
+          <a:noFill/>
+        </p:spPr>
+        <p:txBody>
+          <a:bodyPr wrap="square" lIns="13716" rIns="13716" tIns="13716" bIns="13716" anchor="t">
+            <a:spAutoFit/>
+          </a:bodyPr>
+          <a:lstStyle/>
+          <a:p>
+            <a:pPr algn="r">
+              <a:defRPr sz="900" b="0">
+                <a:solidFill>
+                  <a:srgbClr val="637684"/>
+                </a:solidFill>
+                <a:latin typeface="Aptos"/>
+              </a:defRPr>
+            </a:pPr>
+            <a:r>
+              <a:t>28</a:t>
+            </a:r>
+          </a:p>
+        </p:txBody>
+      </p:sp>
+      <p:pic>
+        <p:nvPicPr>
+          <p:cNvPr id="9" name="Picture 8" descr="gen5_lifetime_numerical_check.png"/>
+          <p:cNvPicPr>
+            <a:picLocks noChangeAspect="1"/>
+          </p:cNvPicPr>
+          <p:nvPr/>
+        </p:nvPicPr>
+        <p:blipFill>
+          <a:blip r:embed="rId2"/>
+          <a:stretch>
+            <a:fillRect/>
+          </a:stretch>
+        </p:blipFill>
+        <p:spPr>
+          <a:xfrm>
+            <a:off x="502920" y="1648747"/>
+            <a:ext cx="7315200" cy="3871400"/>
+          </a:xfrm>
+          <a:prstGeom prst="rect">
+            <a:avLst/>
+          </a:prstGeom>
+        </p:spPr>
+      </p:pic>
+      <p:sp>
+        <p:nvSpPr>
+          <p:cNvPr id="10" name="Rounded Rectangle 9"/>
+          <p:cNvSpPr/>
+          <p:nvPr/>
+        </p:nvSpPr>
+        <p:spPr>
+          <a:xfrm>
+            <a:off x="8046720" y="1691640"/>
+            <a:ext cx="3474720" cy="1554480"/>
+          </a:xfrm>
+          <a:prstGeom prst="roundRect">
+            <a:avLst/>
+          </a:prstGeom>
+          <a:solidFill>
+            <a:srgbClr val="F6F9FB"/>
+          </a:solidFill>
+          <a:ln>
+            <a:solidFill>
+              <a:srgbClr val="DDE7EC"/>
+            </a:solidFill>
+          </a:ln>
+        </p:spPr>
+        <p:style>
+          <a:lnRef idx="1">
+            <a:schemeClr val="accent1"/>
+          </a:lnRef>
+          <a:fillRef idx="3">
+            <a:schemeClr val="accent1"/>
+          </a:fillRef>
+          <a:effectRef idx="2">
+            <a:schemeClr val="accent1"/>
+          </a:effectRef>
+          <a:fontRef idx="minor">
+            <a:schemeClr val="lt1"/>
+          </a:fontRef>
+        </p:style>
+        <p:txBody>
+          <a:bodyPr rtlCol="0" anchor="ctr"/>
+          <a:lstStyle/>
+          <a:p>
+            <a:pPr algn="ctr"/>
+          </a:p>
+        </p:txBody>
+      </p:sp>
+      <p:sp>
+        <p:nvSpPr>
+          <p:cNvPr id="11" name="Rectangle 10"/>
+          <p:cNvSpPr/>
+          <p:nvPr/>
+        </p:nvSpPr>
+        <p:spPr>
+          <a:xfrm>
+            <a:off x="8046720" y="1691640"/>
+            <a:ext cx="73152" cy="1554480"/>
+          </a:xfrm>
+          <a:prstGeom prst="rect">
+            <a:avLst/>
+          </a:prstGeom>
+          <a:solidFill>
+            <a:srgbClr val="D78F2B"/>
+          </a:solidFill>
+          <a:ln>
+            <a:noFill/>
+          </a:ln>
+        </p:spPr>
+        <p:style>
+          <a:lnRef idx="1">
+            <a:schemeClr val="accent1"/>
+          </a:lnRef>
+          <a:fillRef idx="3">
+            <a:schemeClr val="accent1"/>
+          </a:fillRef>
+          <a:effectRef idx="2">
+            <a:schemeClr val="accent1"/>
+          </a:effectRef>
+          <a:fontRef idx="minor">
+            <a:schemeClr val="lt1"/>
+          </a:fontRef>
+        </p:style>
+        <p:txBody>
+          <a:bodyPr rtlCol="0" anchor="ctr"/>
+          <a:lstStyle/>
+          <a:p>
+            <a:pPr algn="ctr"/>
+          </a:p>
+        </p:txBody>
+      </p:sp>
+      <p:sp>
+        <p:nvSpPr>
+          <p:cNvPr id="12" name="TextBox 11"/>
+          <p:cNvSpPr txBox="1"/>
+          <p:nvPr/>
+        </p:nvSpPr>
+        <p:spPr>
+          <a:xfrm>
+            <a:off x="8257032" y="1837944"/>
+            <a:ext cx="3108960" cy="502920"/>
+          </a:xfrm>
+          <a:prstGeom prst="rect">
+            <a:avLst/>
+          </a:prstGeom>
+          <a:noFill/>
+        </p:spPr>
+        <p:txBody>
+          <a:bodyPr wrap="square" lIns="13716" rIns="13716" tIns="13716" bIns="13716" anchor="t">
+            <a:spAutoFit/>
+          </a:bodyPr>
+          <a:lstStyle/>
+          <a:p>
+            <a:pPr algn="l">
+              <a:defRPr sz="1800" b="1">
+                <a:solidFill>
+                  <a:srgbClr val="0D2035"/>
+                </a:solidFill>
+                <a:latin typeface="Aptos"/>
+              </a:defRPr>
+            </a:pPr>
+            <a:r>
+              <a:t>1.602 model ratio</a:t>
+            </a:r>
+          </a:p>
+        </p:txBody>
+      </p:sp>
+      <p:sp>
+        <p:nvSpPr>
+          <p:cNvPr id="13" name="TextBox 12"/>
+          <p:cNvSpPr txBox="1"/>
+          <p:nvPr/>
+        </p:nvSpPr>
+        <p:spPr>
+          <a:xfrm>
+            <a:off x="8257032" y="2441448"/>
+            <a:ext cx="3090672" cy="640080"/>
+          </a:xfrm>
+          <a:prstGeom prst="rect">
+            <a:avLst/>
+          </a:prstGeom>
+          <a:noFill/>
+        </p:spPr>
+        <p:txBody>
+          <a:bodyPr wrap="square" lIns="13716" rIns="13716" tIns="13716" bIns="13716" anchor="t">
+            <a:spAutoFit/>
+          </a:bodyPr>
+          <a:lstStyle/>
+          <a:p>
+            <a:pPr algn="l">
+              <a:defRPr sz="1400" b="0">
+                <a:solidFill>
+                  <a:srgbClr val="1E3144"/>
+                </a:solidFill>
+                <a:latin typeface="Aptos"/>
+              </a:defRPr>
+            </a:pPr>
+            <a:r>
+              <a:t>Separate integration, same static atmosphere. Actual lifetime is unvalidated.</a:t>
+            </a:r>
+          </a:p>
+        </p:txBody>
+      </p:sp>
+      <p:sp>
+        <p:nvSpPr>
+          <p:cNvPr id="14" name="Rounded Rectangle 13"/>
+          <p:cNvSpPr/>
+          <p:nvPr/>
+        </p:nvSpPr>
+        <p:spPr>
+          <a:xfrm>
+            <a:off x="8046720" y="3520440"/>
+            <a:ext cx="3474720" cy="1737360"/>
+          </a:xfrm>
+          <a:prstGeom prst="roundRect">
+            <a:avLst/>
+          </a:prstGeom>
+          <a:solidFill>
+            <a:srgbClr val="F6F9FB"/>
+          </a:solidFill>
+          <a:ln>
+            <a:solidFill>
+              <a:srgbClr val="DDE7EC"/>
+            </a:solidFill>
+          </a:ln>
+        </p:spPr>
+        <p:style>
+          <a:lnRef idx="1">
+            <a:schemeClr val="accent1"/>
+          </a:lnRef>
+          <a:fillRef idx="3">
+            <a:schemeClr val="accent1"/>
+          </a:fillRef>
+          <a:effectRef idx="2">
+            <a:schemeClr val="accent1"/>
+          </a:effectRef>
+          <a:fontRef idx="minor">
+            <a:schemeClr val="lt1"/>
+          </a:fontRef>
+        </p:style>
+        <p:txBody>
+          <a:bodyPr rtlCol="0" anchor="ctr"/>
+          <a:lstStyle/>
+          <a:p>
+            <a:pPr algn="ctr"/>
+          </a:p>
+        </p:txBody>
+      </p:sp>
+      <p:sp>
+        <p:nvSpPr>
+          <p:cNvPr id="15" name="Rectangle 14"/>
+          <p:cNvSpPr/>
+          <p:nvPr/>
+        </p:nvSpPr>
+        <p:spPr>
+          <a:xfrm>
+            <a:off x="8046720" y="3520440"/>
+            <a:ext cx="73152" cy="1737360"/>
+          </a:xfrm>
+          <a:prstGeom prst="rect">
+            <a:avLst/>
+          </a:prstGeom>
+          <a:solidFill>
+            <a:srgbClr val="B94141"/>
+          </a:solidFill>
+          <a:ln>
+            <a:noFill/>
+          </a:ln>
+        </p:spPr>
+        <p:style>
+          <a:lnRef idx="1">
+            <a:schemeClr val="accent1"/>
+          </a:lnRef>
+          <a:fillRef idx="3">
+            <a:schemeClr val="accent1"/>
+          </a:fillRef>
+          <a:effectRef idx="2">
+            <a:schemeClr val="accent1"/>
+          </a:effectRef>
+          <a:fontRef idx="minor">
+            <a:schemeClr val="lt1"/>
+          </a:fontRef>
+        </p:style>
+        <p:txBody>
+          <a:bodyPr rtlCol="0" anchor="ctr"/>
+          <a:lstStyle/>
+          <a:p>
+            <a:pPr algn="ctr"/>
+          </a:p>
+        </p:txBody>
+      </p:sp>
+      <p:sp>
+        <p:nvSpPr>
+          <p:cNvPr id="16" name="TextBox 15"/>
+          <p:cNvSpPr txBox="1"/>
+          <p:nvPr/>
+        </p:nvSpPr>
+        <p:spPr>
+          <a:xfrm>
+            <a:off x="8257032" y="3666744"/>
+            <a:ext cx="3108960" cy="502920"/>
+          </a:xfrm>
+          <a:prstGeom prst="rect">
+            <a:avLst/>
+          </a:prstGeom>
+          <a:noFill/>
+        </p:spPr>
+        <p:txBody>
+          <a:bodyPr wrap="square" lIns="13716" rIns="13716" tIns="13716" bIns="13716" anchor="t">
+            <a:spAutoFit/>
+          </a:bodyPr>
+          <a:lstStyle/>
+          <a:p>
+            <a:pPr algn="l">
+              <a:defRPr sz="1800" b="1">
+                <a:solidFill>
+                  <a:srgbClr val="0D2035"/>
+                </a:solidFill>
+                <a:latin typeface="Aptos"/>
+              </a:defRPr>
+            </a:pPr>
+            <a:r>
+              <a:t>Failures retained</a:t>
+            </a:r>
+          </a:p>
+        </p:txBody>
+      </p:sp>
+      <p:sp>
+        <p:nvSpPr>
+          <p:cNvPr id="17" name="TextBox 16"/>
+          <p:cNvSpPr txBox="1"/>
+          <p:nvPr/>
+        </p:nvSpPr>
+        <p:spPr>
+          <a:xfrm>
+            <a:off x="8257032" y="4270248"/>
+            <a:ext cx="3090672" cy="822959"/>
+          </a:xfrm>
+          <a:prstGeom prst="rect">
+            <a:avLst/>
+          </a:prstGeom>
+          <a:noFill/>
+        </p:spPr>
+        <p:txBody>
+          <a:bodyPr wrap="square" lIns="13716" rIns="13716" tIns="13716" bIns="13716" anchor="t">
+            <a:spAutoFit/>
+          </a:bodyPr>
+          <a:lstStyle/>
+          <a:p>
+            <a:pPr algn="l">
+              <a:defRPr sz="1400" b="0">
+                <a:solidFill>
+                  <a:srgbClr val="1E3144"/>
+                </a:solidFill>
+                <a:latin typeface="Aptos"/>
+              </a:defRPr>
+            </a:pPr>
+            <a:r>
+              <a:t>22 Gen5/R1 intersections classified; 126.562 kg model; no sampled twelve-shot mission closes.</a:t>
+            </a:r>
+          </a:p>
+        </p:txBody>
+      </p:sp>
+    </p:spTree>
+  </p:cSld>
+  <p:clrMapOvr>
+    <a:masterClrMapping/>
+  </p:clrMapOvr>
+</p:sld>
+</file>
+
 <file path=ppt/slides/slide3.xml><?xml version="1.0" encoding="utf-8"?>
 <p:sld xmlns:a="http://schemas.openxmlformats.org/drawingml/2006/main" xmlns:p="http://schemas.openxmlformats.org/presentationml/2006/main" xmlns:r="http://schemas.openxmlformats.org/officeDocument/2006/relationships">
   <p:cSld>
@@ -20305,7 +20936,7 @@
               </a:defRPr>
             </a:pPr>
             <a:r>
-              <a:t>Conditional orbit results; current lifetime not independently closed</a:t>
+              <a:t>Conditional orbit results; real lifetime unvalidated</a:t>
             </a:r>
           </a:p>
         </p:txBody>
@@ -24220,7 +24851,7 @@
               </a:defRPr>
             </a:pPr>
             <a:r>
-              <a:t>Gen5 results, failed criterion and thesis record presented</a:t>
+              <a:t>Gen5 results, failed criteria and thesis record prepared</a:t>
             </a:r>
           </a:p>
         </p:txBody>

</xml_diff>

<commit_message>
Publish native orbital evidence and technical figure revision
</commit_message>
<xml_diff>
--- a/university/final_review_2026_10_10/VOLLEY_Final_Review_2026-10-10.pptx
+++ b/university/final_review_2026_10_10/VOLLEY_Final_Review_2026-10-10.pptx
@@ -33,6 +33,8 @@
     <p:sldId id="281" r:id="rId32"/>
     <p:sldId id="282" r:id="rId33"/>
     <p:sldId id="283" r:id="rId34"/>
+    <p:sldId id="284" r:id="rId35"/>
+    <p:sldId id="285" r:id="rId36"/>
   </p:sldIdLst>
   <p:sldSz cx="12191695" cy="6858000" type="screen4x3"/>
   <p:notesSz cx="6858000" cy="9144000"/>
@@ -17137,6 +17139,352 @@
 </p:sld>
 </file>
 
+<file path=ppt/slides/slide29.xml><?xml version="1.0" encoding="utf-8"?>
+<p:sld xmlns:a="http://schemas.openxmlformats.org/drawingml/2006/main" xmlns:p="http://schemas.openxmlformats.org/presentationml/2006/main" xmlns:r="http://schemas.openxmlformats.org/officeDocument/2006/relationships">
+  <p:cSld>
+    <p:spTree>
+      <p:nvGrpSpPr>
+        <p:cNvPr id="1" name=""/>
+        <p:cNvGrpSpPr/>
+        <p:nvPr/>
+      </p:nvGrpSpPr>
+      <p:grpSpPr/>
+      <p:sp>
+        <p:nvSpPr>
+          <p:cNvPr id="2" name="Rectangle 1"/>
+          <p:cNvSpPr/>
+          <p:nvPr/>
+        </p:nvSpPr>
+        <p:spPr>
+          <a:xfrm>
+            <a:off x="0" y="0"/>
+            <a:ext cx="12191695" cy="6858000"/>
+          </a:xfrm>
+          <a:prstGeom prst="rect">
+            <a:avLst/>
+          </a:prstGeom>
+          <a:solidFill>
+            <a:srgbClr val="FFFFFF"/>
+          </a:solidFill>
+          <a:ln>
+            <a:noFill/>
+          </a:ln>
+        </p:spPr>
+        <p:style>
+          <a:lnRef idx="1">
+            <a:schemeClr val="accent1"/>
+          </a:lnRef>
+          <a:fillRef idx="3">
+            <a:schemeClr val="accent1"/>
+          </a:fillRef>
+          <a:effectRef idx="2">
+            <a:schemeClr val="accent1"/>
+          </a:effectRef>
+          <a:fontRef idx="minor">
+            <a:schemeClr val="lt1"/>
+          </a:fontRef>
+        </p:style>
+        <p:txBody>
+          <a:bodyPr rtlCol="0" anchor="ctr"/>
+          <a:lstStyle/>
+          <a:p>
+            <a:pPr algn="ctr"/>
+          </a:p>
+        </p:txBody>
+      </p:sp>
+      <p:sp>
+        <p:nvSpPr>
+          <p:cNvPr id="3" name="Rectangle 2"/>
+          <p:cNvSpPr/>
+          <p:nvPr/>
+        </p:nvSpPr>
+        <p:spPr>
+          <a:xfrm>
+            <a:off x="0" y="0"/>
+            <a:ext cx="12191695" cy="713232"/>
+          </a:xfrm>
+          <a:prstGeom prst="rect">
+            <a:avLst/>
+          </a:prstGeom>
+          <a:solidFill>
+            <a:srgbClr val="4EACC2"/>
+          </a:solidFill>
+          <a:ln>
+            <a:solidFill>
+              <a:srgbClr val="0D2035"/>
+            </a:solidFill>
+          </a:ln>
+        </p:spPr>
+        <p:style>
+          <a:lnRef idx="1">
+            <a:schemeClr val="accent1"/>
+          </a:lnRef>
+          <a:fillRef idx="3">
+            <a:schemeClr val="accent1"/>
+          </a:fillRef>
+          <a:effectRef idx="2">
+            <a:schemeClr val="accent1"/>
+          </a:effectRef>
+          <a:fontRef idx="minor">
+            <a:schemeClr val="lt1"/>
+          </a:fontRef>
+        </p:style>
+        <p:txBody>
+          <a:bodyPr rtlCol="0" anchor="ctr"/>
+          <a:lstStyle/>
+          <a:p>
+            <a:pPr algn="ctr"/>
+          </a:p>
+        </p:txBody>
+      </p:sp>
+      <p:sp>
+        <p:nvSpPr>
+          <p:cNvPr id="4" name="TextBox 3"/>
+          <p:cNvSpPr txBox="1"/>
+          <p:nvPr/>
+        </p:nvSpPr>
+        <p:spPr>
+          <a:xfrm>
+            <a:off x="402336" y="146304"/>
+            <a:ext cx="11384280" cy="475488"/>
+          </a:xfrm>
+          <a:prstGeom prst="rect">
+            <a:avLst/>
+          </a:prstGeom>
+          <a:noFill/>
+        </p:spPr>
+        <p:txBody>
+          <a:bodyPr wrap="square" lIns="13716" rIns="13716" tIns="13716" bIns="13716" anchor="t">
+            <a:spAutoFit/>
+          </a:bodyPr>
+          <a:lstStyle/>
+          <a:p>
+            <a:pPr algn="l">
+              <a:defRPr sz="2500" b="1">
+                <a:solidFill>
+                  <a:srgbClr val="0D2035"/>
+                </a:solidFill>
+                <a:latin typeface="Aptos"/>
+              </a:defRPr>
+            </a:pPr>
+            <a:r>
+              <a:t>Native solvers: agreement and unresolved differences</a:t>
+            </a:r>
+          </a:p>
+        </p:txBody>
+      </p:sp>
+      <p:sp>
+        <p:nvSpPr>
+          <p:cNvPr id="5" name="TextBox 4"/>
+          <p:cNvSpPr txBox="1"/>
+          <p:nvPr/>
+        </p:nvSpPr>
+        <p:spPr>
+          <a:xfrm>
+            <a:off x="457200" y="905256"/>
+            <a:ext cx="10789920" cy="256032"/>
+          </a:xfrm>
+          <a:prstGeom prst="rect">
+            <a:avLst/>
+          </a:prstGeom>
+          <a:noFill/>
+        </p:spPr>
+        <p:txBody>
+          <a:bodyPr wrap="square" lIns="13716" rIns="13716" tIns="13716" bIns="13716" anchor="t">
+            <a:spAutoFit/>
+          </a:bodyPr>
+          <a:lstStyle/>
+          <a:p>
+            <a:pPr algn="l">
+              <a:defRPr sz="1000" b="1">
+                <a:solidFill>
+                  <a:srgbClr val="0096A0"/>
+                </a:solidFill>
+                <a:latin typeface="Aptos"/>
+              </a:defRPr>
+            </a:pPr>
+            <a:r>
+              <a:t>EVIDENCE APPENDIX</a:t>
+            </a:r>
+          </a:p>
+        </p:txBody>
+      </p:sp>
+      <p:sp>
+        <p:nvSpPr>
+          <p:cNvPr id="6" name="TextBox 5"/>
+          <p:cNvSpPr txBox="1"/>
+          <p:nvPr/>
+        </p:nvSpPr>
+        <p:spPr>
+          <a:xfrm>
+            <a:off x="402336" y="6537960"/>
+            <a:ext cx="2560320" cy="201168"/>
+          </a:xfrm>
+          <a:prstGeom prst="rect">
+            <a:avLst/>
+          </a:prstGeom>
+          <a:noFill/>
+        </p:spPr>
+        <p:txBody>
+          <a:bodyPr wrap="square" lIns="13716" rIns="13716" tIns="13716" bIns="13716" anchor="t">
+            <a:spAutoFit/>
+          </a:bodyPr>
+          <a:lstStyle/>
+          <a:p>
+            <a:pPr algn="l">
+              <a:defRPr sz="850" b="1">
+                <a:solidFill>
+                  <a:srgbClr val="637684"/>
+                </a:solidFill>
+                <a:latin typeface="Aptos"/>
+              </a:defRPr>
+            </a:pPr>
+            <a:r>
+              <a:t>ORBITAL ANALYSIS</a:t>
+            </a:r>
+          </a:p>
+        </p:txBody>
+      </p:sp>
+      <p:sp>
+        <p:nvSpPr>
+          <p:cNvPr id="7" name="TextBox 6"/>
+          <p:cNvSpPr txBox="1"/>
+          <p:nvPr/>
+        </p:nvSpPr>
+        <p:spPr>
+          <a:xfrm>
+            <a:off x="2926080" y="6537960"/>
+            <a:ext cx="8138160" cy="201168"/>
+          </a:xfrm>
+          <a:prstGeom prst="rect">
+            <a:avLst/>
+          </a:prstGeom>
+          <a:noFill/>
+        </p:spPr>
+        <p:txBody>
+          <a:bodyPr wrap="square" lIns="13716" rIns="13716" tIns="13716" bIns="13716" anchor="t">
+            <a:spAutoFit/>
+          </a:bodyPr>
+          <a:lstStyle/>
+          <a:p>
+            <a:pPr algn="l">
+              <a:defRPr sz="850" b="0">
+                <a:solidFill>
+                  <a:srgbClr val="637684"/>
+                </a:solidFill>
+                <a:latin typeface="Aptos"/>
+              </a:defRPr>
+            </a:pPr>
+            <a:r>
+              <a:t>Orekit 13.1.6 / GMAT R2026a; 18 October evidence supplement</a:t>
+            </a:r>
+          </a:p>
+        </p:txBody>
+      </p:sp>
+      <p:sp>
+        <p:nvSpPr>
+          <p:cNvPr id="8" name="TextBox 7"/>
+          <p:cNvSpPr txBox="1"/>
+          <p:nvPr/>
+        </p:nvSpPr>
+        <p:spPr>
+          <a:xfrm>
+            <a:off x="11567160" y="6537960"/>
+            <a:ext cx="320040" cy="201168"/>
+          </a:xfrm>
+          <a:prstGeom prst="rect">
+            <a:avLst/>
+          </a:prstGeom>
+          <a:noFill/>
+        </p:spPr>
+        <p:txBody>
+          <a:bodyPr wrap="square" lIns="13716" rIns="13716" tIns="13716" bIns="13716" anchor="t">
+            <a:spAutoFit/>
+          </a:bodyPr>
+          <a:lstStyle/>
+          <a:p>
+            <a:pPr algn="r">
+              <a:defRPr sz="900" b="0">
+                <a:solidFill>
+                  <a:srgbClr val="637684"/>
+                </a:solidFill>
+                <a:latin typeface="Aptos"/>
+              </a:defRPr>
+            </a:pPr>
+            <a:r>
+              <a:t>29</a:t>
+            </a:r>
+          </a:p>
+        </p:txBody>
+      </p:sp>
+      <p:pic>
+        <p:nvPicPr>
+          <p:cNvPr id="9" name="Picture 8" descr="solver_comparison.png"/>
+          <p:cNvPicPr>
+            <a:picLocks noChangeAspect="1"/>
+          </p:cNvPicPr>
+          <p:nvPr/>
+        </p:nvPicPr>
+        <p:blipFill>
+          <a:blip r:embed="rId2"/>
+          <a:stretch>
+            <a:fillRect/>
+          </a:stretch>
+        </p:blipFill>
+        <p:spPr>
+          <a:xfrm>
+            <a:off x="604520" y="1554480"/>
+            <a:ext cx="10952480" cy="4480560"/>
+          </a:xfrm>
+          <a:prstGeom prst="rect">
+            <a:avLst/>
+          </a:prstGeom>
+        </p:spPr>
+      </p:pic>
+      <p:sp>
+        <p:nvSpPr>
+          <p:cNvPr id="10" name="TextBox 9"/>
+          <p:cNvSpPr txBox="1"/>
+          <p:nvPr/>
+        </p:nvSpPr>
+        <p:spPr>
+          <a:xfrm>
+            <a:off x="731520" y="6080760"/>
+            <a:ext cx="10789920" cy="274320"/>
+          </a:xfrm>
+          <a:prstGeom prst="rect">
+            <a:avLst/>
+          </a:prstGeom>
+          <a:noFill/>
+        </p:spPr>
+        <p:txBody>
+          <a:bodyPr wrap="square" lIns="13716" rIns="13716" tIns="13716" bIns="13716" anchor="t">
+            <a:spAutoFit/>
+          </a:bodyPr>
+          <a:lstStyle/>
+          <a:p>
+            <a:pPr algn="l">
+              <a:defRPr sz="1400" b="0">
+                <a:solidFill>
+                  <a:srgbClr val="1E3144"/>
+                </a:solidFill>
+                <a:latin typeface="Aptos"/>
+              </a:defRPr>
+            </a:pPr>
+            <a:r>
+              <a:t>Prescribed states; no release-accuracy or hardware validation. J2 frames are not harmonized.</a:t>
+            </a:r>
+          </a:p>
+        </p:txBody>
+      </p:sp>
+    </p:spTree>
+  </p:cSld>
+  <p:clrMapOvr>
+    <a:masterClrMapping/>
+  </p:clrMapOvr>
+</p:sld>
+</file>
+
 <file path=ppt/slides/slide3.xml><?xml version="1.0" encoding="utf-8"?>
 <p:sld xmlns:a="http://schemas.openxmlformats.org/drawingml/2006/main" xmlns:p="http://schemas.openxmlformats.org/presentationml/2006/main" xmlns:r="http://schemas.openxmlformats.org/officeDocument/2006/relationships">
   <p:cSld>
@@ -17827,6 +18175,352 @@
             </a:pPr>
             <a:r>
               <a:t>Test on one matched mission against springs, host manoeuvres, transport and onboard propulsion.</a:t>
+            </a:r>
+          </a:p>
+        </p:txBody>
+      </p:sp>
+    </p:spTree>
+  </p:cSld>
+  <p:clrMapOvr>
+    <a:masterClrMapping/>
+  </p:clrMapOvr>
+</p:sld>
+</file>
+
+<file path=ppt/slides/slide30.xml><?xml version="1.0" encoding="utf-8"?>
+<p:sld xmlns:a="http://schemas.openxmlformats.org/drawingml/2006/main" xmlns:p="http://schemas.openxmlformats.org/presentationml/2006/main" xmlns:r="http://schemas.openxmlformats.org/officeDocument/2006/relationships">
+  <p:cSld>
+    <p:spTree>
+      <p:nvGrpSpPr>
+        <p:cNvPr id="1" name=""/>
+        <p:cNvGrpSpPr/>
+        <p:nvPr/>
+      </p:nvGrpSpPr>
+      <p:grpSpPr/>
+      <p:sp>
+        <p:nvSpPr>
+          <p:cNvPr id="2" name="Rectangle 1"/>
+          <p:cNvSpPr/>
+          <p:nvPr/>
+        </p:nvSpPr>
+        <p:spPr>
+          <a:xfrm>
+            <a:off x="0" y="0"/>
+            <a:ext cx="12191695" cy="6858000"/>
+          </a:xfrm>
+          <a:prstGeom prst="rect">
+            <a:avLst/>
+          </a:prstGeom>
+          <a:solidFill>
+            <a:srgbClr val="FFFFFF"/>
+          </a:solidFill>
+          <a:ln>
+            <a:noFill/>
+          </a:ln>
+        </p:spPr>
+        <p:style>
+          <a:lnRef idx="1">
+            <a:schemeClr val="accent1"/>
+          </a:lnRef>
+          <a:fillRef idx="3">
+            <a:schemeClr val="accent1"/>
+          </a:fillRef>
+          <a:effectRef idx="2">
+            <a:schemeClr val="accent1"/>
+          </a:effectRef>
+          <a:fontRef idx="minor">
+            <a:schemeClr val="lt1"/>
+          </a:fontRef>
+        </p:style>
+        <p:txBody>
+          <a:bodyPr rtlCol="0" anchor="ctr"/>
+          <a:lstStyle/>
+          <a:p>
+            <a:pPr algn="ctr"/>
+          </a:p>
+        </p:txBody>
+      </p:sp>
+      <p:sp>
+        <p:nvSpPr>
+          <p:cNvPr id="3" name="Rectangle 2"/>
+          <p:cNvSpPr/>
+          <p:nvPr/>
+        </p:nvSpPr>
+        <p:spPr>
+          <a:xfrm>
+            <a:off x="0" y="0"/>
+            <a:ext cx="12191695" cy="713232"/>
+          </a:xfrm>
+          <a:prstGeom prst="rect">
+            <a:avLst/>
+          </a:prstGeom>
+          <a:solidFill>
+            <a:srgbClr val="4EACC2"/>
+          </a:solidFill>
+          <a:ln>
+            <a:solidFill>
+              <a:srgbClr val="0D2035"/>
+            </a:solidFill>
+          </a:ln>
+        </p:spPr>
+        <p:style>
+          <a:lnRef idx="1">
+            <a:schemeClr val="accent1"/>
+          </a:lnRef>
+          <a:fillRef idx="3">
+            <a:schemeClr val="accent1"/>
+          </a:fillRef>
+          <a:effectRef idx="2">
+            <a:schemeClr val="accent1"/>
+          </a:effectRef>
+          <a:fontRef idx="minor">
+            <a:schemeClr val="lt1"/>
+          </a:fontRef>
+        </p:style>
+        <p:txBody>
+          <a:bodyPr rtlCol="0" anchor="ctr"/>
+          <a:lstStyle/>
+          <a:p>
+            <a:pPr algn="ctr"/>
+          </a:p>
+        </p:txBody>
+      </p:sp>
+      <p:sp>
+        <p:nvSpPr>
+          <p:cNvPr id="4" name="TextBox 3"/>
+          <p:cNvSpPr txBox="1"/>
+          <p:nvPr/>
+        </p:nvSpPr>
+        <p:spPr>
+          <a:xfrm>
+            <a:off x="402336" y="146304"/>
+            <a:ext cx="11384280" cy="475488"/>
+          </a:xfrm>
+          <a:prstGeom prst="rect">
+            <a:avLst/>
+          </a:prstGeom>
+          <a:noFill/>
+        </p:spPr>
+        <p:txBody>
+          <a:bodyPr wrap="square" lIns="13716" rIns="13716" tIns="13716" bIns="13716" anchor="t">
+            <a:spAutoFit/>
+          </a:bodyPr>
+          <a:lstStyle/>
+          <a:p>
+            <a:pPr algn="l">
+              <a:defRPr sz="2500" b="1">
+                <a:solidFill>
+                  <a:srgbClr val="0D2035"/>
+                </a:solidFill>
+                <a:latin typeface="Aptos"/>
+              </a:defRPr>
+            </a:pPr>
+            <a:r>
+              <a:t>Archived campaign: sampled proximity has a limit</a:t>
+            </a:r>
+          </a:p>
+        </p:txBody>
+      </p:sp>
+      <p:sp>
+        <p:nvSpPr>
+          <p:cNvPr id="5" name="TextBox 4"/>
+          <p:cNvSpPr txBox="1"/>
+          <p:nvPr/>
+        </p:nvSpPr>
+        <p:spPr>
+          <a:xfrm>
+            <a:off x="457200" y="905256"/>
+            <a:ext cx="10789920" cy="256032"/>
+          </a:xfrm>
+          <a:prstGeom prst="rect">
+            <a:avLst/>
+          </a:prstGeom>
+          <a:noFill/>
+        </p:spPr>
+        <p:txBody>
+          <a:bodyPr wrap="square" lIns="13716" rIns="13716" tIns="13716" bIns="13716" anchor="t">
+            <a:spAutoFit/>
+          </a:bodyPr>
+          <a:lstStyle/>
+          <a:p>
+            <a:pPr algn="l">
+              <a:defRPr sz="1000" b="1">
+                <a:solidFill>
+                  <a:srgbClr val="0096A0"/>
+                </a:solidFill>
+                <a:latin typeface="Aptos"/>
+              </a:defRPr>
+            </a:pPr>
+            <a:r>
+              <a:t>EVIDENCE APPENDIX</a:t>
+            </a:r>
+          </a:p>
+        </p:txBody>
+      </p:sp>
+      <p:sp>
+        <p:nvSpPr>
+          <p:cNvPr id="6" name="TextBox 5"/>
+          <p:cNvSpPr txBox="1"/>
+          <p:nvPr/>
+        </p:nvSpPr>
+        <p:spPr>
+          <a:xfrm>
+            <a:off x="402336" y="6537960"/>
+            <a:ext cx="2560320" cy="201168"/>
+          </a:xfrm>
+          <a:prstGeom prst="rect">
+            <a:avLst/>
+          </a:prstGeom>
+          <a:noFill/>
+        </p:spPr>
+        <p:txBody>
+          <a:bodyPr wrap="square" lIns="13716" rIns="13716" tIns="13716" bIns="13716" anchor="t">
+            <a:spAutoFit/>
+          </a:bodyPr>
+          <a:lstStyle/>
+          <a:p>
+            <a:pPr algn="l">
+              <a:defRPr sz="850" b="1">
+                <a:solidFill>
+                  <a:srgbClr val="637684"/>
+                </a:solidFill>
+                <a:latin typeface="Aptos"/>
+              </a:defRPr>
+            </a:pPr>
+            <a:r>
+              <a:t>GMAT R1 ARCHIVE</a:t>
+            </a:r>
+          </a:p>
+        </p:txBody>
+      </p:sp>
+      <p:sp>
+        <p:nvSpPr>
+          <p:cNvPr id="7" name="TextBox 6"/>
+          <p:cNvSpPr txBox="1"/>
+          <p:nvPr/>
+        </p:nvSpPr>
+        <p:spPr>
+          <a:xfrm>
+            <a:off x="2926080" y="6537960"/>
+            <a:ext cx="8138160" cy="201168"/>
+          </a:xfrm>
+          <a:prstGeom prst="rect">
+            <a:avLst/>
+          </a:prstGeom>
+          <a:noFill/>
+        </p:spPr>
+        <p:txBody>
+          <a:bodyPr wrap="square" lIns="13716" rIns="13716" tIns="13716" bIns="13716" anchor="t">
+            <a:spAutoFit/>
+          </a:bodyPr>
+          <a:lstStyle/>
+          <a:p>
+            <a:pPr algn="l">
+              <a:defRPr sz="850" b="0">
+                <a:solidFill>
+                  <a:srgbClr val="637684"/>
+                </a:solidFill>
+                <a:latin typeface="Aptos"/>
+              </a:defRPr>
+            </a:pPr>
+            <a:r>
+              <a:t>Twelve preloaded post-release orbits; simulation dates in 2027</a:t>
+            </a:r>
+          </a:p>
+        </p:txBody>
+      </p:sp>
+      <p:sp>
+        <p:nvSpPr>
+          <p:cNvPr id="8" name="TextBox 7"/>
+          <p:cNvSpPr txBox="1"/>
+          <p:nvPr/>
+        </p:nvSpPr>
+        <p:spPr>
+          <a:xfrm>
+            <a:off x="11567160" y="6537960"/>
+            <a:ext cx="320040" cy="201168"/>
+          </a:xfrm>
+          <a:prstGeom prst="rect">
+            <a:avLst/>
+          </a:prstGeom>
+          <a:noFill/>
+        </p:spPr>
+        <p:txBody>
+          <a:bodyPr wrap="square" lIns="13716" rIns="13716" tIns="13716" bIns="13716" anchor="t">
+            <a:spAutoFit/>
+          </a:bodyPr>
+          <a:lstStyle/>
+          <a:p>
+            <a:pPr algn="r">
+              <a:defRPr sz="900" b="0">
+                <a:solidFill>
+                  <a:srgbClr val="637684"/>
+                </a:solidFill>
+                <a:latin typeface="Aptos"/>
+              </a:defRPr>
+            </a:pPr>
+            <a:r>
+              <a:t>30</a:t>
+            </a:r>
+          </a:p>
+        </p:txBody>
+      </p:sp>
+      <p:pic>
+        <p:nvPicPr>
+          <p:cNvPr id="9" name="Picture 8" descr="archived_campaign.png"/>
+          <p:cNvPicPr>
+            <a:picLocks noChangeAspect="1"/>
+          </p:cNvPicPr>
+          <p:nvPr/>
+        </p:nvPicPr>
+        <p:blipFill>
+          <a:blip r:embed="rId2"/>
+          <a:stretch>
+            <a:fillRect/>
+          </a:stretch>
+        </p:blipFill>
+        <p:spPr>
+          <a:xfrm>
+            <a:off x="604520" y="1554480"/>
+            <a:ext cx="10952480" cy="4480560"/>
+          </a:xfrm>
+          <a:prstGeom prst="rect">
+            <a:avLst/>
+          </a:prstGeom>
+        </p:spPr>
+      </p:pic>
+      <p:sp>
+        <p:nvSpPr>
+          <p:cNvPr id="10" name="TextBox 9"/>
+          <p:cNvSpPr txBox="1"/>
+          <p:nvPr/>
+        </p:nvSpPr>
+        <p:spPr>
+          <a:xfrm>
+            <a:off x="731520" y="6080760"/>
+            <a:ext cx="10789920" cy="274320"/>
+          </a:xfrm>
+          <a:prstGeom prst="rect">
+            <a:avLst/>
+          </a:prstGeom>
+          <a:noFill/>
+        </p:spPr>
+        <p:txBody>
+          <a:bodyPr wrap="square" lIns="13716" rIns="13716" tIns="13716" bIns="13716" anchor="t">
+            <a:spAutoFit/>
+          </a:bodyPr>
+          <a:lstStyle/>
+          <a:p>
+            <a:pPr algn="l">
+              <a:defRPr sz="1400" b="0">
+                <a:solidFill>
+                  <a:srgbClr val="1E3144"/>
+                </a:solidFill>
+                <a:latin typeface="Aptos"/>
+              </a:defRPr>
+            </a:pPr>
+            <a:r>
+              <a:t>190.15 m sampled; 180.29 m interpolated. Continuous clearance remains unproven.</a:t>
             </a:r>
           </a:p>
         </p:txBody>

</xml_diff>

<commit_message>
Apply scientific figure conventions and independent VOLLEY evidence boundary
</commit_message>
<xml_diff>
--- a/university/final_review_2026_10_10/VOLLEY_Final_Review_2026-10-10.pptx
+++ b/university/final_review_2026_10_10/VOLLEY_Final_Review_2026-10-10.pptx
@@ -3539,7 +3539,7 @@
               </a:defRPr>
             </a:pPr>
             <a:r>
-              <a:t>Review candidate: 16 October 2026</a:t>
+              <a:t>Review candidate: 19 October 2026</a:t>
             </a:r>
           </a:p>
         </p:txBody>
@@ -11931,7 +11931,7 @@
               </a:defRPr>
             </a:pPr>
             <a:r>
-              <a:t>Computational demonstration: from force to mission decision</a:t>
+              <a:t>Computed results: from force to mission decision</a:t>
             </a:r>
           </a:p>
         </p:txBody>
@@ -12003,7 +12003,7 @@
               </a:defRPr>
             </a:pPr>
             <a:r>
-              <a:t>SIMULATION DEMONSTRATION</a:t>
+              <a:t>CAPTURED COMPUTATIONAL RESULTS</a:t>
             </a:r>
           </a:p>
         </p:txBody>
@@ -16496,7 +16496,7 @@
               </a:defRPr>
             </a:pPr>
             <a:r>
-              <a:t>•  [11] VOLLEY/BOLLEY, Current Plan and Status — PLAN-R2, controlled working baseline, 29 Sep 2026 (project plan).</a:t>
+              <a:t>•  [11] VOLLEY, Gen6 G0 mission and article requirements, 12 Oct 2026 (study requirements).</a:t>
             </a:r>
           </a:p>
         </p:txBody>

</xml_diff>

<commit_message>
Integrate dated computational supplements into academic review
</commit_message>
<xml_diff>
--- a/university/final_review_2026_10_10/VOLLEY_Final_Review_2026-10-10.pptx
+++ b/university/final_review_2026_10_10/VOLLEY_Final_Review_2026-10-10.pptx
@@ -35,6 +35,10 @@
     <p:sldId id="283" r:id="rId34"/>
     <p:sldId id="284" r:id="rId35"/>
     <p:sldId id="285" r:id="rId36"/>
+    <p:sldId id="286" r:id="rId37"/>
+    <p:sldId id="287" r:id="rId38"/>
+    <p:sldId id="288" r:id="rId39"/>
+    <p:sldId id="289" r:id="rId40"/>
   </p:sldIdLst>
   <p:sldSz cx="12191695" cy="6858000" type="screen4x3"/>
   <p:notesSz cx="6858000" cy="9144000"/>
@@ -18521,6 +18525,1493 @@
             </a:pPr>
             <a:r>
               <a:t>190.15 m sampled; 180.29 m interpolated. Continuous clearance remains unproven.</a:t>
+            </a:r>
+          </a:p>
+        </p:txBody>
+      </p:sp>
+    </p:spTree>
+  </p:cSld>
+  <p:clrMapOvr>
+    <a:masterClrMapping/>
+  </p:clrMapOvr>
+</p:sld>
+</file>
+
+<file path=ppt/slides/slide31.xml><?xml version="1.0" encoding="utf-8"?>
+<p:sld xmlns:a="http://schemas.openxmlformats.org/drawingml/2006/main" xmlns:p="http://schemas.openxmlformats.org/presentationml/2006/main" xmlns:r="http://schemas.openxmlformats.org/officeDocument/2006/relationships">
+  <p:cSld>
+    <p:spTree>
+      <p:nvGrpSpPr>
+        <p:cNvPr id="1" name=""/>
+        <p:cNvGrpSpPr/>
+        <p:nvPr/>
+      </p:nvGrpSpPr>
+      <p:grpSpPr/>
+      <p:sp>
+        <p:nvSpPr>
+          <p:cNvPr id="2" name="Rectangle 1"/>
+          <p:cNvSpPr/>
+          <p:nvPr/>
+        </p:nvSpPr>
+        <p:spPr>
+          <a:xfrm>
+            <a:off x="0" y="0"/>
+            <a:ext cx="12191695" cy="6858000"/>
+          </a:xfrm>
+          <a:prstGeom prst="rect">
+            <a:avLst/>
+          </a:prstGeom>
+          <a:solidFill>
+            <a:srgbClr val="FFFFFF"/>
+          </a:solidFill>
+          <a:ln>
+            <a:noFill/>
+          </a:ln>
+        </p:spPr>
+        <p:style>
+          <a:lnRef idx="1">
+            <a:schemeClr val="accent1"/>
+          </a:lnRef>
+          <a:fillRef idx="3">
+            <a:schemeClr val="accent1"/>
+          </a:fillRef>
+          <a:effectRef idx="2">
+            <a:schemeClr val="accent1"/>
+          </a:effectRef>
+          <a:fontRef idx="minor">
+            <a:schemeClr val="lt1"/>
+          </a:fontRef>
+        </p:style>
+        <p:txBody>
+          <a:bodyPr rtlCol="0" anchor="ctr"/>
+          <a:lstStyle/>
+          <a:p>
+            <a:pPr algn="ctr"/>
+          </a:p>
+        </p:txBody>
+      </p:sp>
+      <p:sp>
+        <p:nvSpPr>
+          <p:cNvPr id="3" name="Rectangle 2"/>
+          <p:cNvSpPr/>
+          <p:nvPr/>
+        </p:nvSpPr>
+        <p:spPr>
+          <a:xfrm>
+            <a:off x="0" y="0"/>
+            <a:ext cx="12191695" cy="713232"/>
+          </a:xfrm>
+          <a:prstGeom prst="rect">
+            <a:avLst/>
+          </a:prstGeom>
+          <a:solidFill>
+            <a:srgbClr val="4EACC2"/>
+          </a:solidFill>
+          <a:ln>
+            <a:solidFill>
+              <a:srgbClr val="0D2035"/>
+            </a:solidFill>
+          </a:ln>
+        </p:spPr>
+        <p:style>
+          <a:lnRef idx="1">
+            <a:schemeClr val="accent1"/>
+          </a:lnRef>
+          <a:fillRef idx="3">
+            <a:schemeClr val="accent1"/>
+          </a:fillRef>
+          <a:effectRef idx="2">
+            <a:schemeClr val="accent1"/>
+          </a:effectRef>
+          <a:fontRef idx="minor">
+            <a:schemeClr val="lt1"/>
+          </a:fontRef>
+        </p:style>
+        <p:txBody>
+          <a:bodyPr rtlCol="0" anchor="ctr"/>
+          <a:lstStyle/>
+          <a:p>
+            <a:pPr algn="ctr"/>
+          </a:p>
+        </p:txBody>
+      </p:sp>
+      <p:sp>
+        <p:nvSpPr>
+          <p:cNvPr id="4" name="TextBox 3"/>
+          <p:cNvSpPr txBox="1"/>
+          <p:nvPr/>
+        </p:nvSpPr>
+        <p:spPr>
+          <a:xfrm>
+            <a:off x="402336" y="146304"/>
+            <a:ext cx="11384280" cy="475488"/>
+          </a:xfrm>
+          <a:prstGeom prst="rect">
+            <a:avLst/>
+          </a:prstGeom>
+          <a:noFill/>
+        </p:spPr>
+        <p:txBody>
+          <a:bodyPr wrap="square" lIns="13716" rIns="13716" tIns="13716" bIns="13716" anchor="t">
+            <a:spAutoFit/>
+          </a:bodyPr>
+          <a:lstStyle/>
+          <a:p>
+            <a:pPr algn="l">
+              <a:defRPr sz="2500" b="1">
+                <a:solidFill>
+                  <a:srgbClr val="0D2035"/>
+                </a:solidFill>
+                <a:latin typeface="Aptos"/>
+              </a:defRPr>
+            </a:pPr>
+            <a:r>
+              <a:t>The J2 setup discrepancy now has a bounded resolution</a:t>
+            </a:r>
+          </a:p>
+        </p:txBody>
+      </p:sp>
+      <p:sp>
+        <p:nvSpPr>
+          <p:cNvPr id="5" name="TextBox 4"/>
+          <p:cNvSpPr txBox="1"/>
+          <p:nvPr/>
+        </p:nvSpPr>
+        <p:spPr>
+          <a:xfrm>
+            <a:off x="457200" y="905256"/>
+            <a:ext cx="10789920" cy="256032"/>
+          </a:xfrm>
+          <a:prstGeom prst="rect">
+            <a:avLst/>
+          </a:prstGeom>
+          <a:noFill/>
+        </p:spPr>
+        <p:txBody>
+          <a:bodyPr wrap="square" lIns="13716" rIns="13716" tIns="13716" bIns="13716" anchor="t">
+            <a:spAutoFit/>
+          </a:bodyPr>
+          <a:lstStyle/>
+          <a:p>
+            <a:pPr algn="l">
+              <a:defRPr sz="1000" b="1">
+                <a:solidFill>
+                  <a:srgbClr val="0096A0"/>
+                </a:solidFill>
+                <a:latin typeface="Aptos"/>
+              </a:defRPr>
+            </a:pPr>
+            <a:r>
+              <a:t>EVIDENCE APPENDIX</a:t>
+            </a:r>
+          </a:p>
+        </p:txBody>
+      </p:sp>
+      <p:sp>
+        <p:nvSpPr>
+          <p:cNvPr id="6" name="TextBox 5"/>
+          <p:cNvSpPr txBox="1"/>
+          <p:nvPr/>
+        </p:nvSpPr>
+        <p:spPr>
+          <a:xfrm>
+            <a:off x="402336" y="6537960"/>
+            <a:ext cx="2560320" cy="201168"/>
+          </a:xfrm>
+          <a:prstGeom prst="rect">
+            <a:avLst/>
+          </a:prstGeom>
+          <a:noFill/>
+        </p:spPr>
+        <p:txBody>
+          <a:bodyPr wrap="square" lIns="13716" rIns="13716" tIns="13716" bIns="13716" anchor="t">
+            <a:spAutoFit/>
+          </a:bodyPr>
+          <a:lstStyle/>
+          <a:p>
+            <a:pPr algn="l">
+              <a:defRPr sz="850" b="1">
+                <a:solidFill>
+                  <a:srgbClr val="637684"/>
+                </a:solidFill>
+                <a:latin typeface="Aptos"/>
+              </a:defRPr>
+            </a:pPr>
+            <a:r>
+              <a:t>NUMERICAL CONSISTENCY</a:t>
+            </a:r>
+          </a:p>
+        </p:txBody>
+      </p:sp>
+      <p:sp>
+        <p:nvSpPr>
+          <p:cNvPr id="7" name="TextBox 6"/>
+          <p:cNvSpPr txBox="1"/>
+          <p:nvPr/>
+        </p:nvSpPr>
+        <p:spPr>
+          <a:xfrm>
+            <a:off x="2926080" y="6537960"/>
+            <a:ext cx="8138160" cy="201168"/>
+          </a:xfrm>
+          <a:prstGeom prst="rect">
+            <a:avLst/>
+          </a:prstGeom>
+          <a:noFill/>
+        </p:spPr>
+        <p:txBody>
+          <a:bodyPr wrap="square" lIns="13716" rIns="13716" tIns="13716" bIns="13716" anchor="t">
+            <a:spAutoFit/>
+          </a:bodyPr>
+          <a:lstStyle/>
+          <a:p>
+            <a:pPr algn="l">
+              <a:defRPr sz="850" b="0">
+                <a:solidFill>
+                  <a:srgbClr val="637684"/>
+                </a:solidFill>
+                <a:latin typeface="Aptos"/>
+              </a:defRPr>
+            </a:pPr>
+            <a:r>
+              <a:t>GMAT R2026a / Orekit 13.1.6 · matched prescribed pole, 19 October</a:t>
+            </a:r>
+          </a:p>
+        </p:txBody>
+      </p:sp>
+      <p:sp>
+        <p:nvSpPr>
+          <p:cNvPr id="8" name="TextBox 7"/>
+          <p:cNvSpPr txBox="1"/>
+          <p:nvPr/>
+        </p:nvSpPr>
+        <p:spPr>
+          <a:xfrm>
+            <a:off x="11567160" y="6537960"/>
+            <a:ext cx="320040" cy="201168"/>
+          </a:xfrm>
+          <a:prstGeom prst="rect">
+            <a:avLst/>
+          </a:prstGeom>
+          <a:noFill/>
+        </p:spPr>
+        <p:txBody>
+          <a:bodyPr wrap="square" lIns="13716" rIns="13716" tIns="13716" bIns="13716" anchor="t">
+            <a:spAutoFit/>
+          </a:bodyPr>
+          <a:lstStyle/>
+          <a:p>
+            <a:pPr algn="r">
+              <a:defRPr sz="900" b="0">
+                <a:solidFill>
+                  <a:srgbClr val="637684"/>
+                </a:solidFill>
+                <a:latin typeface="Aptos"/>
+              </a:defRPr>
+            </a:pPr>
+            <a:r>
+              <a:t>31</a:t>
+            </a:r>
+          </a:p>
+        </p:txBody>
+      </p:sp>
+      <p:pic>
+        <p:nvPicPr>
+          <p:cNvPr id="9" name="Picture 8" descr="harmonization.png"/>
+          <p:cNvPicPr>
+            <a:picLocks noChangeAspect="1"/>
+          </p:cNvPicPr>
+          <p:nvPr/>
+        </p:nvPicPr>
+        <p:blipFill>
+          <a:blip r:embed="rId2"/>
+          <a:stretch>
+            <a:fillRect/>
+          </a:stretch>
+        </p:blipFill>
+        <p:spPr>
+          <a:xfrm>
+            <a:off x="1491963" y="1508760"/>
+            <a:ext cx="9177593" cy="4389119"/>
+          </a:xfrm>
+          <a:prstGeom prst="rect">
+            <a:avLst/>
+          </a:prstGeom>
+        </p:spPr>
+      </p:pic>
+      <p:sp>
+        <p:nvSpPr>
+          <p:cNvPr id="10" name="TextBox 9"/>
+          <p:cNvSpPr txBox="1"/>
+          <p:nvPr/>
+        </p:nvSpPr>
+        <p:spPr>
+          <a:xfrm>
+            <a:off x="685800" y="6080760"/>
+            <a:ext cx="10789920" cy="274320"/>
+          </a:xfrm>
+          <a:prstGeom prst="rect">
+            <a:avLst/>
+          </a:prstGeom>
+          <a:noFill/>
+        </p:spPr>
+        <p:txBody>
+          <a:bodyPr wrap="square" lIns="13716" rIns="13716" tIns="13716" bIns="13716" anchor="t">
+            <a:spAutoFit/>
+          </a:bodyPr>
+          <a:lstStyle/>
+          <a:p>
+            <a:pPr algn="l">
+              <a:defRPr sz="1400" b="0">
+                <a:solidFill>
+                  <a:srgbClr val="1E3144"/>
+                </a:solidFill>
+                <a:latin typeface="Aptos"/>
+              </a:defRPr>
+            </a:pPr>
+            <a:r>
+              <a:t>1.285 mm maximum over one day. Shared orientation; no physical orbit or release-accuracy claim.</a:t>
+            </a:r>
+          </a:p>
+        </p:txBody>
+      </p:sp>
+    </p:spTree>
+  </p:cSld>
+  <p:clrMapOvr>
+    <a:masterClrMapping/>
+  </p:clrMapOvr>
+</p:sld>
+</file>
+
+<file path=ppt/slides/slide32.xml><?xml version="1.0" encoding="utf-8"?>
+<p:sld xmlns:a="http://schemas.openxmlformats.org/drawingml/2006/main" xmlns:p="http://schemas.openxmlformats.org/presentationml/2006/main" xmlns:r="http://schemas.openxmlformats.org/officeDocument/2006/relationships">
+  <p:cSld>
+    <p:spTree>
+      <p:nvGrpSpPr>
+        <p:cNvPr id="1" name=""/>
+        <p:cNvGrpSpPr/>
+        <p:nvPr/>
+      </p:nvGrpSpPr>
+      <p:grpSpPr/>
+      <p:sp>
+        <p:nvSpPr>
+          <p:cNvPr id="2" name="Rectangle 1"/>
+          <p:cNvSpPr/>
+          <p:nvPr/>
+        </p:nvSpPr>
+        <p:spPr>
+          <a:xfrm>
+            <a:off x="0" y="0"/>
+            <a:ext cx="12191695" cy="6858000"/>
+          </a:xfrm>
+          <a:prstGeom prst="rect">
+            <a:avLst/>
+          </a:prstGeom>
+          <a:solidFill>
+            <a:srgbClr val="FFFFFF"/>
+          </a:solidFill>
+          <a:ln>
+            <a:noFill/>
+          </a:ln>
+        </p:spPr>
+        <p:style>
+          <a:lnRef idx="1">
+            <a:schemeClr val="accent1"/>
+          </a:lnRef>
+          <a:fillRef idx="3">
+            <a:schemeClr val="accent1"/>
+          </a:fillRef>
+          <a:effectRef idx="2">
+            <a:schemeClr val="accent1"/>
+          </a:effectRef>
+          <a:fontRef idx="minor">
+            <a:schemeClr val="lt1"/>
+          </a:fontRef>
+        </p:style>
+        <p:txBody>
+          <a:bodyPr rtlCol="0" anchor="ctr"/>
+          <a:lstStyle/>
+          <a:p>
+            <a:pPr algn="ctr"/>
+          </a:p>
+        </p:txBody>
+      </p:sp>
+      <p:sp>
+        <p:nvSpPr>
+          <p:cNvPr id="3" name="Rectangle 2"/>
+          <p:cNvSpPr/>
+          <p:nvPr/>
+        </p:nvSpPr>
+        <p:spPr>
+          <a:xfrm>
+            <a:off x="0" y="0"/>
+            <a:ext cx="12191695" cy="713232"/>
+          </a:xfrm>
+          <a:prstGeom prst="rect">
+            <a:avLst/>
+          </a:prstGeom>
+          <a:solidFill>
+            <a:srgbClr val="4EACC2"/>
+          </a:solidFill>
+          <a:ln>
+            <a:solidFill>
+              <a:srgbClr val="0D2035"/>
+            </a:solidFill>
+          </a:ln>
+        </p:spPr>
+        <p:style>
+          <a:lnRef idx="1">
+            <a:schemeClr val="accent1"/>
+          </a:lnRef>
+          <a:fillRef idx="3">
+            <a:schemeClr val="accent1"/>
+          </a:fillRef>
+          <a:effectRef idx="2">
+            <a:schemeClr val="accent1"/>
+          </a:effectRef>
+          <a:fontRef idx="minor">
+            <a:schemeClr val="lt1"/>
+          </a:fontRef>
+        </p:style>
+        <p:txBody>
+          <a:bodyPr rtlCol="0" anchor="ctr"/>
+          <a:lstStyle/>
+          <a:p>
+            <a:pPr algn="ctr"/>
+          </a:p>
+        </p:txBody>
+      </p:sp>
+      <p:sp>
+        <p:nvSpPr>
+          <p:cNvPr id="4" name="TextBox 3"/>
+          <p:cNvSpPr txBox="1"/>
+          <p:nvPr/>
+        </p:nvSpPr>
+        <p:spPr>
+          <a:xfrm>
+            <a:off x="402336" y="146304"/>
+            <a:ext cx="11384280" cy="475488"/>
+          </a:xfrm>
+          <a:prstGeom prst="rect">
+            <a:avLst/>
+          </a:prstGeom>
+          <a:noFill/>
+        </p:spPr>
+        <p:txBody>
+          <a:bodyPr wrap="square" lIns="13716" rIns="13716" tIns="13716" bIns="13716" anchor="t">
+            <a:spAutoFit/>
+          </a:bodyPr>
+          <a:lstStyle/>
+          <a:p>
+            <a:pPr algn="l">
+              <a:defRPr sz="2500" b="1">
+                <a:solidFill>
+                  <a:srgbClr val="0D2035"/>
+                </a:solidFill>
+                <a:latin typeface="Aptos"/>
+              </a:defRPr>
+            </a:pPr>
+            <a:r>
+              <a:t>Host assistance closes mathematical targets, with a cost</a:t>
+            </a:r>
+          </a:p>
+        </p:txBody>
+      </p:sp>
+      <p:sp>
+        <p:nvSpPr>
+          <p:cNvPr id="5" name="TextBox 4"/>
+          <p:cNvSpPr txBox="1"/>
+          <p:nvPr/>
+        </p:nvSpPr>
+        <p:spPr>
+          <a:xfrm>
+            <a:off x="457200" y="905256"/>
+            <a:ext cx="10789920" cy="256032"/>
+          </a:xfrm>
+          <a:prstGeom prst="rect">
+            <a:avLst/>
+          </a:prstGeom>
+          <a:noFill/>
+        </p:spPr>
+        <p:txBody>
+          <a:bodyPr wrap="square" lIns="13716" rIns="13716" tIns="13716" bIns="13716" anchor="t">
+            <a:spAutoFit/>
+          </a:bodyPr>
+          <a:lstStyle/>
+          <a:p>
+            <a:pPr algn="l">
+              <a:defRPr sz="1000" b="1">
+                <a:solidFill>
+                  <a:srgbClr val="0096A0"/>
+                </a:solidFill>
+                <a:latin typeface="Aptos"/>
+              </a:defRPr>
+            </a:pPr>
+            <a:r>
+              <a:t>FUTURE-WORK APPENDIX</a:t>
+            </a:r>
+          </a:p>
+        </p:txBody>
+      </p:sp>
+      <p:sp>
+        <p:nvSpPr>
+          <p:cNvPr id="6" name="TextBox 5"/>
+          <p:cNvSpPr txBox="1"/>
+          <p:nvPr/>
+        </p:nvSpPr>
+        <p:spPr>
+          <a:xfrm>
+            <a:off x="402336" y="6537960"/>
+            <a:ext cx="2560320" cy="201168"/>
+          </a:xfrm>
+          <a:prstGeom prst="rect">
+            <a:avLst/>
+          </a:prstGeom>
+          <a:noFill/>
+        </p:spPr>
+        <p:txBody>
+          <a:bodyPr wrap="square" lIns="13716" rIns="13716" tIns="13716" bIns="13716" anchor="t">
+            <a:spAutoFit/>
+          </a:bodyPr>
+          <a:lstStyle/>
+          <a:p>
+            <a:pPr algn="l">
+              <a:defRPr sz="850" b="1">
+                <a:solidFill>
+                  <a:srgbClr val="637684"/>
+                </a:solidFill>
+                <a:latin typeface="Aptos"/>
+              </a:defRPr>
+            </a:pPr>
+            <a:r>
+              <a:t>GEN6 SURROGATE</a:t>
+            </a:r>
+          </a:p>
+        </p:txBody>
+      </p:sp>
+      <p:sp>
+        <p:nvSpPr>
+          <p:cNvPr id="7" name="TextBox 6"/>
+          <p:cNvSpPr txBox="1"/>
+          <p:nvPr/>
+        </p:nvSpPr>
+        <p:spPr>
+          <a:xfrm>
+            <a:off x="2926080" y="6537960"/>
+            <a:ext cx="8138160" cy="201168"/>
+          </a:xfrm>
+          <a:prstGeom prst="rect">
+            <a:avLst/>
+          </a:prstGeom>
+          <a:noFill/>
+        </p:spPr>
+        <p:txBody>
+          <a:bodyPr wrap="square" lIns="13716" rIns="13716" tIns="13716" bIns="13716" anchor="t">
+            <a:spAutoFit/>
+          </a:bodyPr>
+          <a:lstStyle/>
+          <a:p>
+            <a:pPr algn="l">
+              <a:defRPr sz="850" b="0">
+                <a:solidFill>
+                  <a:srgbClr val="637684"/>
+                </a:solidFill>
+                <a:latin typeface="Aptos"/>
+              </a:defRPr>
+            </a:pPr>
+            <a:r>
+              <a:t>Constructed four/twelve-payload J2 campaign · ideal impulses and mass proxies</a:t>
+            </a:r>
+          </a:p>
+        </p:txBody>
+      </p:sp>
+      <p:sp>
+        <p:nvSpPr>
+          <p:cNvPr id="8" name="TextBox 7"/>
+          <p:cNvSpPr txBox="1"/>
+          <p:nvPr/>
+        </p:nvSpPr>
+        <p:spPr>
+          <a:xfrm>
+            <a:off x="11567160" y="6537960"/>
+            <a:ext cx="320040" cy="201168"/>
+          </a:xfrm>
+          <a:prstGeom prst="rect">
+            <a:avLst/>
+          </a:prstGeom>
+          <a:noFill/>
+        </p:spPr>
+        <p:txBody>
+          <a:bodyPr wrap="square" lIns="13716" rIns="13716" tIns="13716" bIns="13716" anchor="t">
+            <a:spAutoFit/>
+          </a:bodyPr>
+          <a:lstStyle/>
+          <a:p>
+            <a:pPr algn="r">
+              <a:defRPr sz="900" b="0">
+                <a:solidFill>
+                  <a:srgbClr val="637684"/>
+                </a:solidFill>
+                <a:latin typeface="Aptos"/>
+              </a:defRPr>
+            </a:pPr>
+            <a:r>
+              <a:t>32</a:t>
+            </a:r>
+          </a:p>
+        </p:txBody>
+      </p:sp>
+      <p:pic>
+        <p:nvPicPr>
+          <p:cNvPr id="9" name="Picture 8" descr="resource_comparison.png"/>
+          <p:cNvPicPr>
+            <a:picLocks noChangeAspect="1"/>
+          </p:cNvPicPr>
+          <p:nvPr/>
+        </p:nvPicPr>
+        <p:blipFill>
+          <a:blip r:embed="rId2"/>
+          <a:stretch>
+            <a:fillRect/>
+          </a:stretch>
+        </p:blipFill>
+        <p:spPr>
+          <a:xfrm>
+            <a:off x="1517349" y="1508760"/>
+            <a:ext cx="9126820" cy="4389119"/>
+          </a:xfrm>
+          <a:prstGeom prst="rect">
+            <a:avLst/>
+          </a:prstGeom>
+        </p:spPr>
+      </p:pic>
+      <p:sp>
+        <p:nvSpPr>
+          <p:cNvPr id="10" name="TextBox 9"/>
+          <p:cNvSpPr txBox="1"/>
+          <p:nvPr/>
+        </p:nvSpPr>
+        <p:spPr>
+          <a:xfrm>
+            <a:off x="685800" y="6080760"/>
+            <a:ext cx="10789920" cy="274320"/>
+          </a:xfrm>
+          <a:prstGeom prst="rect">
+            <a:avLst/>
+          </a:prstGeom>
+          <a:noFill/>
+        </p:spPr>
+        <p:txBody>
+          <a:bodyPr wrap="square" lIns="13716" rIns="13716" tIns="13716" bIns="13716" anchor="t">
+            <a:spAutoFit/>
+          </a:bodyPr>
+          <a:lstStyle/>
+          <a:p>
+            <a:pPr algn="l">
+              <a:defRPr sz="1400" b="0">
+                <a:solidFill>
+                  <a:srgbClr val="1E3144"/>
+                </a:solidFill>
+                <a:latin typeface="Aptos"/>
+              </a:defRPr>
+            </a:pPr>
+            <a:r>
+              <a:t>Larger-reserve spring case completes. Fuel savings do not recover the assumed device-mass penalty.</a:t>
+            </a:r>
+          </a:p>
+        </p:txBody>
+      </p:sp>
+    </p:spTree>
+  </p:cSld>
+  <p:clrMapOvr>
+    <a:masterClrMapping/>
+  </p:clrMapOvr>
+</p:sld>
+</file>
+
+<file path=ppt/slides/slide33.xml><?xml version="1.0" encoding="utf-8"?>
+<p:sld xmlns:a="http://schemas.openxmlformats.org/drawingml/2006/main" xmlns:p="http://schemas.openxmlformats.org/presentationml/2006/main" xmlns:r="http://schemas.openxmlformats.org/officeDocument/2006/relationships">
+  <p:cSld>
+    <p:spTree>
+      <p:nvGrpSpPr>
+        <p:cNvPr id="1" name=""/>
+        <p:cNvGrpSpPr/>
+        <p:nvPr/>
+      </p:nvGrpSpPr>
+      <p:grpSpPr/>
+      <p:sp>
+        <p:nvSpPr>
+          <p:cNvPr id="2" name="Rectangle 1"/>
+          <p:cNvSpPr/>
+          <p:nvPr/>
+        </p:nvSpPr>
+        <p:spPr>
+          <a:xfrm>
+            <a:off x="0" y="0"/>
+            <a:ext cx="12191695" cy="6858000"/>
+          </a:xfrm>
+          <a:prstGeom prst="rect">
+            <a:avLst/>
+          </a:prstGeom>
+          <a:solidFill>
+            <a:srgbClr val="FFFFFF"/>
+          </a:solidFill>
+          <a:ln>
+            <a:noFill/>
+          </a:ln>
+        </p:spPr>
+        <p:style>
+          <a:lnRef idx="1">
+            <a:schemeClr val="accent1"/>
+          </a:lnRef>
+          <a:fillRef idx="3">
+            <a:schemeClr val="accent1"/>
+          </a:fillRef>
+          <a:effectRef idx="2">
+            <a:schemeClr val="accent1"/>
+          </a:effectRef>
+          <a:fontRef idx="minor">
+            <a:schemeClr val="lt1"/>
+          </a:fontRef>
+        </p:style>
+        <p:txBody>
+          <a:bodyPr rtlCol="0" anchor="ctr"/>
+          <a:lstStyle/>
+          <a:p>
+            <a:pPr algn="ctr"/>
+          </a:p>
+        </p:txBody>
+      </p:sp>
+      <p:sp>
+        <p:nvSpPr>
+          <p:cNvPr id="3" name="Rectangle 2"/>
+          <p:cNvSpPr/>
+          <p:nvPr/>
+        </p:nvSpPr>
+        <p:spPr>
+          <a:xfrm>
+            <a:off x="0" y="0"/>
+            <a:ext cx="12191695" cy="713232"/>
+          </a:xfrm>
+          <a:prstGeom prst="rect">
+            <a:avLst/>
+          </a:prstGeom>
+          <a:solidFill>
+            <a:srgbClr val="4EACC2"/>
+          </a:solidFill>
+          <a:ln>
+            <a:solidFill>
+              <a:srgbClr val="0D2035"/>
+            </a:solidFill>
+          </a:ln>
+        </p:spPr>
+        <p:style>
+          <a:lnRef idx="1">
+            <a:schemeClr val="accent1"/>
+          </a:lnRef>
+          <a:fillRef idx="3">
+            <a:schemeClr val="accent1"/>
+          </a:fillRef>
+          <a:effectRef idx="2">
+            <a:schemeClr val="accent1"/>
+          </a:effectRef>
+          <a:fontRef idx="minor">
+            <a:schemeClr val="lt1"/>
+          </a:fontRef>
+        </p:style>
+        <p:txBody>
+          <a:bodyPr rtlCol="0" anchor="ctr"/>
+          <a:lstStyle/>
+          <a:p>
+            <a:pPr algn="ctr"/>
+          </a:p>
+        </p:txBody>
+      </p:sp>
+      <p:sp>
+        <p:nvSpPr>
+          <p:cNvPr id="4" name="TextBox 3"/>
+          <p:cNvSpPr txBox="1"/>
+          <p:nvPr/>
+        </p:nvSpPr>
+        <p:spPr>
+          <a:xfrm>
+            <a:off x="402336" y="146304"/>
+            <a:ext cx="11384280" cy="475488"/>
+          </a:xfrm>
+          <a:prstGeom prst="rect">
+            <a:avLst/>
+          </a:prstGeom>
+          <a:noFill/>
+        </p:spPr>
+        <p:txBody>
+          <a:bodyPr wrap="square" lIns="13716" rIns="13716" tIns="13716" bIns="13716" anchor="t">
+            <a:spAutoFit/>
+          </a:bodyPr>
+          <a:lstStyle/>
+          <a:p>
+            <a:pPr algn="l">
+              <a:defRPr sz="2500" b="1">
+                <a:solidFill>
+                  <a:srgbClr val="0D2035"/>
+                </a:solidFill>
+                <a:latin typeface="Aptos"/>
+              </a:defRPr>
+            </a:pPr>
+            <a:r>
+              <a:t>Seven feeder concepts: inspectable geometry, open hardware gates</a:t>
+            </a:r>
+          </a:p>
+        </p:txBody>
+      </p:sp>
+      <p:sp>
+        <p:nvSpPr>
+          <p:cNvPr id="5" name="TextBox 4"/>
+          <p:cNvSpPr txBox="1"/>
+          <p:nvPr/>
+        </p:nvSpPr>
+        <p:spPr>
+          <a:xfrm>
+            <a:off x="457200" y="905256"/>
+            <a:ext cx="10789920" cy="256032"/>
+          </a:xfrm>
+          <a:prstGeom prst="rect">
+            <a:avLst/>
+          </a:prstGeom>
+          <a:noFill/>
+        </p:spPr>
+        <p:txBody>
+          <a:bodyPr wrap="square" lIns="13716" rIns="13716" tIns="13716" bIns="13716" anchor="t">
+            <a:spAutoFit/>
+          </a:bodyPr>
+          <a:lstStyle/>
+          <a:p>
+            <a:pPr algn="l">
+              <a:defRPr sz="1000" b="1">
+                <a:solidFill>
+                  <a:srgbClr val="0096A0"/>
+                </a:solidFill>
+                <a:latin typeface="Aptos"/>
+              </a:defRPr>
+            </a:pPr>
+            <a:r>
+              <a:t>FUTURE-WORK APPENDIX</a:t>
+            </a:r>
+          </a:p>
+        </p:txBody>
+      </p:sp>
+      <p:sp>
+        <p:nvSpPr>
+          <p:cNvPr id="6" name="TextBox 5"/>
+          <p:cNvSpPr txBox="1"/>
+          <p:nvPr/>
+        </p:nvSpPr>
+        <p:spPr>
+          <a:xfrm>
+            <a:off x="402336" y="6537960"/>
+            <a:ext cx="2560320" cy="201168"/>
+          </a:xfrm>
+          <a:prstGeom prst="rect">
+            <a:avLst/>
+          </a:prstGeom>
+          <a:noFill/>
+        </p:spPr>
+        <p:txBody>
+          <a:bodyPr wrap="square" lIns="13716" rIns="13716" tIns="13716" bIns="13716" anchor="t">
+            <a:spAutoFit/>
+          </a:bodyPr>
+          <a:lstStyle/>
+          <a:p>
+            <a:pPr algn="l">
+              <a:defRPr sz="850" b="1">
+                <a:solidFill>
+                  <a:srgbClr val="637684"/>
+                </a:solidFill>
+                <a:latin typeface="Aptos"/>
+              </a:defRPr>
+            </a:pPr>
+            <a:r>
+              <a:t>UNSELECTED CANDIDATES</a:t>
+            </a:r>
+          </a:p>
+        </p:txBody>
+      </p:sp>
+      <p:sp>
+        <p:nvSpPr>
+          <p:cNvPr id="7" name="TextBox 6"/>
+          <p:cNvSpPr txBox="1"/>
+          <p:nvPr/>
+        </p:nvSpPr>
+        <p:spPr>
+          <a:xfrm>
+            <a:off x="2926080" y="6537960"/>
+            <a:ext cx="8138160" cy="201168"/>
+          </a:xfrm>
+          <a:prstGeom prst="rect">
+            <a:avLst/>
+          </a:prstGeom>
+          <a:noFill/>
+        </p:spPr>
+        <p:txBody>
+          <a:bodyPr wrap="square" lIns="13716" rIns="13716" tIns="13716" bIns="13716" anchor="t">
+            <a:spAutoFit/>
+          </a:bodyPr>
+          <a:lstStyle/>
+          <a:p>
+            <a:pPr algn="l">
+              <a:defRPr sz="850" b="0">
+                <a:solidFill>
+                  <a:srgbClr val="637684"/>
+                </a:solidFill>
+                <a:latin typeface="Aptos"/>
+              </a:defRPr>
+            </a:pPr>
+            <a:r>
+              <a:t>Native FreeCAD / STEP · analytical cases / CalculiX fixture · 19 October</a:t>
+            </a:r>
+          </a:p>
+        </p:txBody>
+      </p:sp>
+      <p:sp>
+        <p:nvSpPr>
+          <p:cNvPr id="8" name="TextBox 7"/>
+          <p:cNvSpPr txBox="1"/>
+          <p:nvPr/>
+        </p:nvSpPr>
+        <p:spPr>
+          <a:xfrm>
+            <a:off x="11567160" y="6537960"/>
+            <a:ext cx="320040" cy="201168"/>
+          </a:xfrm>
+          <a:prstGeom prst="rect">
+            <a:avLst/>
+          </a:prstGeom>
+          <a:noFill/>
+        </p:spPr>
+        <p:txBody>
+          <a:bodyPr wrap="square" lIns="13716" rIns="13716" tIns="13716" bIns="13716" anchor="t">
+            <a:spAutoFit/>
+          </a:bodyPr>
+          <a:lstStyle/>
+          <a:p>
+            <a:pPr algn="r">
+              <a:defRPr sz="900" b="0">
+                <a:solidFill>
+                  <a:srgbClr val="637684"/>
+                </a:solidFill>
+                <a:latin typeface="Aptos"/>
+              </a:defRPr>
+            </a:pPr>
+            <a:r>
+              <a:t>33</a:t>
+            </a:r>
+          </a:p>
+        </p:txBody>
+      </p:sp>
+      <p:pic>
+        <p:nvPicPr>
+          <p:cNvPr id="9" name="Picture 8" descr="lead_screw_cad.png"/>
+          <p:cNvPicPr>
+            <a:picLocks noChangeAspect="1"/>
+          </p:cNvPicPr>
+          <p:nvPr/>
+        </p:nvPicPr>
+        <p:blipFill>
+          <a:blip r:embed="rId2"/>
+          <a:stretch>
+            <a:fillRect/>
+          </a:stretch>
+        </p:blipFill>
+        <p:spPr>
+          <a:xfrm>
+            <a:off x="548640" y="1636438"/>
+            <a:ext cx="7315200" cy="4133763"/>
+          </a:xfrm>
+          <a:prstGeom prst="rect">
+            <a:avLst/>
+          </a:prstGeom>
+        </p:spPr>
+      </p:pic>
+      <p:sp>
+        <p:nvSpPr>
+          <p:cNvPr id="10" name="TextBox 9"/>
+          <p:cNvSpPr txBox="1"/>
+          <p:nvPr/>
+        </p:nvSpPr>
+        <p:spPr>
+          <a:xfrm>
+            <a:off x="8046720" y="1691640"/>
+            <a:ext cx="3566160" cy="4023360"/>
+          </a:xfrm>
+          <a:prstGeom prst="rect">
+            <a:avLst/>
+          </a:prstGeom>
+          <a:noFill/>
+        </p:spPr>
+        <p:txBody>
+          <a:bodyPr wrap="square" lIns="73152" rIns="73152" tIns="36576" bIns="0">
+            <a:spAutoFit/>
+          </a:bodyPr>
+          <a:lstStyle/>
+          <a:p>
+            <a:pPr>
+              <a:spcAft>
+                <a:spcPts val="2000"/>
+              </a:spcAft>
+              <a:defRPr sz="1800">
+                <a:solidFill>
+                  <a:srgbClr val="1E3144"/>
+                </a:solidFill>
+                <a:latin typeface="Aptos"/>
+              </a:defRPr>
+            </a:pPr>
+            <a:r>
+              <a:t>•  1U/3U CAD and bounded motion checks</a:t>
+            </a:r>
+          </a:p>
+          <a:p>
+            <a:pPr>
+              <a:spcAft>
+                <a:spcPts val="2000"/>
+              </a:spcAft>
+              <a:defRPr sz="1800">
+                <a:solidFill>
+                  <a:srgbClr val="1E3144"/>
+                </a:solidFill>
+                <a:latin typeface="Aptos"/>
+              </a:defRPr>
+            </a:pPr>
+            <a:r>
+              <a:t>•  Load, tolerance and fault cases retained</a:t>
+            </a:r>
+          </a:p>
+          <a:p>
+            <a:pPr>
+              <a:spcAft>
+                <a:spcPts val="2000"/>
+              </a:spcAft>
+              <a:defRPr sz="1800">
+                <a:solidFill>
+                  <a:srgbClr val="1E3144"/>
+                </a:solidFill>
+                <a:latin typeface="Aptos"/>
+              </a:defRPr>
+            </a:pPr>
+            <a:r>
+              <a:t>•  Arrest-tooth sizing fails adverse cases</a:t>
+            </a:r>
+          </a:p>
+          <a:p>
+            <a:pPr>
+              <a:spcAft>
+                <a:spcPts val="2000"/>
+              </a:spcAft>
+              <a:defRPr sz="1800">
+                <a:solidFill>
+                  <a:srgbClr val="1E3144"/>
+                </a:solidFill>
+                <a:latin typeface="Aptos"/>
+              </a:defRPr>
+            </a:pPr>
+            <a:r>
+              <a:t>•  Handoff, latch engagement and installed parts unverified</a:t>
+            </a:r>
+          </a:p>
+          <a:p>
+            <a:pPr>
+              <a:spcAft>
+                <a:spcPts val="2000"/>
+              </a:spcAft>
+              <a:defRPr sz="1800">
+                <a:solidFill>
+                  <a:srgbClr val="1E3144"/>
+                </a:solidFill>
+                <a:latin typeface="Aptos"/>
+              </a:defRPr>
+            </a:pPr>
+            <a:r>
+              <a:t>•  No baseline selection or hardware release</a:t>
+            </a:r>
+          </a:p>
+        </p:txBody>
+      </p:sp>
+      <p:sp>
+        <p:nvSpPr>
+          <p:cNvPr id="11" name="TextBox 10"/>
+          <p:cNvSpPr txBox="1"/>
+          <p:nvPr/>
+        </p:nvSpPr>
+        <p:spPr>
+          <a:xfrm>
+            <a:off x="685800" y="6080760"/>
+            <a:ext cx="10789920" cy="274320"/>
+          </a:xfrm>
+          <a:prstGeom prst="rect">
+            <a:avLst/>
+          </a:prstGeom>
+          <a:noFill/>
+        </p:spPr>
+        <p:txBody>
+          <a:bodyPr wrap="square" lIns="13716" rIns="13716" tIns="13716" bIns="13716" anchor="t">
+            <a:spAutoFit/>
+          </a:bodyPr>
+          <a:lstStyle/>
+          <a:p>
+            <a:pPr algn="l">
+              <a:defRPr sz="1400" b="0">
+                <a:solidFill>
+                  <a:srgbClr val="1E3144"/>
+                </a:solidFill>
+                <a:latin typeface="Aptos"/>
+              </a:defRPr>
+            </a:pPr>
+            <a:r>
+              <a:t>STEP-derived orthographic view; no measured reliability or full-cycle qualification.</a:t>
+            </a:r>
+          </a:p>
+        </p:txBody>
+      </p:sp>
+    </p:spTree>
+  </p:cSld>
+  <p:clrMapOvr>
+    <a:masterClrMapping/>
+  </p:clrMapOvr>
+</p:sld>
+</file>
+
+<file path=ppt/slides/slide34.xml><?xml version="1.0" encoding="utf-8"?>
+<p:sld xmlns:a="http://schemas.openxmlformats.org/drawingml/2006/main" xmlns:p="http://schemas.openxmlformats.org/presentationml/2006/main" xmlns:r="http://schemas.openxmlformats.org/officeDocument/2006/relationships">
+  <p:cSld>
+    <p:spTree>
+      <p:nvGrpSpPr>
+        <p:cNvPr id="1" name=""/>
+        <p:cNvGrpSpPr/>
+        <p:nvPr/>
+      </p:nvGrpSpPr>
+      <p:grpSpPr/>
+      <p:sp>
+        <p:nvSpPr>
+          <p:cNvPr id="2" name="Rectangle 1"/>
+          <p:cNvSpPr/>
+          <p:nvPr/>
+        </p:nvSpPr>
+        <p:spPr>
+          <a:xfrm>
+            <a:off x="0" y="0"/>
+            <a:ext cx="12191695" cy="6858000"/>
+          </a:xfrm>
+          <a:prstGeom prst="rect">
+            <a:avLst/>
+          </a:prstGeom>
+          <a:solidFill>
+            <a:srgbClr val="FFFFFF"/>
+          </a:solidFill>
+          <a:ln>
+            <a:noFill/>
+          </a:ln>
+        </p:spPr>
+        <p:style>
+          <a:lnRef idx="1">
+            <a:schemeClr val="accent1"/>
+          </a:lnRef>
+          <a:fillRef idx="3">
+            <a:schemeClr val="accent1"/>
+          </a:fillRef>
+          <a:effectRef idx="2">
+            <a:schemeClr val="accent1"/>
+          </a:effectRef>
+          <a:fontRef idx="minor">
+            <a:schemeClr val="lt1"/>
+          </a:fontRef>
+        </p:style>
+        <p:txBody>
+          <a:bodyPr rtlCol="0" anchor="ctr"/>
+          <a:lstStyle/>
+          <a:p>
+            <a:pPr algn="ctr"/>
+          </a:p>
+        </p:txBody>
+      </p:sp>
+      <p:sp>
+        <p:nvSpPr>
+          <p:cNvPr id="3" name="Rectangle 2"/>
+          <p:cNvSpPr/>
+          <p:nvPr/>
+        </p:nvSpPr>
+        <p:spPr>
+          <a:xfrm>
+            <a:off x="0" y="0"/>
+            <a:ext cx="12191695" cy="713232"/>
+          </a:xfrm>
+          <a:prstGeom prst="rect">
+            <a:avLst/>
+          </a:prstGeom>
+          <a:solidFill>
+            <a:srgbClr val="4EACC2"/>
+          </a:solidFill>
+          <a:ln>
+            <a:solidFill>
+              <a:srgbClr val="0D2035"/>
+            </a:solidFill>
+          </a:ln>
+        </p:spPr>
+        <p:style>
+          <a:lnRef idx="1">
+            <a:schemeClr val="accent1"/>
+          </a:lnRef>
+          <a:fillRef idx="3">
+            <a:schemeClr val="accent1"/>
+          </a:fillRef>
+          <a:effectRef idx="2">
+            <a:schemeClr val="accent1"/>
+          </a:effectRef>
+          <a:fontRef idx="minor">
+            <a:schemeClr val="lt1"/>
+          </a:fontRef>
+        </p:style>
+        <p:txBody>
+          <a:bodyPr rtlCol="0" anchor="ctr"/>
+          <a:lstStyle/>
+          <a:p>
+            <a:pPr algn="ctr"/>
+          </a:p>
+        </p:txBody>
+      </p:sp>
+      <p:sp>
+        <p:nvSpPr>
+          <p:cNvPr id="4" name="TextBox 3"/>
+          <p:cNvSpPr txBox="1"/>
+          <p:nvPr/>
+        </p:nvSpPr>
+        <p:spPr>
+          <a:xfrm>
+            <a:off x="402336" y="146304"/>
+            <a:ext cx="11384280" cy="475488"/>
+          </a:xfrm>
+          <a:prstGeom prst="rect">
+            <a:avLst/>
+          </a:prstGeom>
+          <a:noFill/>
+        </p:spPr>
+        <p:txBody>
+          <a:bodyPr wrap="square" lIns="13716" rIns="13716" tIns="13716" bIns="13716" anchor="t">
+            <a:spAutoFit/>
+          </a:bodyPr>
+          <a:lstStyle/>
+          <a:p>
+            <a:pPr algn="l">
+              <a:defRPr sz="2500" b="1">
+                <a:solidFill>
+                  <a:srgbClr val="0D2035"/>
+                </a:solidFill>
+                <a:latin typeface="Aptos"/>
+              </a:defRPr>
+            </a:pPr>
+            <a:r>
+              <a:t>Native mesh and result view: keep the fixture explicit</a:t>
+            </a:r>
+          </a:p>
+        </p:txBody>
+      </p:sp>
+      <p:sp>
+        <p:nvSpPr>
+          <p:cNvPr id="5" name="TextBox 4"/>
+          <p:cNvSpPr txBox="1"/>
+          <p:nvPr/>
+        </p:nvSpPr>
+        <p:spPr>
+          <a:xfrm>
+            <a:off x="457200" y="905256"/>
+            <a:ext cx="10789920" cy="256032"/>
+          </a:xfrm>
+          <a:prstGeom prst="rect">
+            <a:avLst/>
+          </a:prstGeom>
+          <a:noFill/>
+        </p:spPr>
+        <p:txBody>
+          <a:bodyPr wrap="square" lIns="13716" rIns="13716" tIns="13716" bIns="13716" anchor="t">
+            <a:spAutoFit/>
+          </a:bodyPr>
+          <a:lstStyle/>
+          <a:p>
+            <a:pPr algn="l">
+              <a:defRPr sz="1000" b="1">
+                <a:solidFill>
+                  <a:srgbClr val="0096A0"/>
+                </a:solidFill>
+                <a:latin typeface="Aptos"/>
+              </a:defRPr>
+            </a:pPr>
+            <a:r>
+              <a:t>EVIDENCE APPENDIX</a:t>
+            </a:r>
+          </a:p>
+        </p:txBody>
+      </p:sp>
+      <p:sp>
+        <p:nvSpPr>
+          <p:cNvPr id="6" name="TextBox 5"/>
+          <p:cNvSpPr txBox="1"/>
+          <p:nvPr/>
+        </p:nvSpPr>
+        <p:spPr>
+          <a:xfrm>
+            <a:off x="402336" y="6537960"/>
+            <a:ext cx="2560320" cy="201168"/>
+          </a:xfrm>
+          <a:prstGeom prst="rect">
+            <a:avLst/>
+          </a:prstGeom>
+          <a:noFill/>
+        </p:spPr>
+        <p:txBody>
+          <a:bodyPr wrap="square" lIns="13716" rIns="13716" tIns="13716" bIns="13716" anchor="t">
+            <a:spAutoFit/>
+          </a:bodyPr>
+          <a:lstStyle/>
+          <a:p>
+            <a:pPr algn="l">
+              <a:defRPr sz="850" b="1">
+                <a:solidFill>
+                  <a:srgbClr val="637684"/>
+                </a:solidFill>
+                <a:latin typeface="Aptos"/>
+              </a:defRPr>
+            </a:pPr>
+            <a:r>
+              <a:t>ASSUMED CLAMPED FLOOR</a:t>
+            </a:r>
+          </a:p>
+        </p:txBody>
+      </p:sp>
+      <p:sp>
+        <p:nvSpPr>
+          <p:cNvPr id="7" name="TextBox 6"/>
+          <p:cNvSpPr txBox="1"/>
+          <p:nvPr/>
+        </p:nvSpPr>
+        <p:spPr>
+          <a:xfrm>
+            <a:off x="2926080" y="6537960"/>
+            <a:ext cx="8138160" cy="201168"/>
+          </a:xfrm>
+          <a:prstGeom prst="rect">
+            <a:avLst/>
+          </a:prstGeom>
+          <a:noFill/>
+        </p:spPr>
+        <p:txBody>
+          <a:bodyPr wrap="square" lIns="13716" rIns="13716" tIns="13716" bIns="13716" anchor="t">
+            <a:spAutoFit/>
+          </a:bodyPr>
+          <a:lstStyle/>
+          <a:p>
+            <a:pPr algn="l">
+              <a:defRPr sz="850" b="0">
+                <a:solidFill>
+                  <a:srgbClr val="637684"/>
+                </a:solidFill>
+                <a:latin typeface="Aptos"/>
+              </a:defRPr>
+            </a:pPr>
+            <a:r>
+              <a:t>CalculiX2.23 DAT / INP displayed in Gmsh4.14.1 · undeformed geometry</a:t>
+            </a:r>
+          </a:p>
+        </p:txBody>
+      </p:sp>
+      <p:sp>
+        <p:nvSpPr>
+          <p:cNvPr id="8" name="TextBox 7"/>
+          <p:cNvSpPr txBox="1"/>
+          <p:nvPr/>
+        </p:nvSpPr>
+        <p:spPr>
+          <a:xfrm>
+            <a:off x="11567160" y="6537960"/>
+            <a:ext cx="320040" cy="201168"/>
+          </a:xfrm>
+          <a:prstGeom prst="rect">
+            <a:avLst/>
+          </a:prstGeom>
+          <a:noFill/>
+        </p:spPr>
+        <p:txBody>
+          <a:bodyPr wrap="square" lIns="13716" rIns="13716" tIns="13716" bIns="13716" anchor="t">
+            <a:spAutoFit/>
+          </a:bodyPr>
+          <a:lstStyle/>
+          <a:p>
+            <a:pPr algn="r">
+              <a:defRPr sz="900" b="0">
+                <a:solidFill>
+                  <a:srgbClr val="637684"/>
+                </a:solidFill>
+                <a:latin typeface="Aptos"/>
+              </a:defRPr>
+            </a:pPr>
+            <a:r>
+              <a:t>34</a:t>
+            </a:r>
+          </a:p>
+        </p:txBody>
+      </p:sp>
+      <p:pic>
+        <p:nvPicPr>
+          <p:cNvPr id="9" name="Picture 8" descr="Gmsh_CalculiX_floor.png"/>
+          <p:cNvPicPr>
+            <a:picLocks noChangeAspect="1"/>
+          </p:cNvPicPr>
+          <p:nvPr/>
+        </p:nvPicPr>
+        <p:blipFill>
+          <a:blip r:embed="rId2"/>
+          <a:stretch>
+            <a:fillRect/>
+          </a:stretch>
+        </p:blipFill>
+        <p:spPr>
+          <a:xfrm>
+            <a:off x="2982557" y="1508760"/>
+            <a:ext cx="6196404" cy="4389120"/>
+          </a:xfrm>
+          <a:prstGeom prst="rect">
+            <a:avLst/>
+          </a:prstGeom>
+        </p:spPr>
+      </p:pic>
+      <p:sp>
+        <p:nvSpPr>
+          <p:cNvPr id="10" name="TextBox 9"/>
+          <p:cNvSpPr txBox="1"/>
+          <p:nvPr/>
+        </p:nvSpPr>
+        <p:spPr>
+          <a:xfrm>
+            <a:off x="685800" y="6080760"/>
+            <a:ext cx="10789920" cy="274320"/>
+          </a:xfrm>
+          <a:prstGeom prst="rect">
+            <a:avLst/>
+          </a:prstGeom>
+          <a:noFill/>
+        </p:spPr>
+        <p:txBody>
+          <a:bodyPr wrap="square" lIns="13716" rIns="13716" tIns="13716" bIns="13716" anchor="t">
+            <a:spAutoFit/>
+          </a:bodyPr>
+          <a:lstStyle/>
+          <a:p>
+            <a:pPr algn="l">
+              <a:defRPr sz="1400" b="0">
+                <a:solidFill>
+                  <a:srgbClr val="1E3144"/>
+                </a:solidFill>
+                <a:latin typeface="Aptos"/>
+              </a:defRPr>
+            </a:pPr>
+            <a:r>
+              <a:t>Displacement norm in metres. Actual joints absent; peak support stress is not converged or a strength pass.</a:t>
             </a:r>
           </a:p>
         </p:txBody>

</xml_diff>

<commit_message>
Document captive-transfer correction, stop limits and replenishment feasibility
</commit_message>
<xml_diff>
--- a/university/final_review_2026_10_10/VOLLEY_Final_Review_2026-10-10.pptx
+++ b/university/final_review_2026_10_10/VOLLEY_Final_Review_2026-10-10.pptx
@@ -39,6 +39,8 @@
     <p:sldId id="287" r:id="rId38"/>
     <p:sldId id="288" r:id="rId39"/>
     <p:sldId id="289" r:id="rId40"/>
+    <p:sldId id="290" r:id="rId41"/>
+    <p:sldId id="291" r:id="rId42"/>
   </p:sldIdLst>
   <p:sldSz cx="12191695" cy="6858000" type="screen4x3"/>
   <p:notesSz cx="6858000" cy="9144000"/>
@@ -20012,6 +20014,785 @@
             </a:pPr>
             <a:r>
               <a:t>Displacement norm in metres. Actual joints absent; peak support stress is not converged or a strength pass.</a:t>
+            </a:r>
+          </a:p>
+        </p:txBody>
+      </p:sp>
+    </p:spTree>
+  </p:cSld>
+  <p:clrMapOvr>
+    <a:masterClrMapping/>
+  </p:clrMapOvr>
+</p:sld>
+</file>
+
+<file path=ppt/slides/slide35.xml><?xml version="1.0" encoding="utf-8"?>
+<p:sld xmlns:a="http://schemas.openxmlformats.org/drawingml/2006/main" xmlns:p="http://schemas.openxmlformats.org/presentationml/2006/main" xmlns:r="http://schemas.openxmlformats.org/officeDocument/2006/relationships">
+  <p:cSld>
+    <p:spTree>
+      <p:nvGrpSpPr>
+        <p:cNvPr id="1" name=""/>
+        <p:cNvGrpSpPr/>
+        <p:nvPr/>
+      </p:nvGrpSpPr>
+      <p:grpSpPr/>
+      <p:sp>
+        <p:nvSpPr>
+          <p:cNvPr id="2" name="Rectangle 1"/>
+          <p:cNvSpPr/>
+          <p:nvPr/>
+        </p:nvSpPr>
+        <p:spPr>
+          <a:xfrm>
+            <a:off x="0" y="0"/>
+            <a:ext cx="12191695" cy="6858000"/>
+          </a:xfrm>
+          <a:prstGeom prst="rect">
+            <a:avLst/>
+          </a:prstGeom>
+          <a:solidFill>
+            <a:srgbClr val="FFFFFF"/>
+          </a:solidFill>
+          <a:ln>
+            <a:noFill/>
+          </a:ln>
+        </p:spPr>
+        <p:style>
+          <a:lnRef idx="1">
+            <a:schemeClr val="accent1"/>
+          </a:lnRef>
+          <a:fillRef idx="3">
+            <a:schemeClr val="accent1"/>
+          </a:fillRef>
+          <a:effectRef idx="2">
+            <a:schemeClr val="accent1"/>
+          </a:effectRef>
+          <a:fontRef idx="minor">
+            <a:schemeClr val="lt1"/>
+          </a:fontRef>
+        </p:style>
+        <p:txBody>
+          <a:bodyPr rtlCol="0" anchor="ctr"/>
+          <a:lstStyle/>
+          <a:p>
+            <a:pPr algn="ctr"/>
+          </a:p>
+        </p:txBody>
+      </p:sp>
+      <p:sp>
+        <p:nvSpPr>
+          <p:cNvPr id="3" name="Rectangle 2"/>
+          <p:cNvSpPr/>
+          <p:nvPr/>
+        </p:nvSpPr>
+        <p:spPr>
+          <a:xfrm>
+            <a:off x="0" y="0"/>
+            <a:ext cx="12191695" cy="713232"/>
+          </a:xfrm>
+          <a:prstGeom prst="rect">
+            <a:avLst/>
+          </a:prstGeom>
+          <a:solidFill>
+            <a:srgbClr val="4EACC2"/>
+          </a:solidFill>
+          <a:ln>
+            <a:solidFill>
+              <a:srgbClr val="0D2035"/>
+            </a:solidFill>
+          </a:ln>
+        </p:spPr>
+        <p:style>
+          <a:lnRef idx="1">
+            <a:schemeClr val="accent1"/>
+          </a:lnRef>
+          <a:fillRef idx="3">
+            <a:schemeClr val="accent1"/>
+          </a:fillRef>
+          <a:effectRef idx="2">
+            <a:schemeClr val="accent1"/>
+          </a:effectRef>
+          <a:fontRef idx="minor">
+            <a:schemeClr val="lt1"/>
+          </a:fontRef>
+        </p:style>
+        <p:txBody>
+          <a:bodyPr rtlCol="0" anchor="ctr"/>
+          <a:lstStyle/>
+          <a:p>
+            <a:pPr algn="ctr"/>
+          </a:p>
+        </p:txBody>
+      </p:sp>
+      <p:sp>
+        <p:nvSpPr>
+          <p:cNvPr id="4" name="TextBox 3"/>
+          <p:cNvSpPr txBox="1"/>
+          <p:nvPr/>
+        </p:nvSpPr>
+        <p:spPr>
+          <a:xfrm>
+            <a:off x="402336" y="146304"/>
+            <a:ext cx="11384280" cy="475488"/>
+          </a:xfrm>
+          <a:prstGeom prst="rect">
+            <a:avLst/>
+          </a:prstGeom>
+          <a:noFill/>
+        </p:spPr>
+        <p:txBody>
+          <a:bodyPr wrap="square" lIns="13716" rIns="13716" tIns="13716" bIns="13716" anchor="t">
+            <a:spAutoFit/>
+          </a:bodyPr>
+          <a:lstStyle/>
+          <a:p>
+            <a:pPr algn="l">
+              <a:defRPr sz="2500" b="1">
+                <a:solidFill>
+                  <a:srgbClr val="0D2035"/>
+                </a:solidFill>
+                <a:latin typeface="Aptos"/>
+              </a:defRPr>
+            </a:pPr>
+            <a:r>
+              <a:t>Continuous feed geometry exposes the remaining safety work</a:t>
+            </a:r>
+          </a:p>
+        </p:txBody>
+      </p:sp>
+      <p:sp>
+        <p:nvSpPr>
+          <p:cNvPr id="5" name="TextBox 4"/>
+          <p:cNvSpPr txBox="1"/>
+          <p:nvPr/>
+        </p:nvSpPr>
+        <p:spPr>
+          <a:xfrm>
+            <a:off x="457200" y="905256"/>
+            <a:ext cx="10789920" cy="256032"/>
+          </a:xfrm>
+          <a:prstGeom prst="rect">
+            <a:avLst/>
+          </a:prstGeom>
+          <a:noFill/>
+        </p:spPr>
+        <p:txBody>
+          <a:bodyPr wrap="square" lIns="13716" rIns="13716" tIns="13716" bIns="13716" anchor="t">
+            <a:spAutoFit/>
+          </a:bodyPr>
+          <a:lstStyle/>
+          <a:p>
+            <a:pPr algn="l">
+              <a:defRPr sz="1000" b="1">
+                <a:solidFill>
+                  <a:srgbClr val="0096A0"/>
+                </a:solidFill>
+                <a:latin typeface="Aptos"/>
+              </a:defRPr>
+            </a:pPr>
+            <a:r>
+              <a:t>FUTURE-WORK APPENDIX</a:t>
+            </a:r>
+          </a:p>
+        </p:txBody>
+      </p:sp>
+      <p:sp>
+        <p:nvSpPr>
+          <p:cNvPr id="6" name="TextBox 5"/>
+          <p:cNvSpPr txBox="1"/>
+          <p:nvPr/>
+        </p:nvSpPr>
+        <p:spPr>
+          <a:xfrm>
+            <a:off x="402336" y="6537960"/>
+            <a:ext cx="2560320" cy="201168"/>
+          </a:xfrm>
+          <a:prstGeom prst="rect">
+            <a:avLst/>
+          </a:prstGeom>
+          <a:noFill/>
+        </p:spPr>
+        <p:txBody>
+          <a:bodyPr wrap="square" lIns="13716" rIns="13716" tIns="13716" bIns="13716" anchor="t">
+            <a:spAutoFit/>
+          </a:bodyPr>
+          <a:lstStyle/>
+          <a:p>
+            <a:pPr algn="l">
+              <a:defRPr sz="850" b="1">
+                <a:solidFill>
+                  <a:srgbClr val="637684"/>
+                </a:solidFill>
+                <a:latin typeface="Aptos"/>
+              </a:defRPr>
+            </a:pPr>
+            <a:r>
+              <a:t>PRESCRIBED MOTION ONLY</a:t>
+            </a:r>
+          </a:p>
+        </p:txBody>
+      </p:sp>
+      <p:sp>
+        <p:nvSpPr>
+          <p:cNvPr id="7" name="TextBox 6"/>
+          <p:cNvSpPr txBox="1"/>
+          <p:nvPr/>
+        </p:nvSpPr>
+        <p:spPr>
+          <a:xfrm>
+            <a:off x="2926080" y="6537960"/>
+            <a:ext cx="8138160" cy="201168"/>
+          </a:xfrm>
+          <a:prstGeom prst="rect">
+            <a:avLst/>
+          </a:prstGeom>
+          <a:noFill/>
+        </p:spPr>
+        <p:txBody>
+          <a:bodyPr wrap="square" lIns="13716" rIns="13716" tIns="13716" bIns="13716" anchor="t">
+            <a:spAutoFit/>
+          </a:bodyPr>
+          <a:lstStyle/>
+          <a:p>
+            <a:pPr algn="l">
+              <a:defRPr sz="850" b="0">
+                <a:solidFill>
+                  <a:srgbClr val="637684"/>
+                </a:solidFill>
+                <a:latin typeface="Aptos"/>
+              </a:defRPr>
+            </a:pPr>
+            <a:r>
+              <a:t>CT-01 · separate captive-transfer coupon; 19 October 2026</a:t>
+            </a:r>
+          </a:p>
+        </p:txBody>
+      </p:sp>
+      <p:sp>
+        <p:nvSpPr>
+          <p:cNvPr id="8" name="TextBox 7"/>
+          <p:cNvSpPr txBox="1"/>
+          <p:nvPr/>
+        </p:nvSpPr>
+        <p:spPr>
+          <a:xfrm>
+            <a:off x="11567160" y="6537960"/>
+            <a:ext cx="320040" cy="201168"/>
+          </a:xfrm>
+          <a:prstGeom prst="rect">
+            <a:avLst/>
+          </a:prstGeom>
+          <a:noFill/>
+        </p:spPr>
+        <p:txBody>
+          <a:bodyPr wrap="square" lIns="13716" rIns="13716" tIns="13716" bIns="13716" anchor="t">
+            <a:spAutoFit/>
+          </a:bodyPr>
+          <a:lstStyle/>
+          <a:p>
+            <a:pPr algn="r">
+              <a:defRPr sz="900" b="0">
+                <a:solidFill>
+                  <a:srgbClr val="637684"/>
+                </a:solidFill>
+                <a:latin typeface="Aptos"/>
+              </a:defRPr>
+            </a:pPr>
+            <a:r>
+              <a:t>35</a:t>
+            </a:r>
+          </a:p>
+        </p:txBody>
+      </p:sp>
+      <p:pic>
+        <p:nvPicPr>
+          <p:cNvPr id="9" name="Picture 8" descr="step_sequence.png"/>
+          <p:cNvPicPr>
+            <a:picLocks noChangeAspect="1"/>
+          </p:cNvPicPr>
+          <p:nvPr/>
+        </p:nvPicPr>
+        <p:blipFill>
+          <a:blip r:embed="rId2"/>
+          <a:stretch>
+            <a:fillRect/>
+          </a:stretch>
+        </p:blipFill>
+        <p:spPr>
+          <a:xfrm>
+            <a:off x="1659688" y="1508760"/>
+            <a:ext cx="4910222" cy="4389120"/>
+          </a:xfrm>
+          <a:prstGeom prst="rect">
+            <a:avLst/>
+          </a:prstGeom>
+        </p:spPr>
+      </p:pic>
+      <p:sp>
+        <p:nvSpPr>
+          <p:cNvPr id="10" name="TextBox 9"/>
+          <p:cNvSpPr txBox="1"/>
+          <p:nvPr/>
+        </p:nvSpPr>
+        <p:spPr>
+          <a:xfrm>
+            <a:off x="7955279" y="1691640"/>
+            <a:ext cx="3611880" cy="4023360"/>
+          </a:xfrm>
+          <a:prstGeom prst="rect">
+            <a:avLst/>
+          </a:prstGeom>
+          <a:noFill/>
+        </p:spPr>
+        <p:txBody>
+          <a:bodyPr wrap="square" lIns="73152" rIns="73152" tIns="36576" bIns="0">
+            <a:spAutoFit/>
+          </a:bodyPr>
+          <a:lstStyle/>
+          <a:p>
+            <a:pPr>
+              <a:spcAft>
+                <a:spcPts val="2000"/>
+              </a:spcAft>
+              <a:defRPr sz="1800">
+                <a:solidFill>
+                  <a:srgbClr val="1E3144"/>
+                </a:solidFill>
+                <a:latin typeface="Aptos"/>
+              </a:defRPr>
+            </a:pPr>
+            <a:r>
+              <a:t>•  20 continuous 1U/3U phase checks</a:t>
+            </a:r>
+          </a:p>
+          <a:p>
+            <a:pPr>
+              <a:spcAft>
+                <a:spcPts val="2000"/>
+              </a:spcAft>
+              <a:defRPr sz="1800">
+                <a:solidFill>
+                  <a:srgbClr val="1E3144"/>
+                </a:solidFill>
+                <a:latin typeface="Aptos"/>
+              </a:defRPr>
+            </a:pPr>
+            <a:r>
+              <a:t>•  Downward gate needs under-deck volume</a:t>
+            </a:r>
+          </a:p>
+          <a:p>
+            <a:pPr>
+              <a:spcAft>
+                <a:spcPts val="2000"/>
+              </a:spcAft>
+              <a:defRPr sz="1800">
+                <a:solidFill>
+                  <a:srgbClr val="1E3144"/>
+                </a:solidFill>
+                <a:latin typeface="Aptos"/>
+              </a:defRPr>
+            </a:pPr>
+            <a:r>
+              <a:t>•  Stop travel and adverse fit cases fail</a:t>
+            </a:r>
+          </a:p>
+          <a:p>
+            <a:pPr>
+              <a:spcAft>
+                <a:spcPts val="2000"/>
+              </a:spcAft>
+              <a:defRPr sz="1800">
+                <a:solidFill>
+                  <a:srgbClr val="1E3144"/>
+                </a:solidFill>
+                <a:latin typeface="Aptos"/>
+              </a:defRPr>
+            </a:pPr>
+            <a:r>
+              <a:t>•  Real latch/custody and drive remain open</a:t>
+            </a:r>
+          </a:p>
+        </p:txBody>
+      </p:sp>
+      <p:sp>
+        <p:nvSpPr>
+          <p:cNvPr id="11" name="TextBox 10"/>
+          <p:cNvSpPr txBox="1"/>
+          <p:nvPr/>
+        </p:nvSpPr>
+        <p:spPr>
+          <a:xfrm>
+            <a:off x="685800" y="6080760"/>
+            <a:ext cx="10789920" cy="274320"/>
+          </a:xfrm>
+          <a:prstGeom prst="rect">
+            <a:avLst/>
+          </a:prstGeom>
+          <a:noFill/>
+        </p:spPr>
+        <p:txBody>
+          <a:bodyPr wrap="square" lIns="13716" rIns="13716" tIns="13716" bIns="13716" anchor="t">
+            <a:spAutoFit/>
+          </a:bodyPr>
+          <a:lstStyle/>
+          <a:p>
+            <a:pPr algn="l">
+              <a:defRPr sz="1400" b="0">
+                <a:solidFill>
+                  <a:srgbClr val="1E3144"/>
+                </a:solidFill>
+                <a:latin typeface="Aptos"/>
+              </a:defRPr>
+            </a:pPr>
+            <a:r>
+              <a:t>Native CAD and nominal translation proof do not establish full mechanism safety or a selected feeder.</a:t>
+            </a:r>
+          </a:p>
+        </p:txBody>
+      </p:sp>
+    </p:spTree>
+  </p:cSld>
+  <p:clrMapOvr>
+    <a:masterClrMapping/>
+  </p:clrMapOvr>
+</p:sld>
+</file>
+
+<file path=ppt/slides/slide36.xml><?xml version="1.0" encoding="utf-8"?>
+<p:sld xmlns:a="http://schemas.openxmlformats.org/drawingml/2006/main" xmlns:p="http://schemas.openxmlformats.org/presentationml/2006/main" xmlns:r="http://schemas.openxmlformats.org/officeDocument/2006/relationships">
+  <p:cSld>
+    <p:spTree>
+      <p:nvGrpSpPr>
+        <p:cNvPr id="1" name=""/>
+        <p:cNvGrpSpPr/>
+        <p:nvPr/>
+      </p:nvGrpSpPr>
+      <p:grpSpPr/>
+      <p:sp>
+        <p:nvSpPr>
+          <p:cNvPr id="2" name="Rectangle 1"/>
+          <p:cNvSpPr/>
+          <p:nvPr/>
+        </p:nvSpPr>
+        <p:spPr>
+          <a:xfrm>
+            <a:off x="0" y="0"/>
+            <a:ext cx="12191695" cy="6858000"/>
+          </a:xfrm>
+          <a:prstGeom prst="rect">
+            <a:avLst/>
+          </a:prstGeom>
+          <a:solidFill>
+            <a:srgbClr val="FFFFFF"/>
+          </a:solidFill>
+          <a:ln>
+            <a:noFill/>
+          </a:ln>
+        </p:spPr>
+        <p:style>
+          <a:lnRef idx="1">
+            <a:schemeClr val="accent1"/>
+          </a:lnRef>
+          <a:fillRef idx="3">
+            <a:schemeClr val="accent1"/>
+          </a:fillRef>
+          <a:effectRef idx="2">
+            <a:schemeClr val="accent1"/>
+          </a:effectRef>
+          <a:fontRef idx="minor">
+            <a:schemeClr val="lt1"/>
+          </a:fontRef>
+        </p:style>
+        <p:txBody>
+          <a:bodyPr rtlCol="0" anchor="ctr"/>
+          <a:lstStyle/>
+          <a:p>
+            <a:pPr algn="ctr"/>
+          </a:p>
+        </p:txBody>
+      </p:sp>
+      <p:sp>
+        <p:nvSpPr>
+          <p:cNvPr id="3" name="Rectangle 2"/>
+          <p:cNvSpPr/>
+          <p:nvPr/>
+        </p:nvSpPr>
+        <p:spPr>
+          <a:xfrm>
+            <a:off x="0" y="0"/>
+            <a:ext cx="12191695" cy="713232"/>
+          </a:xfrm>
+          <a:prstGeom prst="rect">
+            <a:avLst/>
+          </a:prstGeom>
+          <a:solidFill>
+            <a:srgbClr val="4EACC2"/>
+          </a:solidFill>
+          <a:ln>
+            <a:solidFill>
+              <a:srgbClr val="0D2035"/>
+            </a:solidFill>
+          </a:ln>
+        </p:spPr>
+        <p:style>
+          <a:lnRef idx="1">
+            <a:schemeClr val="accent1"/>
+          </a:lnRef>
+          <a:fillRef idx="3">
+            <a:schemeClr val="accent1"/>
+          </a:fillRef>
+          <a:effectRef idx="2">
+            <a:schemeClr val="accent1"/>
+          </a:effectRef>
+          <a:fontRef idx="minor">
+            <a:schemeClr val="lt1"/>
+          </a:fontRef>
+        </p:style>
+        <p:txBody>
+          <a:bodyPr rtlCol="0" anchor="ctr"/>
+          <a:lstStyle/>
+          <a:p>
+            <a:pPr algn="ctr"/>
+          </a:p>
+        </p:txBody>
+      </p:sp>
+      <p:sp>
+        <p:nvSpPr>
+          <p:cNvPr id="4" name="TextBox 3"/>
+          <p:cNvSpPr txBox="1"/>
+          <p:nvPr/>
+        </p:nvSpPr>
+        <p:spPr>
+          <a:xfrm>
+            <a:off x="402336" y="146304"/>
+            <a:ext cx="11384280" cy="475488"/>
+          </a:xfrm>
+          <a:prstGeom prst="rect">
+            <a:avLst/>
+          </a:prstGeom>
+          <a:noFill/>
+        </p:spPr>
+        <p:txBody>
+          <a:bodyPr wrap="square" lIns="13716" rIns="13716" tIns="13716" bIns="13716" anchor="t">
+            <a:spAutoFit/>
+          </a:bodyPr>
+          <a:lstStyle/>
+          <a:p>
+            <a:pPr algn="l">
+              <a:defRPr sz="2500" b="1">
+                <a:solidFill>
+                  <a:srgbClr val="0D2035"/>
+                </a:solidFill>
+                <a:latin typeface="Aptos"/>
+              </a:defRPr>
+            </a:pPr>
+            <a:r>
+              <a:t>Orbital reload: define the interface before promising a service</a:t>
+            </a:r>
+          </a:p>
+        </p:txBody>
+      </p:sp>
+      <p:sp>
+        <p:nvSpPr>
+          <p:cNvPr id="5" name="TextBox 4"/>
+          <p:cNvSpPr txBox="1"/>
+          <p:nvPr/>
+        </p:nvSpPr>
+        <p:spPr>
+          <a:xfrm>
+            <a:off x="457200" y="905256"/>
+            <a:ext cx="10789920" cy="256032"/>
+          </a:xfrm>
+          <a:prstGeom prst="rect">
+            <a:avLst/>
+          </a:prstGeom>
+          <a:noFill/>
+        </p:spPr>
+        <p:txBody>
+          <a:bodyPr wrap="square" lIns="13716" rIns="13716" tIns="13716" bIns="13716" anchor="t">
+            <a:spAutoFit/>
+          </a:bodyPr>
+          <a:lstStyle/>
+          <a:p>
+            <a:pPr algn="l">
+              <a:defRPr sz="1000" b="1">
+                <a:solidFill>
+                  <a:srgbClr val="0096A0"/>
+                </a:solidFill>
+                <a:latin typeface="Aptos"/>
+              </a:defRPr>
+            </a:pPr>
+            <a:r>
+              <a:t>FUTURE-WORK APPENDIX</a:t>
+            </a:r>
+          </a:p>
+        </p:txBody>
+      </p:sp>
+      <p:sp>
+        <p:nvSpPr>
+          <p:cNvPr id="6" name="TextBox 5"/>
+          <p:cNvSpPr txBox="1"/>
+          <p:nvPr/>
+        </p:nvSpPr>
+        <p:spPr>
+          <a:xfrm>
+            <a:off x="402336" y="6537960"/>
+            <a:ext cx="2560320" cy="201168"/>
+          </a:xfrm>
+          <a:prstGeom prst="rect">
+            <a:avLst/>
+          </a:prstGeom>
+          <a:noFill/>
+        </p:spPr>
+        <p:txBody>
+          <a:bodyPr wrap="square" lIns="13716" rIns="13716" tIns="13716" bIns="13716" anchor="t">
+            <a:spAutoFit/>
+          </a:bodyPr>
+          <a:lstStyle/>
+          <a:p>
+            <a:pPr algn="l">
+              <a:defRPr sz="850" b="1">
+                <a:solidFill>
+                  <a:srgbClr val="637684"/>
+                </a:solidFill>
+                <a:latin typeface="Aptos"/>
+              </a:defRPr>
+            </a:pPr>
+            <a:r>
+              <a:t>BASELINE OPERATIONAL NO-GO</a:t>
+            </a:r>
+          </a:p>
+        </p:txBody>
+      </p:sp>
+      <p:sp>
+        <p:nvSpPr>
+          <p:cNvPr id="7" name="TextBox 6"/>
+          <p:cNvSpPr txBox="1"/>
+          <p:nvPr/>
+        </p:nvSpPr>
+        <p:spPr>
+          <a:xfrm>
+            <a:off x="2926080" y="6537960"/>
+            <a:ext cx="8138160" cy="201168"/>
+          </a:xfrm>
+          <a:prstGeom prst="rect">
+            <a:avLst/>
+          </a:prstGeom>
+          <a:noFill/>
+        </p:spPr>
+        <p:txBody>
+          <a:bodyPr wrap="square" lIns="13716" rIns="13716" tIns="13716" bIns="13716" anchor="t">
+            <a:spAutoFit/>
+          </a:bodyPr>
+          <a:lstStyle/>
+          <a:p>
+            <a:pPr algn="l">
+              <a:defRPr sz="850" b="0">
+                <a:solidFill>
+                  <a:srgbClr val="637684"/>
+                </a:solidFill>
+                <a:latin typeface="Aptos"/>
+              </a:defRPr>
+            </a:pPr>
+            <a:r>
+              <a:t>RPL-01 · limited cooperative-cartridge feasibility</a:t>
+            </a:r>
+          </a:p>
+        </p:txBody>
+      </p:sp>
+      <p:sp>
+        <p:nvSpPr>
+          <p:cNvPr id="8" name="TextBox 7"/>
+          <p:cNvSpPr txBox="1"/>
+          <p:nvPr/>
+        </p:nvSpPr>
+        <p:spPr>
+          <a:xfrm>
+            <a:off x="11567160" y="6537960"/>
+            <a:ext cx="320040" cy="201168"/>
+          </a:xfrm>
+          <a:prstGeom prst="rect">
+            <a:avLst/>
+          </a:prstGeom>
+          <a:noFill/>
+        </p:spPr>
+        <p:txBody>
+          <a:bodyPr wrap="square" lIns="13716" rIns="13716" tIns="13716" bIns="13716" anchor="t">
+            <a:spAutoFit/>
+          </a:bodyPr>
+          <a:lstStyle/>
+          <a:p>
+            <a:pPr algn="r">
+              <a:defRPr sz="900" b="0">
+                <a:solidFill>
+                  <a:srgbClr val="637684"/>
+                </a:solidFill>
+                <a:latin typeface="Aptos"/>
+              </a:defRPr>
+            </a:pPr>
+            <a:r>
+              <a:t>36</a:t>
+            </a:r>
+          </a:p>
+        </p:txBody>
+      </p:sp>
+      <p:pic>
+        <p:nvPicPr>
+          <p:cNvPr id="9" name="Picture 8" descr="replenishment.png"/>
+          <p:cNvPicPr>
+            <a:picLocks noChangeAspect="1"/>
+          </p:cNvPicPr>
+          <p:nvPr/>
+        </p:nvPicPr>
+        <p:blipFill>
+          <a:blip r:embed="rId2"/>
+          <a:stretch>
+            <a:fillRect/>
+          </a:stretch>
+        </p:blipFill>
+        <p:spPr>
+          <a:xfrm>
+            <a:off x="625710" y="1508760"/>
+            <a:ext cx="10910098" cy="4389120"/>
+          </a:xfrm>
+          <a:prstGeom prst="rect">
+            <a:avLst/>
+          </a:prstGeom>
+        </p:spPr>
+      </p:pic>
+      <p:sp>
+        <p:nvSpPr>
+          <p:cNvPr id="10" name="TextBox 9"/>
+          <p:cNvSpPr txBox="1"/>
+          <p:nvPr/>
+        </p:nvSpPr>
+        <p:spPr>
+          <a:xfrm>
+            <a:off x="685800" y="6080760"/>
+            <a:ext cx="10789920" cy="274320"/>
+          </a:xfrm>
+          <a:prstGeom prst="rect">
+            <a:avLst/>
+          </a:prstGeom>
+          <a:noFill/>
+        </p:spPr>
+        <p:txBody>
+          <a:bodyPr wrap="square" lIns="13716" rIns="13716" tIns="13716" bIns="13716" anchor="t">
+            <a:spAutoFit/>
+          </a:bodyPr>
+          <a:lstStyle/>
+          <a:p>
+            <a:pPr algn="l">
+              <a:defRPr sz="1400" b="0">
+                <a:solidFill>
+                  <a:srgbClr val="1E3144"/>
+                </a:solidFill>
+                <a:latin typeface="Aptos"/>
+              </a:defRPr>
+            </a:pPr>
+            <a:r>
+              <a:t>108 capture / 36 fit sensitivities. No integrated reload mechanism; ground loading remains the assumption.</a:t>
             </a:r>
           </a:p>
         </p:txBody>

</xml_diff>

<commit_message>
Verify complete native campaigns and derive precision requirements
</commit_message>
<xml_diff>
--- a/university/final_review_2026_10_10/VOLLEY_Final_Review_2026-10-10.pptx
+++ b/university/final_review_2026_10_10/VOLLEY_Final_Review_2026-10-10.pptx
@@ -19014,7 +19014,7 @@
               </a:defRPr>
             </a:pPr>
             <a:r>
-              <a:t>Host assistance closes mathematical targets, with a cost</a:t>
+              <a:t>Precise delivery needs a measured control budget</a:t>
             </a:r>
           </a:p>
         </p:txBody>
@@ -19122,7 +19122,7 @@
               </a:defRPr>
             </a:pPr>
             <a:r>
-              <a:t>Constructed four/twelve-payload J2 campaign · ideal impulses and mass proxies</a:t>
+              <a:t>CNR-01 · complete native event replay and deterministic sensitivity</a:t>
             </a:r>
           </a:p>
         </p:txBody>
@@ -19165,7 +19165,7 @@
       </p:sp>
       <p:pic>
         <p:nvPicPr>
-          <p:cNvPr id="9" name="Picture 8" descr="resource_comparison.png"/>
+          <p:cNvPr id="9" name="Picture 8" descr="control_sensitivity.png"/>
           <p:cNvPicPr>
             <a:picLocks noChangeAspect="1"/>
           </p:cNvPicPr>
@@ -19179,8 +19179,8 @@
         </p:blipFill>
         <p:spPr>
           <a:xfrm>
-            <a:off x="1517349" y="1508760"/>
-            <a:ext cx="9126820" cy="4389119"/>
+            <a:off x="2652915" y="1508760"/>
+            <a:ext cx="6855689" cy="4389120"/>
           </a:xfrm>
           <a:prstGeom prst="rect">
             <a:avLst/>
@@ -19218,7 +19218,7 @@
               </a:defRPr>
             </a:pPr>
             <a:r>
-              <a:t>Larger-reserve spring case completes. Fuel savings do not recover the assumed device-mass penalty.</a:t>
+              <a:t>+0.1% imposed release-speed bias gives ~1.53 km error. Numerical agreement is not flight precision.</a:t>
             </a:r>
           </a:p>
         </p:txBody>

</xml_diff>

<commit_message>
Integrate finite-force results into academic reports and public evidence
</commit_message>
<xml_diff>
--- a/university/final_review_2026_10_10/VOLLEY_Final_Review_2026-10-10.pptx
+++ b/university/final_review_2026_10_10/VOLLEY_Final_Review_2026-10-10.pptx
@@ -41,6 +41,7 @@
     <p:sldId id="289" r:id="rId40"/>
     <p:sldId id="290" r:id="rId41"/>
     <p:sldId id="291" r:id="rId42"/>
+    <p:sldId id="292" r:id="rId43"/>
   </p:sldIdLst>
   <p:sldSz cx="12191695" cy="6858000" type="screen4x3"/>
   <p:notesSz cx="6858000" cy="9144000"/>
@@ -3545,7 +3546,7 @@
               </a:defRPr>
             </a:pPr>
             <a:r>
-              <a:t>Review candidate: 19 October 2026</a:t>
+              <a:t>Review candidate: 20 October 2026</a:t>
             </a:r>
           </a:p>
         </p:txBody>
@@ -16049,7 +16050,7 @@
               </a:defRPr>
             </a:pPr>
             <a:r>
-              <a:t>•  [2] Cal Poly, CubeSat Design Specification, Rev. 14, 2020.</a:t>
+              <a:t>•  [2] Cal Poly, CubeSat Design Specification, Rev. 14.1, 2022.</a:t>
             </a:r>
           </a:p>
           <a:p>
@@ -16486,7 +16487,7 @@
               </a:defRPr>
             </a:pPr>
             <a:r>
-              <a:t>•  [10] A. Mishra, VOLLEY-thesis: manuscript, baseline, provenance and validation records, repo head b30ffdc, 28 Sep 2026.</a:t>
+              <a:t>•  [10] A. Mishra, VOLLEY-thesis: manuscript, baseline, provenance and validation records, evidence snapshot 5b92edc, 20 Oct 2026.</a:t>
             </a:r>
           </a:p>
           <a:p>
@@ -17132,7 +17133,7 @@
               </a:defRPr>
             </a:pPr>
             <a:r>
-              <a:t>22 Gen5/R1 intersections classified; 126.562 kg model; no sampled twelve-shot mission closes.</a:t>
+              <a:t>22 Gen5/R1 intersections; 126.562 kg model; archived mission screens fail. New Gen6 targeting is separately bounded.</a:t>
             </a:r>
           </a:p>
         </p:txBody>
@@ -20793,6 +20794,455 @@
             </a:pPr>
             <a:r>
               <a:t>108 capture / 36 fit sensitivities. No integrated reload mechanism; ground loading remains the assumption.</a:t>
+            </a:r>
+          </a:p>
+        </p:txBody>
+      </p:sp>
+    </p:spTree>
+  </p:cSld>
+  <p:clrMapOvr>
+    <a:masterClrMapping/>
+  </p:clrMapOvr>
+</p:sld>
+</file>
+
+<file path=ppt/slides/slide37.xml><?xml version="1.0" encoding="utf-8"?>
+<p:sld xmlns:a="http://schemas.openxmlformats.org/drawingml/2006/main" xmlns:p="http://schemas.openxmlformats.org/presentationml/2006/main" xmlns:r="http://schemas.openxmlformats.org/officeDocument/2006/relationships">
+  <p:cSld>
+    <p:spTree>
+      <p:nvGrpSpPr>
+        <p:cNvPr id="1" name=""/>
+        <p:cNvGrpSpPr/>
+        <p:nvPr/>
+      </p:nvGrpSpPr>
+      <p:grpSpPr/>
+      <p:sp>
+        <p:nvSpPr>
+          <p:cNvPr id="2" name="Rectangle 1"/>
+          <p:cNvSpPr/>
+          <p:nvPr/>
+        </p:nvSpPr>
+        <p:spPr>
+          <a:xfrm>
+            <a:off x="0" y="0"/>
+            <a:ext cx="12191695" cy="6858000"/>
+          </a:xfrm>
+          <a:prstGeom prst="rect">
+            <a:avLst/>
+          </a:prstGeom>
+          <a:solidFill>
+            <a:srgbClr val="FFFFFF"/>
+          </a:solidFill>
+          <a:ln>
+            <a:noFill/>
+          </a:ln>
+        </p:spPr>
+        <p:style>
+          <a:lnRef idx="1">
+            <a:schemeClr val="accent1"/>
+          </a:lnRef>
+          <a:fillRef idx="3">
+            <a:schemeClr val="accent1"/>
+          </a:fillRef>
+          <a:effectRef idx="2">
+            <a:schemeClr val="accent1"/>
+          </a:effectRef>
+          <a:fontRef idx="minor">
+            <a:schemeClr val="lt1"/>
+          </a:fontRef>
+        </p:style>
+        <p:txBody>
+          <a:bodyPr rtlCol="0" anchor="ctr"/>
+          <a:lstStyle/>
+          <a:p>
+            <a:pPr algn="ctr"/>
+          </a:p>
+        </p:txBody>
+      </p:sp>
+      <p:sp>
+        <p:nvSpPr>
+          <p:cNvPr id="3" name="Rectangle 2"/>
+          <p:cNvSpPr/>
+          <p:nvPr/>
+        </p:nvSpPr>
+        <p:spPr>
+          <a:xfrm>
+            <a:off x="0" y="0"/>
+            <a:ext cx="12191695" cy="713232"/>
+          </a:xfrm>
+          <a:prstGeom prst="rect">
+            <a:avLst/>
+          </a:prstGeom>
+          <a:solidFill>
+            <a:srgbClr val="4EACC2"/>
+          </a:solidFill>
+          <a:ln>
+            <a:solidFill>
+              <a:srgbClr val="0D2035"/>
+            </a:solidFill>
+          </a:ln>
+        </p:spPr>
+        <p:style>
+          <a:lnRef idx="1">
+            <a:schemeClr val="accent1"/>
+          </a:lnRef>
+          <a:fillRef idx="3">
+            <a:schemeClr val="accent1"/>
+          </a:fillRef>
+          <a:effectRef idx="2">
+            <a:schemeClr val="accent1"/>
+          </a:effectRef>
+          <a:fontRef idx="minor">
+            <a:schemeClr val="lt1"/>
+          </a:fontRef>
+        </p:style>
+        <p:txBody>
+          <a:bodyPr rtlCol="0" anchor="ctr"/>
+          <a:lstStyle/>
+          <a:p>
+            <a:pPr algn="ctr"/>
+          </a:p>
+        </p:txBody>
+      </p:sp>
+      <p:sp>
+        <p:nvSpPr>
+          <p:cNvPr id="4" name="TextBox 3"/>
+          <p:cNvSpPr txBox="1"/>
+          <p:nvPr/>
+        </p:nvSpPr>
+        <p:spPr>
+          <a:xfrm>
+            <a:off x="402336" y="146304"/>
+            <a:ext cx="11384280" cy="475488"/>
+          </a:xfrm>
+          <a:prstGeom prst="rect">
+            <a:avLst/>
+          </a:prstGeom>
+          <a:noFill/>
+        </p:spPr>
+        <p:txBody>
+          <a:bodyPr wrap="square" lIns="13716" rIns="13716" tIns="13716" bIns="13716" anchor="t">
+            <a:spAutoFit/>
+          </a:bodyPr>
+          <a:lstStyle/>
+          <a:p>
+            <a:pPr algn="l">
+              <a:defRPr sz="2500" b="1">
+                <a:solidFill>
+                  <a:srgbClr val="0D2035"/>
+                </a:solidFill>
+                <a:latin typeface="Aptos"/>
+              </a:defRPr>
+            </a:pPr>
+            <a:r>
+              <a:t>Finite-duration thrust changes the resource comparison</a:t>
+            </a:r>
+          </a:p>
+        </p:txBody>
+      </p:sp>
+      <p:sp>
+        <p:nvSpPr>
+          <p:cNvPr id="5" name="TextBox 4"/>
+          <p:cNvSpPr txBox="1"/>
+          <p:nvPr/>
+        </p:nvSpPr>
+        <p:spPr>
+          <a:xfrm>
+            <a:off x="457200" y="905256"/>
+            <a:ext cx="10789920" cy="256032"/>
+          </a:xfrm>
+          <a:prstGeom prst="rect">
+            <a:avLst/>
+          </a:prstGeom>
+          <a:noFill/>
+        </p:spPr>
+        <p:txBody>
+          <a:bodyPr wrap="square" lIns="13716" rIns="13716" tIns="13716" bIns="13716" anchor="t">
+            <a:spAutoFit/>
+          </a:bodyPr>
+          <a:lstStyle/>
+          <a:p>
+            <a:pPr algn="l">
+              <a:defRPr sz="1000" b="1">
+                <a:solidFill>
+                  <a:srgbClr val="0096A0"/>
+                </a:solidFill>
+                <a:latin typeface="Aptos"/>
+              </a:defRPr>
+            </a:pPr>
+            <a:r>
+              <a:t>FUTURE-WORK APPENDIX</a:t>
+            </a:r>
+          </a:p>
+        </p:txBody>
+      </p:sp>
+      <p:sp>
+        <p:nvSpPr>
+          <p:cNvPr id="6" name="TextBox 5"/>
+          <p:cNvSpPr txBox="1"/>
+          <p:nvPr/>
+        </p:nvSpPr>
+        <p:spPr>
+          <a:xfrm>
+            <a:off x="402336" y="6537960"/>
+            <a:ext cx="2560320" cy="201168"/>
+          </a:xfrm>
+          <a:prstGeom prst="rect">
+            <a:avLst/>
+          </a:prstGeom>
+          <a:noFill/>
+        </p:spPr>
+        <p:txBody>
+          <a:bodyPr wrap="square" lIns="13716" rIns="13716" tIns="13716" bIns="13716" anchor="t">
+            <a:spAutoFit/>
+          </a:bodyPr>
+          <a:lstStyle/>
+          <a:p>
+            <a:pPr algn="l">
+              <a:defRPr sz="850" b="1">
+                <a:solidFill>
+                  <a:srgbClr val="637684"/>
+                </a:solidFill>
+                <a:latin typeface="Aptos"/>
+              </a:defRPr>
+            </a:pPr>
+            <a:r>
+              <a:t>GEN6 SURROGATE CONTROL</a:t>
+            </a:r>
+          </a:p>
+        </p:txBody>
+      </p:sp>
+      <p:sp>
+        <p:nvSpPr>
+          <p:cNvPr id="7" name="TextBox 6"/>
+          <p:cNvSpPr txBox="1"/>
+          <p:nvPr/>
+        </p:nvSpPr>
+        <p:spPr>
+          <a:xfrm>
+            <a:off x="2926080" y="6537960"/>
+            <a:ext cx="8138160" cy="201168"/>
+          </a:xfrm>
+          <a:prstGeom prst="rect">
+            <a:avLst/>
+          </a:prstGeom>
+          <a:noFill/>
+        </p:spPr>
+        <p:txBody>
+          <a:bodyPr wrap="square" lIns="13716" rIns="13716" tIns="13716" bIns="13716" anchor="t">
+            <a:spAutoFit/>
+          </a:bodyPr>
+          <a:lstStyle/>
+          <a:p>
+            <a:pPr algn="l">
+              <a:defRPr sz="850" b="0">
+                <a:solidFill>
+                  <a:srgbClr val="637684"/>
+                </a:solidFill>
+                <a:latin typeface="Aptos"/>
+              </a:defRPr>
+            </a:pPr>
+            <a:r>
+              <a:t>FBR-01 · 18 targeted schedules / 46 native Orekit runs</a:t>
+            </a:r>
+          </a:p>
+        </p:txBody>
+      </p:sp>
+      <p:sp>
+        <p:nvSpPr>
+          <p:cNvPr id="8" name="TextBox 7"/>
+          <p:cNvSpPr txBox="1"/>
+          <p:nvPr/>
+        </p:nvSpPr>
+        <p:spPr>
+          <a:xfrm>
+            <a:off x="11567160" y="6537960"/>
+            <a:ext cx="320040" cy="201168"/>
+          </a:xfrm>
+          <a:prstGeom prst="rect">
+            <a:avLst/>
+          </a:prstGeom>
+          <a:noFill/>
+        </p:spPr>
+        <p:txBody>
+          <a:bodyPr wrap="square" lIns="13716" rIns="13716" tIns="13716" bIns="13716" anchor="t">
+            <a:spAutoFit/>
+          </a:bodyPr>
+          <a:lstStyle/>
+          <a:p>
+            <a:pPr algn="r">
+              <a:defRPr sz="900" b="0">
+                <a:solidFill>
+                  <a:srgbClr val="637684"/>
+                </a:solidFill>
+                <a:latin typeface="Aptos"/>
+              </a:defRPr>
+            </a:pPr>
+            <a:r>
+              <a:t>37</a:t>
+            </a:r>
+          </a:p>
+        </p:txBody>
+      </p:sp>
+      <p:pic>
+        <p:nvPicPr>
+          <p:cNvPr id="9" name="Picture 8" descr="force_fuel_trade.png"/>
+          <p:cNvPicPr>
+            <a:picLocks noChangeAspect="1"/>
+          </p:cNvPicPr>
+          <p:nvPr/>
+        </p:nvPicPr>
+        <p:blipFill>
+          <a:blip r:embed="rId2"/>
+          <a:stretch>
+            <a:fillRect/>
+          </a:stretch>
+        </p:blipFill>
+        <p:spPr>
+          <a:xfrm>
+            <a:off x="867543" y="1389888"/>
+            <a:ext cx="6585953" cy="4709160"/>
+          </a:xfrm>
+          <a:prstGeom prst="rect">
+            <a:avLst/>
+          </a:prstGeom>
+        </p:spPr>
+      </p:pic>
+      <p:sp>
+        <p:nvSpPr>
+          <p:cNvPr id="10" name="TextBox 9"/>
+          <p:cNvSpPr txBox="1"/>
+          <p:nvPr/>
+        </p:nvSpPr>
+        <p:spPr>
+          <a:xfrm>
+            <a:off x="8028431" y="1508760"/>
+            <a:ext cx="3520440" cy="4389120"/>
+          </a:xfrm>
+          <a:prstGeom prst="rect">
+            <a:avLst/>
+          </a:prstGeom>
+          <a:noFill/>
+        </p:spPr>
+        <p:txBody>
+          <a:bodyPr wrap="square" lIns="73152" rIns="73152" tIns="36576" bIns="0">
+            <a:spAutoFit/>
+          </a:bodyPr>
+          <a:lstStyle/>
+          <a:p>
+            <a:pPr>
+              <a:spcAft>
+                <a:spcPts val="1500"/>
+              </a:spcAft>
+              <a:defRPr sz="1700">
+                <a:solidFill>
+                  <a:srgbClr val="1E3144"/>
+                </a:solidFill>
+                <a:latin typeface="Aptos"/>
+              </a:defRPr>
+            </a:pPr>
+            <a:r>
+              <a:t>•  Four releases fit the 20 N / 10 kg screen</a:t>
+            </a:r>
+          </a:p>
+          <a:p>
+            <a:pPr>
+              <a:spcAft>
+                <a:spcPts val="1500"/>
+              </a:spcAft>
+              <a:defRPr sz="1700">
+                <a:solidFill>
+                  <a:srgbClr val="1E3144"/>
+                </a:solidFill>
+                <a:latin typeface="Aptos"/>
+              </a:defRPr>
+            </a:pPr>
+            <a:r>
+              <a:t>•  Twelve spring inputs exceed 20 N / 20 kg</a:t>
+            </a:r>
+          </a:p>
+          <a:p>
+            <a:pPr>
+              <a:spcAft>
+                <a:spcPts val="1500"/>
+              </a:spcAft>
+              <a:defRPr sz="1700">
+                <a:solidFill>
+                  <a:srgbClr val="1E3144"/>
+                </a:solidFill>
+                <a:latin typeface="Aptos"/>
+              </a:defRPr>
+            </a:pPr>
+            <a:r>
+              <a:t>•  Both twelve-case policies close with 30 kg / 100 N</a:t>
+            </a:r>
+          </a:p>
+          <a:p>
+            <a:pPr>
+              <a:spcAft>
+                <a:spcPts val="1500"/>
+              </a:spcAft>
+              <a:defRPr sz="1700">
+                <a:solidFill>
+                  <a:srgbClr val="1E3144"/>
+                </a:solidFill>
+                <a:latin typeface="Aptos"/>
+              </a:defRPr>
+            </a:pPr>
+            <a:r>
+              <a:t>•  Device mass still exceeds saved propellant</a:t>
+            </a:r>
+          </a:p>
+          <a:p>
+            <a:pPr>
+              <a:spcAft>
+                <a:spcPts val="1500"/>
+              </a:spcAft>
+              <a:defRPr sz="1700">
+                <a:solidFill>
+                  <a:srgbClr val="1E3144"/>
+                </a:solidFill>
+                <a:latin typeface="Aptos"/>
+              </a:defRPr>
+            </a:pPr>
+            <a:r>
+              <a:t>•  Nearly 9°/s reversals if one fixed thruster; host allocation unverified</a:t>
+            </a:r>
+          </a:p>
+        </p:txBody>
+      </p:sp>
+      <p:sp>
+        <p:nvSpPr>
+          <p:cNvPr id="11" name="TextBox 10"/>
+          <p:cNvSpPr txBox="1"/>
+          <p:nvPr/>
+        </p:nvSpPr>
+        <p:spPr>
+          <a:xfrm>
+            <a:off x="685800" y="6163056"/>
+            <a:ext cx="10789920" cy="274320"/>
+          </a:xfrm>
+          <a:prstGeom prst="rect">
+            <a:avLst/>
+          </a:prstGeom>
+          <a:noFill/>
+        </p:spPr>
+        <p:txBody>
+          <a:bodyPr wrap="square" lIns="13716" rIns="13716" tIns="13716" bIns="13716" anchor="t">
+            <a:spAutoFit/>
+          </a:bodyPr>
+          <a:lstStyle/>
+          <a:p>
+            <a:pPr algn="l">
+              <a:defRPr sz="1300" b="0">
+                <a:solidFill>
+                  <a:srgbClr val="1E3144"/>
+                </a:solidFill>
+                <a:latin typeface="Aptos"/>
+              </a:defRPr>
+            </a:pPr>
+            <a:r>
+              <a:t>Finite-force translational targets; imposed release speeds. No rated host, motor, flight precision or physical clearance.</a:t>
             </a:r>
           </a:p>
         </p:txBody>

</xml_diff>

<commit_message>
Reconcile feeder evidence with academic reports and public engineering pages
</commit_message>
<xml_diff>
--- a/university/final_review_2026_10_10/VOLLEY_Final_Review_2026-10-10.pptx
+++ b/university/final_review_2026_10_10/VOLLEY_Final_Review_2026-10-10.pptx
@@ -42,6 +42,7 @@
     <p:sldId id="290" r:id="rId41"/>
     <p:sldId id="291" r:id="rId42"/>
     <p:sldId id="292" r:id="rId43"/>
+    <p:sldId id="293" r:id="rId44"/>
   </p:sldIdLst>
   <p:sldSz cx="12191695" cy="6858000" type="screen4x3"/>
   <p:notesSz cx="6858000" cy="9144000"/>
@@ -21243,6 +21244,455 @@
             </a:pPr>
             <a:r>
               <a:t>Finite-force translational targets; imposed release speeds. No rated host, motor, flight precision or physical clearance.</a:t>
+            </a:r>
+          </a:p>
+        </p:txBody>
+      </p:sp>
+    </p:spTree>
+  </p:cSld>
+  <p:clrMapOvr>
+    <a:masterClrMapping/>
+  </p:clrMapOvr>
+</p:sld>
+</file>
+
+<file path=ppt/slides/slide38.xml><?xml version="1.0" encoding="utf-8"?>
+<p:sld xmlns:a="http://schemas.openxmlformats.org/drawingml/2006/main" xmlns:p="http://schemas.openxmlformats.org/presentationml/2006/main" xmlns:r="http://schemas.openxmlformats.org/officeDocument/2006/relationships">
+  <p:cSld>
+    <p:spTree>
+      <p:nvGrpSpPr>
+        <p:cNvPr id="1" name=""/>
+        <p:cNvGrpSpPr/>
+        <p:nvPr/>
+      </p:nvGrpSpPr>
+      <p:grpSpPr/>
+      <p:sp>
+        <p:nvSpPr>
+          <p:cNvPr id="2" name="Rectangle 1"/>
+          <p:cNvSpPr/>
+          <p:nvPr/>
+        </p:nvSpPr>
+        <p:spPr>
+          <a:xfrm>
+            <a:off x="0" y="0"/>
+            <a:ext cx="12191695" cy="6858000"/>
+          </a:xfrm>
+          <a:prstGeom prst="rect">
+            <a:avLst/>
+          </a:prstGeom>
+          <a:solidFill>
+            <a:srgbClr val="FFFFFF"/>
+          </a:solidFill>
+          <a:ln>
+            <a:noFill/>
+          </a:ln>
+        </p:spPr>
+        <p:style>
+          <a:lnRef idx="1">
+            <a:schemeClr val="accent1"/>
+          </a:lnRef>
+          <a:fillRef idx="3">
+            <a:schemeClr val="accent1"/>
+          </a:fillRef>
+          <a:effectRef idx="2">
+            <a:schemeClr val="accent1"/>
+          </a:effectRef>
+          <a:fontRef idx="minor">
+            <a:schemeClr val="lt1"/>
+          </a:fontRef>
+        </p:style>
+        <p:txBody>
+          <a:bodyPr rtlCol="0" anchor="ctr"/>
+          <a:lstStyle/>
+          <a:p>
+            <a:pPr algn="ctr"/>
+          </a:p>
+        </p:txBody>
+      </p:sp>
+      <p:sp>
+        <p:nvSpPr>
+          <p:cNvPr id="3" name="Rectangle 2"/>
+          <p:cNvSpPr/>
+          <p:nvPr/>
+        </p:nvSpPr>
+        <p:spPr>
+          <a:xfrm>
+            <a:off x="0" y="0"/>
+            <a:ext cx="12191695" cy="713232"/>
+          </a:xfrm>
+          <a:prstGeom prst="rect">
+            <a:avLst/>
+          </a:prstGeom>
+          <a:solidFill>
+            <a:srgbClr val="4EACC2"/>
+          </a:solidFill>
+          <a:ln>
+            <a:solidFill>
+              <a:srgbClr val="0D2035"/>
+            </a:solidFill>
+          </a:ln>
+        </p:spPr>
+        <p:style>
+          <a:lnRef idx="1">
+            <a:schemeClr val="accent1"/>
+          </a:lnRef>
+          <a:fillRef idx="3">
+            <a:schemeClr val="accent1"/>
+          </a:fillRef>
+          <a:effectRef idx="2">
+            <a:schemeClr val="accent1"/>
+          </a:effectRef>
+          <a:fontRef idx="minor">
+            <a:schemeClr val="lt1"/>
+          </a:fontRef>
+        </p:style>
+        <p:txBody>
+          <a:bodyPr rtlCol="0" anchor="ctr"/>
+          <a:lstStyle/>
+          <a:p>
+            <a:pPr algn="ctr"/>
+          </a:p>
+        </p:txBody>
+      </p:sp>
+      <p:sp>
+        <p:nvSpPr>
+          <p:cNvPr id="4" name="TextBox 3"/>
+          <p:cNvSpPr txBox="1"/>
+          <p:nvPr/>
+        </p:nvSpPr>
+        <p:spPr>
+          <a:xfrm>
+            <a:off x="402336" y="146304"/>
+            <a:ext cx="11384280" cy="475488"/>
+          </a:xfrm>
+          <a:prstGeom prst="rect">
+            <a:avLst/>
+          </a:prstGeom>
+          <a:noFill/>
+        </p:spPr>
+        <p:txBody>
+          <a:bodyPr wrap="square" lIns="13716" rIns="13716" tIns="13716" bIns="13716" anchor="t">
+            <a:spAutoFit/>
+          </a:bodyPr>
+          <a:lstStyle/>
+          <a:p>
+            <a:pPr algn="l">
+              <a:defRPr sz="2500" b="1">
+                <a:solidFill>
+                  <a:srgbClr val="0D2035"/>
+                </a:solidFill>
+                <a:latin typeface="Aptos"/>
+              </a:defRPr>
+            </a:pPr>
+            <a:r>
+              <a:t>Feeder handoff: represented geometry, open hardware interfaces</a:t>
+            </a:r>
+          </a:p>
+        </p:txBody>
+      </p:sp>
+      <p:sp>
+        <p:nvSpPr>
+          <p:cNvPr id="5" name="TextBox 4"/>
+          <p:cNvSpPr txBox="1"/>
+          <p:nvPr/>
+        </p:nvSpPr>
+        <p:spPr>
+          <a:xfrm>
+            <a:off x="457200" y="905256"/>
+            <a:ext cx="10789920" cy="256032"/>
+          </a:xfrm>
+          <a:prstGeom prst="rect">
+            <a:avLst/>
+          </a:prstGeom>
+          <a:noFill/>
+        </p:spPr>
+        <p:txBody>
+          <a:bodyPr wrap="square" lIns="13716" rIns="13716" tIns="13716" bIns="13716" anchor="t">
+            <a:spAutoFit/>
+          </a:bodyPr>
+          <a:lstStyle/>
+          <a:p>
+            <a:pPr algn="l">
+              <a:defRPr sz="1000" b="1">
+                <a:solidFill>
+                  <a:srgbClr val="0096A0"/>
+                </a:solidFill>
+                <a:latin typeface="Aptos"/>
+              </a:defRPr>
+            </a:pPr>
+            <a:r>
+              <a:t>FUTURE-WORK APPENDIX</a:t>
+            </a:r>
+          </a:p>
+        </p:txBody>
+      </p:sp>
+      <p:sp>
+        <p:nvSpPr>
+          <p:cNvPr id="6" name="TextBox 5"/>
+          <p:cNvSpPr txBox="1"/>
+          <p:nvPr/>
+        </p:nvSpPr>
+        <p:spPr>
+          <a:xfrm>
+            <a:off x="402336" y="6537960"/>
+            <a:ext cx="2560320" cy="201168"/>
+          </a:xfrm>
+          <a:prstGeom prst="rect">
+            <a:avLst/>
+          </a:prstGeom>
+          <a:noFill/>
+        </p:spPr>
+        <p:txBody>
+          <a:bodyPr wrap="square" lIns="13716" rIns="13716" tIns="13716" bIns="13716" anchor="t">
+            <a:spAutoFit/>
+          </a:bodyPr>
+          <a:lstStyle/>
+          <a:p>
+            <a:pPr algn="l">
+              <a:defRPr sz="850" b="1">
+                <a:solidFill>
+                  <a:srgbClr val="637684"/>
+                </a:solidFill>
+                <a:latin typeface="Aptos"/>
+              </a:defRPr>
+            </a:pPr>
+            <a:r>
+              <a:t>UNSELECTED GEN6 RESEARCH</a:t>
+            </a:r>
+          </a:p>
+        </p:txBody>
+      </p:sp>
+      <p:sp>
+        <p:nvSpPr>
+          <p:cNvPr id="7" name="TextBox 6"/>
+          <p:cNvSpPr txBox="1"/>
+          <p:nvPr/>
+        </p:nvSpPr>
+        <p:spPr>
+          <a:xfrm>
+            <a:off x="2926080" y="6537960"/>
+            <a:ext cx="8138160" cy="201168"/>
+          </a:xfrm>
+          <a:prstGeom prst="rect">
+            <a:avLst/>
+          </a:prstGeom>
+          <a:noFill/>
+        </p:spPr>
+        <p:txBody>
+          <a:bodyPr wrap="square" lIns="13716" rIns="13716" tIns="13716" bIns="13716" anchor="t">
+            <a:spAutoFit/>
+          </a:bodyPr>
+          <a:lstStyle/>
+          <a:p>
+            <a:pPr algn="l">
+              <a:defRPr sz="850" b="0">
+                <a:solidFill>
+                  <a:srgbClr val="637684"/>
+                </a:solidFill>
+                <a:latin typeface="Aptos"/>
+              </a:defRPr>
+            </a:pPr>
+            <a:r>
+              <a:t>FM-02 / IDR-01 / FSR-01 · separate Gen6 studies</a:t>
+            </a:r>
+          </a:p>
+        </p:txBody>
+      </p:sp>
+      <p:sp>
+        <p:nvSpPr>
+          <p:cNvPr id="8" name="TextBox 7"/>
+          <p:cNvSpPr txBox="1"/>
+          <p:nvPr/>
+        </p:nvSpPr>
+        <p:spPr>
+          <a:xfrm>
+            <a:off x="11567160" y="6537960"/>
+            <a:ext cx="320040" cy="201168"/>
+          </a:xfrm>
+          <a:prstGeom prst="rect">
+            <a:avLst/>
+          </a:prstGeom>
+          <a:noFill/>
+        </p:spPr>
+        <p:txBody>
+          <a:bodyPr wrap="square" lIns="13716" rIns="13716" tIns="13716" bIns="13716" anchor="t">
+            <a:spAutoFit/>
+          </a:bodyPr>
+          <a:lstStyle/>
+          <a:p>
+            <a:pPr algn="r">
+              <a:defRPr sz="900" b="0">
+                <a:solidFill>
+                  <a:srgbClr val="637684"/>
+                </a:solidFill>
+                <a:latin typeface="Aptos"/>
+              </a:defRPr>
+            </a:pPr>
+            <a:r>
+              <a:t>38</a:t>
+            </a:r>
+          </a:p>
+        </p:txBody>
+      </p:sp>
+      <p:pic>
+        <p:nvPicPr>
+          <p:cNvPr id="9" name="Picture 8" descr="FreeCAD_FM02_transfer.png"/>
+          <p:cNvPicPr>
+            <a:picLocks noChangeAspect="1"/>
+          </p:cNvPicPr>
+          <p:nvPr/>
+        </p:nvPicPr>
+        <p:blipFill>
+          <a:blip r:embed="rId2"/>
+          <a:stretch>
+            <a:fillRect/>
+          </a:stretch>
+        </p:blipFill>
+        <p:spPr>
+          <a:xfrm>
+            <a:off x="448055" y="1417320"/>
+            <a:ext cx="7242048" cy="4526280"/>
+          </a:xfrm>
+          <a:prstGeom prst="rect">
+            <a:avLst/>
+          </a:prstGeom>
+        </p:spPr>
+      </p:pic>
+      <p:sp>
+        <p:nvSpPr>
+          <p:cNvPr id="10" name="TextBox 9"/>
+          <p:cNvSpPr txBox="1"/>
+          <p:nvPr/>
+        </p:nvSpPr>
+        <p:spPr>
+          <a:xfrm>
+            <a:off x="8001000" y="1508760"/>
+            <a:ext cx="3520440" cy="4297680"/>
+          </a:xfrm>
+          <a:prstGeom prst="rect">
+            <a:avLst/>
+          </a:prstGeom>
+          <a:noFill/>
+        </p:spPr>
+        <p:txBody>
+          <a:bodyPr wrap="square" lIns="73152" rIns="73152" tIns="36576" bIns="0">
+            <a:spAutoFit/>
+          </a:bodyPr>
+          <a:lstStyle/>
+          <a:p>
+            <a:pPr>
+              <a:spcAft>
+                <a:spcPts val="1400"/>
+              </a:spcAft>
+              <a:defRPr sz="1700">
+                <a:solidFill>
+                  <a:srgbClr val="1E3144"/>
+                </a:solidFill>
+                <a:latin typeface="Aptos"/>
+              </a:defRPr>
+            </a:pPr>
+            <a:r>
+              <a:t>•  28 native/STEP poses; 26 continuous rigid phases</a:t>
+            </a:r>
+          </a:p>
+          <a:p>
+            <a:pPr>
+              <a:spcAft>
+                <a:spcPts val="1400"/>
+              </a:spcAft>
+              <a:defRPr sz="1700">
+                <a:solidFill>
+                  <a:srgbClr val="1E3144"/>
+                </a:solidFill>
+                <a:latin typeface="Aptos"/>
+              </a:defRPr>
+            </a:pPr>
+            <a:r>
+              <a:t>•  12 mm underfloor receiving latch; positive crosspins</a:t>
+            </a:r>
+          </a:p>
+          <a:p>
+            <a:pPr>
+              <a:spcAft>
+                <a:spcPts val="1400"/>
+              </a:spcAft>
+              <a:defRPr sz="1700">
+                <a:solidFill>
+                  <a:srgbClr val="1E3144"/>
+                </a:solidFill>
+                <a:latin typeface="Aptos"/>
+              </a:defRPr>
+            </a:pPr>
+            <a:r>
+              <a:t>•  115/324 adverse fit residuals remain nonpositive</a:t>
+            </a:r>
+          </a:p>
+          <a:p>
+            <a:pPr>
+              <a:spcAft>
+                <a:spcPts val="1400"/>
+              </a:spcAft>
+              <a:defRPr sz="1700">
+                <a:solidFill>
+                  <a:srgbClr val="1E3144"/>
+                </a:solidFill>
+                <a:latin typeface="Aptos"/>
+              </a:defRPr>
+            </a:pPr>
+            <a:r>
+              <a:t>•  103 s assumed cycle exceeds 92.18 s later coast</a:t>
+            </a:r>
+          </a:p>
+          <a:p>
+            <a:pPr>
+              <a:spcAft>
+                <a:spcPts val="1400"/>
+              </a:spcAft>
+              <a:defRPr sz="1700">
+                <a:solidFill>
+                  <a:srgbClr val="1E3144"/>
+                </a:solidFill>
+                <a:latin typeface="Aptos"/>
+              </a:defRPr>
+            </a:pPr>
+            <a:r>
+              <a:t>•  Actuation, axial pin retention and installed integration remain open</a:t>
+            </a:r>
+          </a:p>
+        </p:txBody>
+      </p:sp>
+      <p:sp>
+        <p:nvSpPr>
+          <p:cNvPr id="11" name="TextBox 10"/>
+          <p:cNvSpPr txBox="1"/>
+          <p:nvPr/>
+        </p:nvSpPr>
+        <p:spPr>
+          <a:xfrm>
+            <a:off x="640080" y="6181344"/>
+            <a:ext cx="10881360" cy="256032"/>
+          </a:xfrm>
+          <a:prstGeom prst="rect">
+            <a:avLst/>
+          </a:prstGeom>
+          <a:noFill/>
+        </p:spPr>
+        <p:txBody>
+          <a:bodyPr wrap="square" lIns="13716" rIns="13716" tIns="13716" bIns="13716" anchor="t">
+            <a:spAutoFit/>
+          </a:bodyPr>
+          <a:lstStyle/>
+          <a:p>
+            <a:pPr algn="l">
+              <a:defRPr sz="1200" b="0">
+                <a:solidFill>
+                  <a:srgbClr val="1E3144"/>
+                </a:solidFill>
+                <a:latin typeface="Aptos"/>
+              </a:defRPr>
+            </a:pPr>
+            <a:r>
+              <a:t>Genuine FreeCAD Qt/Coin capture. Captive handling only; no launch, measured reliability or manufacturing release.</a:t>
             </a:r>
           </a:p>
         </p:txBody>

</xml_diff>

<commit_message>
Synchronize current feeder evidence across academic and public review surfaces
</commit_message>
<xml_diff>
--- a/university/final_review_2026_10_10/VOLLEY_Final_Review_2026-10-10.pptx
+++ b/university/final_review_2026_10_10/VOLLEY_Final_Review_2026-10-10.pptx
@@ -43,6 +43,8 @@
     <p:sldId id="291" r:id="rId42"/>
     <p:sldId id="292" r:id="rId43"/>
     <p:sldId id="293" r:id="rId44"/>
+    <p:sldId id="294" r:id="rId45"/>
+    <p:sldId id="295" r:id="rId46"/>
   </p:sldIdLst>
   <p:sldSz cx="12191695" cy="6858000" type="screen4x3"/>
   <p:notesSz cx="6858000" cy="9144000"/>
@@ -21385,7 +21387,7 @@
               </a:defRPr>
             </a:pPr>
             <a:r>
-              <a:t>Feeder handoff: represented geometry, open hardware interfaces</a:t>
+              <a:t>Feeder handoff: checked nominal geometry, unresolved hardware</a:t>
             </a:r>
           </a:p>
         </p:txBody>
@@ -21493,7 +21495,7 @@
               </a:defRPr>
             </a:pPr>
             <a:r>
-              <a:t>FM-02 / IDR-01 / FSR-01 · separate Gen6 studies</a:t>
+              <a:t>FM06-R1 · separate Gen6 geometry study</a:t>
             </a:r>
           </a:p>
         </p:txBody>
@@ -21536,7 +21538,7 @@
       </p:sp>
       <p:pic>
         <p:nvPicPr>
-          <p:cNvPr id="9" name="Picture 8" descr="FreeCAD_FM02_transfer.png"/>
+          <p:cNvPr id="9" name="Picture 8" descr="FM06_Technical_transfer.png"/>
           <p:cNvPicPr>
             <a:picLocks noChangeAspect="1"/>
           </p:cNvPicPr>
@@ -21550,8 +21552,8 @@
         </p:blipFill>
         <p:spPr>
           <a:xfrm>
-            <a:off x="448055" y="1417320"/>
-            <a:ext cx="7242048" cy="4526280"/>
+            <a:off x="900683" y="1417320"/>
+            <a:ext cx="6336792" cy="4526280"/>
           </a:xfrm>
           <a:prstGeom prst="rect">
             <a:avLst/>
@@ -21582,7 +21584,7 @@
           <a:p>
             <a:pPr>
               <a:spcAft>
-                <a:spcPts val="1400"/>
+                <a:spcPts val="1500"/>
               </a:spcAft>
               <a:defRPr sz="1700">
                 <a:solidFill>
@@ -21592,13 +21594,13 @@
               </a:defRPr>
             </a:pPr>
             <a:r>
-              <a:t>•  28 native/STEP poses; 26 continuous rigid phases</a:t>
+              <a:t>•  30 native/STEP assembly states; 70 checked part exchanges</a:t>
             </a:r>
           </a:p>
           <a:p>
             <a:pPr>
               <a:spcAft>
-                <a:spcPts val="1400"/>
+                <a:spcPts val="1500"/>
               </a:spcAft>
               <a:defRPr sz="1700">
                 <a:solidFill>
@@ -21608,13 +21610,13 @@
               </a:defRPr>
             </a:pPr>
             <a:r>
-              <a:t>•  12 mm underfloor receiving latch; positive crosspins</a:t>
+              <a:t>•  28 continuous prescribed rigid-translation phases</a:t>
             </a:r>
           </a:p>
           <a:p>
             <a:pPr>
               <a:spcAft>
-                <a:spcPts val="1400"/>
+                <a:spcPts val="1500"/>
               </a:spcAft>
               <a:defRPr sz="1700">
                 <a:solidFill>
@@ -21624,13 +21626,13 @@
               </a:defRPr>
             </a:pPr>
             <a:r>
-              <a:t>•  115/324 adverse fit residuals remain nonpositive</a:t>
+              <a:t>•  Backstop junction corrected; closed surfaces checked</a:t>
             </a:r>
           </a:p>
           <a:p>
             <a:pPr>
               <a:spcAft>
-                <a:spcPts val="1400"/>
+                <a:spcPts val="1500"/>
               </a:spcAft>
               <a:defRPr sz="1700">
                 <a:solidFill>
@@ -21640,13 +21642,382 @@
               </a:defRPr>
             </a:pPr>
             <a:r>
-              <a:t>•  103 s assumed cycle exceeds 92.18 s later coast</a:t>
-            </a:r>
-          </a:p>
+              <a:t>•  Installed actuation, rail-end contacts and forward-stop release remain open</a:t>
+            </a:r>
+          </a:p>
+        </p:txBody>
+      </p:sp>
+      <p:sp>
+        <p:nvSpPr>
+          <p:cNvPr id="11" name="TextBox 10"/>
+          <p:cNvSpPr txBox="1"/>
+          <p:nvPr/>
+        </p:nvSpPr>
+        <p:spPr>
+          <a:xfrm>
+            <a:off x="640080" y="6181344"/>
+            <a:ext cx="10881360" cy="256032"/>
+          </a:xfrm>
+          <a:prstGeom prst="rect">
+            <a:avLst/>
+          </a:prstGeom>
+          <a:noFill/>
+        </p:spPr>
+        <p:txBody>
+          <a:bodyPr wrap="square" lIns="13716" rIns="13716" tIns="13716" bIns="13716" anchor="t">
+            <a:spAutoFit/>
+          </a:bodyPr>
+          <a:lstStyle/>
+          <a:p>
+            <a:pPr algn="l">
+              <a:defRPr sz="1200" b="0">
+                <a:solidFill>
+                  <a:srgbClr val="1E3144"/>
+                </a:solidFill>
+                <a:latin typeface="Aptos"/>
+              </a:defRPr>
+            </a:pPr>
+            <a:r>
+              <a:t>Blender Workbench render of actual native CAD. No manufactured mechanism, launch or qualification claim.</a:t>
+            </a:r>
+          </a:p>
+        </p:txBody>
+      </p:sp>
+    </p:spTree>
+  </p:cSld>
+  <p:clrMapOvr>
+    <a:masterClrMapping/>
+  </p:clrMapOvr>
+</p:sld>
+</file>
+
+<file path=ppt/slides/slide39.xml><?xml version="1.0" encoding="utf-8"?>
+<p:sld xmlns:a="http://schemas.openxmlformats.org/drawingml/2006/main" xmlns:p="http://schemas.openxmlformats.org/presentationml/2006/main" xmlns:r="http://schemas.openxmlformats.org/officeDocument/2006/relationships">
+  <p:cSld>
+    <p:spTree>
+      <p:nvGrpSpPr>
+        <p:cNvPr id="1" name=""/>
+        <p:cNvGrpSpPr/>
+        <p:nvPr/>
+      </p:nvGrpSpPr>
+      <p:grpSpPr/>
+      <p:sp>
+        <p:nvSpPr>
+          <p:cNvPr id="2" name="Rectangle 1"/>
+          <p:cNvSpPr/>
+          <p:nvPr/>
+        </p:nvSpPr>
+        <p:spPr>
+          <a:xfrm>
+            <a:off x="0" y="0"/>
+            <a:ext cx="12191695" cy="6858000"/>
+          </a:xfrm>
+          <a:prstGeom prst="rect">
+            <a:avLst/>
+          </a:prstGeom>
+          <a:solidFill>
+            <a:srgbClr val="FFFFFF"/>
+          </a:solidFill>
+          <a:ln>
+            <a:noFill/>
+          </a:ln>
+        </p:spPr>
+        <p:style>
+          <a:lnRef idx="1">
+            <a:schemeClr val="accent1"/>
+          </a:lnRef>
+          <a:fillRef idx="3">
+            <a:schemeClr val="accent1"/>
+          </a:fillRef>
+          <a:effectRef idx="2">
+            <a:schemeClr val="accent1"/>
+          </a:effectRef>
+          <a:fontRef idx="minor">
+            <a:schemeClr val="lt1"/>
+          </a:fontRef>
+        </p:style>
+        <p:txBody>
+          <a:bodyPr rtlCol="0" anchor="ctr"/>
+          <a:lstStyle/>
+          <a:p>
+            <a:pPr algn="ctr"/>
+          </a:p>
+        </p:txBody>
+      </p:sp>
+      <p:sp>
+        <p:nvSpPr>
+          <p:cNvPr id="3" name="Rectangle 2"/>
+          <p:cNvSpPr/>
+          <p:nvPr/>
+        </p:nvSpPr>
+        <p:spPr>
+          <a:xfrm>
+            <a:off x="0" y="0"/>
+            <a:ext cx="12191695" cy="713232"/>
+          </a:xfrm>
+          <a:prstGeom prst="rect">
+            <a:avLst/>
+          </a:prstGeom>
+          <a:solidFill>
+            <a:srgbClr val="4EACC2"/>
+          </a:solidFill>
+          <a:ln>
+            <a:solidFill>
+              <a:srgbClr val="0D2035"/>
+            </a:solidFill>
+          </a:ln>
+        </p:spPr>
+        <p:style>
+          <a:lnRef idx="1">
+            <a:schemeClr val="accent1"/>
+          </a:lnRef>
+          <a:fillRef idx="3">
+            <a:schemeClr val="accent1"/>
+          </a:fillRef>
+          <a:effectRef idx="2">
+            <a:schemeClr val="accent1"/>
+          </a:effectRef>
+          <a:fontRef idx="minor">
+            <a:schemeClr val="lt1"/>
+          </a:fontRef>
+        </p:style>
+        <p:txBody>
+          <a:bodyPr rtlCol="0" anchor="ctr"/>
+          <a:lstStyle/>
+          <a:p>
+            <a:pPr algn="ctr"/>
+          </a:p>
+        </p:txBody>
+      </p:sp>
+      <p:sp>
+        <p:nvSpPr>
+          <p:cNvPr id="4" name="TextBox 3"/>
+          <p:cNvSpPr txBox="1"/>
+          <p:nvPr/>
+        </p:nvSpPr>
+        <p:spPr>
+          <a:xfrm>
+            <a:off x="402336" y="146304"/>
+            <a:ext cx="11384280" cy="475488"/>
+          </a:xfrm>
+          <a:prstGeom prst="rect">
+            <a:avLst/>
+          </a:prstGeom>
+          <a:noFill/>
+        </p:spPr>
+        <p:txBody>
+          <a:bodyPr wrap="square" lIns="13716" rIns="13716" tIns="13716" bIns="13716" anchor="t">
+            <a:spAutoFit/>
+          </a:bodyPr>
+          <a:lstStyle/>
+          <a:p>
+            <a:pPr algn="l">
+              <a:defRPr sz="2500" b="1">
+                <a:solidFill>
+                  <a:srgbClr val="0D2035"/>
+                </a:solidFill>
+                <a:latin typeface="Aptos"/>
+              </a:defRPr>
+            </a:pPr>
+            <a:r>
+              <a:t>Component stiffness improves within an idealized fixture</a:t>
+            </a:r>
+          </a:p>
+        </p:txBody>
+      </p:sp>
+      <p:sp>
+        <p:nvSpPr>
+          <p:cNvPr id="5" name="TextBox 4"/>
+          <p:cNvSpPr txBox="1"/>
+          <p:nvPr/>
+        </p:nvSpPr>
+        <p:spPr>
+          <a:xfrm>
+            <a:off x="457200" y="905256"/>
+            <a:ext cx="10789920" cy="256032"/>
+          </a:xfrm>
+          <a:prstGeom prst="rect">
+            <a:avLst/>
+          </a:prstGeom>
+          <a:noFill/>
+        </p:spPr>
+        <p:txBody>
+          <a:bodyPr wrap="square" lIns="13716" rIns="13716" tIns="13716" bIns="13716" anchor="t">
+            <a:spAutoFit/>
+          </a:bodyPr>
+          <a:lstStyle/>
+          <a:p>
+            <a:pPr algn="l">
+              <a:defRPr sz="1000" b="1">
+                <a:solidFill>
+                  <a:srgbClr val="0096A0"/>
+                </a:solidFill>
+                <a:latin typeface="Aptos"/>
+              </a:defRPr>
+            </a:pPr>
+            <a:r>
+              <a:t>FUTURE-WORK APPENDIX</a:t>
+            </a:r>
+          </a:p>
+        </p:txBody>
+      </p:sp>
+      <p:sp>
+        <p:nvSpPr>
+          <p:cNvPr id="6" name="TextBox 5"/>
+          <p:cNvSpPr txBox="1"/>
+          <p:nvPr/>
+        </p:nvSpPr>
+        <p:spPr>
+          <a:xfrm>
+            <a:off x="402336" y="6537960"/>
+            <a:ext cx="2560320" cy="201168"/>
+          </a:xfrm>
+          <a:prstGeom prst="rect">
+            <a:avLst/>
+          </a:prstGeom>
+          <a:noFill/>
+        </p:spPr>
+        <p:txBody>
+          <a:bodyPr wrap="square" lIns="13716" rIns="13716" tIns="13716" bIns="13716" anchor="t">
+            <a:spAutoFit/>
+          </a:bodyPr>
+          <a:lstStyle/>
+          <a:p>
+            <a:pPr algn="l">
+              <a:defRPr sz="850" b="1">
+                <a:solidFill>
+                  <a:srgbClr val="637684"/>
+                </a:solidFill>
+                <a:latin typeface="Aptos"/>
+              </a:defRPr>
+            </a:pPr>
+            <a:r>
+              <a:t>COMPONENT FIXTURE RESULTS</a:t>
+            </a:r>
+          </a:p>
+        </p:txBody>
+      </p:sp>
+      <p:sp>
+        <p:nvSpPr>
+          <p:cNvPr id="7" name="TextBox 6"/>
+          <p:cNvSpPr txBox="1"/>
+          <p:nvPr/>
+        </p:nvSpPr>
+        <p:spPr>
+          <a:xfrm>
+            <a:off x="2926080" y="6537960"/>
+            <a:ext cx="8138160" cy="201168"/>
+          </a:xfrm>
+          <a:prstGeom prst="rect">
+            <a:avLst/>
+          </a:prstGeom>
+          <a:noFill/>
+        </p:spPr>
+        <p:txBody>
+          <a:bodyPr wrap="square" lIns="13716" rIns="13716" tIns="13716" bIns="13716" anchor="t">
+            <a:spAutoFit/>
+          </a:bodyPr>
+          <a:lstStyle/>
+          <a:p>
+            <a:pPr algn="l">
+              <a:defRPr sz="850" b="0">
+                <a:solidFill>
+                  <a:srgbClr val="637684"/>
+                </a:solidFill>
+                <a:latin typeface="Aptos"/>
+              </a:defRPr>
+            </a:pPr>
+            <a:r>
+              <a:t>FLR01 / FLR02 / FLR03 · Gmsh 4.14.1 / CalculiX 2.23</a:t>
+            </a:r>
+          </a:p>
+        </p:txBody>
+      </p:sp>
+      <p:sp>
+        <p:nvSpPr>
+          <p:cNvPr id="8" name="TextBox 7"/>
+          <p:cNvSpPr txBox="1"/>
+          <p:nvPr/>
+        </p:nvSpPr>
+        <p:spPr>
+          <a:xfrm>
+            <a:off x="11567160" y="6537960"/>
+            <a:ext cx="320040" cy="201168"/>
+          </a:xfrm>
+          <a:prstGeom prst="rect">
+            <a:avLst/>
+          </a:prstGeom>
+          <a:noFill/>
+        </p:spPr>
+        <p:txBody>
+          <a:bodyPr wrap="square" lIns="13716" rIns="13716" tIns="13716" bIns="13716" anchor="t">
+            <a:spAutoFit/>
+          </a:bodyPr>
+          <a:lstStyle/>
+          <a:p>
+            <a:pPr algn="r">
+              <a:defRPr sz="900" b="0">
+                <a:solidFill>
+                  <a:srgbClr val="637684"/>
+                </a:solidFill>
+                <a:latin typeface="Aptos"/>
+              </a:defRPr>
+            </a:pPr>
+            <a:r>
+              <a:t>39</a:t>
+            </a:r>
+          </a:p>
+        </p:txBody>
+      </p:sp>
+      <p:pic>
+        <p:nvPicPr>
+          <p:cNvPr id="9" name="Picture 8" descr="component_compliance.png"/>
+          <p:cNvPicPr>
+            <a:picLocks noChangeAspect="1"/>
+          </p:cNvPicPr>
+          <p:nvPr/>
+        </p:nvPicPr>
+        <p:blipFill>
+          <a:blip r:embed="rId2"/>
+          <a:stretch>
+            <a:fillRect/>
+          </a:stretch>
+        </p:blipFill>
+        <p:spPr>
+          <a:xfrm>
+            <a:off x="502919" y="2198846"/>
+            <a:ext cx="7132320" cy="3008947"/>
+          </a:xfrm>
+          <a:prstGeom prst="rect">
+            <a:avLst/>
+          </a:prstGeom>
+        </p:spPr>
+      </p:pic>
+      <p:sp>
+        <p:nvSpPr>
+          <p:cNvPr id="10" name="TextBox 9"/>
+          <p:cNvSpPr txBox="1"/>
+          <p:nvPr/>
+        </p:nvSpPr>
+        <p:spPr>
+          <a:xfrm>
+            <a:off x="7909560" y="1645920"/>
+            <a:ext cx="3657600" cy="4206240"/>
+          </a:xfrm>
+          <a:prstGeom prst="rect">
+            <a:avLst/>
+          </a:prstGeom>
+          <a:noFill/>
+        </p:spPr>
+        <p:txBody>
+          <a:bodyPr wrap="square" lIns="73152" rIns="73152" tIns="36576" bIns="0">
+            <a:spAutoFit/>
+          </a:bodyPr>
+          <a:lstStyle/>
           <a:p>
             <a:pPr>
               <a:spcAft>
-                <a:spcPts val="1400"/>
+                <a:spcPts val="1500"/>
               </a:spcAft>
               <a:defRPr sz="1700">
                 <a:solidFill>
@@ -21656,7 +22027,55 @@
               </a:defRPr>
             </a:pPr>
             <a:r>
-              <a:t>•  Actuation, axial pin retention and installed integration remain open</a:t>
+              <a:t>•  12 actual-FM06 plus 40 historical receiver analyses</a:t>
+            </a:r>
+          </a:p>
+          <a:p>
+            <a:pPr>
+              <a:spcAft>
+                <a:spcPts val="1500"/>
+              </a:spcAft>
+              <a:defRPr sz="1700">
+                <a:solidFill>
+                  <a:srgbClr val="1E3144"/>
+                </a:solidFill>
+                <a:latin typeface="Aptos"/>
+              </a:defRPr>
+            </a:pPr>
+            <a:r>
+              <a:t>•  3U one-dog mean: 1.883 to 0.0600 mm</a:t>
+            </a:r>
+          </a:p>
+          <a:p>
+            <a:pPr>
+              <a:spcAft>
+                <a:spcPts val="1500"/>
+              </a:spcAft>
+              <a:defRPr sz="1700">
+                <a:solidFill>
+                  <a:srgbClr val="1E3144"/>
+                </a:solidFill>
+                <a:latin typeface="Aptos"/>
+              </a:defRPr>
+            </a:pPr>
+            <a:r>
+              <a:t>•  Clamped bores do not bound assembled stiffness</a:t>
+            </a:r>
+          </a:p>
+          <a:p>
+            <a:pPr>
+              <a:spcAft>
+                <a:spcPts val="1500"/>
+              </a:spcAft>
+              <a:defRPr sz="1700">
+                <a:solidFill>
+                  <a:srgbClr val="1E3144"/>
+                </a:solidFill>
+                <a:latin typeface="Aptos"/>
+              </a:defRPr>
+            </a:pPr>
+            <a:r>
+              <a:t>•  1,117/1,215 adverse guide-fit residuals nonpositive</a:t>
             </a:r>
           </a:p>
         </p:txBody>
@@ -21692,7 +22111,7 @@
               </a:defRPr>
             </a:pPr>
             <a:r>
-              <a:t>Genuine FreeCAD Qt/Coin capture. Captive handling only; no launch, measured reliability or manufacturing release.</a:t>
+              <a:t>Assumed elastic properties; no selected material allowable, real joint-contact acceptance or hardware testing.</a:t>
             </a:r>
           </a:p>
         </p:txBody>
@@ -23188,6 +23607,439 @@
             </a:pPr>
             <a:r>
               <a:t>Armature, high-g or maturity constraints vary</a:t>
+            </a:r>
+          </a:p>
+        </p:txBody>
+      </p:sp>
+    </p:spTree>
+  </p:cSld>
+  <p:clrMapOvr>
+    <a:masterClrMapping/>
+  </p:clrMapOvr>
+</p:sld>
+</file>
+
+<file path=ppt/slides/slide40.xml><?xml version="1.0" encoding="utf-8"?>
+<p:sld xmlns:a="http://schemas.openxmlformats.org/drawingml/2006/main" xmlns:p="http://schemas.openxmlformats.org/presentationml/2006/main" xmlns:r="http://schemas.openxmlformats.org/officeDocument/2006/relationships">
+  <p:cSld>
+    <p:spTree>
+      <p:nvGrpSpPr>
+        <p:cNvPr id="1" name=""/>
+        <p:cNvGrpSpPr/>
+        <p:nvPr/>
+      </p:nvGrpSpPr>
+      <p:grpSpPr/>
+      <p:sp>
+        <p:nvSpPr>
+          <p:cNvPr id="2" name="Rectangle 1"/>
+          <p:cNvSpPr/>
+          <p:nvPr/>
+        </p:nvSpPr>
+        <p:spPr>
+          <a:xfrm>
+            <a:off x="0" y="0"/>
+            <a:ext cx="12191695" cy="6858000"/>
+          </a:xfrm>
+          <a:prstGeom prst="rect">
+            <a:avLst/>
+          </a:prstGeom>
+          <a:solidFill>
+            <a:srgbClr val="FFFFFF"/>
+          </a:solidFill>
+          <a:ln>
+            <a:noFill/>
+          </a:ln>
+        </p:spPr>
+        <p:style>
+          <a:lnRef idx="1">
+            <a:schemeClr val="accent1"/>
+          </a:lnRef>
+          <a:fillRef idx="3">
+            <a:schemeClr val="accent1"/>
+          </a:fillRef>
+          <a:effectRef idx="2">
+            <a:schemeClr val="accent1"/>
+          </a:effectRef>
+          <a:fontRef idx="minor">
+            <a:schemeClr val="lt1"/>
+          </a:fontRef>
+        </p:style>
+        <p:txBody>
+          <a:bodyPr rtlCol="0" anchor="ctr"/>
+          <a:lstStyle/>
+          <a:p>
+            <a:pPr algn="ctr"/>
+          </a:p>
+        </p:txBody>
+      </p:sp>
+      <p:sp>
+        <p:nvSpPr>
+          <p:cNvPr id="3" name="Rectangle 2"/>
+          <p:cNvSpPr/>
+          <p:nvPr/>
+        </p:nvSpPr>
+        <p:spPr>
+          <a:xfrm>
+            <a:off x="0" y="0"/>
+            <a:ext cx="12191695" cy="713232"/>
+          </a:xfrm>
+          <a:prstGeom prst="rect">
+            <a:avLst/>
+          </a:prstGeom>
+          <a:solidFill>
+            <a:srgbClr val="4EACC2"/>
+          </a:solidFill>
+          <a:ln>
+            <a:solidFill>
+              <a:srgbClr val="0D2035"/>
+            </a:solidFill>
+          </a:ln>
+        </p:spPr>
+        <p:style>
+          <a:lnRef idx="1">
+            <a:schemeClr val="accent1"/>
+          </a:lnRef>
+          <a:fillRef idx="3">
+            <a:schemeClr val="accent1"/>
+          </a:fillRef>
+          <a:effectRef idx="2">
+            <a:schemeClr val="accent1"/>
+          </a:effectRef>
+          <a:fontRef idx="minor">
+            <a:schemeClr val="lt1"/>
+          </a:fontRef>
+        </p:style>
+        <p:txBody>
+          <a:bodyPr rtlCol="0" anchor="ctr"/>
+          <a:lstStyle/>
+          <a:p>
+            <a:pPr algn="ctr"/>
+          </a:p>
+        </p:txBody>
+      </p:sp>
+      <p:sp>
+        <p:nvSpPr>
+          <p:cNvPr id="4" name="TextBox 3"/>
+          <p:cNvSpPr txBox="1"/>
+          <p:nvPr/>
+        </p:nvSpPr>
+        <p:spPr>
+          <a:xfrm>
+            <a:off x="402336" y="146304"/>
+            <a:ext cx="11384280" cy="475488"/>
+          </a:xfrm>
+          <a:prstGeom prst="rect">
+            <a:avLst/>
+          </a:prstGeom>
+          <a:noFill/>
+        </p:spPr>
+        <p:txBody>
+          <a:bodyPr wrap="square" lIns="13716" rIns="13716" tIns="13716" bIns="13716" anchor="t">
+            <a:spAutoFit/>
+          </a:bodyPr>
+          <a:lstStyle/>
+          <a:p>
+            <a:pPr algn="l">
+              <a:defRPr sz="2500" b="1">
+                <a:solidFill>
+                  <a:srgbClr val="0D2035"/>
+                </a:solidFill>
+                <a:latin typeface="Aptos"/>
+              </a:defRPr>
+            </a:pPr>
+            <a:r>
+              <a:t>Native contact runs expose a model limitation</a:t>
+            </a:r>
+          </a:p>
+        </p:txBody>
+      </p:sp>
+      <p:sp>
+        <p:nvSpPr>
+          <p:cNvPr id="5" name="TextBox 4"/>
+          <p:cNvSpPr txBox="1"/>
+          <p:nvPr/>
+        </p:nvSpPr>
+        <p:spPr>
+          <a:xfrm>
+            <a:off x="457200" y="905256"/>
+            <a:ext cx="10789920" cy="256032"/>
+          </a:xfrm>
+          <a:prstGeom prst="rect">
+            <a:avLst/>
+          </a:prstGeom>
+          <a:noFill/>
+        </p:spPr>
+        <p:txBody>
+          <a:bodyPr wrap="square" lIns="13716" rIns="13716" tIns="13716" bIns="13716" anchor="t">
+            <a:spAutoFit/>
+          </a:bodyPr>
+          <a:lstStyle/>
+          <a:p>
+            <a:pPr algn="l">
+              <a:defRPr sz="1000" b="1">
+                <a:solidFill>
+                  <a:srgbClr val="0096A0"/>
+                </a:solidFill>
+                <a:latin typeface="Aptos"/>
+              </a:defRPr>
+            </a:pPr>
+            <a:r>
+              <a:t>FUTURE-WORK APPENDIX</a:t>
+            </a:r>
+          </a:p>
+        </p:txBody>
+      </p:sp>
+      <p:sp>
+        <p:nvSpPr>
+          <p:cNvPr id="6" name="TextBox 5"/>
+          <p:cNvSpPr txBox="1"/>
+          <p:nvPr/>
+        </p:nvSpPr>
+        <p:spPr>
+          <a:xfrm>
+            <a:off x="402336" y="6537960"/>
+            <a:ext cx="2560320" cy="201168"/>
+          </a:xfrm>
+          <a:prstGeom prst="rect">
+            <a:avLst/>
+          </a:prstGeom>
+          <a:noFill/>
+        </p:spPr>
+        <p:txBody>
+          <a:bodyPr wrap="square" lIns="13716" rIns="13716" tIns="13716" bIns="13716" anchor="t">
+            <a:spAutoFit/>
+          </a:bodyPr>
+          <a:lstStyle/>
+          <a:p>
+            <a:pPr algn="l">
+              <a:defRPr sz="850" b="1">
+                <a:solidFill>
+                  <a:srgbClr val="637684"/>
+                </a:solidFill>
+                <a:latin typeface="Aptos"/>
+              </a:defRPr>
+            </a:pPr>
+            <a:r>
+              <a:t>NUMERICAL ACCEPTANCE NOT ESTABLISHED</a:t>
+            </a:r>
+          </a:p>
+        </p:txBody>
+      </p:sp>
+      <p:sp>
+        <p:nvSpPr>
+          <p:cNvPr id="7" name="TextBox 6"/>
+          <p:cNvSpPr txBox="1"/>
+          <p:nvPr/>
+        </p:nvSpPr>
+        <p:spPr>
+          <a:xfrm>
+            <a:off x="2926080" y="6537960"/>
+            <a:ext cx="8138160" cy="201168"/>
+          </a:xfrm>
+          <a:prstGeom prst="rect">
+            <a:avLst/>
+          </a:prstGeom>
+          <a:noFill/>
+        </p:spPr>
+        <p:txBody>
+          <a:bodyPr wrap="square" lIns="13716" rIns="13716" tIns="13716" bIns="13716" anchor="t">
+            <a:spAutoFit/>
+          </a:bodyPr>
+          <a:lstStyle/>
+          <a:p>
+            <a:pPr algn="l">
+              <a:defRPr sz="850" b="0">
+                <a:solidFill>
+                  <a:srgbClr val="637684"/>
+                </a:solidFill>
+                <a:latin typeface="Aptos"/>
+              </a:defRPr>
+            </a:pPr>
+            <a:r>
+              <a:t>FCE08 · Project Chrono 10.0.0; 12 captured cases</a:t>
+            </a:r>
+          </a:p>
+        </p:txBody>
+      </p:sp>
+      <p:sp>
+        <p:nvSpPr>
+          <p:cNvPr id="8" name="TextBox 7"/>
+          <p:cNvSpPr txBox="1"/>
+          <p:nvPr/>
+        </p:nvSpPr>
+        <p:spPr>
+          <a:xfrm>
+            <a:off x="11567160" y="6537960"/>
+            <a:ext cx="320040" cy="201168"/>
+          </a:xfrm>
+          <a:prstGeom prst="rect">
+            <a:avLst/>
+          </a:prstGeom>
+          <a:noFill/>
+        </p:spPr>
+        <p:txBody>
+          <a:bodyPr wrap="square" lIns="13716" rIns="13716" tIns="13716" bIns="13716" anchor="t">
+            <a:spAutoFit/>
+          </a:bodyPr>
+          <a:lstStyle/>
+          <a:p>
+            <a:pPr algn="r">
+              <a:defRPr sz="900" b="0">
+                <a:solidFill>
+                  <a:srgbClr val="637684"/>
+                </a:solidFill>
+                <a:latin typeface="Aptos"/>
+              </a:defRPr>
+            </a:pPr>
+            <a:r>
+              <a:t>40</a:t>
+            </a:r>
+          </a:p>
+        </p:txBody>
+      </p:sp>
+      <p:pic>
+        <p:nvPicPr>
+          <p:cNvPr id="9" name="Picture 8" descr="contact_refinement.png"/>
+          <p:cNvPicPr>
+            <a:picLocks noChangeAspect="1"/>
+          </p:cNvPicPr>
+          <p:nvPr/>
+        </p:nvPicPr>
+        <p:blipFill>
+          <a:blip r:embed="rId2"/>
+          <a:stretch>
+            <a:fillRect/>
+          </a:stretch>
+        </p:blipFill>
+        <p:spPr>
+          <a:xfrm>
+            <a:off x="457200" y="2234901"/>
+            <a:ext cx="7132320" cy="2936837"/>
+          </a:xfrm>
+          <a:prstGeom prst="rect">
+            <a:avLst/>
+          </a:prstGeom>
+        </p:spPr>
+      </p:pic>
+      <p:sp>
+        <p:nvSpPr>
+          <p:cNvPr id="10" name="TextBox 9"/>
+          <p:cNvSpPr txBox="1"/>
+          <p:nvPr/>
+        </p:nvSpPr>
+        <p:spPr>
+          <a:xfrm>
+            <a:off x="7909560" y="1645920"/>
+            <a:ext cx="3657600" cy="4206240"/>
+          </a:xfrm>
+          <a:prstGeom prst="rect">
+            <a:avLst/>
+          </a:prstGeom>
+          <a:noFill/>
+        </p:spPr>
+        <p:txBody>
+          <a:bodyPr wrap="square" lIns="73152" rIns="73152" tIns="36576" bIns="0">
+            <a:spAutoFit/>
+          </a:bodyPr>
+          <a:lstStyle/>
+          <a:p>
+            <a:pPr>
+              <a:spcAft>
+                <a:spcPts val="1500"/>
+              </a:spcAft>
+              <a:defRPr sz="1700">
+                <a:solidFill>
+                  <a:srgbClr val="1E3144"/>
+                </a:solidFill>
+                <a:latin typeface="Aptos"/>
+              </a:defRPr>
+            </a:pPr>
+            <a:r>
+              <a:t>•  Nominal transfer sequences reach their programmed endpoint</a:t>
+            </a:r>
+          </a:p>
+          <a:p>
+            <a:pPr>
+              <a:spcAft>
+                <a:spcPts val="1500"/>
+              </a:spcAft>
+              <a:defRPr sz="1700">
+                <a:solidFill>
+                  <a:srgbClr val="1E3144"/>
+                </a:solidFill>
+                <a:latin typeface="Aptos"/>
+              </a:defRPr>
+            </a:pPr>
+            <a:r>
+              <a:t>•  Contact peaks and final pose remain step/iteration sensitive</a:t>
+            </a:r>
+          </a:p>
+          <a:p>
+            <a:pPr>
+              <a:spcAft>
+                <a:spcPts val="1500"/>
+              </a:spcAft>
+              <a:defRPr sz="1700">
+                <a:solidFill>
+                  <a:srgbClr val="1E3144"/>
+                </a:solidFill>
+                <a:latin typeface="Aptos"/>
+              </a:defRPr>
+            </a:pPr>
+            <a:r>
+              <a:t>•  Independent B-rep checks detect payload/fork overlap</a:t>
+            </a:r>
+          </a:p>
+          <a:p>
+            <a:pPr>
+              <a:spcAft>
+                <a:spcPts val="1500"/>
+              </a:spcAft>
+              <a:defRPr sz="1700">
+                <a:solidFill>
+                  <a:srgbClr val="1E3144"/>
+                </a:solidFill>
+                <a:latin typeface="Aptos"/>
+              </a:defRPr>
+            </a:pPr>
+            <a:r>
+              <a:t>•  No dynamic-clearance, precision or design-load acceptance</a:t>
+            </a:r>
+          </a:p>
+        </p:txBody>
+      </p:sp>
+      <p:sp>
+        <p:nvSpPr>
+          <p:cNvPr id="11" name="TextBox 10"/>
+          <p:cNvSpPr txBox="1"/>
+          <p:nvPr/>
+        </p:nvSpPr>
+        <p:spPr>
+          <a:xfrm>
+            <a:off x="640080" y="6181344"/>
+            <a:ext cx="10881360" cy="256032"/>
+          </a:xfrm>
+          <a:prstGeom prst="rect">
+            <a:avLst/>
+          </a:prstGeom>
+          <a:noFill/>
+        </p:spPr>
+        <p:txBody>
+          <a:bodyPr wrap="square" lIns="13716" rIns="13716" tIns="13716" bIns="13716" anchor="t">
+            <a:spAutoFit/>
+          </a:bodyPr>
+          <a:lstStyle/>
+          <a:p>
+            <a:pPr algn="l">
+              <a:defRPr sz="1200" b="0">
+                <a:solidFill>
+                  <a:srgbClr val="1E3144"/>
+                </a:solidFill>
+                <a:latin typeface="Aptos"/>
+              </a:defRPr>
+            </a:pPr>
+            <a:r>
+              <a:t>A completed simulation sequence does not establish a validated contact model or physical reliability.</a:t>
             </a:r>
           </a:p>
         </p:txBody>

</xml_diff>

<commit_message>
Synchronize contact verification, academic deliverables and project front pages
</commit_message>
<xml_diff>
--- a/university/final_review_2026_10_10/VOLLEY_Final_Review_2026-10-10.pptx
+++ b/university/final_review_2026_10_10/VOLLEY_Final_Review_2026-10-10.pptx
@@ -23748,7 +23748,7 @@
               </a:defRPr>
             </a:pPr>
             <a:r>
-              <a:t>Native contact runs expose a model limitation</a:t>
+              <a:t>Contact representation: calibrated controls, sensitive final pose</a:t>
             </a:r>
           </a:p>
         </p:txBody>
@@ -23820,7 +23820,7 @@
               </a:defRPr>
             </a:pPr>
             <a:r>
-              <a:t>NUMERICAL ACCEPTANCE NOT ESTABLISHED</a:t>
+              <a:t>NUMERICAL METHOD RESULTS</a:t>
             </a:r>
           </a:p>
         </p:txBody>
@@ -23856,7 +23856,7 @@
               </a:defRPr>
             </a:pPr>
             <a:r>
-              <a:t>FCE08 · Project Chrono 10.0.0; 12 captured cases</a:t>
+              <a:t>FCE12 · Project Chrono 10.0.0; 12 captured cases</a:t>
             </a:r>
           </a:p>
         </p:txBody>
@@ -23899,7 +23899,7 @@
       </p:sp>
       <p:pic>
         <p:nvPicPr>
-          <p:cNvPr id="9" name="Picture 8" descr="contact_refinement.png"/>
+          <p:cNvPr id="9" name="Picture 8" descr="contact_calibration.png"/>
           <p:cNvPicPr>
             <a:picLocks noChangeAspect="1"/>
           </p:cNvPicPr>
@@ -23913,8 +23913,8 @@
         </p:blipFill>
         <p:spPr>
           <a:xfrm>
-            <a:off x="457200" y="2234901"/>
-            <a:ext cx="7132320" cy="2936837"/>
+            <a:off x="457199" y="2257044"/>
+            <a:ext cx="7132320" cy="2892552"/>
           </a:xfrm>
           <a:prstGeom prst="rect">
             <a:avLst/>
@@ -23955,7 +23955,7 @@
               </a:defRPr>
             </a:pPr>
             <a:r>
-              <a:t>•  Nominal transfer sequences reach their programmed endpoint</a:t>
+              <a:t>•  14 planar controls; largest checked gap error 4.28 nm</a:t>
             </a:r>
           </a:p>
           <a:p>
@@ -23971,7 +23971,7 @@
               </a:defRPr>
             </a:pPr>
             <a:r>
-              <a:t>•  Contact peaks and final pose remain step/iteration sensitive</a:t>
+              <a:t>•  10 endpoint sequences; two injected faults abort</a:t>
             </a:r>
           </a:p>
           <a:p>
@@ -23987,7 +23987,7 @@
               </a:defRPr>
             </a:pPr>
             <a:r>
-              <a:t>•  Independent B-rep checks detect payload/fork overlap</a:t>
+              <a:t>•  84 full-solid pose checks; residuals bounded at 1 µm</a:t>
             </a:r>
           </a:p>
           <a:p>
@@ -24003,7 +24003,7 @@
               </a:defRPr>
             </a:pPr>
             <a:r>
-              <a:t>•  No dynamic-clearance, precision or design-load acceptance</a:t>
+              <a:t>•  Final COM refinement changes 1.51 / 1.47 mm; no precision rating</a:t>
             </a:r>
           </a:p>
         </p:txBody>
@@ -24039,7 +24039,7 @@
               </a:defRPr>
             </a:pPr>
             <a:r>
-              <a:t>A completed simulation sequence does not establish a validated contact model or physical reliability.</a:t>
+              <a:t>Calibrated planar controls and sampled geometry do not establish continuous loaded clearance or hardware reliability.</a:t>
             </a:r>
           </a:p>
         </p:txBody>

</xml_diff>

<commit_message>
Synchronize release-reset geometry across academic and project editions
</commit_message>
<xml_diff>
--- a/university/final_review_2026_10_10/VOLLEY_Final_Review_2026-10-10.pptx
+++ b/university/final_review_2026_10_10/VOLLEY_Final_Review_2026-10-10.pptx
@@ -21387,7 +21387,7 @@
               </a:defRPr>
             </a:pPr>
             <a:r>
-              <a:t>Feeder handoff: checked nominal geometry, unresolved hardware</a:t>
+              <a:t>Feeder geometry includes exit release and empty reset</a:t>
             </a:r>
           </a:p>
         </p:txBody>
@@ -21459,7 +21459,7 @@
               </a:defRPr>
             </a:pPr>
             <a:r>
-              <a:t>UNSELECTED GEN6 RESEARCH</a:t>
+              <a:t>NATIVE GEOMETRY RESULTS</a:t>
             </a:r>
           </a:p>
         </p:txBody>
@@ -21495,7 +21495,7 @@
               </a:defRPr>
             </a:pPr>
             <a:r>
-              <a:t>FM06-R1 · separate Gen6 geometry study</a:t>
+              <a:t>FM07-R5 · separate Gen6 nominal geometry</a:t>
             </a:r>
           </a:p>
         </p:txBody>
@@ -21538,7 +21538,7 @@
       </p:sp>
       <p:pic>
         <p:nvPicPr>
-          <p:cNvPr id="9" name="Picture 8" descr="FM06_Technical_transfer.png"/>
+          <p:cNvPr id="9" name="Picture 8" descr="FM07_Technical_exit_open.png"/>
           <p:cNvPicPr>
             <a:picLocks noChangeAspect="1"/>
           </p:cNvPicPr>
@@ -21594,7 +21594,7 @@
               </a:defRPr>
             </a:pPr>
             <a:r>
-              <a:t>•  30 native/STEP assembly states; 70 checked part exchanges</a:t>
+              <a:t>•  46 cycle poses; 34 additional door-angle samples</a:t>
             </a:r>
           </a:p>
           <a:p>
@@ -21610,7 +21610,7 @@
               </a:defRPr>
             </a:pPr>
             <a:r>
-              <a:t>•  28 continuous prescribed rigid-translation phases</a:t>
+              <a:t>•  40 continuous prescribed linear sweeps</a:t>
             </a:r>
           </a:p>
           <a:p>
@@ -21626,7 +21626,7 @@
               </a:defRPr>
             </a:pPr>
             <a:r>
-              <a:t>•  Backstop junction corrected; closed surfaces checked</a:t>
+              <a:t>•  20 assembly STEP files; 74 checked individual parts</a:t>
             </a:r>
           </a:p>
           <a:p>
@@ -21642,7 +21642,7 @@
               </a:defRPr>
             </a:pPr>
             <a:r>
-              <a:t>•  Installed actuation, rail-end contacts and forward-stop release remain open</a:t>
+              <a:t>•  Loaded fits, installed actuation and seven-way downselect remain acceptance gates</a:t>
             </a:r>
           </a:p>
         </p:txBody>
@@ -21678,7 +21678,7 @@
               </a:defRPr>
             </a:pPr>
             <a:r>
-              <a:t>Blender Workbench render of actual native CAD. No manufactured mechanism, launch or qualification claim.</a:t>
+              <a:t>Blender Workbench render of actual native CAD. Prescribed geometry, not launch dynamics or hardware qualification.</a:t>
             </a:r>
           </a:p>
         </p:txBody>

</xml_diff>

<commit_message>
Adopt commanded electromagnetic deployment study title across academic editions
</commit_message>
<xml_diff>
--- a/university/final_review_2026_10_10/VOLLEY_Final_Review_2026-10-10.pptx
+++ b/university/final_review_2026_10_10/VOLLEY_Final_Review_2026-10-10.pptx
@@ -3251,7 +3251,7 @@
         <p:spPr>
           <a:xfrm>
             <a:off x="640080" y="1051560"/>
-            <a:ext cx="10908792" cy="475488"/>
+            <a:ext cx="10908792" cy="411480"/>
           </a:xfrm>
           <a:prstGeom prst="rect">
             <a:avLst/>
@@ -3265,7 +3265,7 @@
           <a:lstStyle/>
           <a:p>
             <a:pPr algn="ctr">
-              <a:defRPr sz="2900" b="1">
+              <a:defRPr sz="2500" b="1">
                 <a:solidFill>
                   <a:srgbClr val="234D81"/>
                 </a:solidFill>
@@ -3273,7 +3273,7 @@
               </a:defRPr>
             </a:pPr>
             <a:r>
-              <a:t>VOLLEY: Controlled CubeSat Deployment</a:t>
+              <a:t>VOLLEY: Design and Computational</a:t>
             </a:r>
           </a:p>
         </p:txBody>
@@ -3286,8 +3286,8 @@
         </p:nvSpPr>
         <p:spPr>
           <a:xfrm>
-            <a:off x="640080" y="1572768"/>
-            <a:ext cx="10908792" cy="457200"/>
+            <a:off x="640080" y="1527048"/>
+            <a:ext cx="10908792" cy="411480"/>
           </a:xfrm>
           <a:prstGeom prst="rect">
             <a:avLst/>
@@ -3301,7 +3301,7 @@
           <a:lstStyle/>
           <a:p>
             <a:pPr algn="ctr">
-              <a:defRPr sz="2700" b="1">
+              <a:defRPr sz="2500" b="1">
                 <a:solidFill>
                   <a:srgbClr val="234D81"/>
                 </a:solidFill>
@@ -3309,7 +3309,7 @@
               </a:defRPr>
             </a:pPr>
             <a:r>
-              <a:t>from a Hosted Orbital Platform</a:t>
+              <a:t>Feasibility Assessment of a Commanded</a:t>
             </a:r>
           </a:p>
         </p:txBody>
@@ -3322,8 +3322,8 @@
         </p:nvSpPr>
         <p:spPr>
           <a:xfrm>
-            <a:off x="1097280" y="2002536"/>
-            <a:ext cx="9994392" cy="329184"/>
+            <a:off x="640080" y="2002536"/>
+            <a:ext cx="10908792" cy="365760"/>
           </a:xfrm>
           <a:prstGeom prst="rect">
             <a:avLst/>
@@ -3337,7 +3337,7 @@
           <a:lstStyle/>
           <a:p>
             <a:pPr algn="ctr">
-              <a:defRPr sz="1700" b="1">
+              <a:defRPr sz="2300" b="1">
                 <a:solidFill>
                   <a:srgbClr val="234D81"/>
                 </a:solidFill>
@@ -3345,7 +3345,7 @@
               </a:defRPr>
             </a:pPr>
             <a:r>
-              <a:t>Gen5 computational feasibility review</a:t>
+              <a:t>Electromagnetic CubeSat Deployment Mechanism</a:t>
             </a:r>
           </a:p>
         </p:txBody>
@@ -3549,7 +3549,7 @@
               </a:defRPr>
             </a:pPr>
             <a:r>
-              <a:t>Review candidate: 20 October 2026</a:t>
+              <a:t>Review candidate: 21 October 2026</a:t>
             </a:r>
           </a:p>
         </p:txBody>

</xml_diff>

<commit_message>
Add common-boundary feeder CAD and verified computational study findings
</commit_message>
<xml_diff>
--- a/university/final_review_2026_10_10/VOLLEY_Final_Review_2026-10-10.pptx
+++ b/university/final_review_2026_10_10/VOLLEY_Final_Review_2026-10-10.pptx
@@ -19364,7 +19364,7 @@
               </a:defRPr>
             </a:pPr>
             <a:r>
-              <a:t>Seven feeder concepts: inspectable geometry, open hardware gates</a:t>
+              <a:t>Seven feeders on one four-payload comparison boundary</a:t>
             </a:r>
           </a:p>
         </p:txBody>
@@ -19472,7 +19472,7 @@
               </a:defRPr>
             </a:pPr>
             <a:r>
-              <a:t>Native FreeCAD / STEP · analytical cases / CalculiX fixture · 19 October</a:t>
+              <a:t>FDR09 · native FreeCAD / STEP and source-backed option screens · 22 October</a:t>
             </a:r>
           </a:p>
         </p:txBody>
@@ -19515,7 +19515,7 @@
       </p:sp>
       <p:pic>
         <p:nvPicPr>
-          <p:cNvPr id="9" name="Picture 8" descr="lead_screw_cad.png"/>
+          <p:cNvPr id="9" name="Picture 8" descr="comparison_mass.png"/>
           <p:cNvPicPr>
             <a:picLocks noChangeAspect="1"/>
           </p:cNvPicPr>
@@ -19529,8 +19529,8 @@
         </p:blipFill>
         <p:spPr>
           <a:xfrm>
-            <a:off x="548640" y="1636438"/>
-            <a:ext cx="7315200" cy="4133763"/>
+            <a:off x="457200" y="1953168"/>
+            <a:ext cx="7315199" cy="3500303"/>
           </a:xfrm>
           <a:prstGeom prst="rect">
             <a:avLst/>
@@ -19561,9 +19561,9 @@
           <a:p>
             <a:pPr>
               <a:spcAft>
-                <a:spcPts val="2000"/>
+                <a:spcPts val="1600"/>
               </a:spcAft>
-              <a:defRPr sz="1800">
+              <a:defRPr sz="1700">
                 <a:solidFill>
                   <a:srgbClr val="1E3144"/>
                 </a:solidFill>
@@ -19571,15 +19571,15 @@
               </a:defRPr>
             </a:pPr>
             <a:r>
-              <a:t>•  1U/3U CAD and bounded motion checks</a:t>
+              <a:t>•  Two 1U + two 3U; one shared receiver</a:t>
             </a:r>
           </a:p>
           <a:p>
             <a:pPr>
               <a:spcAft>
-                <a:spcPts val="2000"/>
+                <a:spcPts val="1600"/>
               </a:spcAft>
-              <a:defRPr sz="1800">
+              <a:defRPr sz="1700">
                 <a:solidFill>
                   <a:srgbClr val="1E3144"/>
                 </a:solidFill>
@@ -19587,15 +19587,15 @@
               </a:defRPr>
             </a:pPr>
             <a:r>
-              <a:t>•  Load, tolerance and fault cases retained</a:t>
+              <a:t>•  Seven concepts; ten checked native/STEP pairs</a:t>
             </a:r>
           </a:p>
           <a:p>
             <a:pPr>
               <a:spcAft>
-                <a:spcPts val="2000"/>
+                <a:spcPts val="1600"/>
               </a:spcAft>
-              <a:defRPr sz="1800">
+              <a:defRPr sz="1700">
                 <a:solidFill>
                   <a:srgbClr val="1E3144"/>
                 </a:solidFill>
@@ -19603,15 +19603,15 @@
               </a:defRPr>
             </a:pPr>
             <a:r>
-              <a:t>•  Arrest-tooth sizing fails adverse cases</a:t>
+              <a:t>•  Separate R2 nominal payload sweep: eight collisions to zero</a:t>
             </a:r>
           </a:p>
           <a:p>
             <a:pPr>
               <a:spcAft>
-                <a:spcPts val="2000"/>
+                <a:spcPts val="1600"/>
               </a:spcAft>
-              <a:defRPr sz="1800">
+              <a:defRPr sz="1700">
                 <a:solidFill>
                   <a:srgbClr val="1E3144"/>
                 </a:solidFill>
@@ -19619,15 +19619,15 @@
               </a:defRPr>
             </a:pPr>
             <a:r>
-              <a:t>•  Handoff, latch engagement and installed parts unverified</a:t>
+              <a:t>•  Full installed mass, loaded support and custody remain unverified</a:t>
             </a:r>
           </a:p>
           <a:p>
             <a:pPr>
               <a:spcAft>
-                <a:spcPts val="2000"/>
+                <a:spcPts val="1600"/>
               </a:spcAft>
-              <a:defRPr sz="1800">
+              <a:defRPr sz="1700">
                 <a:solidFill>
                   <a:srgbClr val="1E3144"/>
                 </a:solidFill>
@@ -19635,7 +19635,7 @@
               </a:defRPr>
             </a:pPr>
             <a:r>
-              <a:t>•  No baseline selection or hardware release</a:t>
+              <a:t>•  No eligible architecture selection</a:t>
             </a:r>
           </a:p>
         </p:txBody>
@@ -19663,7 +19663,7 @@
           <a:lstStyle/>
           <a:p>
             <a:pPr algn="l">
-              <a:defRPr sz="1400" b="0">
+              <a:defRPr sz="1300" b="0">
                 <a:solidFill>
                   <a:srgbClr val="1E3144"/>
                 </a:solidFill>
@@ -19671,7 +19671,7 @@
               </a:defRPr>
             </a:pPr>
             <a:r>
-              <a:t>STEP-derived orthographic view; no measured reliability or full-cycle qualification.</a:t>
+              <a:t>CAD material and unintegrated catalog options are partial accounting; no mass ranking or hardware qualification.</a:t>
             </a:r>
           </a:p>
         </p:txBody>
@@ -21387,7 +21387,7 @@
               </a:defRPr>
             </a:pPr>
             <a:r>
-              <a:t>Feeder geometry includes exit release and empty reset</a:t>
+              <a:t>Gate relief passes the complete-angle nominal screen</a:t>
             </a:r>
           </a:p>
         </p:txBody>
@@ -21495,7 +21495,7 @@
               </a:defRPr>
             </a:pPr>
             <a:r>
-              <a:t>FM07-R5 · separate Gen6 nominal geometry</a:t>
+              <a:t>RVC01 · FM07-R6 candidate; separate from evaluated Gen5</a:t>
             </a:r>
           </a:p>
         </p:txBody>
@@ -21538,7 +21538,7 @@
       </p:sp>
       <p:pic>
         <p:nvPicPr>
-          <p:cNvPr id="9" name="Picture 8" descr="FM07_Technical_exit_open.png"/>
+          <p:cNvPr id="9" name="Picture 8" descr="rotary_clearance.png"/>
           <p:cNvPicPr>
             <a:picLocks noChangeAspect="1"/>
           </p:cNvPicPr>
@@ -21552,8 +21552,8 @@
         </p:blipFill>
         <p:spPr>
           <a:xfrm>
-            <a:off x="900683" y="1417320"/>
-            <a:ext cx="6336792" cy="4526280"/>
+            <a:off x="411480" y="2512060"/>
+            <a:ext cx="7315200" cy="2519680"/>
           </a:xfrm>
           <a:prstGeom prst="rect">
             <a:avLst/>
@@ -21594,7 +21594,7 @@
               </a:defRPr>
             </a:pPr>
             <a:r>
-              <a:t>•  46 cycle poses; 34 additional door-angle samples</a:t>
+              <a:t>•  Panel lower edge relieved by 0.25 mm</a:t>
             </a:r>
           </a:p>
           <a:p>
@@ -21610,7 +21610,7 @@
               </a:defRPr>
             </a:pPr>
             <a:r>
-              <a:t>•  40 continuous prescribed linear sweeps</a:t>
+              <a:t>•  Four full opening/closing intervals checked</a:t>
             </a:r>
           </a:p>
           <a:p>
@@ -21626,7 +21626,7 @@
               </a:defRPr>
             </a:pPr>
             <a:r>
-              <a:t>•  20 assembly STEP files; 74 checked individual parts</a:t>
+              <a:t>•  Eight assembly and two gate STEP readbacks</a:t>
             </a:r>
           </a:p>
           <a:p>
@@ -21642,7 +21642,7 @@
               </a:defRPr>
             </a:pPr>
             <a:r>
-              <a:t>•  Loaded fits, installed actuation and seven-way downselect remain acceptance gates</a:t>
+              <a:t>•  Nominal numerical bound; loaded fit and actuation remain separate</a:t>
             </a:r>
           </a:p>
         </p:txBody>
@@ -21678,7 +21678,7 @@
               </a:defRPr>
             </a:pPr>
             <a:r>
-              <a:t>Blender Workbench render of actual native CAD. Prescribed geometry, not launch dynamics or hardware qualification.</a:t>
+              <a:t>Smallest guarded bound: 0.0098846 mm. No manufactured-clearance, contact-convergence or qualification claim.</a:t>
             </a:r>
           </a:p>
         </p:txBody>
@@ -23748,7 +23748,7 @@
               </a:defRPr>
             </a:pPr>
             <a:r>
-              <a:t>Contact representation: calibrated controls, sensitive final pose</a:t>
+              <a:t>Contact diagnosis retains the numerical acceptance criteria</a:t>
             </a:r>
           </a:p>
         </p:txBody>
@@ -23856,7 +23856,7 @@
               </a:defRPr>
             </a:pPr>
             <a:r>
-              <a:t>FCE12 · Project Chrono 10.0.0; 12 captured cases</a:t>
+              <a:t>FCE13 · FM06-R1; six additional completed native Chrono cases</a:t>
             </a:r>
           </a:p>
         </p:txBody>
@@ -23899,7 +23899,7 @@
       </p:sp>
       <p:pic>
         <p:nvPicPr>
-          <p:cNvPr id="9" name="Picture 8" descr="contact_calibration.png"/>
+          <p:cNvPr id="9" name="Picture 8" descr="convergence_publication.png"/>
           <p:cNvPicPr>
             <a:picLocks noChangeAspect="1"/>
           </p:cNvPicPr>
@@ -23913,8 +23913,8 @@
         </p:blipFill>
         <p:spPr>
           <a:xfrm>
-            <a:off x="457199" y="2257044"/>
-            <a:ext cx="7132320" cy="2892552"/>
+            <a:off x="411480" y="2219960"/>
+            <a:ext cx="7315200" cy="2692400"/>
           </a:xfrm>
           <a:prstGeom prst="rect">
             <a:avLst/>
@@ -23929,7 +23929,7 @@
         </p:nvSpPr>
         <p:spPr>
           <a:xfrm>
-            <a:off x="7909560" y="1645920"/>
+            <a:off x="7955279" y="1645920"/>
             <a:ext cx="3657600" cy="4206240"/>
           </a:xfrm>
           <a:prstGeom prst="rect">
@@ -23955,7 +23955,7 @@
               </a:defRPr>
             </a:pPr>
             <a:r>
-              <a:t>•  14 planar controls; largest checked gap error 4.28 nm</a:t>
+              <a:t>•  Instrumented baseline reproduced byte for byte</a:t>
             </a:r>
           </a:p>
           <a:p>
@@ -23971,7 +23971,7 @@
               </a:defRPr>
             </a:pPr>
             <a:r>
-              <a:t>•  10 endpoint sequences; two injected faults abort</a:t>
+              <a:t>•  PSOR, BB and exact-box refinements exceed pose limits</a:t>
             </a:r>
           </a:p>
           <a:p>
@@ -23987,7 +23987,7 @@
               </a:defRPr>
             </a:pPr>
             <a:r>
-              <a:t>•  84 full-solid pose checks; residuals bounded at 1 µm</a:t>
+              <a:t>•  Sensitivity develops during feed deceleration</a:t>
             </a:r>
           </a:p>
           <a:p>
@@ -24003,7 +24003,7 @@
               </a:defRPr>
             </a:pPr>
             <a:r>
-              <a:t>•  Final COM refinement changes 1.51 / 1.47 mm; no precision rating</a:t>
+              <a:t>•  No qualified correction or contact-force rating</a:t>
             </a:r>
           </a:p>
         </p:txBody>
@@ -24039,7 +24039,7 @@
               </a:defRPr>
             </a:pPr>
             <a:r>
-              <a:t>Calibrated planar controls and sampled geometry do not establish continuous loaded clearance or hardware reliability.</a:t>
+              <a:t>Nominal FM07-R6 rotary screens pass separately; FM06 contact results do not validate that revised assembly.</a:t>
             </a:r>
           </a:p>
         </p:txBody>

</xml_diff>

<commit_message>
Select guided feeder and release reproducible academic evidence
</commit_message>
<xml_diff>
--- a/university/final_review_2026_10_10/VOLLEY_Final_Review_2026-10-10.pptx
+++ b/university/final_review_2026_10_10/VOLLEY_Final_Review_2026-10-10.pptx
@@ -3549,7 +3549,7 @@
               </a:defRPr>
             </a:pPr>
             <a:r>
-              <a:t>Review candidate: 21 October 2026</a:t>
+              <a:t>Final review: 31 October 2026</a:t>
             </a:r>
           </a:p>
         </p:txBody>
@@ -13604,7 +13604,7 @@
               </a:defRPr>
             </a:pPr>
             <a:r>
-              <a:t>Gen6 has a testable mission, but no selected article</a:t>
+              <a:t>Commanded release trades host propellant against device burden</a:t>
             </a:r>
           </a:p>
         </p:txBody>
@@ -13640,7 +13640,7 @@
               </a:defRPr>
             </a:pPr>
             <a:r>
-              <a:t>FUTURE WORK</a:t>
+              <a:t>GEN6 MISSION STUDY</a:t>
             </a:r>
           </a:p>
         </p:txBody>
@@ -13676,7 +13676,7 @@
               </a:defRPr>
             </a:pPr>
             <a:r>
-              <a:t>GEN6 SCREEN • NOT ACHIEVED</a:t>
+              <a:t>CONDITIONAL RESOURCE STUDY</a:t>
             </a:r>
           </a:p>
         </p:txBody>
@@ -13712,7 +13712,7 @@
               </a:defRPr>
             </a:pPr>
             <a:r>
-              <a:t>P130 matched four-release J2 screen; P131–P132 first-article bounds</a:t>
+              <a:t>FBR-02 · selected-feeder mass retarget and 26 native Orekit replays</a:t>
             </a:r>
           </a:p>
         </p:txBody>
@@ -13755,7 +13755,7 @@
       </p:sp>
       <p:pic>
         <p:nvPicPr>
-          <p:cNvPr id="9" name="Picture 8" descr="gen6_matched_campaign.png"/>
+          <p:cNvPr id="9" name="Picture 8" descr="mission_mass_sensitivity.png"/>
           <p:cNvPicPr>
             <a:picLocks noChangeAspect="1"/>
           </p:cNvPicPr>
@@ -13769,8 +13769,8 @@
         </p:blipFill>
         <p:spPr>
           <a:xfrm>
-            <a:off x="438912" y="2260854"/>
-            <a:ext cx="6675120" cy="2336291"/>
+            <a:off x="438912" y="2053990"/>
+            <a:ext cx="6675120" cy="3024339"/>
           </a:xfrm>
           <a:prstGeom prst="rect">
             <a:avLst/>
@@ -13888,7 +13888,7 @@
           <a:lstStyle/>
           <a:p>
             <a:pPr algn="l">
-              <a:defRPr sz="1800" b="1">
+              <a:defRPr sz="2100" b="1">
                 <a:solidFill>
                   <a:srgbClr val="0D2035"/>
                 </a:solidFill>
@@ -13896,7 +13896,7 @@
               </a:defRPr>
             </a:pPr>
             <a:r>
-              <a:t>Matched mission</a:t>
+              <a:t>4.04 / 12.82 kg</a:t>
             </a:r>
           </a:p>
         </p:txBody>
@@ -13932,7 +13932,7 @@
               </a:defRPr>
             </a:pPr>
             <a:r>
-              <a:t>Two 1U + two 3U targets: both release choices reach ideal states. Assumed device + fuel favors springs by 10.72 kg.</a:t>
+              <a:t>Less propellant for four / twelve releases at the central allowance, compared with lowest-consumption tested springs.</a:t>
             </a:r>
           </a:p>
         </p:txBody>
@@ -13997,7 +13997,7 @@
             <a:avLst/>
           </a:prstGeom>
           <a:solidFill>
-            <a:srgbClr val="B94141"/>
+            <a:srgbClr val="D78F2B"/>
           </a:solidFill>
           <a:ln>
             <a:noFill/>
@@ -14048,7 +14048,7 @@
           <a:lstStyle/>
           <a:p>
             <a:pPr algn="l">
-              <a:defRPr sz="1800" b="1">
+              <a:defRPr sz="2000" b="1">
                 <a:solidFill>
                   <a:srgbClr val="0D2035"/>
                 </a:solidFill>
@@ -14056,7 +14056,7 @@
               </a:defRPr>
             </a:pPr>
             <a:r>
-              <a:t>First-article gap</a:t>
+              <a:t>Dry burden is larger</a:t>
             </a:r>
           </a:p>
         </p:txBody>
@@ -14092,7 +14092,7 @@
               </a:defRPr>
             </a:pPr>
             <a:r>
-              <a:t>Two STEP envelopes exist; ~9.35 kg remains for all omitted hardware under a surrogate parity screen.</a:t>
+              <a:t>38.84 / 60.33 kg added device mass exceeds the propellant-use reduction. No installed-mass advantage established.</a:t>
             </a:r>
           </a:p>
         </p:txBody>
@@ -14105,7 +14105,7 @@
         </p:nvSpPr>
         <p:spPr>
           <a:xfrm>
-            <a:off x="822960" y="5806440"/>
+            <a:off x="822960" y="5897880"/>
             <a:ext cx="10561320" cy="393192"/>
           </a:xfrm>
           <a:prstGeom prst="rect">
@@ -14120,7 +14120,7 @@
           <a:lstStyle/>
           <a:p>
             <a:pPr algn="ctr">
-              <a:defRPr sz="1500" b="1">
+              <a:defRPr sz="1400" b="1">
                 <a:solidFill>
                   <a:srgbClr val="0D2035"/>
                 </a:solidFill>
@@ -14128,7 +14128,7 @@
               </a:defRPr>
             </a:pPr>
             <a:r>
-              <a:t>1 km/s remains separate long-range research; no command range or motor rating established.</a:t>
+              <a:t>Imposed 3–6 m/s release; no achieved motor rating. Spring alternatives may use longer maneuver windows.</a:t>
             </a:r>
           </a:p>
         </p:txBody>
@@ -14270,7 +14270,7 @@
               </a:defRPr>
             </a:pPr>
             <a:r>
-              <a:t>Paired cells improve the nominal acceleration path</a:t>
+              <a:t>A guided lead screw controls each cassette transfer</a:t>
             </a:r>
           </a:p>
         </p:txBody>
@@ -14306,7 +14306,7 @@
               </a:defRPr>
             </a:pPr>
             <a:r>
-              <a:t>FUTURE WORK</a:t>
+              <a:t>GEN6 SELECTED DESIGN</a:t>
             </a:r>
           </a:p>
         </p:txBody>
@@ -14342,7 +14342,7 @@
               </a:defRPr>
             </a:pPr>
             <a:r>
-              <a:t>GEN6 GEOMETRY • UNSELECTED</a:t>
+              <a:t>SELECTED ACADEMIC DESIGN</a:t>
             </a:r>
           </a:p>
         </p:txBody>
@@ -14378,7 +14378,7 @@
               </a:defRPr>
             </a:pPr>
             <a:r>
-              <a:t>FreeCAD/STEP R0 packaging comparison; no feeder mechanism selected</a:t>
+              <a:t>FM08-R3 · native CAD / STEP and FDR10 design verification · 23 October</a:t>
             </a:r>
           </a:p>
         </p:txBody>
@@ -14421,7 +14421,7 @@
       </p:sp>
       <p:pic>
         <p:nvPicPr>
-          <p:cNvPr id="9" name="Picture 8" descr="Four_Cell_R0_Plan.png"/>
+          <p:cNvPr id="9" name="Picture 8" descr="FM08_sequence.png"/>
           <p:cNvPicPr>
             <a:picLocks noChangeAspect="1"/>
           </p:cNvPicPr>
@@ -14435,8 +14435,8 @@
         </p:blipFill>
         <p:spPr>
           <a:xfrm>
-            <a:off x="475488" y="1991281"/>
-            <a:ext cx="7315200" cy="3094892"/>
+            <a:off x="1588370" y="1463040"/>
+            <a:ext cx="4997994" cy="4434840"/>
           </a:xfrm>
           <a:prstGeom prst="rect">
             <a:avLst/>
@@ -14445,116 +14445,131 @@
       </p:pic>
       <p:sp>
         <p:nvSpPr>
-          <p:cNvPr id="10" name="Rounded Rectangle 9"/>
-          <p:cNvSpPr/>
-          <p:nvPr/>
-        </p:nvSpPr>
-        <p:spPr>
-          <a:xfrm>
-            <a:off x="7973568" y="1627632"/>
-            <a:ext cx="3584448" cy="1618488"/>
-          </a:xfrm>
-          <a:prstGeom prst="roundRect">
-            <a:avLst/>
-          </a:prstGeom>
-          <a:solidFill>
-            <a:srgbClr val="F6F9FB"/>
-          </a:solidFill>
-          <a:ln>
-            <a:solidFill>
-              <a:srgbClr val="DDE7EC"/>
-            </a:solidFill>
-          </a:ln>
-        </p:spPr>
-        <p:style>
-          <a:lnRef idx="1">
-            <a:schemeClr val="accent1"/>
-          </a:lnRef>
-          <a:fillRef idx="3">
-            <a:schemeClr val="accent1"/>
-          </a:fillRef>
-          <a:effectRef idx="2">
-            <a:schemeClr val="accent1"/>
-          </a:effectRef>
-          <a:fontRef idx="minor">
-            <a:schemeClr val="lt1"/>
-          </a:fontRef>
-        </p:style>
-        <p:txBody>
-          <a:bodyPr rtlCol="0" anchor="ctr"/>
-          <a:lstStyle/>
-          <a:p>
-            <a:pPr algn="ctr"/>
-          </a:p>
-        </p:txBody>
-      </p:sp>
-      <p:sp>
-        <p:nvSpPr>
-          <p:cNvPr id="11" name="Rectangle 10"/>
-          <p:cNvSpPr/>
-          <p:nvPr/>
-        </p:nvSpPr>
-        <p:spPr>
-          <a:xfrm>
-            <a:off x="7973568" y="1627632"/>
-            <a:ext cx="73152" cy="1618488"/>
-          </a:xfrm>
-          <a:prstGeom prst="rect">
-            <a:avLst/>
-          </a:prstGeom>
-          <a:solidFill>
-            <a:srgbClr val="B94141"/>
-          </a:solidFill>
-          <a:ln>
-            <a:noFill/>
-          </a:ln>
-        </p:spPr>
-        <p:style>
-          <a:lnRef idx="1">
-            <a:schemeClr val="accent1"/>
-          </a:lnRef>
-          <a:fillRef idx="3">
-            <a:schemeClr val="accent1"/>
-          </a:fillRef>
-          <a:effectRef idx="2">
-            <a:schemeClr val="accent1"/>
-          </a:effectRef>
-          <a:fontRef idx="minor">
-            <a:schemeClr val="lt1"/>
-          </a:fontRef>
-        </p:style>
-        <p:txBody>
-          <a:bodyPr rtlCol="0" anchor="ctr"/>
-          <a:lstStyle/>
-          <a:p>
-            <a:pPr algn="ctr"/>
-          </a:p>
-        </p:txBody>
-      </p:sp>
-      <p:sp>
-        <p:nvSpPr>
-          <p:cNvPr id="12" name="TextBox 11"/>
-          <p:cNvSpPr txBox="1"/>
-          <p:nvPr/>
-        </p:nvSpPr>
-        <p:spPr>
-          <a:xfrm>
-            <a:off x="8183880" y="1773936"/>
-            <a:ext cx="3218688" cy="502920"/>
-          </a:xfrm>
-          <a:prstGeom prst="rect">
-            <a:avLst/>
-          </a:prstGeom>
-          <a:noFill/>
-        </p:spPr>
-        <p:txBody>
-          <a:bodyPr wrap="square" lIns="13716" rIns="13716" tIns="13716" bIns="13716" anchor="t">
-            <a:spAutoFit/>
-          </a:bodyPr>
-          <a:lstStyle/>
-          <a:p>
-            <a:pPr algn="l">
-              <a:defRPr sz="1700" b="1">
+          <p:cNvPr id="10" name="TextBox 9"/>
+          <p:cNvSpPr txBox="1"/>
+          <p:nvPr/>
+        </p:nvSpPr>
+        <p:spPr>
+          <a:xfrm>
+            <a:off x="8001000" y="1627632"/>
+            <a:ext cx="3566160" cy="4251960"/>
+          </a:xfrm>
+          <a:prstGeom prst="rect">
+            <a:avLst/>
+          </a:prstGeom>
+          <a:noFill/>
+        </p:spPr>
+        <p:txBody>
+          <a:bodyPr wrap="square" lIns="73152" rIns="73152" tIns="36576" bIns="0">
+            <a:spAutoFit/>
+          </a:bodyPr>
+          <a:lstStyle/>
+          <a:p>
+            <a:pPr>
+              <a:spcAft>
+                <a:spcPts val="1600"/>
+              </a:spcAft>
+              <a:defRPr sz="1700">
+                <a:solidFill>
+                  <a:srgbClr val="1E3144"/>
+                </a:solidFill>
+                <a:latin typeface="Aptos"/>
+              </a:defRPr>
+            </a:pPr>
+            <a:r>
+              <a:t>•  Two 1U + two 3U; one indexed receiver</a:t>
+            </a:r>
+          </a:p>
+          <a:p>
+            <a:pPr>
+              <a:spcAft>
+                <a:spcPts val="1600"/>
+              </a:spcAft>
+              <a:defRPr sz="1700">
+                <a:solidFill>
+                  <a:srgbClr val="1E3144"/>
+                </a:solidFill>
+                <a:latin typeface="Aptos"/>
+              </a:defRPr>
+            </a:pPr>
+            <a:r>
+              <a:t>•  Fixed 1U spacers stay in their cassettes</a:t>
+            </a:r>
+          </a:p>
+          <a:p>
+            <a:pPr>
+              <a:spcAft>
+                <a:spcPts val="1600"/>
+              </a:spcAft>
+              <a:defRPr sz="1700">
+                <a:solidFill>
+                  <a:srgbClr val="1E3144"/>
+                </a:solidFill>
+                <a:latin typeface="Aptos"/>
+              </a:defRPr>
+            </a:pPr>
+            <a:r>
+              <a:t>•  Far stop proved → feed → seating proof → capture</a:t>
+            </a:r>
+          </a:p>
+          <a:p>
+            <a:pPr>
+              <a:spcAft>
+                <a:spcPts val="1600"/>
+              </a:spcAft>
+              <a:defRPr sz="1700">
+                <a:solidFill>
+                  <a:srgbClr val="1E3144"/>
+                </a:solidFill>
+                <a:latin typeface="Aptos"/>
+              </a:defRPr>
+            </a:pPr>
+            <a:r>
+              <a:t>•  Index clutch disengaged before launch arming</a:t>
+            </a:r>
+          </a:p>
+          <a:p>
+            <a:pPr>
+              <a:spcAft>
+                <a:spcPts val="1600"/>
+              </a:spcAft>
+              <a:defRPr sz="1700">
+                <a:solidFill>
+                  <a:srgbClr val="1E3144"/>
+                </a:solidFill>
+                <a:latin typeface="Aptos"/>
+              </a:defRPr>
+            </a:pPr>
+            <a:r>
+              <a:t>•  Release inhibited on jam, power loss or contradictory state</a:t>
+            </a:r>
+          </a:p>
+        </p:txBody>
+      </p:sp>
+      <p:sp>
+        <p:nvSpPr>
+          <p:cNvPr id="11" name="TextBox 10"/>
+          <p:cNvSpPr txBox="1"/>
+          <p:nvPr/>
+        </p:nvSpPr>
+        <p:spPr>
+          <a:xfrm>
+            <a:off x="658368" y="6099048"/>
+            <a:ext cx="10927080" cy="310896"/>
+          </a:xfrm>
+          <a:prstGeom prst="rect">
+            <a:avLst/>
+          </a:prstGeom>
+          <a:noFill/>
+        </p:spPr>
+        <p:txBody>
+          <a:bodyPr wrap="square" lIns="13716" rIns="13716" tIns="13716" bIns="13716" anchor="t">
+            <a:spAutoFit/>
+          </a:bodyPr>
+          <a:lstStyle/>
+          <a:p>
+            <a:pPr algn="ctr">
+              <a:defRPr sz="1200" b="1">
                 <a:solidFill>
                   <a:srgbClr val="0D2035"/>
                 </a:solidFill>
@@ -14562,239 +14577,7 @@
               </a:defRPr>
             </a:pPr>
             <a:r>
-              <a:t>Staggered</a:t>
-            </a:r>
-          </a:p>
-        </p:txBody>
-      </p:sp>
-      <p:sp>
-        <p:nvSpPr>
-          <p:cNvPr id="13" name="TextBox 12"/>
-          <p:cNvSpPr txBox="1"/>
-          <p:nvPr/>
-        </p:nvSpPr>
-        <p:spPr>
-          <a:xfrm>
-            <a:off x="8183880" y="2377440"/>
-            <a:ext cx="3200400" cy="704088"/>
-          </a:xfrm>
-          <a:prstGeom prst="rect">
-            <a:avLst/>
-          </a:prstGeom>
-          <a:noFill/>
-        </p:spPr>
-        <p:txBody>
-          <a:bodyPr wrap="square" lIns="13716" rIns="13716" tIns="13716" bIns="13716" anchor="t">
-            <a:spAutoFit/>
-          </a:bodyPr>
-          <a:lstStyle/>
-          <a:p>
-            <a:pPr algn="l">
-              <a:defRPr sz="1400" b="0">
-                <a:solidFill>
-                  <a:srgbClr val="1E3144"/>
-                </a:solidFill>
-                <a:latin typeface="Aptos"/>
-              </a:defRPr>
-            </a:pPr>
-            <a:r>
-              <a:t>Last cell: 330 mm to brake; 5.56 g ideal mean for 6 m/s.</a:t>
-            </a:r>
-          </a:p>
-        </p:txBody>
-      </p:sp>
-      <p:sp>
-        <p:nvSpPr>
-          <p:cNvPr id="14" name="Rounded Rectangle 13"/>
-          <p:cNvSpPr/>
-          <p:nvPr/>
-        </p:nvSpPr>
-        <p:spPr>
-          <a:xfrm>
-            <a:off x="7973568" y="3419856"/>
-            <a:ext cx="3584448" cy="1618488"/>
-          </a:xfrm>
-          <a:prstGeom prst="roundRect">
-            <a:avLst/>
-          </a:prstGeom>
-          <a:solidFill>
-            <a:srgbClr val="F6F9FB"/>
-          </a:solidFill>
-          <a:ln>
-            <a:solidFill>
-              <a:srgbClr val="DDE7EC"/>
-            </a:solidFill>
-          </a:ln>
-        </p:spPr>
-        <p:style>
-          <a:lnRef idx="1">
-            <a:schemeClr val="accent1"/>
-          </a:lnRef>
-          <a:fillRef idx="3">
-            <a:schemeClr val="accent1"/>
-          </a:fillRef>
-          <a:effectRef idx="2">
-            <a:schemeClr val="accent1"/>
-          </a:effectRef>
-          <a:fontRef idx="minor">
-            <a:schemeClr val="lt1"/>
-          </a:fontRef>
-        </p:style>
-        <p:txBody>
-          <a:bodyPr rtlCol="0" anchor="ctr"/>
-          <a:lstStyle/>
-          <a:p>
-            <a:pPr algn="ctr"/>
-          </a:p>
-        </p:txBody>
-      </p:sp>
-      <p:sp>
-        <p:nvSpPr>
-          <p:cNvPr id="15" name="Rectangle 14"/>
-          <p:cNvSpPr/>
-          <p:nvPr/>
-        </p:nvSpPr>
-        <p:spPr>
-          <a:xfrm>
-            <a:off x="7973568" y="3419856"/>
-            <a:ext cx="73152" cy="1618488"/>
-          </a:xfrm>
-          <a:prstGeom prst="rect">
-            <a:avLst/>
-          </a:prstGeom>
-          <a:solidFill>
-            <a:srgbClr val="0096A0"/>
-          </a:solidFill>
-          <a:ln>
-            <a:noFill/>
-          </a:ln>
-        </p:spPr>
-        <p:style>
-          <a:lnRef idx="1">
-            <a:schemeClr val="accent1"/>
-          </a:lnRef>
-          <a:fillRef idx="3">
-            <a:schemeClr val="accent1"/>
-          </a:fillRef>
-          <a:effectRef idx="2">
-            <a:schemeClr val="accent1"/>
-          </a:effectRef>
-          <a:fontRef idx="minor">
-            <a:schemeClr val="lt1"/>
-          </a:fontRef>
-        </p:style>
-        <p:txBody>
-          <a:bodyPr rtlCol="0" anchor="ctr"/>
-          <a:lstStyle/>
-          <a:p>
-            <a:pPr algn="ctr"/>
-          </a:p>
-        </p:txBody>
-      </p:sp>
-      <p:sp>
-        <p:nvSpPr>
-          <p:cNvPr id="16" name="TextBox 15"/>
-          <p:cNvSpPr txBox="1"/>
-          <p:nvPr/>
-        </p:nvSpPr>
-        <p:spPr>
-          <a:xfrm>
-            <a:off x="8183880" y="3566160"/>
-            <a:ext cx="3218688" cy="502920"/>
-          </a:xfrm>
-          <a:prstGeom prst="rect">
-            <a:avLst/>
-          </a:prstGeom>
-          <a:noFill/>
-        </p:spPr>
-        <p:txBody>
-          <a:bodyPr wrap="square" lIns="13716" rIns="13716" tIns="13716" bIns="13716" anchor="t">
-            <a:spAutoFit/>
-          </a:bodyPr>
-          <a:lstStyle/>
-          <a:p>
-            <a:pPr algn="l">
-              <a:defRPr sz="1700" b="1">
-                <a:solidFill>
-                  <a:srgbClr val="0D2035"/>
-                </a:solidFill>
-                <a:latin typeface="Aptos"/>
-              </a:defRPr>
-            </a:pPr>
-            <a:r>
-              <a:t>Paired</a:t>
-            </a:r>
-          </a:p>
-        </p:txBody>
-      </p:sp>
-      <p:sp>
-        <p:nvSpPr>
-          <p:cNvPr id="17" name="TextBox 16"/>
-          <p:cNvSpPr txBox="1"/>
-          <p:nvPr/>
-        </p:nvSpPr>
-        <p:spPr>
-          <a:xfrm>
-            <a:off x="8183880" y="4169664"/>
-            <a:ext cx="3200400" cy="704088"/>
-          </a:xfrm>
-          <a:prstGeom prst="rect">
-            <a:avLst/>
-          </a:prstGeom>
-          <a:noFill/>
-        </p:spPr>
-        <p:txBody>
-          <a:bodyPr wrap="square" lIns="13716" rIns="13716" tIns="13716" bIns="13716" anchor="t">
-            <a:spAutoFit/>
-          </a:bodyPr>
-          <a:lstStyle/>
-          <a:p>
-            <a:pPr algn="l">
-              <a:defRPr sz="1400" b="0">
-                <a:solidFill>
-                  <a:srgbClr val="1E3144"/>
-                </a:solidFill>
-                <a:latin typeface="Aptos"/>
-              </a:defRPr>
-            </a:pPr>
-            <a:r>
-              <a:t>At least 900 mm per cell; 2.04 g largest ideal mean at 6 m/s.</a:t>
-            </a:r>
-          </a:p>
-        </p:txBody>
-      </p:sp>
-      <p:sp>
-        <p:nvSpPr>
-          <p:cNvPr id="18" name="TextBox 17"/>
-          <p:cNvSpPr txBox="1"/>
-          <p:nvPr/>
-        </p:nvSpPr>
-        <p:spPr>
-          <a:xfrm>
-            <a:off x="731520" y="5788152"/>
-            <a:ext cx="10881360" cy="457200"/>
-          </a:xfrm>
-          <a:prstGeom prst="rect">
-            <a:avLst/>
-          </a:prstGeom>
-          <a:noFill/>
-        </p:spPr>
-        <p:txBody>
-          <a:bodyPr wrap="square" lIns="13716" rIns="13716" tIns="13716" bIns="13716" anchor="t">
-            <a:spAutoFit/>
-          </a:bodyPr>
-          <a:lstStyle/>
-          <a:p>
-            <a:pPr algn="ctr">
-              <a:defRPr sz="1300" b="1">
-                <a:solidFill>
-                  <a:srgbClr val="0D2035"/>
-                </a:solidFill>
-                <a:latin typeface="Aptos"/>
-              </a:defRPr>
-            </a:pPr>
-            <a:r>
-              <a:t>26 nominal FreeCAD/STEP states pass represented-solid checks; locks, contact, docking and host fit remain open.</a:t>
+              <a:t>Source-derived prescribed CAD states. Academic design selection; measured reliability and qualification require hardware.</a:t>
             </a:r>
           </a:p>
         </p:txBody>
@@ -14936,7 +14719,7 @@
               </a:defRPr>
             </a:pPr>
             <a:r>
-              <a:t>Next milestone: close G0 and G1 before any build</a:t>
+              <a:t>Next phase: instrument and test the selected design</a:t>
             </a:r>
           </a:p>
         </p:txBody>
@@ -15008,7 +14791,7 @@
               </a:defRPr>
             </a:pPr>
             <a:r>
-              <a:t>GEN6 PLAN • NOT ACHIEVED</a:t>
+              <a:t>PHYSICAL DEVELOPMENT</a:t>
             </a:r>
           </a:p>
         </p:txBody>
@@ -15044,7 +14827,7 @@
               </a:defRPr>
             </a:pPr>
             <a:r>
-              <a:t>P130–P132; G0/G1 review gates; no construction authorization</a:t>
+              <a:t>Selected FM08-R3 design; physical development and provider integration</a:t>
             </a:r>
           </a:p>
         </p:txBody>
@@ -15159,7 +14942,7 @@
               </a:defRPr>
             </a:pPr>
             <a:r>
-              <a:t>Specify</a:t>
+              <a:t>Integrate</a:t>
             </a:r>
           </a:p>
         </p:txBody>
@@ -15238,7 +15021,7 @@
               </a:defRPr>
             </a:pPr>
             <a:r>
-              <a:t>Real customer targets, tolerances and provider interface</a:t>
+              <a:t>Confirm payload, host, material and supplier interfaces</a:t>
             </a:r>
           </a:p>
         </p:txBody>
@@ -15317,7 +15100,7 @@
               </a:defRPr>
             </a:pPr>
             <a:r>
-              <a:t>Decide</a:t>
+              <a:t>Build</a:t>
             </a:r>
           </a:p>
         </p:txBody>
@@ -15396,7 +15179,7 @@
               </a:defRPr>
             </a:pPr>
             <a:r>
-              <a:t>Complete motor, source, brake, contact and installed BOM</a:t>
+              <a:t>Manufacture and inspect the selected mechanism</a:t>
             </a:r>
           </a:p>
         </p:txBody>
@@ -15554,7 +15337,7 @@
               </a:defRPr>
             </a:pPr>
             <a:r>
-              <a:t>Field, contact, release, arrest, loads and cycle behavior</a:t>
+              <a:t>Transfer, custody, release, arrest and repeated-cycle behavior</a:t>
             </a:r>
           </a:p>
         </p:txBody>
@@ -15633,7 +15416,7 @@
               </a:defRPr>
             </a:pPr>
             <a:r>
-              <a:t>Review</a:t>
+              <a:t>Qualify</a:t>
             </a:r>
           </a:p>
         </p:txBody>
@@ -15712,7 +15495,7 @@
               </a:defRPr>
             </a:pPr>
             <a:r>
-              <a:t>Drawings, BOM, procedures, uncertainty and review decision</a:t>
+              <a:t>Environmental tests and independent integration review</a:t>
             </a:r>
           </a:p>
         </p:txBody>
@@ -19364,7 +19147,7 @@
               </a:defRPr>
             </a:pPr>
             <a:r>
-              <a:t>Seven feeders on one four-payload comparison boundary</a:t>
+              <a:t>The safety-led trade selects a reversible guided drive</a:t>
             </a:r>
           </a:p>
         </p:txBody>
@@ -19400,7 +19183,7 @@
               </a:defRPr>
             </a:pPr>
             <a:r>
-              <a:t>FUTURE-WORK APPENDIX</a:t>
+              <a:t>SELECTED FEEDER APPENDIX</a:t>
             </a:r>
           </a:p>
         </p:txBody>
@@ -19436,7 +19219,7 @@
               </a:defRPr>
             </a:pPr>
             <a:r>
-              <a:t>UNSELECTED CANDIDATES</a:t>
+              <a:t>SELECTED LEAD SCREW</a:t>
             </a:r>
           </a:p>
         </p:txBody>
@@ -19472,7 +19255,7 @@
               </a:defRPr>
             </a:pPr>
             <a:r>
-              <a:t>FDR09 · native FreeCAD / STEP and source-backed option screens · 22 October</a:t>
+              <a:t>FDR10 / FM08-R3 · quantified judgment sensitivity and executable checks</a:t>
             </a:r>
           </a:p>
         </p:txBody>
@@ -19515,7 +19298,7 @@
       </p:sp>
       <p:pic>
         <p:nvPicPr>
-          <p:cNvPr id="9" name="Picture 8" descr="comparison_mass.png"/>
+          <p:cNvPr id="9" name="Picture 8" descr="feeder_trade.png"/>
           <p:cNvPicPr>
             <a:picLocks noChangeAspect="1"/>
           </p:cNvPicPr>
@@ -19529,8 +19312,8 @@
         </p:blipFill>
         <p:spPr>
           <a:xfrm>
-            <a:off x="457200" y="1953168"/>
-            <a:ext cx="7315199" cy="3500303"/>
+            <a:off x="411480" y="1961387"/>
+            <a:ext cx="7360920" cy="3575304"/>
           </a:xfrm>
           <a:prstGeom prst="rect">
             <a:avLst/>
@@ -19546,7 +19329,7 @@
         <p:spPr>
           <a:xfrm>
             <a:off x="8046720" y="1691640"/>
-            <a:ext cx="3566160" cy="4023360"/>
+            <a:ext cx="3474720" cy="4114800"/>
           </a:xfrm>
           <a:prstGeom prst="rect">
             <a:avLst/>
@@ -19561,9 +19344,9 @@
           <a:p>
             <a:pPr>
               <a:spcAft>
-                <a:spcPts val="1600"/>
+                <a:spcPts val="1500"/>
               </a:spcAft>
-              <a:defRPr sz="1700">
+              <a:defRPr sz="1600">
                 <a:solidFill>
                   <a:srgbClr val="1E3144"/>
                 </a:solidFill>
@@ -19571,15 +19354,15 @@
               </a:defRPr>
             </a:pPr>
             <a:r>
-              <a:t>•  Two 1U + two 3U; one shared receiver</a:t>
+              <a:t>•  Lead screw 7.30; rack/pawl runner-up 7.10</a:t>
             </a:r>
           </a:p>
           <a:p>
             <a:pPr>
               <a:spcAft>
-                <a:spcPts val="1600"/>
+                <a:spcPts val="1500"/>
               </a:spcAft>
-              <a:defRPr sz="1700">
+              <a:defRPr sz="1600">
                 <a:solidFill>
                   <a:srgbClr val="1E3144"/>
                 </a:solidFill>
@@ -19587,15 +19370,15 @@
               </a:defRPr>
             </a:pPr>
             <a:r>
-              <a:t>•  Seven concepts; ten checked native/STEP pairs</a:t>
+              <a:t>•  Equal weights tie the top three</a:t>
             </a:r>
           </a:p>
           <a:p>
             <a:pPr>
               <a:spcAft>
-                <a:spcPts val="1600"/>
+                <a:spcPts val="1500"/>
               </a:spcAft>
-              <a:defRPr sz="1700">
+              <a:defRPr sz="1600">
                 <a:solidFill>
                   <a:srgbClr val="1E3144"/>
                 </a:solidFill>
@@ -19603,15 +19386,15 @@
               </a:defRPr>
             </a:pPr>
             <a:r>
-              <a:t>•  Separate R2 nominal payload sweep: eight collisions to zero</a:t>
+              <a:t>•  Conditional motor sizing at 50 N / 100 N</a:t>
             </a:r>
           </a:p>
           <a:p>
             <a:pPr>
               <a:spcAft>
-                <a:spcPts val="1600"/>
+                <a:spcPts val="1500"/>
               </a:spcAft>
-              <a:defRPr sz="1700">
+              <a:defRPr sz="1600">
                 <a:solidFill>
                   <a:srgbClr val="1E3144"/>
                 </a:solidFill>
@@ -19619,15 +19402,15 @@
               </a:defRPr>
             </a:pPr>
             <a:r>
-              <a:t>•  Full installed mass, loaded support and custody remain unverified</a:t>
+              <a:t>•  Four- and twelve-cell fault-sequence checks</a:t>
             </a:r>
           </a:p>
           <a:p>
             <a:pPr>
               <a:spcAft>
-                <a:spcPts val="1600"/>
+                <a:spcPts val="1500"/>
               </a:spcAft>
-              <a:defRPr sz="1700">
+              <a:defRPr sz="1600">
                 <a:solidFill>
                   <a:srgbClr val="1E3144"/>
                 </a:solidFill>
@@ -19635,7 +19418,7 @@
               </a:defRPr>
             </a:pPr>
             <a:r>
-              <a:t>•  No eligible architecture selection</a:t>
+              <a:t>•  Scores and logical tests do not measure reliability</a:t>
             </a:r>
           </a:p>
         </p:txBody>
@@ -19648,22 +19431,22 @@
         </p:nvSpPr>
         <p:spPr>
           <a:xfrm>
-            <a:off x="685800" y="6080760"/>
-            <a:ext cx="10789920" cy="274320"/>
-          </a:xfrm>
-          <a:prstGeom prst="rect">
-            <a:avLst/>
-          </a:prstGeom>
-          <a:noFill/>
-        </p:spPr>
-        <p:txBody>
-          <a:bodyPr wrap="square" lIns="13716" rIns="13716" tIns="13716" bIns="13716" anchor="t">
-            <a:spAutoFit/>
-          </a:bodyPr>
-          <a:lstStyle/>
-          <a:p>
-            <a:pPr algn="l">
-              <a:defRPr sz="1300" b="0">
+            <a:off x="640080" y="6144768"/>
+            <a:ext cx="10927080" cy="256032"/>
+          </a:xfrm>
+          <a:prstGeom prst="rect">
+            <a:avLst/>
+          </a:prstGeom>
+          <a:noFill/>
+        </p:spPr>
+        <p:txBody>
+          <a:bodyPr wrap="square" lIns="13716" rIns="13716" tIns="13716" bIns="13716" anchor="t">
+            <a:spAutoFit/>
+          </a:bodyPr>
+          <a:lstStyle/>
+          <a:p>
+            <a:pPr algn="l">
+              <a:defRPr sz="1200" b="0">
                 <a:solidFill>
                   <a:srgbClr val="1E3144"/>
                 </a:solidFill>
@@ -19671,7 +19454,7 @@
               </a:defRPr>
             </a:pPr>
             <a:r>
-              <a:t>CAD material and unintegrated catalog options are partial accounting; no mass ranking or hardware qualification.</a:t>
+              <a:t>Channel containment and controllability drive the choice. Original unconverged contact results supply no precision/load rating.</a:t>
             </a:r>
           </a:p>
         </p:txBody>
@@ -20938,7 +20721,7 @@
               </a:defRPr>
             </a:pPr>
             <a:r>
-              <a:t>Finite-duration thrust changes the resource comparison</a:t>
+              <a:t>Twelve dedicated cells require a larger host allocation</a:t>
             </a:r>
           </a:p>
         </p:txBody>
@@ -20974,7 +20757,7 @@
               </a:defRPr>
             </a:pPr>
             <a:r>
-              <a:t>FUTURE-WORK APPENDIX</a:t>
+              <a:t>GEN6 SCALING APPENDIX</a:t>
             </a:r>
           </a:p>
         </p:txBody>
@@ -21010,7 +20793,7 @@
               </a:defRPr>
             </a:pPr>
             <a:r>
-              <a:t>GEN6 SURROGATE CONTROL</a:t>
+              <a:t>DETAILED SCALING STUDY</a:t>
             </a:r>
           </a:p>
         </p:txBody>
@@ -21046,7 +20829,7 @@
               </a:defRPr>
             </a:pPr>
             <a:r>
-              <a:t>FBR-01 · 18 targeted schedules / 46 native Orekit runs</a:t>
+              <a:t>Native FreeCAD / STEP · FBR-02 nominal scheduling and mass boundary</a:t>
             </a:r>
           </a:p>
         </p:txBody>
@@ -21089,7 +20872,7 @@
       </p:sp>
       <p:pic>
         <p:nvPicPr>
-          <p:cNvPr id="9" name="Picture 8" descr="force_fuel_trade.png"/>
+          <p:cNvPr id="9" name="Picture 8" descr="twelve_capacity_plan.png"/>
           <p:cNvPicPr>
             <a:picLocks noChangeAspect="1"/>
           </p:cNvPicPr>
@@ -21103,8 +20886,8 @@
         </p:blipFill>
         <p:spPr>
           <a:xfrm>
-            <a:off x="867543" y="1389888"/>
-            <a:ext cx="6585953" cy="4709160"/>
+            <a:off x="1279413" y="1508760"/>
+            <a:ext cx="9602692" cy="2560320"/>
           </a:xfrm>
           <a:prstGeom prst="rect">
             <a:avLst/>
@@ -21113,31 +20896,152 @@
       </p:pic>
       <p:sp>
         <p:nvSpPr>
-          <p:cNvPr id="10" name="TextBox 9"/>
-          <p:cNvSpPr txBox="1"/>
-          <p:nvPr/>
-        </p:nvSpPr>
-        <p:spPr>
-          <a:xfrm>
-            <a:off x="8028431" y="1508760"/>
-            <a:ext cx="3520440" cy="4389120"/>
-          </a:xfrm>
-          <a:prstGeom prst="rect">
-            <a:avLst/>
-          </a:prstGeom>
-          <a:noFill/>
-        </p:spPr>
-        <p:txBody>
-          <a:bodyPr wrap="square" lIns="73152" rIns="73152" tIns="36576" bIns="0">
-            <a:spAutoFit/>
-          </a:bodyPr>
-          <a:lstStyle/>
-          <a:p>
-            <a:pPr>
-              <a:spcAft>
-                <a:spcPts val="1500"/>
-              </a:spcAft>
-              <a:defRPr sz="1700">
+          <p:cNvPr id="10" name="Rounded Rectangle 9"/>
+          <p:cNvSpPr/>
+          <p:nvPr/>
+        </p:nvSpPr>
+        <p:spPr>
+          <a:xfrm>
+            <a:off x="731520" y="4251960"/>
+            <a:ext cx="5303520" cy="1508760"/>
+          </a:xfrm>
+          <a:prstGeom prst="roundRect">
+            <a:avLst/>
+          </a:prstGeom>
+          <a:solidFill>
+            <a:srgbClr val="F6F9FB"/>
+          </a:solidFill>
+          <a:ln>
+            <a:solidFill>
+              <a:srgbClr val="DDE7EC"/>
+            </a:solidFill>
+          </a:ln>
+        </p:spPr>
+        <p:style>
+          <a:lnRef idx="1">
+            <a:schemeClr val="accent1"/>
+          </a:lnRef>
+          <a:fillRef idx="3">
+            <a:schemeClr val="accent1"/>
+          </a:fillRef>
+          <a:effectRef idx="2">
+            <a:schemeClr val="accent1"/>
+          </a:effectRef>
+          <a:fontRef idx="minor">
+            <a:schemeClr val="lt1"/>
+          </a:fontRef>
+        </p:style>
+        <p:txBody>
+          <a:bodyPr rtlCol="0" anchor="ctr"/>
+          <a:lstStyle/>
+          <a:p>
+            <a:pPr algn="ctr"/>
+          </a:p>
+        </p:txBody>
+      </p:sp>
+      <p:sp>
+        <p:nvSpPr>
+          <p:cNvPr id="11" name="Rectangle 10"/>
+          <p:cNvSpPr/>
+          <p:nvPr/>
+        </p:nvSpPr>
+        <p:spPr>
+          <a:xfrm>
+            <a:off x="731520" y="4251960"/>
+            <a:ext cx="73152" cy="1508760"/>
+          </a:xfrm>
+          <a:prstGeom prst="rect">
+            <a:avLst/>
+          </a:prstGeom>
+          <a:solidFill>
+            <a:srgbClr val="0096A0"/>
+          </a:solidFill>
+          <a:ln>
+            <a:noFill/>
+          </a:ln>
+        </p:spPr>
+        <p:style>
+          <a:lnRef idx="1">
+            <a:schemeClr val="accent1"/>
+          </a:lnRef>
+          <a:fillRef idx="3">
+            <a:schemeClr val="accent1"/>
+          </a:fillRef>
+          <a:effectRef idx="2">
+            <a:schemeClr val="accent1"/>
+          </a:effectRef>
+          <a:fontRef idx="minor">
+            <a:schemeClr val="lt1"/>
+          </a:fontRef>
+        </p:style>
+        <p:txBody>
+          <a:bodyPr rtlCol="0" anchor="ctr"/>
+          <a:lstStyle/>
+          <a:p>
+            <a:pPr algn="ctr"/>
+          </a:p>
+        </p:txBody>
+      </p:sp>
+      <p:sp>
+        <p:nvSpPr>
+          <p:cNvPr id="12" name="TextBox 11"/>
+          <p:cNvSpPr txBox="1"/>
+          <p:nvPr/>
+        </p:nvSpPr>
+        <p:spPr>
+          <a:xfrm>
+            <a:off x="941832" y="4398264"/>
+            <a:ext cx="4937759" cy="502920"/>
+          </a:xfrm>
+          <a:prstGeom prst="rect">
+            <a:avLst/>
+          </a:prstGeom>
+          <a:noFill/>
+        </p:spPr>
+        <p:txBody>
+          <a:bodyPr wrap="square" lIns="13716" rIns="13716" tIns="13716" bIns="13716" anchor="t">
+            <a:spAutoFit/>
+          </a:bodyPr>
+          <a:lstStyle/>
+          <a:p>
+            <a:pPr algn="l">
+              <a:defRPr sz="1900" b="1">
+                <a:solidFill>
+                  <a:srgbClr val="0D2035"/>
+                </a:solidFill>
+                <a:latin typeface="Aptos"/>
+              </a:defRPr>
+            </a:pPr>
+            <a:r>
+              <a:t>398 parts; 4.21 m envelope</a:t>
+            </a:r>
+          </a:p>
+        </p:txBody>
+      </p:sp>
+      <p:sp>
+        <p:nvSpPr>
+          <p:cNvPr id="13" name="TextBox 12"/>
+          <p:cNvSpPr txBox="1"/>
+          <p:nvPr/>
+        </p:nvSpPr>
+        <p:spPr>
+          <a:xfrm>
+            <a:off x="941832" y="5001768"/>
+            <a:ext cx="4919472" cy="594359"/>
+          </a:xfrm>
+          <a:prstGeom prst="rect">
+            <a:avLst/>
+          </a:prstGeom>
+          <a:noFill/>
+        </p:spPr>
+        <p:txBody>
+          <a:bodyPr wrap="square" lIns="13716" rIns="13716" tIns="13716" bIns="13716" anchor="t">
+            <a:spAutoFit/>
+          </a:bodyPr>
+          <a:lstStyle/>
+          <a:p>
+            <a:pPr algn="l">
+              <a:defRPr sz="1300" b="0">
                 <a:solidFill>
                   <a:srgbClr val="1E3144"/>
                 </a:solidFill>
@@ -21145,15 +21049,159 @@
               </a:defRPr>
             </a:pPr>
             <a:r>
-              <a:t>•  Four releases fit the 20 N / 10 kg screen</a:t>
-            </a:r>
-          </a:p>
-          <a:p>
-            <a:pPr>
-              <a:spcAft>
-                <a:spcPts val="1500"/>
-              </a:spcAft>
-              <a:defRPr sz="1700">
+              <a:t>Six 1U + six 3U; 83.331 kg partial feeder accounting. Full installed mass and host approval are separate.</a:t>
+            </a:r>
+          </a:p>
+        </p:txBody>
+      </p:sp>
+      <p:sp>
+        <p:nvSpPr>
+          <p:cNvPr id="14" name="Rounded Rectangle 13"/>
+          <p:cNvSpPr/>
+          <p:nvPr/>
+        </p:nvSpPr>
+        <p:spPr>
+          <a:xfrm>
+            <a:off x="6263640" y="4251960"/>
+            <a:ext cx="5166360" cy="1508760"/>
+          </a:xfrm>
+          <a:prstGeom prst="roundRect">
+            <a:avLst/>
+          </a:prstGeom>
+          <a:solidFill>
+            <a:srgbClr val="F6F9FB"/>
+          </a:solidFill>
+          <a:ln>
+            <a:solidFill>
+              <a:srgbClr val="DDE7EC"/>
+            </a:solidFill>
+          </a:ln>
+        </p:spPr>
+        <p:style>
+          <a:lnRef idx="1">
+            <a:schemeClr val="accent1"/>
+          </a:lnRef>
+          <a:fillRef idx="3">
+            <a:schemeClr val="accent1"/>
+          </a:fillRef>
+          <a:effectRef idx="2">
+            <a:schemeClr val="accent1"/>
+          </a:effectRef>
+          <a:fontRef idx="minor">
+            <a:schemeClr val="lt1"/>
+          </a:fontRef>
+        </p:style>
+        <p:txBody>
+          <a:bodyPr rtlCol="0" anchor="ctr"/>
+          <a:lstStyle/>
+          <a:p>
+            <a:pPr algn="ctr"/>
+          </a:p>
+        </p:txBody>
+      </p:sp>
+      <p:sp>
+        <p:nvSpPr>
+          <p:cNvPr id="15" name="Rectangle 14"/>
+          <p:cNvSpPr/>
+          <p:nvPr/>
+        </p:nvSpPr>
+        <p:spPr>
+          <a:xfrm>
+            <a:off x="6263640" y="4251960"/>
+            <a:ext cx="73152" cy="1508760"/>
+          </a:xfrm>
+          <a:prstGeom prst="rect">
+            <a:avLst/>
+          </a:prstGeom>
+          <a:solidFill>
+            <a:srgbClr val="D78F2B"/>
+          </a:solidFill>
+          <a:ln>
+            <a:noFill/>
+          </a:ln>
+        </p:spPr>
+        <p:style>
+          <a:lnRef idx="1">
+            <a:schemeClr val="accent1"/>
+          </a:lnRef>
+          <a:fillRef idx="3">
+            <a:schemeClr val="accent1"/>
+          </a:fillRef>
+          <a:effectRef idx="2">
+            <a:schemeClr val="accent1"/>
+          </a:effectRef>
+          <a:fontRef idx="minor">
+            <a:schemeClr val="lt1"/>
+          </a:fontRef>
+        </p:style>
+        <p:txBody>
+          <a:bodyPr rtlCol="0" anchor="ctr"/>
+          <a:lstStyle/>
+          <a:p>
+            <a:pPr algn="ctr"/>
+          </a:p>
+        </p:txBody>
+      </p:sp>
+      <p:sp>
+        <p:nvSpPr>
+          <p:cNvPr id="16" name="TextBox 15"/>
+          <p:cNvSpPr txBox="1"/>
+          <p:nvPr/>
+        </p:nvSpPr>
+        <p:spPr>
+          <a:xfrm>
+            <a:off x="6473952" y="4398264"/>
+            <a:ext cx="4800600" cy="502920"/>
+          </a:xfrm>
+          <a:prstGeom prst="rect">
+            <a:avLst/>
+          </a:prstGeom>
+          <a:noFill/>
+        </p:spPr>
+        <p:txBody>
+          <a:bodyPr wrap="square" lIns="13716" rIns="13716" tIns="13716" bIns="13716" anchor="t">
+            <a:spAutoFit/>
+          </a:bodyPr>
+          <a:lstStyle/>
+          <a:p>
+            <a:pPr algn="l">
+              <a:defRPr sz="1900" b="1">
+                <a:solidFill>
+                  <a:srgbClr val="0D2035"/>
+                </a:solidFill>
+                <a:latin typeface="Aptos"/>
+              </a:defRPr>
+            </a:pPr>
+            <a:r>
+              <a:t>18.26 s allocation residual</a:t>
+            </a:r>
+          </a:p>
+        </p:txBody>
+      </p:sp>
+      <p:sp>
+        <p:nvSpPr>
+          <p:cNvPr id="17" name="TextBox 16"/>
+          <p:cNvSpPr txBox="1"/>
+          <p:nvPr/>
+        </p:nvSpPr>
+        <p:spPr>
+          <a:xfrm>
+            <a:off x="6473952" y="5001768"/>
+            <a:ext cx="4782312" cy="594359"/>
+          </a:xfrm>
+          <a:prstGeom prst="rect">
+            <a:avLst/>
+          </a:prstGeom>
+          <a:noFill/>
+        </p:spPr>
+        <p:txBody>
+          <a:bodyPr wrap="square" lIns="13716" rIns="13716" tIns="13716" bIns="13716" anchor="t">
+            <a:spAutoFit/>
+          </a:bodyPr>
+          <a:lstStyle/>
+          <a:p>
+            <a:pPr algn="l">
+              <a:defRPr sz="1300" b="0">
                 <a:solidFill>
                   <a:srgbClr val="1E3144"/>
                 </a:solidFill>
@@ -21161,15 +21209,35 @@
               </a:defRPr>
             </a:pPr>
             <a:r>
-              <a:t>•  Twelve spring inputs exceed 20 N / 20 kg</a:t>
-            </a:r>
-          </a:p>
-          <a:p>
-            <a:pPr>
-              <a:spcAft>
-                <a:spcPts val="1500"/>
-              </a:spcAft>
-              <a:defRPr sz="1700">
+              <a:t>241.818 s coast minus 223.556 s feeder-only allocation. Launch, charging, braking and reset must also fit.</a:t>
+            </a:r>
+          </a:p>
+        </p:txBody>
+      </p:sp>
+      <p:sp>
+        <p:nvSpPr>
+          <p:cNvPr id="18" name="TextBox 17"/>
+          <p:cNvSpPr txBox="1"/>
+          <p:nvPr/>
+        </p:nvSpPr>
+        <p:spPr>
+          <a:xfrm>
+            <a:off x="685800" y="6080760"/>
+            <a:ext cx="10789920" cy="274320"/>
+          </a:xfrm>
+          <a:prstGeom prst="rect">
+            <a:avLst/>
+          </a:prstGeom>
+          <a:noFill/>
+        </p:spPr>
+        <p:txBody>
+          <a:bodyPr wrap="square" lIns="13716" rIns="13716" tIns="13716" bIns="13716" anchor="t">
+            <a:spAutoFit/>
+          </a:bodyPr>
+          <a:lstStyle/>
+          <a:p>
+            <a:pPr algn="l">
+              <a:defRPr sz="1200" b="0">
                 <a:solidFill>
                   <a:srgbClr val="1E3144"/>
                 </a:solidFill>
@@ -21177,75 +21245,7 @@
               </a:defRPr>
             </a:pPr>
             <a:r>
-              <a:t>•  Both twelve-case policies close with 30 kg / 100 N</a:t>
-            </a:r>
-          </a:p>
-          <a:p>
-            <a:pPr>
-              <a:spcAft>
-                <a:spcPts val="1500"/>
-              </a:spcAft>
-              <a:defRPr sz="1700">
-                <a:solidFill>
-                  <a:srgbClr val="1E3144"/>
-                </a:solidFill>
-                <a:latin typeface="Aptos"/>
-              </a:defRPr>
-            </a:pPr>
-            <a:r>
-              <a:t>•  Device mass still exceeds saved propellant</a:t>
-            </a:r>
-          </a:p>
-          <a:p>
-            <a:pPr>
-              <a:spcAft>
-                <a:spcPts val="1500"/>
-              </a:spcAft>
-              <a:defRPr sz="1700">
-                <a:solidFill>
-                  <a:srgbClr val="1E3144"/>
-                </a:solidFill>
-                <a:latin typeface="Aptos"/>
-              </a:defRPr>
-            </a:pPr>
-            <a:r>
-              <a:t>•  Nearly 9°/s reversals if one fixed thruster; host allocation unverified</a:t>
-            </a:r>
-          </a:p>
-        </p:txBody>
-      </p:sp>
-      <p:sp>
-        <p:nvSpPr>
-          <p:cNvPr id="11" name="TextBox 10"/>
-          <p:cNvSpPr txBox="1"/>
-          <p:nvPr/>
-        </p:nvSpPr>
-        <p:spPr>
-          <a:xfrm>
-            <a:off x="685800" y="6163056"/>
-            <a:ext cx="10789920" cy="274320"/>
-          </a:xfrm>
-          <a:prstGeom prst="rect">
-            <a:avLst/>
-          </a:prstGeom>
-          <a:noFill/>
-        </p:spPr>
-        <p:txBody>
-          <a:bodyPr wrap="square" lIns="13716" rIns="13716" tIns="13716" bIns="13716" anchor="t">
-            <a:spAutoFit/>
-          </a:bodyPr>
-          <a:lstStyle/>
-          <a:p>
-            <a:pPr algn="l">
-              <a:defRPr sz="1300" b="0">
-                <a:solidFill>
-                  <a:srgbClr val="1E3144"/>
-                </a:solidFill>
-                <a:latin typeface="Aptos"/>
-              </a:defRPr>
-            </a:pPr>
-            <a:r>
-              <a:t>Finite-force translational targets; imposed release speeds. No rated host, motor, flight precision or physical clearance.</a:t>
+              <a:t>Two nominal native/STEP states and twelve modeled payload swept corridors clear represented geometry; no hardware qualification.</a:t>
             </a:r>
           </a:p>
         </p:txBody>
@@ -25330,7 +25330,7 @@
               </a:defRPr>
             </a:pPr>
             <a:r>
-              <a:t>Reference CAD and subsystem concepts documented; feed remains open</a:t>
+              <a:t>Evaluated Gen5 reference; separate FM08-R3 feeder selected</a:t>
             </a:r>
           </a:p>
         </p:txBody>
@@ -29569,7 +29569,7 @@
               </a:defRPr>
             </a:pPr>
             <a:r>
-              <a:t>Gen5 results, failed criteria and thesis record prepared</a:t>
+              <a:t>Gen5 study and FM08-R3 feeder design selection</a:t>
             </a:r>
           </a:p>
         </p:txBody>

</xml_diff>